<commit_message>
docs: the suite is 228 after the DLB-04 regression test
The test pinning the injection rule brought the count from 227, so the deck,
the video captions and narration, and every document that states the current
figure are rebuilt against it. The audit caught the mismatch rather than
someone noticing later.

Co-Authored-By: Claude Opus 5 <noreply@anthropic.com>
</commit_message>
<xml_diff>
--- a/Docs/PRESENTATION/2. 최종/09285_백준현_AI_Master_최종발표자료_v12.pptx
+++ b/Docs/PRESENTATION/2. 최종/09285_백준현_AI_Master_최종발표자료_v12.pptx
@@ -2,16 +2,16 @@
 <file path=ppt/presentation.xml><?xml version="1.0" encoding="utf-8"?>
 <p:presentation xmlns:p="http://schemas.openxmlformats.org/presentationml/2006/main">
   <p:sldMasterIdLst>
-    <p:sldMasterId xmlns:r="http://schemas.openxmlformats.org/officeDocument/2006/relationships" id="2147483648" r:id="R1f5bb25cee584c8a"/>
+    <p:sldMasterId xmlns:r="http://schemas.openxmlformats.org/officeDocument/2006/relationships" id="2147483648" r:id="R6c891491c8e04eb4"/>
   </p:sldMasterIdLst>
   <p:notesMasterIdLst>
-    <p:notesMasterId xmlns:r="http://schemas.openxmlformats.org/officeDocument/2006/relationships" r:id="R90dbc0acb0e04825"/>
+    <p:notesMasterId xmlns:r="http://schemas.openxmlformats.org/officeDocument/2006/relationships" r:id="R903e2cdfe67945be"/>
   </p:notesMasterIdLst>
   <p:sldIdLst>
-    <p:sldId xmlns:r="http://schemas.openxmlformats.org/officeDocument/2006/relationships" id="256" r:id="Rb89bdfe6513247c8"/>
-    <p:sldId xmlns:r="http://schemas.openxmlformats.org/officeDocument/2006/relationships" id="257" r:id="R62459e1783b44873"/>
-    <p:sldId xmlns:r="http://schemas.openxmlformats.org/officeDocument/2006/relationships" id="258" r:id="R2076fe158b8542de"/>
-    <p:sldId xmlns:r="http://schemas.openxmlformats.org/officeDocument/2006/relationships" id="259" r:id="R2b2da4c70fec4718"/>
+    <p:sldId xmlns:r="http://schemas.openxmlformats.org/officeDocument/2006/relationships" id="256" r:id="R91dd1c551ab94144"/>
+    <p:sldId xmlns:r="http://schemas.openxmlformats.org/officeDocument/2006/relationships" id="257" r:id="Rd4e72466c455458e"/>
+    <p:sldId xmlns:r="http://schemas.openxmlformats.org/officeDocument/2006/relationships" id="258" r:id="R000df1ffa86644c2"/>
+    <p:sldId xmlns:r="http://schemas.openxmlformats.org/officeDocument/2006/relationships" id="259" r:id="R95d09c6520df4eea"/>
   </p:sldIdLst>
   <p:sldSz cx="12192000" cy="6858000"/>
   <p:notesSz cx="6858000" cy="9144000"/>
@@ -953,7 +953,7 @@
   </p:cSld>
   <p:clrMap bg1="lt1" tx1="dk1" bg2="lt2" tx2="dk2" accent1="accent1" accent2="accent2" accent3="accent3" accent4="accent4" accent5="accent5" accent6="accent6" hlink="hlink" folHlink="folHlink"/>
   <p:sldLayoutIdLst>
-    <p:sldLayoutId xmlns:r="http://schemas.openxmlformats.org/officeDocument/2006/relationships" id="2147483649" r:id="Rd3dc6380a1304245"/>
+    <p:sldLayoutId xmlns:r="http://schemas.openxmlformats.org/officeDocument/2006/relationships" id="2147483649" r:id="Rd10503dd10ca4247"/>
   </p:sldLayoutIdLst>
   <p:txStyles>
     <p:titleStyle>
@@ -1504,7 +1504,7 @@
           <p:cNvPr id="9" name="">
             <a:extLst xmlns:a="http://schemas.openxmlformats.org/drawingml/2006/main">
               <a:ext uri="{FF2B5EF4-FFF2-40B4-BE49-F238E27FC236}">
-                <a16:creationId xmlns:a16="http://schemas.microsoft.com/office/drawing/2014/main" id="{F4982A81-33EB-480F-9B8C-2933D11283A7}"/>
+                <a16:creationId xmlns:a16="http://schemas.microsoft.com/office/drawing/2014/main" id="{E229C907-B832-462A-ADEF-16B1FBA6EF52}"/>
               </a:ext>
             </a:extLst>
           </p:cNvPr>
@@ -1534,7 +1534,7 @@
           <p:cNvPr id="2" name="">
             <a:extLst xmlns:a="http://schemas.openxmlformats.org/drawingml/2006/main">
               <a:ext uri="{FF2B5EF4-FFF2-40B4-BE49-F238E27FC236}">
-                <a16:creationId xmlns:a16="http://schemas.microsoft.com/office/drawing/2014/main" id="{1257D798-E48D-4F6D-A0A1-15137FDC9E06}"/>
+                <a16:creationId xmlns:a16="http://schemas.microsoft.com/office/drawing/2014/main" id="{6604E904-FA8A-45F6-A658-048F12AF8631}"/>
               </a:ext>
             </a:extLst>
           </p:cNvPr>
@@ -1591,7 +1591,7 @@
           <p:cNvPr id="3" name="">
             <a:extLst xmlns:a="http://schemas.openxmlformats.org/drawingml/2006/main">
               <a:ext uri="{FF2B5EF4-FFF2-40B4-BE49-F238E27FC236}">
-                <a16:creationId xmlns:a16="http://schemas.microsoft.com/office/drawing/2014/main" id="{51648273-0D8C-4A01-8D15-31E9CB4808F5}"/>
+                <a16:creationId xmlns:a16="http://schemas.microsoft.com/office/drawing/2014/main" id="{ADDE149B-BC1A-43E8-9404-446F69AEF811}"/>
               </a:ext>
             </a:extLst>
           </p:cNvPr>
@@ -1648,7 +1648,7 @@
           <p:cNvPr id="4" name="">
             <a:extLst xmlns:a="http://schemas.openxmlformats.org/drawingml/2006/main">
               <a:ext uri="{FF2B5EF4-FFF2-40B4-BE49-F238E27FC236}">
-                <a16:creationId xmlns:a16="http://schemas.microsoft.com/office/drawing/2014/main" id="{0BFEE76A-1445-4D5F-81F7-1FCB66B755D3}"/>
+                <a16:creationId xmlns:a16="http://schemas.microsoft.com/office/drawing/2014/main" id="{29CC8B87-BE09-460A-899E-094C60B18C2A}"/>
               </a:ext>
             </a:extLst>
           </p:cNvPr>
@@ -1705,7 +1705,7 @@
           <p:cNvPr id="5" name="">
             <a:extLst xmlns:a="http://schemas.openxmlformats.org/drawingml/2006/main">
               <a:ext uri="{FF2B5EF4-FFF2-40B4-BE49-F238E27FC236}">
-                <a16:creationId xmlns:a16="http://schemas.microsoft.com/office/drawing/2014/main" id="{549FEF1D-81E2-4A8D-A21E-678A9434B6D8}"/>
+                <a16:creationId xmlns:a16="http://schemas.microsoft.com/office/drawing/2014/main" id="{3A3CAA68-737A-4A22-BF47-4222681CC103}"/>
               </a:ext>
             </a:extLst>
           </p:cNvPr>
@@ -1735,7 +1735,7 @@
           <p:cNvPr id="6" name="">
             <a:extLst xmlns:a="http://schemas.openxmlformats.org/drawingml/2006/main">
               <a:ext uri="{FF2B5EF4-FFF2-40B4-BE49-F238E27FC236}">
-                <a16:creationId xmlns:a16="http://schemas.microsoft.com/office/drawing/2014/main" id="{0D1973D4-6DEF-4BE7-B175-ADF8486466A0}"/>
+                <a16:creationId xmlns:a16="http://schemas.microsoft.com/office/drawing/2014/main" id="{77536DDB-F09D-4F90-822E-ADED86EC5D2C}"/>
               </a:ext>
             </a:extLst>
           </p:cNvPr>
@@ -1792,7 +1792,7 @@
           <p:cNvPr id="7" name="">
             <a:extLst xmlns:a="http://schemas.openxmlformats.org/drawingml/2006/main">
               <a:ext uri="{FF2B5EF4-FFF2-40B4-BE49-F238E27FC236}">
-                <a16:creationId xmlns:a16="http://schemas.microsoft.com/office/drawing/2014/main" id="{B42FCDDD-D1A2-4273-99FD-9637D00FCBF3}"/>
+                <a16:creationId xmlns:a16="http://schemas.microsoft.com/office/drawing/2014/main" id="{C5D8883F-DF63-49AC-8EAB-66A1CD6F9285}"/>
               </a:ext>
             </a:extLst>
           </p:cNvPr>
@@ -1849,7 +1849,7 @@
           <p:cNvPr id="8" name="">
             <a:extLst xmlns:a="http://schemas.openxmlformats.org/drawingml/2006/main">
               <a:ext uri="{FF2B5EF4-FFF2-40B4-BE49-F238E27FC236}">
-                <a16:creationId xmlns:a16="http://schemas.microsoft.com/office/drawing/2014/main" id="{3E54C61A-6816-432C-AA92-F607D3E14FDD}"/>
+                <a16:creationId xmlns:a16="http://schemas.microsoft.com/office/drawing/2014/main" id="{93891492-19A6-42D4-AEEE-38BDD1C42E5C}"/>
               </a:ext>
             </a:extLst>
           </p:cNvPr>
@@ -1904,7 +1904,7 @@
     </p:spTree>
     <p:extLst>
       <p:ext uri="{BB962C8B-B14F-4D97-AF65-F5344CB8AC3E}">
-        <p14:creationId xmlns:p14="http://schemas.microsoft.com/office/powerpoint/2010/main" val="418444902"/>
+        <p14:creationId xmlns:p14="http://schemas.microsoft.com/office/powerpoint/2010/main" val="450220570"/>
       </p:ext>
     </p:extLst>
   </p:cSld>
@@ -1935,7 +1935,7 @@
           <p:cNvPr id="46" name="">
             <a:extLst xmlns:a="http://schemas.openxmlformats.org/drawingml/2006/main">
               <a:ext uri="{FF2B5EF4-FFF2-40B4-BE49-F238E27FC236}">
-                <a16:creationId xmlns:a16="http://schemas.microsoft.com/office/drawing/2014/main" id="{7A2250E3-5B7B-4E72-A8F9-DAF82A90E3B7}"/>
+                <a16:creationId xmlns:a16="http://schemas.microsoft.com/office/drawing/2014/main" id="{63B2A801-0B81-4DFF-AF6B-8718B70A4CCB}"/>
               </a:ext>
             </a:extLst>
           </p:cNvPr>
@@ -1965,7 +1965,7 @@
           <p:cNvPr id="2" name="">
             <a:extLst xmlns:a="http://schemas.openxmlformats.org/drawingml/2006/main">
               <a:ext uri="{FF2B5EF4-FFF2-40B4-BE49-F238E27FC236}">
-                <a16:creationId xmlns:a16="http://schemas.microsoft.com/office/drawing/2014/main" id="{366BEAC7-4364-422F-ADD5-36B3AF6E84BA}"/>
+                <a16:creationId xmlns:a16="http://schemas.microsoft.com/office/drawing/2014/main" id="{68E149FB-72E0-474E-B7BE-2635185C1CFC}"/>
               </a:ext>
             </a:extLst>
           </p:cNvPr>
@@ -2022,7 +2022,7 @@
           <p:cNvPr id="3" name="">
             <a:extLst xmlns:a="http://schemas.openxmlformats.org/drawingml/2006/main">
               <a:ext uri="{FF2B5EF4-FFF2-40B4-BE49-F238E27FC236}">
-                <a16:creationId xmlns:a16="http://schemas.microsoft.com/office/drawing/2014/main" id="{8E96C052-8044-41DC-A9AF-35A17C899ABA}"/>
+                <a16:creationId xmlns:a16="http://schemas.microsoft.com/office/drawing/2014/main" id="{F640BAC5-98AE-4BE9-A9FD-CE633CFDD424}"/>
               </a:ext>
             </a:extLst>
           </p:cNvPr>
@@ -2052,7 +2052,7 @@
           <p:cNvPr id="4" name="">
             <a:extLst xmlns:a="http://schemas.openxmlformats.org/drawingml/2006/main">
               <a:ext uri="{FF2B5EF4-FFF2-40B4-BE49-F238E27FC236}">
-                <a16:creationId xmlns:a16="http://schemas.microsoft.com/office/drawing/2014/main" id="{0A344D52-13B2-4E48-B717-B9AE423F4B89}"/>
+                <a16:creationId xmlns:a16="http://schemas.microsoft.com/office/drawing/2014/main" id="{F560E0DF-C831-4B6B-B407-574505BAE29F}"/>
               </a:ext>
             </a:extLst>
           </p:cNvPr>
@@ -2109,7 +2109,7 @@
           <p:cNvPr id="5" name="">
             <a:extLst xmlns:a="http://schemas.openxmlformats.org/drawingml/2006/main">
               <a:ext uri="{FF2B5EF4-FFF2-40B4-BE49-F238E27FC236}">
-                <a16:creationId xmlns:a16="http://schemas.microsoft.com/office/drawing/2014/main" id="{3E5E0E0D-10CA-478C-8C6E-A0BAC69A08A2}"/>
+                <a16:creationId xmlns:a16="http://schemas.microsoft.com/office/drawing/2014/main" id="{1B7519EA-98D2-4441-A3A2-DDCE0383D46D}"/>
               </a:ext>
             </a:extLst>
           </p:cNvPr>
@@ -2166,7 +2166,7 @@
           <p:cNvPr id="6" name="">
             <a:extLst xmlns:a="http://schemas.openxmlformats.org/drawingml/2006/main">
               <a:ext uri="{FF2B5EF4-FFF2-40B4-BE49-F238E27FC236}">
-                <a16:creationId xmlns:a16="http://schemas.microsoft.com/office/drawing/2014/main" id="{7F2D4896-D96C-4CE3-B3C9-4D2CEED51F90}"/>
+                <a16:creationId xmlns:a16="http://schemas.microsoft.com/office/drawing/2014/main" id="{11E61FF9-C3B2-4BDE-B2A0-C8DEB6C71C0A}"/>
               </a:ext>
             </a:extLst>
           </p:cNvPr>
@@ -2223,7 +2223,7 @@
           <p:cNvPr id="7" name="">
             <a:extLst xmlns:a="http://schemas.openxmlformats.org/drawingml/2006/main">
               <a:ext uri="{FF2B5EF4-FFF2-40B4-BE49-F238E27FC236}">
-                <a16:creationId xmlns:a16="http://schemas.microsoft.com/office/drawing/2014/main" id="{119E63A5-6495-4D59-821D-55AE74E653D2}"/>
+                <a16:creationId xmlns:a16="http://schemas.microsoft.com/office/drawing/2014/main" id="{A1795976-9A5A-4967-B56F-2861EABCB2BD}"/>
               </a:ext>
             </a:extLst>
           </p:cNvPr>
@@ -2257,7 +2257,7 @@
           <p:cNvPr id="8" name="">
             <a:extLst xmlns:a="http://schemas.openxmlformats.org/drawingml/2006/main">
               <a:ext uri="{FF2B5EF4-FFF2-40B4-BE49-F238E27FC236}">
-                <a16:creationId xmlns:a16="http://schemas.microsoft.com/office/drawing/2014/main" id="{5C189DA6-D066-478C-BB00-11F88B27B157}"/>
+                <a16:creationId xmlns:a16="http://schemas.microsoft.com/office/drawing/2014/main" id="{1183016A-F3F3-48C7-A94D-C5DFE84F3333}"/>
               </a:ext>
             </a:extLst>
           </p:cNvPr>
@@ -2289,7 +2289,7 @@
           <p:cNvPr id="9" name="">
             <a:extLst xmlns:a="http://schemas.openxmlformats.org/drawingml/2006/main">
               <a:ext uri="{FF2B5EF4-FFF2-40B4-BE49-F238E27FC236}">
-                <a16:creationId xmlns:a16="http://schemas.microsoft.com/office/drawing/2014/main" id="{C59AA0F9-A69A-45D4-A066-E340ED905161}"/>
+                <a16:creationId xmlns:a16="http://schemas.microsoft.com/office/drawing/2014/main" id="{05B21BAB-4BBF-4634-838F-B50D410427B3}"/>
               </a:ext>
             </a:extLst>
           </p:cNvPr>
@@ -2346,7 +2346,7 @@
           <p:cNvPr id="10" name="">
             <a:extLst xmlns:a="http://schemas.openxmlformats.org/drawingml/2006/main">
               <a:ext uri="{FF2B5EF4-FFF2-40B4-BE49-F238E27FC236}">
-                <a16:creationId xmlns:a16="http://schemas.microsoft.com/office/drawing/2014/main" id="{654FCC31-C032-4FD3-B68C-38770CEEAA76}"/>
+                <a16:creationId xmlns:a16="http://schemas.microsoft.com/office/drawing/2014/main" id="{9F1BCDB5-85FD-4206-8A21-74D0641549B7}"/>
               </a:ext>
             </a:extLst>
           </p:cNvPr>
@@ -2426,7 +2426,7 @@
           <p:cNvPr id="11" name="">
             <a:extLst xmlns:a="http://schemas.openxmlformats.org/drawingml/2006/main">
               <a:ext uri="{FF2B5EF4-FFF2-40B4-BE49-F238E27FC236}">
-                <a16:creationId xmlns:a16="http://schemas.microsoft.com/office/drawing/2014/main" id="{34973555-052B-4A64-B8CF-02B356DE8D44}"/>
+                <a16:creationId xmlns:a16="http://schemas.microsoft.com/office/drawing/2014/main" id="{098AEBD2-8227-4D6F-A9AA-F0EA5661A80A}"/>
               </a:ext>
             </a:extLst>
           </p:cNvPr>
@@ -2456,7 +2456,7 @@
           <p:cNvPr id="12" name="">
             <a:extLst xmlns:a="http://schemas.openxmlformats.org/drawingml/2006/main">
               <a:ext uri="{FF2B5EF4-FFF2-40B4-BE49-F238E27FC236}">
-                <a16:creationId xmlns:a16="http://schemas.microsoft.com/office/drawing/2014/main" id="{EC924D7F-EE92-4AAB-89F8-4CF587C75B59}"/>
+                <a16:creationId xmlns:a16="http://schemas.microsoft.com/office/drawing/2014/main" id="{13090EAC-3743-4280-98E9-B907C51AE191}"/>
               </a:ext>
             </a:extLst>
           </p:cNvPr>
@@ -2490,7 +2490,7 @@
           <p:cNvPr id="13" name="">
             <a:extLst xmlns:a="http://schemas.openxmlformats.org/drawingml/2006/main">
               <a:ext uri="{FF2B5EF4-FFF2-40B4-BE49-F238E27FC236}">
-                <a16:creationId xmlns:a16="http://schemas.microsoft.com/office/drawing/2014/main" id="{59BB35EF-866F-4F20-9879-7312600DE712}"/>
+                <a16:creationId xmlns:a16="http://schemas.microsoft.com/office/drawing/2014/main" id="{C2EE831F-F502-4B56-BA1B-3AEB09FC9072}"/>
               </a:ext>
             </a:extLst>
           </p:cNvPr>
@@ -2522,7 +2522,7 @@
           <p:cNvPr id="14" name="">
             <a:extLst xmlns:a="http://schemas.openxmlformats.org/drawingml/2006/main">
               <a:ext uri="{FF2B5EF4-FFF2-40B4-BE49-F238E27FC236}">
-                <a16:creationId xmlns:a16="http://schemas.microsoft.com/office/drawing/2014/main" id="{84281AE3-D3D8-45ED-8987-D77CEC225ACF}"/>
+                <a16:creationId xmlns:a16="http://schemas.microsoft.com/office/drawing/2014/main" id="{85A24E75-C3DE-49E0-B59B-19C7848E6340}"/>
               </a:ext>
             </a:extLst>
           </p:cNvPr>
@@ -2579,7 +2579,7 @@
           <p:cNvPr id="15" name="">
             <a:extLst xmlns:a="http://schemas.openxmlformats.org/drawingml/2006/main">
               <a:ext uri="{FF2B5EF4-FFF2-40B4-BE49-F238E27FC236}">
-                <a16:creationId xmlns:a16="http://schemas.microsoft.com/office/drawing/2014/main" id="{CBB55C41-987B-439C-819F-02C2D207C999}"/>
+                <a16:creationId xmlns:a16="http://schemas.microsoft.com/office/drawing/2014/main" id="{4E5FF2E8-A56E-4C9E-BAD8-96B8CBF3DA35}"/>
               </a:ext>
             </a:extLst>
           </p:cNvPr>
@@ -2659,7 +2659,7 @@
           <p:cNvPr id="16" name="">
             <a:extLst xmlns:a="http://schemas.openxmlformats.org/drawingml/2006/main">
               <a:ext uri="{FF2B5EF4-FFF2-40B4-BE49-F238E27FC236}">
-                <a16:creationId xmlns:a16="http://schemas.microsoft.com/office/drawing/2014/main" id="{466567CB-9300-4524-B565-9DF68F8006FB}"/>
+                <a16:creationId xmlns:a16="http://schemas.microsoft.com/office/drawing/2014/main" id="{F7191E1C-A27A-40FB-A4E3-E9772D13A7B7}"/>
               </a:ext>
             </a:extLst>
           </p:cNvPr>
@@ -2689,7 +2689,7 @@
           <p:cNvPr id="17" name="">
             <a:extLst xmlns:a="http://schemas.openxmlformats.org/drawingml/2006/main">
               <a:ext uri="{FF2B5EF4-FFF2-40B4-BE49-F238E27FC236}">
-                <a16:creationId xmlns:a16="http://schemas.microsoft.com/office/drawing/2014/main" id="{B41DE8FA-D828-47F0-A312-B4418F0E705B}"/>
+                <a16:creationId xmlns:a16="http://schemas.microsoft.com/office/drawing/2014/main" id="{B062FACD-F7FE-4134-B4C1-957B084E4A44}"/>
               </a:ext>
             </a:extLst>
           </p:cNvPr>
@@ -2723,7 +2723,7 @@
           <p:cNvPr id="18" name="">
             <a:extLst xmlns:a="http://schemas.openxmlformats.org/drawingml/2006/main">
               <a:ext uri="{FF2B5EF4-FFF2-40B4-BE49-F238E27FC236}">
-                <a16:creationId xmlns:a16="http://schemas.microsoft.com/office/drawing/2014/main" id="{26E8B4DB-E764-4406-8553-3EF19D995CDC}"/>
+                <a16:creationId xmlns:a16="http://schemas.microsoft.com/office/drawing/2014/main" id="{AA7F0A32-B632-4415-A1DF-F82567B80E55}"/>
               </a:ext>
             </a:extLst>
           </p:cNvPr>
@@ -2755,7 +2755,7 @@
           <p:cNvPr id="19" name="">
             <a:extLst xmlns:a="http://schemas.openxmlformats.org/drawingml/2006/main">
               <a:ext uri="{FF2B5EF4-FFF2-40B4-BE49-F238E27FC236}">
-                <a16:creationId xmlns:a16="http://schemas.microsoft.com/office/drawing/2014/main" id="{93C2D1E4-2024-4F91-A6BC-E9896397A749}"/>
+                <a16:creationId xmlns:a16="http://schemas.microsoft.com/office/drawing/2014/main" id="{47B081AE-E9BE-428E-A299-E2498EFC6755}"/>
               </a:ext>
             </a:extLst>
           </p:cNvPr>
@@ -2812,7 +2812,7 @@
           <p:cNvPr id="20" name="">
             <a:extLst xmlns:a="http://schemas.openxmlformats.org/drawingml/2006/main">
               <a:ext uri="{FF2B5EF4-FFF2-40B4-BE49-F238E27FC236}">
-                <a16:creationId xmlns:a16="http://schemas.microsoft.com/office/drawing/2014/main" id="{ADB26829-57E5-449B-BBE9-13BDEF8327CA}"/>
+                <a16:creationId xmlns:a16="http://schemas.microsoft.com/office/drawing/2014/main" id="{E9871A4E-5376-4D54-A0C4-B23CAA56D2B2}"/>
               </a:ext>
             </a:extLst>
           </p:cNvPr>
@@ -2892,7 +2892,7 @@
           <p:cNvPr id="21" name="">
             <a:extLst xmlns:a="http://schemas.openxmlformats.org/drawingml/2006/main">
               <a:ext uri="{FF2B5EF4-FFF2-40B4-BE49-F238E27FC236}">
-                <a16:creationId xmlns:a16="http://schemas.microsoft.com/office/drawing/2014/main" id="{2871AE45-4EDD-4625-8DA7-7E47C61018B6}"/>
+                <a16:creationId xmlns:a16="http://schemas.microsoft.com/office/drawing/2014/main" id="{D385C034-4CBB-47DD-9C82-CF11EB1E4C2F}"/>
               </a:ext>
             </a:extLst>
           </p:cNvPr>
@@ -2922,7 +2922,7 @@
           <p:cNvPr id="22" name="">
             <a:extLst xmlns:a="http://schemas.openxmlformats.org/drawingml/2006/main">
               <a:ext uri="{FF2B5EF4-FFF2-40B4-BE49-F238E27FC236}">
-                <a16:creationId xmlns:a16="http://schemas.microsoft.com/office/drawing/2014/main" id="{9C4A2454-FA9A-463B-9928-B699DE6B3B78}"/>
+                <a16:creationId xmlns:a16="http://schemas.microsoft.com/office/drawing/2014/main" id="{455A238C-B75B-47A9-9BE2-ED47593FD7D9}"/>
               </a:ext>
             </a:extLst>
           </p:cNvPr>
@@ -2956,7 +2956,7 @@
           <p:cNvPr id="23" name="">
             <a:extLst xmlns:a="http://schemas.openxmlformats.org/drawingml/2006/main">
               <a:ext uri="{FF2B5EF4-FFF2-40B4-BE49-F238E27FC236}">
-                <a16:creationId xmlns:a16="http://schemas.microsoft.com/office/drawing/2014/main" id="{7061E416-21E8-4E9A-9DAB-CA599792908F}"/>
+                <a16:creationId xmlns:a16="http://schemas.microsoft.com/office/drawing/2014/main" id="{E8BE7A93-4307-4930-9BDE-9596EA55DFA0}"/>
               </a:ext>
             </a:extLst>
           </p:cNvPr>
@@ -2988,7 +2988,7 @@
           <p:cNvPr id="24" name="">
             <a:extLst xmlns:a="http://schemas.openxmlformats.org/drawingml/2006/main">
               <a:ext uri="{FF2B5EF4-FFF2-40B4-BE49-F238E27FC236}">
-                <a16:creationId xmlns:a16="http://schemas.microsoft.com/office/drawing/2014/main" id="{20D5372E-6ECB-42CB-82D9-11E3DA90266E}"/>
+                <a16:creationId xmlns:a16="http://schemas.microsoft.com/office/drawing/2014/main" id="{3FB6096B-DF85-4D83-8E84-7AFEEE2E9871}"/>
               </a:ext>
             </a:extLst>
           </p:cNvPr>
@@ -3045,7 +3045,7 @@
           <p:cNvPr id="25" name="">
             <a:extLst xmlns:a="http://schemas.openxmlformats.org/drawingml/2006/main">
               <a:ext uri="{FF2B5EF4-FFF2-40B4-BE49-F238E27FC236}">
-                <a16:creationId xmlns:a16="http://schemas.microsoft.com/office/drawing/2014/main" id="{35B2F0B8-1B4F-4497-8DBC-6145F6EFF349}"/>
+                <a16:creationId xmlns:a16="http://schemas.microsoft.com/office/drawing/2014/main" id="{F68D3DB7-24A5-47AC-A735-0E4975EFB07D}"/>
               </a:ext>
             </a:extLst>
           </p:cNvPr>
@@ -3125,7 +3125,7 @@
           <p:cNvPr id="26" name="">
             <a:extLst xmlns:a="http://schemas.openxmlformats.org/drawingml/2006/main">
               <a:ext uri="{FF2B5EF4-FFF2-40B4-BE49-F238E27FC236}">
-                <a16:creationId xmlns:a16="http://schemas.microsoft.com/office/drawing/2014/main" id="{A4C6E2BF-0F26-4B09-B1DA-CD4AB75B5C61}"/>
+                <a16:creationId xmlns:a16="http://schemas.microsoft.com/office/drawing/2014/main" id="{E312DF1B-FD2B-4FFB-8C9C-66237C77E225}"/>
               </a:ext>
             </a:extLst>
           </p:cNvPr>
@@ -3155,7 +3155,7 @@
           <p:cNvPr id="27" name="">
             <a:extLst xmlns:a="http://schemas.openxmlformats.org/drawingml/2006/main">
               <a:ext uri="{FF2B5EF4-FFF2-40B4-BE49-F238E27FC236}">
-                <a16:creationId xmlns:a16="http://schemas.microsoft.com/office/drawing/2014/main" id="{DA7942B9-5744-4247-AF6F-5075F112A19A}"/>
+                <a16:creationId xmlns:a16="http://schemas.microsoft.com/office/drawing/2014/main" id="{9AC3365B-D6F4-4878-9B28-4452A39E1669}"/>
               </a:ext>
             </a:extLst>
           </p:cNvPr>
@@ -3189,7 +3189,7 @@
           <p:cNvPr id="28" name="">
             <a:extLst xmlns:a="http://schemas.openxmlformats.org/drawingml/2006/main">
               <a:ext uri="{FF2B5EF4-FFF2-40B4-BE49-F238E27FC236}">
-                <a16:creationId xmlns:a16="http://schemas.microsoft.com/office/drawing/2014/main" id="{7E5EFD9C-C02A-4DEE-B3BA-9B983F36B443}"/>
+                <a16:creationId xmlns:a16="http://schemas.microsoft.com/office/drawing/2014/main" id="{2C44BE54-768C-4753-A0CA-4048D236D5CF}"/>
               </a:ext>
             </a:extLst>
           </p:cNvPr>
@@ -3221,7 +3221,7 @@
           <p:cNvPr id="29" name="">
             <a:extLst xmlns:a="http://schemas.openxmlformats.org/drawingml/2006/main">
               <a:ext uri="{FF2B5EF4-FFF2-40B4-BE49-F238E27FC236}">
-                <a16:creationId xmlns:a16="http://schemas.microsoft.com/office/drawing/2014/main" id="{40829765-7AE7-4FFA-8DAD-B8785C56011C}"/>
+                <a16:creationId xmlns:a16="http://schemas.microsoft.com/office/drawing/2014/main" id="{7BB908B8-B1B9-47DA-85AD-BD6B04766141}"/>
               </a:ext>
             </a:extLst>
           </p:cNvPr>
@@ -3278,7 +3278,7 @@
           <p:cNvPr id="30" name="">
             <a:extLst xmlns:a="http://schemas.openxmlformats.org/drawingml/2006/main">
               <a:ext uri="{FF2B5EF4-FFF2-40B4-BE49-F238E27FC236}">
-                <a16:creationId xmlns:a16="http://schemas.microsoft.com/office/drawing/2014/main" id="{4E72E15B-EB71-44C4-A41B-5CC21F6A2211}"/>
+                <a16:creationId xmlns:a16="http://schemas.microsoft.com/office/drawing/2014/main" id="{CB2EDC32-BCF4-46BC-842F-74E036318EEA}"/>
               </a:ext>
             </a:extLst>
           </p:cNvPr>
@@ -3358,7 +3358,7 @@
           <p:cNvPr id="31" name="">
             <a:extLst xmlns:a="http://schemas.openxmlformats.org/drawingml/2006/main">
               <a:ext uri="{FF2B5EF4-FFF2-40B4-BE49-F238E27FC236}">
-                <a16:creationId xmlns:a16="http://schemas.microsoft.com/office/drawing/2014/main" id="{52544AE9-B3D6-4472-B232-C3542B920B58}"/>
+                <a16:creationId xmlns:a16="http://schemas.microsoft.com/office/drawing/2014/main" id="{759E9D3B-7E25-4086-AE88-563EF3CC813D}"/>
               </a:ext>
             </a:extLst>
           </p:cNvPr>
@@ -3415,7 +3415,7 @@
           <p:cNvPr id="32" name="">
             <a:extLst xmlns:a="http://schemas.openxmlformats.org/drawingml/2006/main">
               <a:ext uri="{FF2B5EF4-FFF2-40B4-BE49-F238E27FC236}">
-                <a16:creationId xmlns:a16="http://schemas.microsoft.com/office/drawing/2014/main" id="{A8DFA41A-69C2-4960-8B18-7674B3C693EF}"/>
+                <a16:creationId xmlns:a16="http://schemas.microsoft.com/office/drawing/2014/main" id="{4A2F98E3-6050-4026-A9D7-E992769CBE32}"/>
               </a:ext>
             </a:extLst>
           </p:cNvPr>
@@ -3472,7 +3472,7 @@
           <p:cNvPr id="33" name="">
             <a:extLst xmlns:a="http://schemas.openxmlformats.org/drawingml/2006/main">
               <a:ext uri="{FF2B5EF4-FFF2-40B4-BE49-F238E27FC236}">
-                <a16:creationId xmlns:a16="http://schemas.microsoft.com/office/drawing/2014/main" id="{B1811D88-E571-444D-81D4-30CA8C322FB9}"/>
+                <a16:creationId xmlns:a16="http://schemas.microsoft.com/office/drawing/2014/main" id="{A1938C23-11BE-4683-951C-6C5D2C030C3E}"/>
               </a:ext>
             </a:extLst>
           </p:cNvPr>
@@ -3529,7 +3529,7 @@
           <p:cNvPr id="34" name="">
             <a:extLst xmlns:a="http://schemas.openxmlformats.org/drawingml/2006/main">
               <a:ext uri="{FF2B5EF4-FFF2-40B4-BE49-F238E27FC236}">
-                <a16:creationId xmlns:a16="http://schemas.microsoft.com/office/drawing/2014/main" id="{1E28D2B6-AEE1-4555-B558-2DE8AD654F98}"/>
+                <a16:creationId xmlns:a16="http://schemas.microsoft.com/office/drawing/2014/main" id="{D5C7B1C7-D2DB-4811-8F42-9D46091F78BF}"/>
               </a:ext>
             </a:extLst>
           </p:cNvPr>
@@ -3586,7 +3586,7 @@
           <p:cNvPr id="35" name="">
             <a:extLst xmlns:a="http://schemas.openxmlformats.org/drawingml/2006/main">
               <a:ext uri="{FF2B5EF4-FFF2-40B4-BE49-F238E27FC236}">
-                <a16:creationId xmlns:a16="http://schemas.microsoft.com/office/drawing/2014/main" id="{5F046CF8-98CC-491D-BC76-666764967B45}"/>
+                <a16:creationId xmlns:a16="http://schemas.microsoft.com/office/drawing/2014/main" id="{839B07F5-DAD9-411D-8C9A-5860CB661C33}"/>
               </a:ext>
             </a:extLst>
           </p:cNvPr>
@@ -3643,7 +3643,7 @@
           <p:cNvPr id="36" name="">
             <a:extLst xmlns:a="http://schemas.openxmlformats.org/drawingml/2006/main">
               <a:ext uri="{FF2B5EF4-FFF2-40B4-BE49-F238E27FC236}">
-                <a16:creationId xmlns:a16="http://schemas.microsoft.com/office/drawing/2014/main" id="{62B5AC0A-0C46-4801-88C1-4C757D1910B5}"/>
+                <a16:creationId xmlns:a16="http://schemas.microsoft.com/office/drawing/2014/main" id="{B499622E-2161-4BE7-B667-D527E1A7F04B}"/>
               </a:ext>
             </a:extLst>
           </p:cNvPr>
@@ -3700,7 +3700,7 @@
           <p:cNvPr id="37" name="">
             <a:extLst xmlns:a="http://schemas.openxmlformats.org/drawingml/2006/main">
               <a:ext uri="{FF2B5EF4-FFF2-40B4-BE49-F238E27FC236}">
-                <a16:creationId xmlns:a16="http://schemas.microsoft.com/office/drawing/2014/main" id="{C00F5916-050E-4AF0-B0F9-3C3E0CCD1DCE}"/>
+                <a16:creationId xmlns:a16="http://schemas.microsoft.com/office/drawing/2014/main" id="{7DAA555E-AD0B-4A64-B758-9635A94D6F34}"/>
               </a:ext>
             </a:extLst>
           </p:cNvPr>
@@ -3757,7 +3757,7 @@
           <p:cNvPr id="38" name="">
             <a:extLst xmlns:a="http://schemas.openxmlformats.org/drawingml/2006/main">
               <a:ext uri="{FF2B5EF4-FFF2-40B4-BE49-F238E27FC236}">
-                <a16:creationId xmlns:a16="http://schemas.microsoft.com/office/drawing/2014/main" id="{99612E8C-031B-4B65-A51E-4F49B58BAA03}"/>
+                <a16:creationId xmlns:a16="http://schemas.microsoft.com/office/drawing/2014/main" id="{B70990CC-458D-487C-96F0-DB2519FB9F70}"/>
               </a:ext>
             </a:extLst>
           </p:cNvPr>
@@ -3814,7 +3814,7 @@
           <p:cNvPr id="39" name="">
             <a:extLst xmlns:a="http://schemas.openxmlformats.org/drawingml/2006/main">
               <a:ext uri="{FF2B5EF4-FFF2-40B4-BE49-F238E27FC236}">
-                <a16:creationId xmlns:a16="http://schemas.microsoft.com/office/drawing/2014/main" id="{5403E7AF-EAE8-4AF5-95EA-D5800BA37F8B}"/>
+                <a16:creationId xmlns:a16="http://schemas.microsoft.com/office/drawing/2014/main" id="{197262B5-3E43-46CA-9602-269DF9D526C1}"/>
               </a:ext>
             </a:extLst>
           </p:cNvPr>
@@ -3871,7 +3871,7 @@
           <p:cNvPr id="40" name="">
             <a:extLst xmlns:a="http://schemas.openxmlformats.org/drawingml/2006/main">
               <a:ext uri="{FF2B5EF4-FFF2-40B4-BE49-F238E27FC236}">
-                <a16:creationId xmlns:a16="http://schemas.microsoft.com/office/drawing/2014/main" id="{40A3CCBF-DB60-4746-AFD1-9B75C6FDD7B0}"/>
+                <a16:creationId xmlns:a16="http://schemas.microsoft.com/office/drawing/2014/main" id="{E002CA74-E65D-42E4-A8A5-A1EDD9B82408}"/>
               </a:ext>
             </a:extLst>
           </p:cNvPr>
@@ -3918,7 +3918,7 @@
                 <a:ea typeface="Malgun Gothic"/>
                 <a:cs typeface="Malgun Gothic"/>
               </a:rPr>
-              <a:t>보조 검증  |  pytest 227 passed  ·  중복 재조회 35/35</a:t>
+              <a:t>보조 검증  |  pytest 228 passed  ·  중복 재조회 35/35</a:t>
             </a:r>
           </a:p>
         </p:txBody>
@@ -3928,7 +3928,7 @@
           <p:cNvPr id="41" name="">
             <a:extLst xmlns:a="http://schemas.openxmlformats.org/drawingml/2006/main">
               <a:ext uri="{FF2B5EF4-FFF2-40B4-BE49-F238E27FC236}">
-                <a16:creationId xmlns:a16="http://schemas.microsoft.com/office/drawing/2014/main" id="{5ACDBB2B-4C42-474B-B7B9-338158AFCFE8}"/>
+                <a16:creationId xmlns:a16="http://schemas.microsoft.com/office/drawing/2014/main" id="{F80AE92D-1BA8-4FBA-89E0-7CA1AA10F6A2}"/>
               </a:ext>
             </a:extLst>
           </p:cNvPr>
@@ -3985,7 +3985,7 @@
           <p:cNvPr id="42" name="">
             <a:extLst xmlns:a="http://schemas.openxmlformats.org/drawingml/2006/main">
               <a:ext uri="{FF2B5EF4-FFF2-40B4-BE49-F238E27FC236}">
-                <a16:creationId xmlns:a16="http://schemas.microsoft.com/office/drawing/2014/main" id="{7D5D756C-0537-455C-A91B-FB4C38A25061}"/>
+                <a16:creationId xmlns:a16="http://schemas.microsoft.com/office/drawing/2014/main" id="{C8D80887-8D62-4921-A810-9479BC910AE2}"/>
               </a:ext>
             </a:extLst>
           </p:cNvPr>
@@ -4042,7 +4042,7 @@
           <p:cNvPr id="43" name="">
             <a:extLst xmlns:a="http://schemas.openxmlformats.org/drawingml/2006/main">
               <a:ext uri="{FF2B5EF4-FFF2-40B4-BE49-F238E27FC236}">
-                <a16:creationId xmlns:a16="http://schemas.microsoft.com/office/drawing/2014/main" id="{A4F935FC-980E-4023-A87D-6946C51083B6}"/>
+                <a16:creationId xmlns:a16="http://schemas.microsoft.com/office/drawing/2014/main" id="{C8123489-06A6-447F-81A2-7FA97597FD97}"/>
               </a:ext>
             </a:extLst>
           </p:cNvPr>
@@ -4099,7 +4099,7 @@
           <p:cNvPr id="44" name="">
             <a:extLst xmlns:a="http://schemas.openxmlformats.org/drawingml/2006/main">
               <a:ext uri="{FF2B5EF4-FFF2-40B4-BE49-F238E27FC236}">
-                <a16:creationId xmlns:a16="http://schemas.microsoft.com/office/drawing/2014/main" id="{9B1EF45A-292C-4670-84C2-AEFD48664D0E}"/>
+                <a16:creationId xmlns:a16="http://schemas.microsoft.com/office/drawing/2014/main" id="{A5986EC0-C700-4586-B172-6EC501AC79D6}"/>
               </a:ext>
             </a:extLst>
           </p:cNvPr>
@@ -4131,7 +4131,7 @@
           <p:cNvPr id="45" name="">
             <a:extLst xmlns:a="http://schemas.openxmlformats.org/drawingml/2006/main">
               <a:ext uri="{FF2B5EF4-FFF2-40B4-BE49-F238E27FC236}">
-                <a16:creationId xmlns:a16="http://schemas.microsoft.com/office/drawing/2014/main" id="{FDB33265-245D-45AE-888B-E7F4DCB0C4C8}"/>
+                <a16:creationId xmlns:a16="http://schemas.microsoft.com/office/drawing/2014/main" id="{46781895-2D14-47AD-90FC-CB140146630A}"/>
               </a:ext>
             </a:extLst>
           </p:cNvPr>
@@ -4186,7 +4186,7 @@
     </p:spTree>
     <p:extLst>
       <p:ext uri="{BB962C8B-B14F-4D97-AF65-F5344CB8AC3E}">
-        <p14:creationId xmlns:p14="http://schemas.microsoft.com/office/powerpoint/2010/main" val="497755918"/>
+        <p14:creationId xmlns:p14="http://schemas.microsoft.com/office/powerpoint/2010/main" val="642944771"/>
       </p:ext>
     </p:extLst>
   </p:cSld>
@@ -4217,7 +4217,7 @@
           <p:cNvPr id="56" name="">
             <a:extLst xmlns:a="http://schemas.openxmlformats.org/drawingml/2006/main">
               <a:ext uri="{FF2B5EF4-FFF2-40B4-BE49-F238E27FC236}">
-                <a16:creationId xmlns:a16="http://schemas.microsoft.com/office/drawing/2014/main" id="{725C6355-062D-4FEC-B85B-7F48B11012AE}"/>
+                <a16:creationId xmlns:a16="http://schemas.microsoft.com/office/drawing/2014/main" id="{9A49D0B4-0A68-444D-86C2-5E97B84700A5}"/>
               </a:ext>
             </a:extLst>
           </p:cNvPr>
@@ -4247,7 +4247,7 @@
           <p:cNvPr id="2" name="">
             <a:extLst xmlns:a="http://schemas.openxmlformats.org/drawingml/2006/main">
               <a:ext uri="{FF2B5EF4-FFF2-40B4-BE49-F238E27FC236}">
-                <a16:creationId xmlns:a16="http://schemas.microsoft.com/office/drawing/2014/main" id="{C8E06E21-4560-4408-9D22-9A0C9B945678}"/>
+                <a16:creationId xmlns:a16="http://schemas.microsoft.com/office/drawing/2014/main" id="{4E21D0A2-14E2-427D-BAE5-5CDE3EDFF4DA}"/>
               </a:ext>
             </a:extLst>
           </p:cNvPr>
@@ -4304,7 +4304,7 @@
           <p:cNvPr id="3" name="">
             <a:extLst xmlns:a="http://schemas.openxmlformats.org/drawingml/2006/main">
               <a:ext uri="{FF2B5EF4-FFF2-40B4-BE49-F238E27FC236}">
-                <a16:creationId xmlns:a16="http://schemas.microsoft.com/office/drawing/2014/main" id="{DD092C29-D8E6-45E6-9BF6-5D88DDF88BE8}"/>
+                <a16:creationId xmlns:a16="http://schemas.microsoft.com/office/drawing/2014/main" id="{27991C32-866A-423D-ABDB-C0BA91FE932B}"/>
               </a:ext>
             </a:extLst>
           </p:cNvPr>
@@ -4334,7 +4334,7 @@
           <p:cNvPr id="4" name="">
             <a:extLst xmlns:a="http://schemas.openxmlformats.org/drawingml/2006/main">
               <a:ext uri="{FF2B5EF4-FFF2-40B4-BE49-F238E27FC236}">
-                <a16:creationId xmlns:a16="http://schemas.microsoft.com/office/drawing/2014/main" id="{89154C00-ACF3-4306-8DD1-CD7A53BE2FB3}"/>
+                <a16:creationId xmlns:a16="http://schemas.microsoft.com/office/drawing/2014/main" id="{4B83E259-F692-4235-8425-5E72D3C265ED}"/>
               </a:ext>
             </a:extLst>
           </p:cNvPr>
@@ -4391,7 +4391,7 @@
           <p:cNvPr id="5" name="">
             <a:extLst xmlns:a="http://schemas.openxmlformats.org/drawingml/2006/main">
               <a:ext uri="{FF2B5EF4-FFF2-40B4-BE49-F238E27FC236}">
-                <a16:creationId xmlns:a16="http://schemas.microsoft.com/office/drawing/2014/main" id="{7B7BAD21-4A99-4518-85F0-847986C92246}"/>
+                <a16:creationId xmlns:a16="http://schemas.microsoft.com/office/drawing/2014/main" id="{7A9431DB-EE7D-400E-8929-55493894EEBE}"/>
               </a:ext>
             </a:extLst>
           </p:cNvPr>
@@ -4448,7 +4448,7 @@
           <p:cNvPr id="6" name="">
             <a:extLst xmlns:a="http://schemas.openxmlformats.org/drawingml/2006/main">
               <a:ext uri="{FF2B5EF4-FFF2-40B4-BE49-F238E27FC236}">
-                <a16:creationId xmlns:a16="http://schemas.microsoft.com/office/drawing/2014/main" id="{E43DC21F-C471-4EF3-8647-3365A7B5D6C1}"/>
+                <a16:creationId xmlns:a16="http://schemas.microsoft.com/office/drawing/2014/main" id="{AFC2F603-C7E8-4629-ACC6-80133AE106C5}"/>
               </a:ext>
             </a:extLst>
           </p:cNvPr>
@@ -4482,7 +4482,7 @@
           <p:cNvPr id="7" name="">
             <a:extLst xmlns:a="http://schemas.openxmlformats.org/drawingml/2006/main">
               <a:ext uri="{FF2B5EF4-FFF2-40B4-BE49-F238E27FC236}">
-                <a16:creationId xmlns:a16="http://schemas.microsoft.com/office/drawing/2014/main" id="{BF273617-3BA9-44B3-880C-35D178EFDF60}"/>
+                <a16:creationId xmlns:a16="http://schemas.microsoft.com/office/drawing/2014/main" id="{AD349F84-7B68-4EDF-B3E0-28A4D006B9BB}"/>
               </a:ext>
             </a:extLst>
           </p:cNvPr>
@@ -4514,7 +4514,7 @@
           <p:cNvPr id="8" name="">
             <a:extLst xmlns:a="http://schemas.openxmlformats.org/drawingml/2006/main">
               <a:ext uri="{FF2B5EF4-FFF2-40B4-BE49-F238E27FC236}">
-                <a16:creationId xmlns:a16="http://schemas.microsoft.com/office/drawing/2014/main" id="{7F15E6D0-069D-47F9-B551-6FD3A875547A}"/>
+                <a16:creationId xmlns:a16="http://schemas.microsoft.com/office/drawing/2014/main" id="{40953E71-E736-4D56-8882-76156164843F}"/>
               </a:ext>
             </a:extLst>
           </p:cNvPr>
@@ -4571,7 +4571,7 @@
           <p:cNvPr id="9" name="">
             <a:extLst xmlns:a="http://schemas.openxmlformats.org/drawingml/2006/main">
               <a:ext uri="{FF2B5EF4-FFF2-40B4-BE49-F238E27FC236}">
-                <a16:creationId xmlns:a16="http://schemas.microsoft.com/office/drawing/2014/main" id="{A03A849D-3589-4D02-BC53-4DE79EA642FE}"/>
+                <a16:creationId xmlns:a16="http://schemas.microsoft.com/office/drawing/2014/main" id="{8A06C9A0-1A1D-4E4E-A2F9-145DDF862B1F}"/>
               </a:ext>
             </a:extLst>
           </p:cNvPr>
@@ -4628,7 +4628,7 @@
           <p:cNvPr id="10" name="">
             <a:extLst xmlns:a="http://schemas.openxmlformats.org/drawingml/2006/main">
               <a:ext uri="{FF2B5EF4-FFF2-40B4-BE49-F238E27FC236}">
-                <a16:creationId xmlns:a16="http://schemas.microsoft.com/office/drawing/2014/main" id="{8EBDFD83-F592-4C8A-AE2A-5CC7B6B6944C}"/>
+                <a16:creationId xmlns:a16="http://schemas.microsoft.com/office/drawing/2014/main" id="{34E361BB-DC73-4FF2-84D5-ECE62D0E07EA}"/>
               </a:ext>
             </a:extLst>
           </p:cNvPr>
@@ -4685,7 +4685,7 @@
           <p:cNvPr id="11" name="">
             <a:extLst xmlns:a="http://schemas.openxmlformats.org/drawingml/2006/main">
               <a:ext uri="{FF2B5EF4-FFF2-40B4-BE49-F238E27FC236}">
-                <a16:creationId xmlns:a16="http://schemas.microsoft.com/office/drawing/2014/main" id="{1EB9FEDD-EDAB-4206-878E-98049C606975}"/>
+                <a16:creationId xmlns:a16="http://schemas.microsoft.com/office/drawing/2014/main" id="{F2AA413E-25F0-45FE-9797-34CF90E7E67E}"/>
               </a:ext>
             </a:extLst>
           </p:cNvPr>
@@ -4715,7 +4715,7 @@
           <p:cNvPr id="12" name="">
             <a:extLst xmlns:a="http://schemas.openxmlformats.org/drawingml/2006/main">
               <a:ext uri="{FF2B5EF4-FFF2-40B4-BE49-F238E27FC236}">
-                <a16:creationId xmlns:a16="http://schemas.microsoft.com/office/drawing/2014/main" id="{1CE52419-9021-4471-81C2-95C0C841D56A}"/>
+                <a16:creationId xmlns:a16="http://schemas.microsoft.com/office/drawing/2014/main" id="{D59A99F7-02A7-4F49-AC83-DDB49B2DFE9F}"/>
               </a:ext>
             </a:extLst>
           </p:cNvPr>
@@ -4749,7 +4749,7 @@
           <p:cNvPr id="13" name="">
             <a:extLst xmlns:a="http://schemas.openxmlformats.org/drawingml/2006/main">
               <a:ext uri="{FF2B5EF4-FFF2-40B4-BE49-F238E27FC236}">
-                <a16:creationId xmlns:a16="http://schemas.microsoft.com/office/drawing/2014/main" id="{4783877D-368B-4AF5-ACA9-F3466794E641}"/>
+                <a16:creationId xmlns:a16="http://schemas.microsoft.com/office/drawing/2014/main" id="{08B4CE2A-3CA2-42EF-8541-174B59BD83E7}"/>
               </a:ext>
             </a:extLst>
           </p:cNvPr>
@@ -4781,7 +4781,7 @@
           <p:cNvPr id="14" name="">
             <a:extLst xmlns:a="http://schemas.openxmlformats.org/drawingml/2006/main">
               <a:ext uri="{FF2B5EF4-FFF2-40B4-BE49-F238E27FC236}">
-                <a16:creationId xmlns:a16="http://schemas.microsoft.com/office/drawing/2014/main" id="{44B5C63C-2232-48F5-903B-740FAC45CFA7}"/>
+                <a16:creationId xmlns:a16="http://schemas.microsoft.com/office/drawing/2014/main" id="{35A9C4D1-A676-4558-9868-85982193C6BF}"/>
               </a:ext>
             </a:extLst>
           </p:cNvPr>
@@ -4838,7 +4838,7 @@
           <p:cNvPr id="15" name="">
             <a:extLst xmlns:a="http://schemas.openxmlformats.org/drawingml/2006/main">
               <a:ext uri="{FF2B5EF4-FFF2-40B4-BE49-F238E27FC236}">
-                <a16:creationId xmlns:a16="http://schemas.microsoft.com/office/drawing/2014/main" id="{83993E2B-F121-410D-9937-A97587DBE8AD}"/>
+                <a16:creationId xmlns:a16="http://schemas.microsoft.com/office/drawing/2014/main" id="{DC3990F0-103B-4299-BBE7-A3EBCC463A2F}"/>
               </a:ext>
             </a:extLst>
           </p:cNvPr>
@@ -4895,7 +4895,7 @@
           <p:cNvPr id="16" name="">
             <a:extLst xmlns:a="http://schemas.openxmlformats.org/drawingml/2006/main">
               <a:ext uri="{FF2B5EF4-FFF2-40B4-BE49-F238E27FC236}">
-                <a16:creationId xmlns:a16="http://schemas.microsoft.com/office/drawing/2014/main" id="{B514F82E-5100-43DB-83D9-1AD962F7A576}"/>
+                <a16:creationId xmlns:a16="http://schemas.microsoft.com/office/drawing/2014/main" id="{2FA6972B-7A36-4C6E-9C10-29E9C8F24558}"/>
               </a:ext>
             </a:extLst>
           </p:cNvPr>
@@ -4952,7 +4952,7 @@
           <p:cNvPr id="17" name="">
             <a:extLst xmlns:a="http://schemas.openxmlformats.org/drawingml/2006/main">
               <a:ext uri="{FF2B5EF4-FFF2-40B4-BE49-F238E27FC236}">
-                <a16:creationId xmlns:a16="http://schemas.microsoft.com/office/drawing/2014/main" id="{7A5AABA0-AA12-423B-8671-A31CD0B926CE}"/>
+                <a16:creationId xmlns:a16="http://schemas.microsoft.com/office/drawing/2014/main" id="{9B743FD1-6308-4896-BC6A-BCD0D0B38681}"/>
               </a:ext>
             </a:extLst>
           </p:cNvPr>
@@ -4982,7 +4982,7 @@
           <p:cNvPr id="18" name="">
             <a:extLst xmlns:a="http://schemas.openxmlformats.org/drawingml/2006/main">
               <a:ext uri="{FF2B5EF4-FFF2-40B4-BE49-F238E27FC236}">
-                <a16:creationId xmlns:a16="http://schemas.microsoft.com/office/drawing/2014/main" id="{EFE68240-25A2-45E0-88DC-6BD707FEDF82}"/>
+                <a16:creationId xmlns:a16="http://schemas.microsoft.com/office/drawing/2014/main" id="{531C96F4-43DD-43C2-9345-C5EDB00780FA}"/>
               </a:ext>
             </a:extLst>
           </p:cNvPr>
@@ -5016,7 +5016,7 @@
           <p:cNvPr id="19" name="">
             <a:extLst xmlns:a="http://schemas.openxmlformats.org/drawingml/2006/main">
               <a:ext uri="{FF2B5EF4-FFF2-40B4-BE49-F238E27FC236}">
-                <a16:creationId xmlns:a16="http://schemas.microsoft.com/office/drawing/2014/main" id="{14210D37-7A6F-427C-B877-C3935DE0CD8A}"/>
+                <a16:creationId xmlns:a16="http://schemas.microsoft.com/office/drawing/2014/main" id="{839A6090-2327-4B8B-8C81-C49A76D657CD}"/>
               </a:ext>
             </a:extLst>
           </p:cNvPr>
@@ -5048,7 +5048,7 @@
           <p:cNvPr id="20" name="">
             <a:extLst xmlns:a="http://schemas.openxmlformats.org/drawingml/2006/main">
               <a:ext uri="{FF2B5EF4-FFF2-40B4-BE49-F238E27FC236}">
-                <a16:creationId xmlns:a16="http://schemas.microsoft.com/office/drawing/2014/main" id="{7FDCFAD4-B557-4CBD-B275-25F5E56ED1A2}"/>
+                <a16:creationId xmlns:a16="http://schemas.microsoft.com/office/drawing/2014/main" id="{DBE19246-0911-4341-89BF-D31007DD0010}"/>
               </a:ext>
             </a:extLst>
           </p:cNvPr>
@@ -5105,7 +5105,7 @@
           <p:cNvPr id="21" name="">
             <a:extLst xmlns:a="http://schemas.openxmlformats.org/drawingml/2006/main">
               <a:ext uri="{FF2B5EF4-FFF2-40B4-BE49-F238E27FC236}">
-                <a16:creationId xmlns:a16="http://schemas.microsoft.com/office/drawing/2014/main" id="{013E25AA-0F91-45A8-9F0D-47D5CCDAD75A}"/>
+                <a16:creationId xmlns:a16="http://schemas.microsoft.com/office/drawing/2014/main" id="{4CD2A8AA-63BF-4C70-AB42-80F6891E97DD}"/>
               </a:ext>
             </a:extLst>
           </p:cNvPr>
@@ -5162,7 +5162,7 @@
           <p:cNvPr id="22" name="">
             <a:extLst xmlns:a="http://schemas.openxmlformats.org/drawingml/2006/main">
               <a:ext uri="{FF2B5EF4-FFF2-40B4-BE49-F238E27FC236}">
-                <a16:creationId xmlns:a16="http://schemas.microsoft.com/office/drawing/2014/main" id="{4DAA719A-C76E-48D0-89AC-2713749CF2F5}"/>
+                <a16:creationId xmlns:a16="http://schemas.microsoft.com/office/drawing/2014/main" id="{30A1DBC4-5960-4C07-9DC7-5CFA3CA33BF2}"/>
               </a:ext>
             </a:extLst>
           </p:cNvPr>
@@ -5219,7 +5219,7 @@
           <p:cNvPr id="23" name="">
             <a:extLst xmlns:a="http://schemas.openxmlformats.org/drawingml/2006/main">
               <a:ext uri="{FF2B5EF4-FFF2-40B4-BE49-F238E27FC236}">
-                <a16:creationId xmlns:a16="http://schemas.microsoft.com/office/drawing/2014/main" id="{FA84AEE3-09CB-4689-AD15-BFB35F34B6D3}"/>
+                <a16:creationId xmlns:a16="http://schemas.microsoft.com/office/drawing/2014/main" id="{3E9D362F-B913-4759-A6F4-006AD0774B82}"/>
               </a:ext>
             </a:extLst>
           </p:cNvPr>
@@ -5249,7 +5249,7 @@
           <p:cNvPr id="24" name="">
             <a:extLst xmlns:a="http://schemas.openxmlformats.org/drawingml/2006/main">
               <a:ext uri="{FF2B5EF4-FFF2-40B4-BE49-F238E27FC236}">
-                <a16:creationId xmlns:a16="http://schemas.microsoft.com/office/drawing/2014/main" id="{889FFB0C-6595-4526-AD77-1F854095068C}"/>
+                <a16:creationId xmlns:a16="http://schemas.microsoft.com/office/drawing/2014/main" id="{4E05CF62-5668-4FF9-A289-3B42EC8ED0DC}"/>
               </a:ext>
             </a:extLst>
           </p:cNvPr>
@@ -5283,7 +5283,7 @@
           <p:cNvPr id="25" name="">
             <a:extLst xmlns:a="http://schemas.openxmlformats.org/drawingml/2006/main">
               <a:ext uri="{FF2B5EF4-FFF2-40B4-BE49-F238E27FC236}">
-                <a16:creationId xmlns:a16="http://schemas.microsoft.com/office/drawing/2014/main" id="{8F19F06A-7D18-4235-BDBF-7C1CDB585FFA}"/>
+                <a16:creationId xmlns:a16="http://schemas.microsoft.com/office/drawing/2014/main" id="{A5ED9A67-5B59-4929-ACC7-E950BDF13C14}"/>
               </a:ext>
             </a:extLst>
           </p:cNvPr>
@@ -5315,7 +5315,7 @@
           <p:cNvPr id="26" name="">
             <a:extLst xmlns:a="http://schemas.openxmlformats.org/drawingml/2006/main">
               <a:ext uri="{FF2B5EF4-FFF2-40B4-BE49-F238E27FC236}">
-                <a16:creationId xmlns:a16="http://schemas.microsoft.com/office/drawing/2014/main" id="{E6257BBF-6DB2-4FE4-A601-2D7C3F4DA57A}"/>
+                <a16:creationId xmlns:a16="http://schemas.microsoft.com/office/drawing/2014/main" id="{F913C3BD-7611-40EC-8519-28719838BF0A}"/>
               </a:ext>
             </a:extLst>
           </p:cNvPr>
@@ -5372,7 +5372,7 @@
           <p:cNvPr id="27" name="">
             <a:extLst xmlns:a="http://schemas.openxmlformats.org/drawingml/2006/main">
               <a:ext uri="{FF2B5EF4-FFF2-40B4-BE49-F238E27FC236}">
-                <a16:creationId xmlns:a16="http://schemas.microsoft.com/office/drawing/2014/main" id="{F472E77E-5B3A-47D2-81D0-0D99B018315D}"/>
+                <a16:creationId xmlns:a16="http://schemas.microsoft.com/office/drawing/2014/main" id="{B4E9EFCA-E4D4-4D38-A717-1F0937FC90D8}"/>
               </a:ext>
             </a:extLst>
           </p:cNvPr>
@@ -5429,7 +5429,7 @@
           <p:cNvPr id="28" name="">
             <a:extLst xmlns:a="http://schemas.openxmlformats.org/drawingml/2006/main">
               <a:ext uri="{FF2B5EF4-FFF2-40B4-BE49-F238E27FC236}">
-                <a16:creationId xmlns:a16="http://schemas.microsoft.com/office/drawing/2014/main" id="{A420F73E-8F71-43FB-9CC5-B39AB2A51373}"/>
+                <a16:creationId xmlns:a16="http://schemas.microsoft.com/office/drawing/2014/main" id="{0AF3B3ED-27CF-439E-99A6-956D275CB1E4}"/>
               </a:ext>
             </a:extLst>
           </p:cNvPr>
@@ -5486,7 +5486,7 @@
           <p:cNvPr id="29" name="">
             <a:extLst xmlns:a="http://schemas.openxmlformats.org/drawingml/2006/main">
               <a:ext uri="{FF2B5EF4-FFF2-40B4-BE49-F238E27FC236}">
-                <a16:creationId xmlns:a16="http://schemas.microsoft.com/office/drawing/2014/main" id="{E9C5E9AE-B96E-4D7C-887B-967539D0C53F}"/>
+                <a16:creationId xmlns:a16="http://schemas.microsoft.com/office/drawing/2014/main" id="{E6468A66-96E0-47A2-918A-BF06DD7FD51C}"/>
               </a:ext>
             </a:extLst>
           </p:cNvPr>
@@ -5516,7 +5516,7 @@
           <p:cNvPr id="30" name="">
             <a:extLst xmlns:a="http://schemas.openxmlformats.org/drawingml/2006/main">
               <a:ext uri="{FF2B5EF4-FFF2-40B4-BE49-F238E27FC236}">
-                <a16:creationId xmlns:a16="http://schemas.microsoft.com/office/drawing/2014/main" id="{7F0A281A-2437-4DE2-9F34-E938C3AB46B4}"/>
+                <a16:creationId xmlns:a16="http://schemas.microsoft.com/office/drawing/2014/main" id="{0160AC9F-CB18-4251-9806-E5E30289B030}"/>
               </a:ext>
             </a:extLst>
           </p:cNvPr>
@@ -5550,7 +5550,7 @@
           <p:cNvPr id="31" name="">
             <a:extLst xmlns:a="http://schemas.openxmlformats.org/drawingml/2006/main">
               <a:ext uri="{FF2B5EF4-FFF2-40B4-BE49-F238E27FC236}">
-                <a16:creationId xmlns:a16="http://schemas.microsoft.com/office/drawing/2014/main" id="{102411AA-3455-426F-B61A-CB62E3CADA74}"/>
+                <a16:creationId xmlns:a16="http://schemas.microsoft.com/office/drawing/2014/main" id="{8C5CBABE-900B-4BB6-9019-176AECFE2A74}"/>
               </a:ext>
             </a:extLst>
           </p:cNvPr>
@@ -5582,7 +5582,7 @@
           <p:cNvPr id="32" name="">
             <a:extLst xmlns:a="http://schemas.openxmlformats.org/drawingml/2006/main">
               <a:ext uri="{FF2B5EF4-FFF2-40B4-BE49-F238E27FC236}">
-                <a16:creationId xmlns:a16="http://schemas.microsoft.com/office/drawing/2014/main" id="{5C20F7BD-73FB-4867-A974-AC4075B6FF03}"/>
+                <a16:creationId xmlns:a16="http://schemas.microsoft.com/office/drawing/2014/main" id="{66D14A8E-F673-4B22-BD19-1639EB9588B1}"/>
               </a:ext>
             </a:extLst>
           </p:cNvPr>
@@ -5639,7 +5639,7 @@
           <p:cNvPr id="33" name="">
             <a:extLst xmlns:a="http://schemas.openxmlformats.org/drawingml/2006/main">
               <a:ext uri="{FF2B5EF4-FFF2-40B4-BE49-F238E27FC236}">
-                <a16:creationId xmlns:a16="http://schemas.microsoft.com/office/drawing/2014/main" id="{EB463B6B-C645-4C8D-AC8B-F9C0422F8580}"/>
+                <a16:creationId xmlns:a16="http://schemas.microsoft.com/office/drawing/2014/main" id="{E3437826-7287-46F4-BB8D-F4FEBE207B43}"/>
               </a:ext>
             </a:extLst>
           </p:cNvPr>
@@ -5696,7 +5696,7 @@
           <p:cNvPr id="34" name="">
             <a:extLst xmlns:a="http://schemas.openxmlformats.org/drawingml/2006/main">
               <a:ext uri="{FF2B5EF4-FFF2-40B4-BE49-F238E27FC236}">
-                <a16:creationId xmlns:a16="http://schemas.microsoft.com/office/drawing/2014/main" id="{0F6E3B7A-D2D9-4071-849B-124F7B239021}"/>
+                <a16:creationId xmlns:a16="http://schemas.microsoft.com/office/drawing/2014/main" id="{C47EC12F-498F-468F-80C7-BCFCC3661274}"/>
               </a:ext>
             </a:extLst>
           </p:cNvPr>
@@ -5753,7 +5753,7 @@
           <p:cNvPr id="35" name="">
             <a:extLst xmlns:a="http://schemas.openxmlformats.org/drawingml/2006/main">
               <a:ext uri="{FF2B5EF4-FFF2-40B4-BE49-F238E27FC236}">
-                <a16:creationId xmlns:a16="http://schemas.microsoft.com/office/drawing/2014/main" id="{DB4EE802-5588-4271-9D7A-B2482B33F2CB}"/>
+                <a16:creationId xmlns:a16="http://schemas.microsoft.com/office/drawing/2014/main" id="{6D2E00BD-4C73-4A6D-8258-CB65DFD7FAD9}"/>
               </a:ext>
             </a:extLst>
           </p:cNvPr>
@@ -5783,7 +5783,7 @@
           <p:cNvPr id="36" name="">
             <a:extLst xmlns:a="http://schemas.openxmlformats.org/drawingml/2006/main">
               <a:ext uri="{FF2B5EF4-FFF2-40B4-BE49-F238E27FC236}">
-                <a16:creationId xmlns:a16="http://schemas.microsoft.com/office/drawing/2014/main" id="{28DA99E7-5B7A-4EE5-A5A5-00C5F0C137F9}"/>
+                <a16:creationId xmlns:a16="http://schemas.microsoft.com/office/drawing/2014/main" id="{6C27BEDB-93AC-418E-B76D-F94B8D97F4A4}"/>
               </a:ext>
             </a:extLst>
           </p:cNvPr>
@@ -5817,7 +5817,7 @@
           <p:cNvPr id="37" name="">
             <a:extLst xmlns:a="http://schemas.openxmlformats.org/drawingml/2006/main">
               <a:ext uri="{FF2B5EF4-FFF2-40B4-BE49-F238E27FC236}">
-                <a16:creationId xmlns:a16="http://schemas.microsoft.com/office/drawing/2014/main" id="{92D18439-370C-4472-B244-7B955744E552}"/>
+                <a16:creationId xmlns:a16="http://schemas.microsoft.com/office/drawing/2014/main" id="{3AA59CA7-963D-42CC-A5D9-98FBFDC92F68}"/>
               </a:ext>
             </a:extLst>
           </p:cNvPr>
@@ -5849,7 +5849,7 @@
           <p:cNvPr id="38" name="">
             <a:extLst xmlns:a="http://schemas.openxmlformats.org/drawingml/2006/main">
               <a:ext uri="{FF2B5EF4-FFF2-40B4-BE49-F238E27FC236}">
-                <a16:creationId xmlns:a16="http://schemas.microsoft.com/office/drawing/2014/main" id="{7E05F5DA-8B56-48D6-8F8D-0AC398EE6ABA}"/>
+                <a16:creationId xmlns:a16="http://schemas.microsoft.com/office/drawing/2014/main" id="{275D27BF-0DED-4F97-868B-21E85F16D1EE}"/>
               </a:ext>
             </a:extLst>
           </p:cNvPr>
@@ -5906,7 +5906,7 @@
           <p:cNvPr id="39" name="">
             <a:extLst xmlns:a="http://schemas.openxmlformats.org/drawingml/2006/main">
               <a:ext uri="{FF2B5EF4-FFF2-40B4-BE49-F238E27FC236}">
-                <a16:creationId xmlns:a16="http://schemas.microsoft.com/office/drawing/2014/main" id="{8775339C-5CF5-465F-8B3E-EF16E99D5CA5}"/>
+                <a16:creationId xmlns:a16="http://schemas.microsoft.com/office/drawing/2014/main" id="{8CFE2DAD-357B-40F7-A161-A14B4152E224}"/>
               </a:ext>
             </a:extLst>
           </p:cNvPr>
@@ -5963,7 +5963,7 @@
           <p:cNvPr id="40" name="">
             <a:extLst xmlns:a="http://schemas.openxmlformats.org/drawingml/2006/main">
               <a:ext uri="{FF2B5EF4-FFF2-40B4-BE49-F238E27FC236}">
-                <a16:creationId xmlns:a16="http://schemas.microsoft.com/office/drawing/2014/main" id="{A042DD81-300F-4CD2-A3D7-EC9F9D7B4D05}"/>
+                <a16:creationId xmlns:a16="http://schemas.microsoft.com/office/drawing/2014/main" id="{B186A293-3C7C-4BF0-9AAC-31A8BC7FED96}"/>
               </a:ext>
             </a:extLst>
           </p:cNvPr>
@@ -6020,7 +6020,7 @@
           <p:cNvPr id="41" name="">
             <a:extLst xmlns:a="http://schemas.openxmlformats.org/drawingml/2006/main">
               <a:ext uri="{FF2B5EF4-FFF2-40B4-BE49-F238E27FC236}">
-                <a16:creationId xmlns:a16="http://schemas.microsoft.com/office/drawing/2014/main" id="{F996AD92-89F8-47FA-8CF2-576900F000A1}"/>
+                <a16:creationId xmlns:a16="http://schemas.microsoft.com/office/drawing/2014/main" id="{B314D751-D776-4359-914B-D686503B34B8}"/>
               </a:ext>
             </a:extLst>
           </p:cNvPr>
@@ -6052,7 +6052,7 @@
           <p:cNvPr id="42" name="">
             <a:extLst xmlns:a="http://schemas.openxmlformats.org/drawingml/2006/main">
               <a:ext uri="{FF2B5EF4-FFF2-40B4-BE49-F238E27FC236}">
-                <a16:creationId xmlns:a16="http://schemas.microsoft.com/office/drawing/2014/main" id="{7EBA00B1-F47C-4A2E-8130-1CB50EA3F67F}"/>
+                <a16:creationId xmlns:a16="http://schemas.microsoft.com/office/drawing/2014/main" id="{8C933799-BECC-4C6A-B1A2-C8E391A402A0}"/>
               </a:ext>
             </a:extLst>
           </p:cNvPr>
@@ -6109,7 +6109,7 @@
           <p:cNvPr id="43" name="">
             <a:extLst xmlns:a="http://schemas.openxmlformats.org/drawingml/2006/main">
               <a:ext uri="{FF2B5EF4-FFF2-40B4-BE49-F238E27FC236}">
-                <a16:creationId xmlns:a16="http://schemas.microsoft.com/office/drawing/2014/main" id="{EBF6C13F-57F6-4255-A78C-8D9FB39E4D70}"/>
+                <a16:creationId xmlns:a16="http://schemas.microsoft.com/office/drawing/2014/main" id="{44CB333E-3144-44E0-807D-A5CE296B3761}"/>
               </a:ext>
             </a:extLst>
           </p:cNvPr>
@@ -6166,7 +6166,7 @@
           <p:cNvPr id="44" name="">
             <a:extLst xmlns:a="http://schemas.openxmlformats.org/drawingml/2006/main">
               <a:ext uri="{FF2B5EF4-FFF2-40B4-BE49-F238E27FC236}">
-                <a16:creationId xmlns:a16="http://schemas.microsoft.com/office/drawing/2014/main" id="{B5896052-9617-4C81-8F36-30DBC48142A3}"/>
+                <a16:creationId xmlns:a16="http://schemas.microsoft.com/office/drawing/2014/main" id="{8649B80A-9E7C-40BF-9002-5A2412DD36C6}"/>
               </a:ext>
             </a:extLst>
           </p:cNvPr>
@@ -6223,7 +6223,7 @@
           <p:cNvPr id="45" name="">
             <a:extLst xmlns:a="http://schemas.openxmlformats.org/drawingml/2006/main">
               <a:ext uri="{FF2B5EF4-FFF2-40B4-BE49-F238E27FC236}">
-                <a16:creationId xmlns:a16="http://schemas.microsoft.com/office/drawing/2014/main" id="{04AEC9AB-F16C-4598-AB49-E6BAFD9BFCA7}"/>
+                <a16:creationId xmlns:a16="http://schemas.microsoft.com/office/drawing/2014/main" id="{1901D8F6-6109-48E2-8D4F-8BA307CB9713}"/>
               </a:ext>
             </a:extLst>
           </p:cNvPr>
@@ -6280,7 +6280,7 @@
           <p:cNvPr id="46" name="">
             <a:extLst xmlns:a="http://schemas.openxmlformats.org/drawingml/2006/main">
               <a:ext uri="{FF2B5EF4-FFF2-40B4-BE49-F238E27FC236}">
-                <a16:creationId xmlns:a16="http://schemas.microsoft.com/office/drawing/2014/main" id="{EDC2EAA5-CC55-4714-B486-7FF50CE63D0B}"/>
+                <a16:creationId xmlns:a16="http://schemas.microsoft.com/office/drawing/2014/main" id="{667F52DA-AAAC-4260-9481-9D69D7F15057}"/>
               </a:ext>
             </a:extLst>
           </p:cNvPr>
@@ -6337,7 +6337,7 @@
           <p:cNvPr id="47" name="">
             <a:extLst xmlns:a="http://schemas.openxmlformats.org/drawingml/2006/main">
               <a:ext uri="{FF2B5EF4-FFF2-40B4-BE49-F238E27FC236}">
-                <a16:creationId xmlns:a16="http://schemas.microsoft.com/office/drawing/2014/main" id="{43040C63-A99F-44A2-BDAC-DEE529F36A9D}"/>
+                <a16:creationId xmlns:a16="http://schemas.microsoft.com/office/drawing/2014/main" id="{D7C3133E-7135-4596-80A1-FB38FBA4F8BF}"/>
               </a:ext>
             </a:extLst>
           </p:cNvPr>
@@ -6394,7 +6394,7 @@
           <p:cNvPr id="48" name="">
             <a:extLst xmlns:a="http://schemas.openxmlformats.org/drawingml/2006/main">
               <a:ext uri="{FF2B5EF4-FFF2-40B4-BE49-F238E27FC236}">
-                <a16:creationId xmlns:a16="http://schemas.microsoft.com/office/drawing/2014/main" id="{7887E1FD-3C87-4D94-9B25-360966F0D344}"/>
+                <a16:creationId xmlns:a16="http://schemas.microsoft.com/office/drawing/2014/main" id="{34F4B509-8582-458A-B051-54E5774C9451}"/>
               </a:ext>
             </a:extLst>
           </p:cNvPr>
@@ -6451,7 +6451,7 @@
           <p:cNvPr id="49" name="">
             <a:extLst xmlns:a="http://schemas.openxmlformats.org/drawingml/2006/main">
               <a:ext uri="{FF2B5EF4-FFF2-40B4-BE49-F238E27FC236}">
-                <a16:creationId xmlns:a16="http://schemas.microsoft.com/office/drawing/2014/main" id="{A1E9C5BC-6285-4E58-A118-EC3BA05D8DE3}"/>
+                <a16:creationId xmlns:a16="http://schemas.microsoft.com/office/drawing/2014/main" id="{8FBF0A8C-C763-481E-80B6-61630A4C4987}"/>
               </a:ext>
             </a:extLst>
           </p:cNvPr>
@@ -6531,7 +6531,7 @@
           <p:cNvPr id="50" name="">
             <a:extLst xmlns:a="http://schemas.openxmlformats.org/drawingml/2006/main">
               <a:ext uri="{FF2B5EF4-FFF2-40B4-BE49-F238E27FC236}">
-                <a16:creationId xmlns:a16="http://schemas.microsoft.com/office/drawing/2014/main" id="{BE2F2B45-4B45-4797-9794-51B32193E5ED}"/>
+                <a16:creationId xmlns:a16="http://schemas.microsoft.com/office/drawing/2014/main" id="{95967649-0518-47DA-A1D5-E497F2DE3ED5}"/>
               </a:ext>
             </a:extLst>
           </p:cNvPr>
@@ -6588,7 +6588,7 @@
           <p:cNvPr id="51" name="">
             <a:extLst xmlns:a="http://schemas.openxmlformats.org/drawingml/2006/main">
               <a:ext uri="{FF2B5EF4-FFF2-40B4-BE49-F238E27FC236}">
-                <a16:creationId xmlns:a16="http://schemas.microsoft.com/office/drawing/2014/main" id="{5FD4010F-E058-4A06-8A98-A9080879628B}"/>
+                <a16:creationId xmlns:a16="http://schemas.microsoft.com/office/drawing/2014/main" id="{37025B08-5657-45B4-8133-7B1801CBCCF2}"/>
               </a:ext>
             </a:extLst>
           </p:cNvPr>
@@ -6668,7 +6668,7 @@
           <p:cNvPr id="52" name="">
             <a:extLst xmlns:a="http://schemas.openxmlformats.org/drawingml/2006/main">
               <a:ext uri="{FF2B5EF4-FFF2-40B4-BE49-F238E27FC236}">
-                <a16:creationId xmlns:a16="http://schemas.microsoft.com/office/drawing/2014/main" id="{5632D49E-E48A-44F3-B1A7-0FC69E0AB098}"/>
+                <a16:creationId xmlns:a16="http://schemas.microsoft.com/office/drawing/2014/main" id="{7F37FA0C-696B-4961-BCA6-73729631A901}"/>
               </a:ext>
             </a:extLst>
           </p:cNvPr>
@@ -6725,7 +6725,7 @@
           <p:cNvPr id="53" name="">
             <a:extLst xmlns:a="http://schemas.openxmlformats.org/drawingml/2006/main">
               <a:ext uri="{FF2B5EF4-FFF2-40B4-BE49-F238E27FC236}">
-                <a16:creationId xmlns:a16="http://schemas.microsoft.com/office/drawing/2014/main" id="{000A73E7-170F-4064-AD62-43F6CF5BD4FE}"/>
+                <a16:creationId xmlns:a16="http://schemas.microsoft.com/office/drawing/2014/main" id="{44F9105A-48E7-45EF-927A-D09DEEE5A35F}"/>
               </a:ext>
             </a:extLst>
           </p:cNvPr>
@@ -6805,7 +6805,7 @@
           <p:cNvPr id="54" name="">
             <a:extLst xmlns:a="http://schemas.openxmlformats.org/drawingml/2006/main">
               <a:ext uri="{FF2B5EF4-FFF2-40B4-BE49-F238E27FC236}">
-                <a16:creationId xmlns:a16="http://schemas.microsoft.com/office/drawing/2014/main" id="{E07FF912-611A-45B1-BDC7-62654EB89C16}"/>
+                <a16:creationId xmlns:a16="http://schemas.microsoft.com/office/drawing/2014/main" id="{DE97F408-6476-4206-A082-3F0C350AB0DF}"/>
               </a:ext>
             </a:extLst>
           </p:cNvPr>
@@ -6837,7 +6837,7 @@
           <p:cNvPr id="55" name="">
             <a:extLst xmlns:a="http://schemas.openxmlformats.org/drawingml/2006/main">
               <a:ext uri="{FF2B5EF4-FFF2-40B4-BE49-F238E27FC236}">
-                <a16:creationId xmlns:a16="http://schemas.microsoft.com/office/drawing/2014/main" id="{E665115B-3F4A-49AB-A1E4-B7AB880C7F34}"/>
+                <a16:creationId xmlns:a16="http://schemas.microsoft.com/office/drawing/2014/main" id="{6DA2024C-C66E-4CEF-B787-F6EE3F9F7522}"/>
               </a:ext>
             </a:extLst>
           </p:cNvPr>
@@ -6892,7 +6892,7 @@
     </p:spTree>
     <p:extLst>
       <p:ext uri="{BB962C8B-B14F-4D97-AF65-F5344CB8AC3E}">
-        <p14:creationId xmlns:p14="http://schemas.microsoft.com/office/powerpoint/2010/main" val="645214022"/>
+        <p14:creationId xmlns:p14="http://schemas.microsoft.com/office/powerpoint/2010/main" val="1873447589"/>
       </p:ext>
     </p:extLst>
   </p:cSld>
@@ -6923,7 +6923,7 @@
           <p:cNvPr id="44" name="">
             <a:extLst xmlns:a="http://schemas.openxmlformats.org/drawingml/2006/main">
               <a:ext uri="{FF2B5EF4-FFF2-40B4-BE49-F238E27FC236}">
-                <a16:creationId xmlns:a16="http://schemas.microsoft.com/office/drawing/2014/main" id="{7DDFD384-15DB-4D10-AA65-5EBD3777EC37}"/>
+                <a16:creationId xmlns:a16="http://schemas.microsoft.com/office/drawing/2014/main" id="{ED649951-CF2F-4DB0-9731-28F2512208AB}"/>
               </a:ext>
             </a:extLst>
           </p:cNvPr>
@@ -6953,7 +6953,7 @@
           <p:cNvPr id="2" name="">
             <a:extLst xmlns:a="http://schemas.openxmlformats.org/drawingml/2006/main">
               <a:ext uri="{FF2B5EF4-FFF2-40B4-BE49-F238E27FC236}">
-                <a16:creationId xmlns:a16="http://schemas.microsoft.com/office/drawing/2014/main" id="{D9EE927B-9891-409A-BAB0-967133C4100A}"/>
+                <a16:creationId xmlns:a16="http://schemas.microsoft.com/office/drawing/2014/main" id="{A91E3FD0-E3A5-489E-B35A-75D32A1FC587}"/>
               </a:ext>
             </a:extLst>
           </p:cNvPr>
@@ -7010,7 +7010,7 @@
           <p:cNvPr id="3" name="">
             <a:extLst xmlns:a="http://schemas.openxmlformats.org/drawingml/2006/main">
               <a:ext uri="{FF2B5EF4-FFF2-40B4-BE49-F238E27FC236}">
-                <a16:creationId xmlns:a16="http://schemas.microsoft.com/office/drawing/2014/main" id="{A8893B91-FD05-4B6E-9FB4-42D5E60D18CC}"/>
+                <a16:creationId xmlns:a16="http://schemas.microsoft.com/office/drawing/2014/main" id="{31F5EBD1-085A-424F-8A1E-570F4D8B2367}"/>
               </a:ext>
             </a:extLst>
           </p:cNvPr>
@@ -7040,7 +7040,7 @@
           <p:cNvPr id="4" name="">
             <a:extLst xmlns:a="http://schemas.openxmlformats.org/drawingml/2006/main">
               <a:ext uri="{FF2B5EF4-FFF2-40B4-BE49-F238E27FC236}">
-                <a16:creationId xmlns:a16="http://schemas.microsoft.com/office/drawing/2014/main" id="{FDBC120C-F5E1-41CA-BDFA-DB036975FAC6}"/>
+                <a16:creationId xmlns:a16="http://schemas.microsoft.com/office/drawing/2014/main" id="{7546DFB3-DB10-44C4-8C6A-04FD8B6BD24C}"/>
               </a:ext>
             </a:extLst>
           </p:cNvPr>
@@ -7097,7 +7097,7 @@
           <p:cNvPr id="5" name="">
             <a:extLst xmlns:a="http://schemas.openxmlformats.org/drawingml/2006/main">
               <a:ext uri="{FF2B5EF4-FFF2-40B4-BE49-F238E27FC236}">
-                <a16:creationId xmlns:a16="http://schemas.microsoft.com/office/drawing/2014/main" id="{EAB03F45-247E-4ADB-B8F3-E4271BB6D93D}"/>
+                <a16:creationId xmlns:a16="http://schemas.microsoft.com/office/drawing/2014/main" id="{49387929-ABE5-4816-B2AA-E3D8498EE705}"/>
               </a:ext>
             </a:extLst>
           </p:cNvPr>
@@ -7154,7 +7154,7 @@
           <p:cNvPr id="6" name="">
             <a:extLst xmlns:a="http://schemas.openxmlformats.org/drawingml/2006/main">
               <a:ext uri="{FF2B5EF4-FFF2-40B4-BE49-F238E27FC236}">
-                <a16:creationId xmlns:a16="http://schemas.microsoft.com/office/drawing/2014/main" id="{7CBA8390-7FCA-4280-BBE5-C5C8CCBC1717}"/>
+                <a16:creationId xmlns:a16="http://schemas.microsoft.com/office/drawing/2014/main" id="{17B62CA5-A0FC-4C07-B48B-EEDC117445B4}"/>
               </a:ext>
             </a:extLst>
           </p:cNvPr>
@@ -7211,7 +7211,7 @@
           <p:cNvPr id="7" name="">
             <a:extLst xmlns:a="http://schemas.openxmlformats.org/drawingml/2006/main">
               <a:ext uri="{FF2B5EF4-FFF2-40B4-BE49-F238E27FC236}">
-                <a16:creationId xmlns:a16="http://schemas.microsoft.com/office/drawing/2014/main" id="{EE475DC2-2ADD-4C25-9E76-474778D74D20}"/>
+                <a16:creationId xmlns:a16="http://schemas.microsoft.com/office/drawing/2014/main" id="{B2110859-1D46-4549-95FD-D10D426353B0}"/>
               </a:ext>
             </a:extLst>
           </p:cNvPr>
@@ -7241,7 +7241,7 @@
           <p:cNvPr id="8" name="">
             <a:extLst xmlns:a="http://schemas.openxmlformats.org/drawingml/2006/main">
               <a:ext uri="{FF2B5EF4-FFF2-40B4-BE49-F238E27FC236}">
-                <a16:creationId xmlns:a16="http://schemas.microsoft.com/office/drawing/2014/main" id="{AE1E8257-DB93-4F96-88BA-8D610B24E036}"/>
+                <a16:creationId xmlns:a16="http://schemas.microsoft.com/office/drawing/2014/main" id="{6AA4F3B6-DFE9-48C4-8FF2-62FA82045D9F}"/>
               </a:ext>
             </a:extLst>
           </p:cNvPr>
@@ -7298,7 +7298,7 @@
           <p:cNvPr id="9" name="">
             <a:extLst xmlns:a="http://schemas.openxmlformats.org/drawingml/2006/main">
               <a:ext uri="{FF2B5EF4-FFF2-40B4-BE49-F238E27FC236}">
-                <a16:creationId xmlns:a16="http://schemas.microsoft.com/office/drawing/2014/main" id="{E730F7E5-7381-4B13-84D6-1C921DF9AC97}"/>
+                <a16:creationId xmlns:a16="http://schemas.microsoft.com/office/drawing/2014/main" id="{BF480078-83BD-488A-AA87-DB0C7CF65E59}"/>
               </a:ext>
             </a:extLst>
           </p:cNvPr>
@@ -7355,7 +7355,7 @@
           <p:cNvPr id="10" name="">
             <a:extLst xmlns:a="http://schemas.openxmlformats.org/drawingml/2006/main">
               <a:ext uri="{FF2B5EF4-FFF2-40B4-BE49-F238E27FC236}">
-                <a16:creationId xmlns:a16="http://schemas.microsoft.com/office/drawing/2014/main" id="{EEE4D21C-435E-4A53-94B4-012A3256BC41}"/>
+                <a16:creationId xmlns:a16="http://schemas.microsoft.com/office/drawing/2014/main" id="{0E7088FC-55DB-4886-85BB-BD8E0ADF79C3}"/>
               </a:ext>
             </a:extLst>
           </p:cNvPr>
@@ -7412,7 +7412,7 @@
           <p:cNvPr id="11" name="">
             <a:extLst xmlns:a="http://schemas.openxmlformats.org/drawingml/2006/main">
               <a:ext uri="{FF2B5EF4-FFF2-40B4-BE49-F238E27FC236}">
-                <a16:creationId xmlns:a16="http://schemas.microsoft.com/office/drawing/2014/main" id="{ABD48C57-F6A7-4ACC-8455-95F86AD74252}"/>
+                <a16:creationId xmlns:a16="http://schemas.microsoft.com/office/drawing/2014/main" id="{DE2714D1-3A75-4921-B5D0-00A6F6465F94}"/>
               </a:ext>
             </a:extLst>
           </p:cNvPr>
@@ -7444,7 +7444,7 @@
           <p:cNvPr id="12" name="">
             <a:extLst xmlns:a="http://schemas.openxmlformats.org/drawingml/2006/main">
               <a:ext uri="{FF2B5EF4-FFF2-40B4-BE49-F238E27FC236}">
-                <a16:creationId xmlns:a16="http://schemas.microsoft.com/office/drawing/2014/main" id="{CAB14B5F-EDEB-4296-8705-88B6CE0729D3}"/>
+                <a16:creationId xmlns:a16="http://schemas.microsoft.com/office/drawing/2014/main" id="{999D491F-9479-4598-83DF-18EB29BC732D}"/>
               </a:ext>
             </a:extLst>
           </p:cNvPr>
@@ -7501,7 +7501,7 @@
           <p:cNvPr id="13" name="">
             <a:extLst xmlns:a="http://schemas.openxmlformats.org/drawingml/2006/main">
               <a:ext uri="{FF2B5EF4-FFF2-40B4-BE49-F238E27FC236}">
-                <a16:creationId xmlns:a16="http://schemas.microsoft.com/office/drawing/2014/main" id="{DD15BD3C-145E-4712-894A-D628D4A973C0}"/>
+                <a16:creationId xmlns:a16="http://schemas.microsoft.com/office/drawing/2014/main" id="{C66BB0F2-1E50-4AB8-86DF-B463F3768959}"/>
               </a:ext>
             </a:extLst>
           </p:cNvPr>
@@ -7558,7 +7558,7 @@
           <p:cNvPr id="14" name="">
             <a:extLst xmlns:a="http://schemas.openxmlformats.org/drawingml/2006/main">
               <a:ext uri="{FF2B5EF4-FFF2-40B4-BE49-F238E27FC236}">
-                <a16:creationId xmlns:a16="http://schemas.microsoft.com/office/drawing/2014/main" id="{93E889F7-5B09-4547-82DF-B2BC2359B45B}"/>
+                <a16:creationId xmlns:a16="http://schemas.microsoft.com/office/drawing/2014/main" id="{A02826FA-24AD-4A79-AE40-6347ED72EE09}"/>
               </a:ext>
             </a:extLst>
           </p:cNvPr>
@@ -7615,7 +7615,7 @@
           <p:cNvPr id="15" name="">
             <a:extLst xmlns:a="http://schemas.openxmlformats.org/drawingml/2006/main">
               <a:ext uri="{FF2B5EF4-FFF2-40B4-BE49-F238E27FC236}">
-                <a16:creationId xmlns:a16="http://schemas.microsoft.com/office/drawing/2014/main" id="{3E463ADD-C4DC-4DA0-8F10-5AF21742F9F3}"/>
+                <a16:creationId xmlns:a16="http://schemas.microsoft.com/office/drawing/2014/main" id="{029CDFEE-7D6C-45F4-AFA3-B1A8101EE618}"/>
               </a:ext>
             </a:extLst>
           </p:cNvPr>
@@ -7647,7 +7647,7 @@
           <p:cNvPr id="16" name="">
             <a:extLst xmlns:a="http://schemas.openxmlformats.org/drawingml/2006/main">
               <a:ext uri="{FF2B5EF4-FFF2-40B4-BE49-F238E27FC236}">
-                <a16:creationId xmlns:a16="http://schemas.microsoft.com/office/drawing/2014/main" id="{788D5F49-10DF-4F5B-9C6A-C70DF74CE11D}"/>
+                <a16:creationId xmlns:a16="http://schemas.microsoft.com/office/drawing/2014/main" id="{8A6AB2C7-FCBF-4869-B7AA-09576B7F1990}"/>
               </a:ext>
             </a:extLst>
           </p:cNvPr>
@@ -7704,7 +7704,7 @@
           <p:cNvPr id="17" name="">
             <a:extLst xmlns:a="http://schemas.openxmlformats.org/drawingml/2006/main">
               <a:ext uri="{FF2B5EF4-FFF2-40B4-BE49-F238E27FC236}">
-                <a16:creationId xmlns:a16="http://schemas.microsoft.com/office/drawing/2014/main" id="{4D15703F-84F1-48F7-A0ED-7BEBCDDCBEF0}"/>
+                <a16:creationId xmlns:a16="http://schemas.microsoft.com/office/drawing/2014/main" id="{BFE8D485-4442-42EE-ABEF-AEEA653612CD}"/>
               </a:ext>
             </a:extLst>
           </p:cNvPr>
@@ -7761,7 +7761,7 @@
           <p:cNvPr id="18" name="">
             <a:extLst xmlns:a="http://schemas.openxmlformats.org/drawingml/2006/main">
               <a:ext uri="{FF2B5EF4-FFF2-40B4-BE49-F238E27FC236}">
-                <a16:creationId xmlns:a16="http://schemas.microsoft.com/office/drawing/2014/main" id="{E209C297-064B-4AE6-A727-82218D59CF72}"/>
+                <a16:creationId xmlns:a16="http://schemas.microsoft.com/office/drawing/2014/main" id="{CD822F91-ABEE-4921-ABA6-BF94F7B9D884}"/>
               </a:ext>
             </a:extLst>
           </p:cNvPr>
@@ -7818,7 +7818,7 @@
           <p:cNvPr id="19" name="">
             <a:extLst xmlns:a="http://schemas.openxmlformats.org/drawingml/2006/main">
               <a:ext uri="{FF2B5EF4-FFF2-40B4-BE49-F238E27FC236}">
-                <a16:creationId xmlns:a16="http://schemas.microsoft.com/office/drawing/2014/main" id="{021BED3B-79A2-4D2D-BFC1-177C924A84DB}"/>
+                <a16:creationId xmlns:a16="http://schemas.microsoft.com/office/drawing/2014/main" id="{AD602451-3E5E-423D-B1C4-F01DE56C432A}"/>
               </a:ext>
             </a:extLst>
           </p:cNvPr>
@@ -7850,7 +7850,7 @@
           <p:cNvPr id="20" name="">
             <a:extLst xmlns:a="http://schemas.openxmlformats.org/drawingml/2006/main">
               <a:ext uri="{FF2B5EF4-FFF2-40B4-BE49-F238E27FC236}">
-                <a16:creationId xmlns:a16="http://schemas.microsoft.com/office/drawing/2014/main" id="{38F5C037-2343-4E21-B730-04592DA1A338}"/>
+                <a16:creationId xmlns:a16="http://schemas.microsoft.com/office/drawing/2014/main" id="{78A13C51-0304-4754-BB0F-851C9DF9B057}"/>
               </a:ext>
             </a:extLst>
           </p:cNvPr>
@@ -7907,7 +7907,7 @@
           <p:cNvPr id="21" name="">
             <a:extLst xmlns:a="http://schemas.openxmlformats.org/drawingml/2006/main">
               <a:ext uri="{FF2B5EF4-FFF2-40B4-BE49-F238E27FC236}">
-                <a16:creationId xmlns:a16="http://schemas.microsoft.com/office/drawing/2014/main" id="{6458420E-AA1D-41E1-91AC-FFE24628C7CC}"/>
+                <a16:creationId xmlns:a16="http://schemas.microsoft.com/office/drawing/2014/main" id="{9EAD3F2B-766F-4A44-9F4F-F41C4A896726}"/>
               </a:ext>
             </a:extLst>
           </p:cNvPr>
@@ -7964,7 +7964,7 @@
           <p:cNvPr id="22" name="">
             <a:extLst xmlns:a="http://schemas.openxmlformats.org/drawingml/2006/main">
               <a:ext uri="{FF2B5EF4-FFF2-40B4-BE49-F238E27FC236}">
-                <a16:creationId xmlns:a16="http://schemas.microsoft.com/office/drawing/2014/main" id="{49CF4578-9A43-48EA-92E7-4FFD2B5A9677}"/>
+                <a16:creationId xmlns:a16="http://schemas.microsoft.com/office/drawing/2014/main" id="{92C34A7C-2C2F-441C-8A88-74AAD68E29BC}"/>
               </a:ext>
             </a:extLst>
           </p:cNvPr>
@@ -8021,7 +8021,7 @@
           <p:cNvPr id="23" name="">
             <a:extLst xmlns:a="http://schemas.openxmlformats.org/drawingml/2006/main">
               <a:ext uri="{FF2B5EF4-FFF2-40B4-BE49-F238E27FC236}">
-                <a16:creationId xmlns:a16="http://schemas.microsoft.com/office/drawing/2014/main" id="{DED79EB1-5E6F-4179-8EB9-AEB1CC7D6B23}"/>
+                <a16:creationId xmlns:a16="http://schemas.microsoft.com/office/drawing/2014/main" id="{007CCB9D-2AA6-440D-A396-6586A4ECB802}"/>
               </a:ext>
             </a:extLst>
           </p:cNvPr>
@@ -8053,7 +8053,7 @@
           <p:cNvPr id="24" name="">
             <a:extLst xmlns:a="http://schemas.openxmlformats.org/drawingml/2006/main">
               <a:ext uri="{FF2B5EF4-FFF2-40B4-BE49-F238E27FC236}">
-                <a16:creationId xmlns:a16="http://schemas.microsoft.com/office/drawing/2014/main" id="{A5D0315C-7CFF-472F-BB6C-8492ED86694D}"/>
+                <a16:creationId xmlns:a16="http://schemas.microsoft.com/office/drawing/2014/main" id="{3192DA2E-5CCD-4D08-8E41-1B6E32945F4E}"/>
               </a:ext>
             </a:extLst>
           </p:cNvPr>
@@ -8110,7 +8110,7 @@
           <p:cNvPr id="25" name="">
             <a:extLst xmlns:a="http://schemas.openxmlformats.org/drawingml/2006/main">
               <a:ext uri="{FF2B5EF4-FFF2-40B4-BE49-F238E27FC236}">
-                <a16:creationId xmlns:a16="http://schemas.microsoft.com/office/drawing/2014/main" id="{5FF1C964-B2A2-493D-9075-460014E5B2D2}"/>
+                <a16:creationId xmlns:a16="http://schemas.microsoft.com/office/drawing/2014/main" id="{390CF50E-DB33-41C3-BB57-197D1AF0D5CD}"/>
               </a:ext>
             </a:extLst>
           </p:cNvPr>
@@ -8167,7 +8167,7 @@
           <p:cNvPr id="26" name="">
             <a:extLst xmlns:a="http://schemas.openxmlformats.org/drawingml/2006/main">
               <a:ext uri="{FF2B5EF4-FFF2-40B4-BE49-F238E27FC236}">
-                <a16:creationId xmlns:a16="http://schemas.microsoft.com/office/drawing/2014/main" id="{F1D2725E-BF1D-483C-965E-231A50180399}"/>
+                <a16:creationId xmlns:a16="http://schemas.microsoft.com/office/drawing/2014/main" id="{1FFA062E-562A-49DC-B7CA-39914594B82D}"/>
               </a:ext>
             </a:extLst>
           </p:cNvPr>
@@ -8224,7 +8224,7 @@
           <p:cNvPr id="27" name="">
             <a:extLst xmlns:a="http://schemas.openxmlformats.org/drawingml/2006/main">
               <a:ext uri="{FF2B5EF4-FFF2-40B4-BE49-F238E27FC236}">
-                <a16:creationId xmlns:a16="http://schemas.microsoft.com/office/drawing/2014/main" id="{9907793F-B9E8-4805-869A-B869C5A0471B}"/>
+                <a16:creationId xmlns:a16="http://schemas.microsoft.com/office/drawing/2014/main" id="{4AED417C-B817-4668-A321-639B33E0A184}"/>
               </a:ext>
             </a:extLst>
           </p:cNvPr>
@@ -8256,7 +8256,7 @@
           <p:cNvPr id="28" name="">
             <a:extLst xmlns:a="http://schemas.openxmlformats.org/drawingml/2006/main">
               <a:ext uri="{FF2B5EF4-FFF2-40B4-BE49-F238E27FC236}">
-                <a16:creationId xmlns:a16="http://schemas.microsoft.com/office/drawing/2014/main" id="{BEFC357C-CB5C-47BD-AB73-56544057B806}"/>
+                <a16:creationId xmlns:a16="http://schemas.microsoft.com/office/drawing/2014/main" id="{2930A085-87C2-4DD2-8B40-D13E7CB65F18}"/>
               </a:ext>
             </a:extLst>
           </p:cNvPr>
@@ -8313,7 +8313,7 @@
           <p:cNvPr id="29" name="">
             <a:extLst xmlns:a="http://schemas.openxmlformats.org/drawingml/2006/main">
               <a:ext uri="{FF2B5EF4-FFF2-40B4-BE49-F238E27FC236}">
-                <a16:creationId xmlns:a16="http://schemas.microsoft.com/office/drawing/2014/main" id="{7FB0C5BB-49B7-4AF6-84F4-B8065FDAD0FA}"/>
+                <a16:creationId xmlns:a16="http://schemas.microsoft.com/office/drawing/2014/main" id="{842112DE-65D5-4904-845D-999DF09F68DF}"/>
               </a:ext>
             </a:extLst>
           </p:cNvPr>
@@ -8370,7 +8370,7 @@
           <p:cNvPr id="30" name="">
             <a:extLst xmlns:a="http://schemas.openxmlformats.org/drawingml/2006/main">
               <a:ext uri="{FF2B5EF4-FFF2-40B4-BE49-F238E27FC236}">
-                <a16:creationId xmlns:a16="http://schemas.microsoft.com/office/drawing/2014/main" id="{CA536630-B521-4511-8B79-EF5BF1FA871E}"/>
+                <a16:creationId xmlns:a16="http://schemas.microsoft.com/office/drawing/2014/main" id="{79602463-46FE-4589-94AD-B0007FACBED0}"/>
               </a:ext>
             </a:extLst>
           </p:cNvPr>
@@ -8427,7 +8427,7 @@
           <p:cNvPr id="31" name="">
             <a:extLst xmlns:a="http://schemas.openxmlformats.org/drawingml/2006/main">
               <a:ext uri="{FF2B5EF4-FFF2-40B4-BE49-F238E27FC236}">
-                <a16:creationId xmlns:a16="http://schemas.microsoft.com/office/drawing/2014/main" id="{C6331603-B5C4-4255-9B27-209126C899FB}"/>
+                <a16:creationId xmlns:a16="http://schemas.microsoft.com/office/drawing/2014/main" id="{FEAB12DD-0DA5-4EBE-93BA-E7921B72CADD}"/>
               </a:ext>
             </a:extLst>
           </p:cNvPr>
@@ -8484,7 +8484,7 @@
           <p:cNvPr id="32" name="">
             <a:extLst xmlns:a="http://schemas.openxmlformats.org/drawingml/2006/main">
               <a:ext uri="{FF2B5EF4-FFF2-40B4-BE49-F238E27FC236}">
-                <a16:creationId xmlns:a16="http://schemas.microsoft.com/office/drawing/2014/main" id="{91999C2C-E421-4B2C-B41A-0D201111FB68}"/>
+                <a16:creationId xmlns:a16="http://schemas.microsoft.com/office/drawing/2014/main" id="{4B1C3085-FC3E-44FE-9C7A-EFC3BAED035B}"/>
               </a:ext>
             </a:extLst>
           </p:cNvPr>
@@ -8541,7 +8541,7 @@
           <p:cNvPr id="33" name="">
             <a:extLst xmlns:a="http://schemas.openxmlformats.org/drawingml/2006/main">
               <a:ext uri="{FF2B5EF4-FFF2-40B4-BE49-F238E27FC236}">
-                <a16:creationId xmlns:a16="http://schemas.microsoft.com/office/drawing/2014/main" id="{35361C99-6D56-4AEE-A832-D84968A13682}"/>
+                <a16:creationId xmlns:a16="http://schemas.microsoft.com/office/drawing/2014/main" id="{C233F415-48F0-4FD7-B40D-7D778BA10B52}"/>
               </a:ext>
             </a:extLst>
           </p:cNvPr>
@@ -8598,7 +8598,7 @@
           <p:cNvPr id="34" name="">
             <a:extLst xmlns:a="http://schemas.openxmlformats.org/drawingml/2006/main">
               <a:ext uri="{FF2B5EF4-FFF2-40B4-BE49-F238E27FC236}">
-                <a16:creationId xmlns:a16="http://schemas.microsoft.com/office/drawing/2014/main" id="{3132AFD9-D873-4706-9CD3-663F91576C1E}"/>
+                <a16:creationId xmlns:a16="http://schemas.microsoft.com/office/drawing/2014/main" id="{34FAB92B-E72F-4F73-AFA7-90D529F11FFD}"/>
               </a:ext>
             </a:extLst>
           </p:cNvPr>
@@ -8655,7 +8655,7 @@
           <p:cNvPr id="35" name="">
             <a:extLst xmlns:a="http://schemas.openxmlformats.org/drawingml/2006/main">
               <a:ext uri="{FF2B5EF4-FFF2-40B4-BE49-F238E27FC236}">
-                <a16:creationId xmlns:a16="http://schemas.microsoft.com/office/drawing/2014/main" id="{56C7C535-8282-4998-A19F-0FC3A4BE5D28}"/>
+                <a16:creationId xmlns:a16="http://schemas.microsoft.com/office/drawing/2014/main" id="{91BB7EF2-02B8-4202-9A4F-564072168E9F}"/>
               </a:ext>
             </a:extLst>
           </p:cNvPr>
@@ -8712,7 +8712,7 @@
           <p:cNvPr id="36" name="">
             <a:extLst xmlns:a="http://schemas.openxmlformats.org/drawingml/2006/main">
               <a:ext uri="{FF2B5EF4-FFF2-40B4-BE49-F238E27FC236}">
-                <a16:creationId xmlns:a16="http://schemas.microsoft.com/office/drawing/2014/main" id="{89E2B748-F67C-41AA-BE30-214DB183D018}"/>
+                <a16:creationId xmlns:a16="http://schemas.microsoft.com/office/drawing/2014/main" id="{9F7064DF-9209-4DE3-9F5E-F7C97B1B16E4}"/>
               </a:ext>
             </a:extLst>
           </p:cNvPr>
@@ -8769,7 +8769,7 @@
           <p:cNvPr id="37" name="">
             <a:extLst xmlns:a="http://schemas.openxmlformats.org/drawingml/2006/main">
               <a:ext uri="{FF2B5EF4-FFF2-40B4-BE49-F238E27FC236}">
-                <a16:creationId xmlns:a16="http://schemas.microsoft.com/office/drawing/2014/main" id="{050FADC4-4A28-416B-A3ED-5E40E86B5774}"/>
+                <a16:creationId xmlns:a16="http://schemas.microsoft.com/office/drawing/2014/main" id="{39BDB328-2C63-450A-A0CE-B589285272C9}"/>
               </a:ext>
             </a:extLst>
           </p:cNvPr>
@@ -8826,7 +8826,7 @@
           <p:cNvPr id="38" name="">
             <a:extLst xmlns:a="http://schemas.openxmlformats.org/drawingml/2006/main">
               <a:ext uri="{FF2B5EF4-FFF2-40B4-BE49-F238E27FC236}">
-                <a16:creationId xmlns:a16="http://schemas.microsoft.com/office/drawing/2014/main" id="{A99C86DA-59A7-4ACD-AA58-97CA6C3230D0}"/>
+                <a16:creationId xmlns:a16="http://schemas.microsoft.com/office/drawing/2014/main" id="{7A9F2AE7-49B0-46E1-B399-D9B36876FF48}"/>
               </a:ext>
             </a:extLst>
           </p:cNvPr>
@@ -8883,7 +8883,7 @@
           <p:cNvPr id="39" name="">
             <a:extLst xmlns:a="http://schemas.openxmlformats.org/drawingml/2006/main">
               <a:ext uri="{FF2B5EF4-FFF2-40B4-BE49-F238E27FC236}">
-                <a16:creationId xmlns:a16="http://schemas.microsoft.com/office/drawing/2014/main" id="{49CA5133-DB39-4D95-8429-2F37D4BE68DB}"/>
+                <a16:creationId xmlns:a16="http://schemas.microsoft.com/office/drawing/2014/main" id="{1F8AA73E-FF92-481F-9B6E-1E916DD4DE71}"/>
               </a:ext>
             </a:extLst>
           </p:cNvPr>
@@ -8940,7 +8940,7 @@
           <p:cNvPr id="40" name="">
             <a:extLst xmlns:a="http://schemas.openxmlformats.org/drawingml/2006/main">
               <a:ext uri="{FF2B5EF4-FFF2-40B4-BE49-F238E27FC236}">
-                <a16:creationId xmlns:a16="http://schemas.microsoft.com/office/drawing/2014/main" id="{59C22003-25EA-4C26-82B6-A71F301C51D6}"/>
+                <a16:creationId xmlns:a16="http://schemas.microsoft.com/office/drawing/2014/main" id="{1B03CC05-FBB9-4A05-AA64-D91637343998}"/>
               </a:ext>
             </a:extLst>
           </p:cNvPr>
@@ -8997,7 +8997,7 @@
           <p:cNvPr id="41" name="">
             <a:extLst xmlns:a="http://schemas.openxmlformats.org/drawingml/2006/main">
               <a:ext uri="{FF2B5EF4-FFF2-40B4-BE49-F238E27FC236}">
-                <a16:creationId xmlns:a16="http://schemas.microsoft.com/office/drawing/2014/main" id="{2AD13A96-DE26-49BC-A38D-A74BBFB0730B}"/>
+                <a16:creationId xmlns:a16="http://schemas.microsoft.com/office/drawing/2014/main" id="{82E9390F-CCEA-4ECF-A1B5-A8FA8BE97DC7}"/>
               </a:ext>
             </a:extLst>
           </p:cNvPr>
@@ -9054,7 +9054,7 @@
           <p:cNvPr id="42" name="">
             <a:extLst xmlns:a="http://schemas.openxmlformats.org/drawingml/2006/main">
               <a:ext uri="{FF2B5EF4-FFF2-40B4-BE49-F238E27FC236}">
-                <a16:creationId xmlns:a16="http://schemas.microsoft.com/office/drawing/2014/main" id="{F6FD1984-0891-45BA-8E90-D7584B7FBCE2}"/>
+                <a16:creationId xmlns:a16="http://schemas.microsoft.com/office/drawing/2014/main" id="{33D287B5-6CE7-48DE-B665-AA69CCAC83D8}"/>
               </a:ext>
             </a:extLst>
           </p:cNvPr>
@@ -9111,7 +9111,7 @@
           <p:cNvPr id="43" name="">
             <a:extLst xmlns:a="http://schemas.openxmlformats.org/drawingml/2006/main">
               <a:ext uri="{FF2B5EF4-FFF2-40B4-BE49-F238E27FC236}">
-                <a16:creationId xmlns:a16="http://schemas.microsoft.com/office/drawing/2014/main" id="{8745ED2B-4A5E-41E9-A744-6699155E777C}"/>
+                <a16:creationId xmlns:a16="http://schemas.microsoft.com/office/drawing/2014/main" id="{D016D450-E71A-4780-930D-2345935619D5}"/>
               </a:ext>
             </a:extLst>
           </p:cNvPr>
@@ -9166,7 +9166,7 @@
     </p:spTree>
     <p:extLst>
       <p:ext uri="{BB962C8B-B14F-4D97-AF65-F5344CB8AC3E}">
-        <p14:creationId xmlns:p14="http://schemas.microsoft.com/office/powerpoint/2010/main" val="278598998"/>
+        <p14:creationId xmlns:p14="http://schemas.microsoft.com/office/powerpoint/2010/main" val="663571164"/>
       </p:ext>
     </p:extLst>
   </p:cSld>

</xml_diff>

<commit_message>
fix: the caption rewrite dropped two claims the audit requires
Renaming the deliberation caption to "Reason" took the technique's full name
and the "not Full ToT" boundary out of the subtitle file, and shortening the
slide's technique line took the full name off the deck. Both are back, and the
raw Chain-of-Thought point moves to the evaluation caption so nothing is lost.

Numbers follow the rebuilt artifacts: the video reports 2분 38.6초 and the
speaker notes are 3,814 spoken characters after the RAG/ReAct paragraph.

Co-Authored-By: Claude Opus 5 <noreply@anthropic.com>
</commit_message>
<xml_diff>
--- a/Docs/PRESENTATION/2. 최종/09285_백준현_AI_Master_최종발표자료_v12.pptx
+++ b/Docs/PRESENTATION/2. 최종/09285_백준현_AI_Master_최종발표자료_v12.pptx
@@ -2,16 +2,16 @@
 <file path=ppt/presentation.xml><?xml version="1.0" encoding="utf-8"?>
 <p:presentation xmlns:p="http://schemas.openxmlformats.org/presentationml/2006/main">
   <p:sldMasterIdLst>
-    <p:sldMasterId xmlns:r="http://schemas.openxmlformats.org/officeDocument/2006/relationships" id="2147483648" r:id="R46176f043030474a"/>
+    <p:sldMasterId xmlns:r="http://schemas.openxmlformats.org/officeDocument/2006/relationships" id="2147483648" r:id="R6a9deaf4a541424d"/>
   </p:sldMasterIdLst>
   <p:notesMasterIdLst>
-    <p:notesMasterId xmlns:r="http://schemas.openxmlformats.org/officeDocument/2006/relationships" r:id="R42decd384bcb4d21"/>
+    <p:notesMasterId xmlns:r="http://schemas.openxmlformats.org/officeDocument/2006/relationships" r:id="R0e3be6c008504a15"/>
   </p:notesMasterIdLst>
   <p:sldIdLst>
-    <p:sldId xmlns:r="http://schemas.openxmlformats.org/officeDocument/2006/relationships" id="256" r:id="Rab3dd916f49b421e"/>
-    <p:sldId xmlns:r="http://schemas.openxmlformats.org/officeDocument/2006/relationships" id="257" r:id="Re540fb3e453f4a4d"/>
-    <p:sldId xmlns:r="http://schemas.openxmlformats.org/officeDocument/2006/relationships" id="258" r:id="R69c6203641684b55"/>
-    <p:sldId xmlns:r="http://schemas.openxmlformats.org/officeDocument/2006/relationships" id="259" r:id="Rcf3bef0f1d6944c8"/>
+    <p:sldId xmlns:r="http://schemas.openxmlformats.org/officeDocument/2006/relationships" id="256" r:id="Reed1bba53a5f4d73"/>
+    <p:sldId xmlns:r="http://schemas.openxmlformats.org/officeDocument/2006/relationships" id="257" r:id="Rfc4cf90a051b49ca"/>
+    <p:sldId xmlns:r="http://schemas.openxmlformats.org/officeDocument/2006/relationships" id="258" r:id="R8bdc1015844140ee"/>
+    <p:sldId xmlns:r="http://schemas.openxmlformats.org/officeDocument/2006/relationships" id="259" r:id="Rb69663cdab6b4ac5"/>
   </p:sldIdLst>
   <p:sldSz cx="12192000" cy="6858000"/>
   <p:notesSz cx="6858000" cy="9144000"/>
@@ -958,7 +958,7 @@
   </p:cSld>
   <p:clrMap bg1="lt1" tx1="dk1" bg2="lt2" tx2="dk2" accent1="accent1" accent2="accent2" accent3="accent3" accent4="accent4" accent5="accent5" accent6="accent6" hlink="hlink" folHlink="folHlink"/>
   <p:sldLayoutIdLst>
-    <p:sldLayoutId xmlns:r="http://schemas.openxmlformats.org/officeDocument/2006/relationships" id="2147483649" r:id="R814c52a483694e0b"/>
+    <p:sldLayoutId xmlns:r="http://schemas.openxmlformats.org/officeDocument/2006/relationships" id="2147483649" r:id="R9abd9f5203bb4352"/>
   </p:sldLayoutIdLst>
   <p:txStyles>
     <p:titleStyle>
@@ -1509,7 +1509,7 @@
           <p:cNvPr id="9" name="">
             <a:extLst xmlns:a="http://schemas.openxmlformats.org/drawingml/2006/main">
               <a:ext uri="{FF2B5EF4-FFF2-40B4-BE49-F238E27FC236}">
-                <a16:creationId xmlns:a16="http://schemas.microsoft.com/office/drawing/2014/main" id="{B89F78F8-2EE2-4FE9-923B-05DAEB998680}"/>
+                <a16:creationId xmlns:a16="http://schemas.microsoft.com/office/drawing/2014/main" id="{00BA9D6E-1724-45B0-8215-C247B9FC3999}"/>
               </a:ext>
             </a:extLst>
           </p:cNvPr>
@@ -1539,7 +1539,7 @@
           <p:cNvPr id="2" name="">
             <a:extLst xmlns:a="http://schemas.openxmlformats.org/drawingml/2006/main">
               <a:ext uri="{FF2B5EF4-FFF2-40B4-BE49-F238E27FC236}">
-                <a16:creationId xmlns:a16="http://schemas.microsoft.com/office/drawing/2014/main" id="{3D94A82E-55E1-4C58-A0AC-2A4BB22CE232}"/>
+                <a16:creationId xmlns:a16="http://schemas.microsoft.com/office/drawing/2014/main" id="{8EEE7466-FB7C-45FC-A9DA-AD86B72D740D}"/>
               </a:ext>
             </a:extLst>
           </p:cNvPr>
@@ -1596,7 +1596,7 @@
           <p:cNvPr id="3" name="">
             <a:extLst xmlns:a="http://schemas.openxmlformats.org/drawingml/2006/main">
               <a:ext uri="{FF2B5EF4-FFF2-40B4-BE49-F238E27FC236}">
-                <a16:creationId xmlns:a16="http://schemas.microsoft.com/office/drawing/2014/main" id="{67752625-C77E-4C13-A29D-BBF7DB454895}"/>
+                <a16:creationId xmlns:a16="http://schemas.microsoft.com/office/drawing/2014/main" id="{233AF5B9-9E89-402F-8CC0-DC7598A1F3A4}"/>
               </a:ext>
             </a:extLst>
           </p:cNvPr>
@@ -1653,7 +1653,7 @@
           <p:cNvPr id="4" name="">
             <a:extLst xmlns:a="http://schemas.openxmlformats.org/drawingml/2006/main">
               <a:ext uri="{FF2B5EF4-FFF2-40B4-BE49-F238E27FC236}">
-                <a16:creationId xmlns:a16="http://schemas.microsoft.com/office/drawing/2014/main" id="{01527271-9785-44C4-A903-204B53B1B801}"/>
+                <a16:creationId xmlns:a16="http://schemas.microsoft.com/office/drawing/2014/main" id="{269C32EE-AAA1-4BAE-8B03-B225EAD0ECC2}"/>
               </a:ext>
             </a:extLst>
           </p:cNvPr>
@@ -1710,7 +1710,7 @@
           <p:cNvPr id="5" name="">
             <a:extLst xmlns:a="http://schemas.openxmlformats.org/drawingml/2006/main">
               <a:ext uri="{FF2B5EF4-FFF2-40B4-BE49-F238E27FC236}">
-                <a16:creationId xmlns:a16="http://schemas.microsoft.com/office/drawing/2014/main" id="{62419A40-A2B1-47D1-99B0-1F829ECBC572}"/>
+                <a16:creationId xmlns:a16="http://schemas.microsoft.com/office/drawing/2014/main" id="{723DFEA5-BE5E-4698-AFF8-0C33F54BFC0E}"/>
               </a:ext>
             </a:extLst>
           </p:cNvPr>
@@ -1740,7 +1740,7 @@
           <p:cNvPr id="6" name="">
             <a:extLst xmlns:a="http://schemas.openxmlformats.org/drawingml/2006/main">
               <a:ext uri="{FF2B5EF4-FFF2-40B4-BE49-F238E27FC236}">
-                <a16:creationId xmlns:a16="http://schemas.microsoft.com/office/drawing/2014/main" id="{DC9A08FC-E9F0-4536-BA57-E7463B81E7B7}"/>
+                <a16:creationId xmlns:a16="http://schemas.microsoft.com/office/drawing/2014/main" id="{678BFB27-E753-4D48-9B33-C6CD41BBFA2F}"/>
               </a:ext>
             </a:extLst>
           </p:cNvPr>
@@ -1797,7 +1797,7 @@
           <p:cNvPr id="7" name="">
             <a:extLst xmlns:a="http://schemas.openxmlformats.org/drawingml/2006/main">
               <a:ext uri="{FF2B5EF4-FFF2-40B4-BE49-F238E27FC236}">
-                <a16:creationId xmlns:a16="http://schemas.microsoft.com/office/drawing/2014/main" id="{8198C706-86A1-4839-8038-125DBFF0B730}"/>
+                <a16:creationId xmlns:a16="http://schemas.microsoft.com/office/drawing/2014/main" id="{35E421A4-CFBA-4EF4-9092-50E2E33E078D}"/>
               </a:ext>
             </a:extLst>
           </p:cNvPr>
@@ -1854,7 +1854,7 @@
           <p:cNvPr id="8" name="">
             <a:extLst xmlns:a="http://schemas.openxmlformats.org/drawingml/2006/main">
               <a:ext uri="{FF2B5EF4-FFF2-40B4-BE49-F238E27FC236}">
-                <a16:creationId xmlns:a16="http://schemas.microsoft.com/office/drawing/2014/main" id="{F6E4A886-29DC-4268-AC5D-B2D70CB85006}"/>
+                <a16:creationId xmlns:a16="http://schemas.microsoft.com/office/drawing/2014/main" id="{C97DFD3A-E33E-4C6A-953A-D5E1E5B93EC1}"/>
               </a:ext>
             </a:extLst>
           </p:cNvPr>
@@ -1909,7 +1909,7 @@
     </p:spTree>
     <p:extLst>
       <p:ext uri="{BB962C8B-B14F-4D97-AF65-F5344CB8AC3E}">
-        <p14:creationId xmlns:p14="http://schemas.microsoft.com/office/powerpoint/2010/main" val="907321896"/>
+        <p14:creationId xmlns:p14="http://schemas.microsoft.com/office/powerpoint/2010/main" val="597242214"/>
       </p:ext>
     </p:extLst>
   </p:cSld>
@@ -1940,7 +1940,7 @@
           <p:cNvPr id="46" name="">
             <a:extLst xmlns:a="http://schemas.openxmlformats.org/drawingml/2006/main">
               <a:ext uri="{FF2B5EF4-FFF2-40B4-BE49-F238E27FC236}">
-                <a16:creationId xmlns:a16="http://schemas.microsoft.com/office/drawing/2014/main" id="{E7D6C455-9E08-4FD9-B5C6-788A8C8B932E}"/>
+                <a16:creationId xmlns:a16="http://schemas.microsoft.com/office/drawing/2014/main" id="{A51A43EA-0EB1-4F38-A161-3B1BB494BD9F}"/>
               </a:ext>
             </a:extLst>
           </p:cNvPr>
@@ -1970,7 +1970,7 @@
           <p:cNvPr id="2" name="">
             <a:extLst xmlns:a="http://schemas.openxmlformats.org/drawingml/2006/main">
               <a:ext uri="{FF2B5EF4-FFF2-40B4-BE49-F238E27FC236}">
-                <a16:creationId xmlns:a16="http://schemas.microsoft.com/office/drawing/2014/main" id="{F26D22A8-1209-407B-93D2-32081ACB285B}"/>
+                <a16:creationId xmlns:a16="http://schemas.microsoft.com/office/drawing/2014/main" id="{9A8BCECD-5847-4C52-A2DF-D1277C45E4D5}"/>
               </a:ext>
             </a:extLst>
           </p:cNvPr>
@@ -2027,7 +2027,7 @@
           <p:cNvPr id="3" name="">
             <a:extLst xmlns:a="http://schemas.openxmlformats.org/drawingml/2006/main">
               <a:ext uri="{FF2B5EF4-FFF2-40B4-BE49-F238E27FC236}">
-                <a16:creationId xmlns:a16="http://schemas.microsoft.com/office/drawing/2014/main" id="{8EDDF49F-CA31-4374-86EA-1DCD8290C19D}"/>
+                <a16:creationId xmlns:a16="http://schemas.microsoft.com/office/drawing/2014/main" id="{5328E098-91E1-4DD1-80DF-3F44909F4D6D}"/>
               </a:ext>
             </a:extLst>
           </p:cNvPr>
@@ -2057,7 +2057,7 @@
           <p:cNvPr id="4" name="">
             <a:extLst xmlns:a="http://schemas.openxmlformats.org/drawingml/2006/main">
               <a:ext uri="{FF2B5EF4-FFF2-40B4-BE49-F238E27FC236}">
-                <a16:creationId xmlns:a16="http://schemas.microsoft.com/office/drawing/2014/main" id="{8CAA159A-E4BE-4105-B460-1208FA7C4B78}"/>
+                <a16:creationId xmlns:a16="http://schemas.microsoft.com/office/drawing/2014/main" id="{321ECF12-BFB8-45D3-AF6E-D01F629A7576}"/>
               </a:ext>
             </a:extLst>
           </p:cNvPr>
@@ -2114,7 +2114,7 @@
           <p:cNvPr id="5" name="">
             <a:extLst xmlns:a="http://schemas.openxmlformats.org/drawingml/2006/main">
               <a:ext uri="{FF2B5EF4-FFF2-40B4-BE49-F238E27FC236}">
-                <a16:creationId xmlns:a16="http://schemas.microsoft.com/office/drawing/2014/main" id="{2F28005E-6E87-4E89-8033-6FEA698082CA}"/>
+                <a16:creationId xmlns:a16="http://schemas.microsoft.com/office/drawing/2014/main" id="{FF701AA5-8248-4179-801A-52781AD9B81D}"/>
               </a:ext>
             </a:extLst>
           </p:cNvPr>
@@ -2171,7 +2171,7 @@
           <p:cNvPr id="6" name="">
             <a:extLst xmlns:a="http://schemas.openxmlformats.org/drawingml/2006/main">
               <a:ext uri="{FF2B5EF4-FFF2-40B4-BE49-F238E27FC236}">
-                <a16:creationId xmlns:a16="http://schemas.microsoft.com/office/drawing/2014/main" id="{A3C2248F-EFEC-4BC3-94FF-0FA7EF369DBA}"/>
+                <a16:creationId xmlns:a16="http://schemas.microsoft.com/office/drawing/2014/main" id="{0C89A1F8-2622-436F-B61A-764CB6461FEE}"/>
               </a:ext>
             </a:extLst>
           </p:cNvPr>
@@ -2228,7 +2228,7 @@
           <p:cNvPr id="7" name="">
             <a:extLst xmlns:a="http://schemas.openxmlformats.org/drawingml/2006/main">
               <a:ext uri="{FF2B5EF4-FFF2-40B4-BE49-F238E27FC236}">
-                <a16:creationId xmlns:a16="http://schemas.microsoft.com/office/drawing/2014/main" id="{4FEDC4D7-77EA-4715-A5D2-C06723490CF8}"/>
+                <a16:creationId xmlns:a16="http://schemas.microsoft.com/office/drawing/2014/main" id="{59F6ECE5-8A7D-424B-B6C8-CD3F0ED3EE58}"/>
               </a:ext>
             </a:extLst>
           </p:cNvPr>
@@ -2262,7 +2262,7 @@
           <p:cNvPr id="8" name="">
             <a:extLst xmlns:a="http://schemas.openxmlformats.org/drawingml/2006/main">
               <a:ext uri="{FF2B5EF4-FFF2-40B4-BE49-F238E27FC236}">
-                <a16:creationId xmlns:a16="http://schemas.microsoft.com/office/drawing/2014/main" id="{5B7D9852-4FC7-4C11-8DCB-F7E78D665330}"/>
+                <a16:creationId xmlns:a16="http://schemas.microsoft.com/office/drawing/2014/main" id="{374A16D3-5D91-4EE7-B6F7-12974BE5A64F}"/>
               </a:ext>
             </a:extLst>
           </p:cNvPr>
@@ -2294,7 +2294,7 @@
           <p:cNvPr id="9" name="">
             <a:extLst xmlns:a="http://schemas.openxmlformats.org/drawingml/2006/main">
               <a:ext uri="{FF2B5EF4-FFF2-40B4-BE49-F238E27FC236}">
-                <a16:creationId xmlns:a16="http://schemas.microsoft.com/office/drawing/2014/main" id="{6A2A5DB0-5C53-4E6D-8A66-D05F49B2CDFC}"/>
+                <a16:creationId xmlns:a16="http://schemas.microsoft.com/office/drawing/2014/main" id="{F39D2DBC-A812-49A1-8E35-B9AFF1CDF5A4}"/>
               </a:ext>
             </a:extLst>
           </p:cNvPr>
@@ -2351,7 +2351,7 @@
           <p:cNvPr id="10" name="">
             <a:extLst xmlns:a="http://schemas.openxmlformats.org/drawingml/2006/main">
               <a:ext uri="{FF2B5EF4-FFF2-40B4-BE49-F238E27FC236}">
-                <a16:creationId xmlns:a16="http://schemas.microsoft.com/office/drawing/2014/main" id="{3A472772-F36D-4CF6-8B03-F2A4023D24AB}"/>
+                <a16:creationId xmlns:a16="http://schemas.microsoft.com/office/drawing/2014/main" id="{EF0CC780-EAF4-465C-8B48-CE483583A32E}"/>
               </a:ext>
             </a:extLst>
           </p:cNvPr>
@@ -2431,7 +2431,7 @@
           <p:cNvPr id="11" name="">
             <a:extLst xmlns:a="http://schemas.openxmlformats.org/drawingml/2006/main">
               <a:ext uri="{FF2B5EF4-FFF2-40B4-BE49-F238E27FC236}">
-                <a16:creationId xmlns:a16="http://schemas.microsoft.com/office/drawing/2014/main" id="{747F0817-5EDB-4DE8-91D3-6DD8DA7E29CE}"/>
+                <a16:creationId xmlns:a16="http://schemas.microsoft.com/office/drawing/2014/main" id="{A1EC963D-B96C-4524-9B85-61D6198F084C}"/>
               </a:ext>
             </a:extLst>
           </p:cNvPr>
@@ -2461,7 +2461,7 @@
           <p:cNvPr id="12" name="">
             <a:extLst xmlns:a="http://schemas.openxmlformats.org/drawingml/2006/main">
               <a:ext uri="{FF2B5EF4-FFF2-40B4-BE49-F238E27FC236}">
-                <a16:creationId xmlns:a16="http://schemas.microsoft.com/office/drawing/2014/main" id="{7521978C-8055-447B-81F3-E3925E99FA62}"/>
+                <a16:creationId xmlns:a16="http://schemas.microsoft.com/office/drawing/2014/main" id="{EF2DD65E-81E9-4538-B3CA-C75E56A5A0F5}"/>
               </a:ext>
             </a:extLst>
           </p:cNvPr>
@@ -2495,7 +2495,7 @@
           <p:cNvPr id="13" name="">
             <a:extLst xmlns:a="http://schemas.openxmlformats.org/drawingml/2006/main">
               <a:ext uri="{FF2B5EF4-FFF2-40B4-BE49-F238E27FC236}">
-                <a16:creationId xmlns:a16="http://schemas.microsoft.com/office/drawing/2014/main" id="{7D83756E-4BCF-4AB0-8C5E-CBE72C2F7D0B}"/>
+                <a16:creationId xmlns:a16="http://schemas.microsoft.com/office/drawing/2014/main" id="{7E7B32BC-E756-4D38-9614-0F18BF3920D2}"/>
               </a:ext>
             </a:extLst>
           </p:cNvPr>
@@ -2527,7 +2527,7 @@
           <p:cNvPr id="14" name="">
             <a:extLst xmlns:a="http://schemas.openxmlformats.org/drawingml/2006/main">
               <a:ext uri="{FF2B5EF4-FFF2-40B4-BE49-F238E27FC236}">
-                <a16:creationId xmlns:a16="http://schemas.microsoft.com/office/drawing/2014/main" id="{53108ADF-2A7A-4961-9A82-CE07A9FFA587}"/>
+                <a16:creationId xmlns:a16="http://schemas.microsoft.com/office/drawing/2014/main" id="{B55849CB-1EC1-43D7-85FE-76D8F6CD90A4}"/>
               </a:ext>
             </a:extLst>
           </p:cNvPr>
@@ -2584,7 +2584,7 @@
           <p:cNvPr id="15" name="">
             <a:extLst xmlns:a="http://schemas.openxmlformats.org/drawingml/2006/main">
               <a:ext uri="{FF2B5EF4-FFF2-40B4-BE49-F238E27FC236}">
-                <a16:creationId xmlns:a16="http://schemas.microsoft.com/office/drawing/2014/main" id="{A6AB23A2-B093-437A-B9F9-9D05813CC97C}"/>
+                <a16:creationId xmlns:a16="http://schemas.microsoft.com/office/drawing/2014/main" id="{AC598822-0D8D-4204-94D3-0C90D265ACA1}"/>
               </a:ext>
             </a:extLst>
           </p:cNvPr>
@@ -2664,7 +2664,7 @@
           <p:cNvPr id="16" name="">
             <a:extLst xmlns:a="http://schemas.openxmlformats.org/drawingml/2006/main">
               <a:ext uri="{FF2B5EF4-FFF2-40B4-BE49-F238E27FC236}">
-                <a16:creationId xmlns:a16="http://schemas.microsoft.com/office/drawing/2014/main" id="{00C03AA0-DF75-4DCB-B896-515D414FE0A4}"/>
+                <a16:creationId xmlns:a16="http://schemas.microsoft.com/office/drawing/2014/main" id="{699B0987-2CE7-4D1B-82D2-E312AEF2E17A}"/>
               </a:ext>
             </a:extLst>
           </p:cNvPr>
@@ -2694,7 +2694,7 @@
           <p:cNvPr id="17" name="">
             <a:extLst xmlns:a="http://schemas.openxmlformats.org/drawingml/2006/main">
               <a:ext uri="{FF2B5EF4-FFF2-40B4-BE49-F238E27FC236}">
-                <a16:creationId xmlns:a16="http://schemas.microsoft.com/office/drawing/2014/main" id="{C750649C-5326-487A-80D8-64A032354976}"/>
+                <a16:creationId xmlns:a16="http://schemas.microsoft.com/office/drawing/2014/main" id="{9E1B3610-1685-4B4B-B6A0-9DFEDE04D536}"/>
               </a:ext>
             </a:extLst>
           </p:cNvPr>
@@ -2728,7 +2728,7 @@
           <p:cNvPr id="18" name="">
             <a:extLst xmlns:a="http://schemas.openxmlformats.org/drawingml/2006/main">
               <a:ext uri="{FF2B5EF4-FFF2-40B4-BE49-F238E27FC236}">
-                <a16:creationId xmlns:a16="http://schemas.microsoft.com/office/drawing/2014/main" id="{7093FD12-79B6-43D6-B563-4242B4C6C38E}"/>
+                <a16:creationId xmlns:a16="http://schemas.microsoft.com/office/drawing/2014/main" id="{C1C7BE5D-046C-4D3F-96F2-02FD81D4E544}"/>
               </a:ext>
             </a:extLst>
           </p:cNvPr>
@@ -2760,7 +2760,7 @@
           <p:cNvPr id="19" name="">
             <a:extLst xmlns:a="http://schemas.openxmlformats.org/drawingml/2006/main">
               <a:ext uri="{FF2B5EF4-FFF2-40B4-BE49-F238E27FC236}">
-                <a16:creationId xmlns:a16="http://schemas.microsoft.com/office/drawing/2014/main" id="{BEF77772-CA67-40B0-8330-3EE793832DCA}"/>
+                <a16:creationId xmlns:a16="http://schemas.microsoft.com/office/drawing/2014/main" id="{AAD21B6F-5264-4625-9F92-7D83B414D018}"/>
               </a:ext>
             </a:extLst>
           </p:cNvPr>
@@ -2817,7 +2817,7 @@
           <p:cNvPr id="20" name="">
             <a:extLst xmlns:a="http://schemas.openxmlformats.org/drawingml/2006/main">
               <a:ext uri="{FF2B5EF4-FFF2-40B4-BE49-F238E27FC236}">
-                <a16:creationId xmlns:a16="http://schemas.microsoft.com/office/drawing/2014/main" id="{592CBB99-F340-42F2-B214-57F9E326FCB1}"/>
+                <a16:creationId xmlns:a16="http://schemas.microsoft.com/office/drawing/2014/main" id="{23D1E04D-E887-4E8C-B57F-04E0095332AD}"/>
               </a:ext>
             </a:extLst>
           </p:cNvPr>
@@ -2897,7 +2897,7 @@
           <p:cNvPr id="21" name="">
             <a:extLst xmlns:a="http://schemas.openxmlformats.org/drawingml/2006/main">
               <a:ext uri="{FF2B5EF4-FFF2-40B4-BE49-F238E27FC236}">
-                <a16:creationId xmlns:a16="http://schemas.microsoft.com/office/drawing/2014/main" id="{0BB5F308-76E2-49E2-A0CF-E81B16573F30}"/>
+                <a16:creationId xmlns:a16="http://schemas.microsoft.com/office/drawing/2014/main" id="{A3AFC1D4-A544-4F28-9DD0-12C5552CC5C9}"/>
               </a:ext>
             </a:extLst>
           </p:cNvPr>
@@ -2927,7 +2927,7 @@
           <p:cNvPr id="22" name="">
             <a:extLst xmlns:a="http://schemas.openxmlformats.org/drawingml/2006/main">
               <a:ext uri="{FF2B5EF4-FFF2-40B4-BE49-F238E27FC236}">
-                <a16:creationId xmlns:a16="http://schemas.microsoft.com/office/drawing/2014/main" id="{41A9D7CA-E6CF-4648-B81B-8072D6AD62C4}"/>
+                <a16:creationId xmlns:a16="http://schemas.microsoft.com/office/drawing/2014/main" id="{AC92CD64-56C7-4D96-B5F3-5CA3B9FBD317}"/>
               </a:ext>
             </a:extLst>
           </p:cNvPr>
@@ -2961,7 +2961,7 @@
           <p:cNvPr id="23" name="">
             <a:extLst xmlns:a="http://schemas.openxmlformats.org/drawingml/2006/main">
               <a:ext uri="{FF2B5EF4-FFF2-40B4-BE49-F238E27FC236}">
-                <a16:creationId xmlns:a16="http://schemas.microsoft.com/office/drawing/2014/main" id="{39DFEACE-CBD9-4176-910E-2B3D7DD83EDE}"/>
+                <a16:creationId xmlns:a16="http://schemas.microsoft.com/office/drawing/2014/main" id="{FEB70F2C-B91D-46A0-9ACB-FC0255A03BCC}"/>
               </a:ext>
             </a:extLst>
           </p:cNvPr>
@@ -2993,7 +2993,7 @@
           <p:cNvPr id="24" name="">
             <a:extLst xmlns:a="http://schemas.openxmlformats.org/drawingml/2006/main">
               <a:ext uri="{FF2B5EF4-FFF2-40B4-BE49-F238E27FC236}">
-                <a16:creationId xmlns:a16="http://schemas.microsoft.com/office/drawing/2014/main" id="{9644AFEB-BE40-42FC-90D5-2AD91628DDB3}"/>
+                <a16:creationId xmlns:a16="http://schemas.microsoft.com/office/drawing/2014/main" id="{62F93259-BBD7-4418-B5CD-8DCAED849A07}"/>
               </a:ext>
             </a:extLst>
           </p:cNvPr>
@@ -3050,7 +3050,7 @@
           <p:cNvPr id="25" name="">
             <a:extLst xmlns:a="http://schemas.openxmlformats.org/drawingml/2006/main">
               <a:ext uri="{FF2B5EF4-FFF2-40B4-BE49-F238E27FC236}">
-                <a16:creationId xmlns:a16="http://schemas.microsoft.com/office/drawing/2014/main" id="{69F0FA7E-AE5B-4BDE-89FA-16FF8055DF7D}"/>
+                <a16:creationId xmlns:a16="http://schemas.microsoft.com/office/drawing/2014/main" id="{1A3DCFA1-1572-4D5F-9B1A-F8593818398B}"/>
               </a:ext>
             </a:extLst>
           </p:cNvPr>
@@ -3130,7 +3130,7 @@
           <p:cNvPr id="26" name="">
             <a:extLst xmlns:a="http://schemas.openxmlformats.org/drawingml/2006/main">
               <a:ext uri="{FF2B5EF4-FFF2-40B4-BE49-F238E27FC236}">
-                <a16:creationId xmlns:a16="http://schemas.microsoft.com/office/drawing/2014/main" id="{E80ACA26-52A1-4E6E-AAA2-8BDE709EA5C5}"/>
+                <a16:creationId xmlns:a16="http://schemas.microsoft.com/office/drawing/2014/main" id="{D94DEBCB-57F1-4DDF-AFD9-5102E2CBF3E7}"/>
               </a:ext>
             </a:extLst>
           </p:cNvPr>
@@ -3160,7 +3160,7 @@
           <p:cNvPr id="27" name="">
             <a:extLst xmlns:a="http://schemas.openxmlformats.org/drawingml/2006/main">
               <a:ext uri="{FF2B5EF4-FFF2-40B4-BE49-F238E27FC236}">
-                <a16:creationId xmlns:a16="http://schemas.microsoft.com/office/drawing/2014/main" id="{29559DDD-7B8F-4608-BE48-89F3303E47E9}"/>
+                <a16:creationId xmlns:a16="http://schemas.microsoft.com/office/drawing/2014/main" id="{E4178E62-E0E7-485A-B3D8-0A7CF50B3FE6}"/>
               </a:ext>
             </a:extLst>
           </p:cNvPr>
@@ -3194,7 +3194,7 @@
           <p:cNvPr id="28" name="">
             <a:extLst xmlns:a="http://schemas.openxmlformats.org/drawingml/2006/main">
               <a:ext uri="{FF2B5EF4-FFF2-40B4-BE49-F238E27FC236}">
-                <a16:creationId xmlns:a16="http://schemas.microsoft.com/office/drawing/2014/main" id="{21F64E0D-87E6-4628-AB5A-8239CF10AC0C}"/>
+                <a16:creationId xmlns:a16="http://schemas.microsoft.com/office/drawing/2014/main" id="{AA92DD5F-9EAE-4800-AABA-F9679E9E8EFA}"/>
               </a:ext>
             </a:extLst>
           </p:cNvPr>
@@ -3226,7 +3226,7 @@
           <p:cNvPr id="29" name="">
             <a:extLst xmlns:a="http://schemas.openxmlformats.org/drawingml/2006/main">
               <a:ext uri="{FF2B5EF4-FFF2-40B4-BE49-F238E27FC236}">
-                <a16:creationId xmlns:a16="http://schemas.microsoft.com/office/drawing/2014/main" id="{AE28DB58-CA44-428C-B75C-C6039B564EE3}"/>
+                <a16:creationId xmlns:a16="http://schemas.microsoft.com/office/drawing/2014/main" id="{E8147818-2808-48BA-9B05-927A982606D8}"/>
               </a:ext>
             </a:extLst>
           </p:cNvPr>
@@ -3283,7 +3283,7 @@
           <p:cNvPr id="30" name="">
             <a:extLst xmlns:a="http://schemas.openxmlformats.org/drawingml/2006/main">
               <a:ext uri="{FF2B5EF4-FFF2-40B4-BE49-F238E27FC236}">
-                <a16:creationId xmlns:a16="http://schemas.microsoft.com/office/drawing/2014/main" id="{BFFD78D4-BEE5-40BD-8DFD-EC786D8ABAF8}"/>
+                <a16:creationId xmlns:a16="http://schemas.microsoft.com/office/drawing/2014/main" id="{2814C527-9016-4216-A5EF-36CF518FC9C4}"/>
               </a:ext>
             </a:extLst>
           </p:cNvPr>
@@ -3363,7 +3363,7 @@
           <p:cNvPr id="31" name="">
             <a:extLst xmlns:a="http://schemas.openxmlformats.org/drawingml/2006/main">
               <a:ext uri="{FF2B5EF4-FFF2-40B4-BE49-F238E27FC236}">
-                <a16:creationId xmlns:a16="http://schemas.microsoft.com/office/drawing/2014/main" id="{622359F8-A2F5-4343-920D-A059FC789C26}"/>
+                <a16:creationId xmlns:a16="http://schemas.microsoft.com/office/drawing/2014/main" id="{AB05E5ED-5056-4063-95DF-037528454530}"/>
               </a:ext>
             </a:extLst>
           </p:cNvPr>
@@ -3420,7 +3420,7 @@
           <p:cNvPr id="32" name="">
             <a:extLst xmlns:a="http://schemas.openxmlformats.org/drawingml/2006/main">
               <a:ext uri="{FF2B5EF4-FFF2-40B4-BE49-F238E27FC236}">
-                <a16:creationId xmlns:a16="http://schemas.microsoft.com/office/drawing/2014/main" id="{84E8A899-9B34-460B-8547-A0746557B9EB}"/>
+                <a16:creationId xmlns:a16="http://schemas.microsoft.com/office/drawing/2014/main" id="{79033D50-B063-4594-92E3-9843E0022B9E}"/>
               </a:ext>
             </a:extLst>
           </p:cNvPr>
@@ -3477,7 +3477,7 @@
           <p:cNvPr id="33" name="">
             <a:extLst xmlns:a="http://schemas.openxmlformats.org/drawingml/2006/main">
               <a:ext uri="{FF2B5EF4-FFF2-40B4-BE49-F238E27FC236}">
-                <a16:creationId xmlns:a16="http://schemas.microsoft.com/office/drawing/2014/main" id="{42FCCE6D-4C4D-40C7-9E6E-3F6FAF2FDA1A}"/>
+                <a16:creationId xmlns:a16="http://schemas.microsoft.com/office/drawing/2014/main" id="{32997F68-2530-4097-839A-514DA28EE37D}"/>
               </a:ext>
             </a:extLst>
           </p:cNvPr>
@@ -3534,7 +3534,7 @@
           <p:cNvPr id="34" name="">
             <a:extLst xmlns:a="http://schemas.openxmlformats.org/drawingml/2006/main">
               <a:ext uri="{FF2B5EF4-FFF2-40B4-BE49-F238E27FC236}">
-                <a16:creationId xmlns:a16="http://schemas.microsoft.com/office/drawing/2014/main" id="{912BC311-5FA9-463A-A752-8A4D9DA07C24}"/>
+                <a16:creationId xmlns:a16="http://schemas.microsoft.com/office/drawing/2014/main" id="{3699BDD2-6C75-44B0-9FA2-C44B266796C0}"/>
               </a:ext>
             </a:extLst>
           </p:cNvPr>
@@ -3591,7 +3591,7 @@
           <p:cNvPr id="35" name="">
             <a:extLst xmlns:a="http://schemas.openxmlformats.org/drawingml/2006/main">
               <a:ext uri="{FF2B5EF4-FFF2-40B4-BE49-F238E27FC236}">
-                <a16:creationId xmlns:a16="http://schemas.microsoft.com/office/drawing/2014/main" id="{74E56CBC-4EB7-460D-AB2E-6D9CAE373704}"/>
+                <a16:creationId xmlns:a16="http://schemas.microsoft.com/office/drawing/2014/main" id="{9C5905EF-D626-47DE-AC26-C2614BCF5812}"/>
               </a:ext>
             </a:extLst>
           </p:cNvPr>
@@ -3648,7 +3648,7 @@
           <p:cNvPr id="36" name="">
             <a:extLst xmlns:a="http://schemas.openxmlformats.org/drawingml/2006/main">
               <a:ext uri="{FF2B5EF4-FFF2-40B4-BE49-F238E27FC236}">
-                <a16:creationId xmlns:a16="http://schemas.microsoft.com/office/drawing/2014/main" id="{7D164BE8-57C6-4626-B707-F26C3B9B3CEA}"/>
+                <a16:creationId xmlns:a16="http://schemas.microsoft.com/office/drawing/2014/main" id="{E97CEA58-AE7F-42AC-B568-FC519C582CD3}"/>
               </a:ext>
             </a:extLst>
           </p:cNvPr>
@@ -3705,7 +3705,7 @@
           <p:cNvPr id="37" name="">
             <a:extLst xmlns:a="http://schemas.openxmlformats.org/drawingml/2006/main">
               <a:ext uri="{FF2B5EF4-FFF2-40B4-BE49-F238E27FC236}">
-                <a16:creationId xmlns:a16="http://schemas.microsoft.com/office/drawing/2014/main" id="{5CC89D65-5AF5-4BFB-B244-74965368AC26}"/>
+                <a16:creationId xmlns:a16="http://schemas.microsoft.com/office/drawing/2014/main" id="{8CA5995F-2477-44F4-AC52-6EAB116055EB}"/>
               </a:ext>
             </a:extLst>
           </p:cNvPr>
@@ -3762,7 +3762,7 @@
           <p:cNvPr id="38" name="">
             <a:extLst xmlns:a="http://schemas.openxmlformats.org/drawingml/2006/main">
               <a:ext uri="{FF2B5EF4-FFF2-40B4-BE49-F238E27FC236}">
-                <a16:creationId xmlns:a16="http://schemas.microsoft.com/office/drawing/2014/main" id="{51FD696C-0DBE-4458-B306-364906B3789A}"/>
+                <a16:creationId xmlns:a16="http://schemas.microsoft.com/office/drawing/2014/main" id="{2585ADD7-160B-4C6E-863E-FE8449DFC2E6}"/>
               </a:ext>
             </a:extLst>
           </p:cNvPr>
@@ -3819,7 +3819,7 @@
           <p:cNvPr id="39" name="">
             <a:extLst xmlns:a="http://schemas.openxmlformats.org/drawingml/2006/main">
               <a:ext uri="{FF2B5EF4-FFF2-40B4-BE49-F238E27FC236}">
-                <a16:creationId xmlns:a16="http://schemas.microsoft.com/office/drawing/2014/main" id="{0CBF763F-9A7D-448B-84C1-59BA63EB0E7A}"/>
+                <a16:creationId xmlns:a16="http://schemas.microsoft.com/office/drawing/2014/main" id="{D08161D3-6E29-4B43-A673-972DA7A7FCDE}"/>
               </a:ext>
             </a:extLst>
           </p:cNvPr>
@@ -3876,7 +3876,7 @@
           <p:cNvPr id="40" name="">
             <a:extLst xmlns:a="http://schemas.openxmlformats.org/drawingml/2006/main">
               <a:ext uri="{FF2B5EF4-FFF2-40B4-BE49-F238E27FC236}">
-                <a16:creationId xmlns:a16="http://schemas.microsoft.com/office/drawing/2014/main" id="{E38F218C-7170-4170-8A9D-93298085EF63}"/>
+                <a16:creationId xmlns:a16="http://schemas.microsoft.com/office/drawing/2014/main" id="{25F284AE-0D23-4C37-AB1C-F1EB8673085D}"/>
               </a:ext>
             </a:extLst>
           </p:cNvPr>
@@ -3933,7 +3933,7 @@
           <p:cNvPr id="41" name="">
             <a:extLst xmlns:a="http://schemas.openxmlformats.org/drawingml/2006/main">
               <a:ext uri="{FF2B5EF4-FFF2-40B4-BE49-F238E27FC236}">
-                <a16:creationId xmlns:a16="http://schemas.microsoft.com/office/drawing/2014/main" id="{D1AD4CFF-7598-408B-851D-35CB4FEBD944}"/>
+                <a16:creationId xmlns:a16="http://schemas.microsoft.com/office/drawing/2014/main" id="{F4CDBF12-79DB-48A6-AA99-DBABDA49E2A7}"/>
               </a:ext>
             </a:extLst>
           </p:cNvPr>
@@ -3990,7 +3990,7 @@
           <p:cNvPr id="42" name="">
             <a:extLst xmlns:a="http://schemas.openxmlformats.org/drawingml/2006/main">
               <a:ext uri="{FF2B5EF4-FFF2-40B4-BE49-F238E27FC236}">
-                <a16:creationId xmlns:a16="http://schemas.microsoft.com/office/drawing/2014/main" id="{C67CE3CD-86E5-45A9-AB61-42C09037F93A}"/>
+                <a16:creationId xmlns:a16="http://schemas.microsoft.com/office/drawing/2014/main" id="{F2153BB1-B9D4-48CC-8A16-500BBA4117F8}"/>
               </a:ext>
             </a:extLst>
           </p:cNvPr>
@@ -4047,7 +4047,7 @@
           <p:cNvPr id="43" name="">
             <a:extLst xmlns:a="http://schemas.openxmlformats.org/drawingml/2006/main">
               <a:ext uri="{FF2B5EF4-FFF2-40B4-BE49-F238E27FC236}">
-                <a16:creationId xmlns:a16="http://schemas.microsoft.com/office/drawing/2014/main" id="{E2C81024-F463-4FFB-85AD-581F6F97B60A}"/>
+                <a16:creationId xmlns:a16="http://schemas.microsoft.com/office/drawing/2014/main" id="{842D6556-081E-48D5-955D-C92D6FCF5546}"/>
               </a:ext>
             </a:extLst>
           </p:cNvPr>
@@ -4104,7 +4104,7 @@
           <p:cNvPr id="44" name="">
             <a:extLst xmlns:a="http://schemas.openxmlformats.org/drawingml/2006/main">
               <a:ext uri="{FF2B5EF4-FFF2-40B4-BE49-F238E27FC236}">
-                <a16:creationId xmlns:a16="http://schemas.microsoft.com/office/drawing/2014/main" id="{09C9B169-4A7A-4A2E-B065-FD0E7CE9B90C}"/>
+                <a16:creationId xmlns:a16="http://schemas.microsoft.com/office/drawing/2014/main" id="{B48FC2A8-F48D-4641-BCE7-89918A73A15D}"/>
               </a:ext>
             </a:extLst>
           </p:cNvPr>
@@ -4136,7 +4136,7 @@
           <p:cNvPr id="45" name="">
             <a:extLst xmlns:a="http://schemas.openxmlformats.org/drawingml/2006/main">
               <a:ext uri="{FF2B5EF4-FFF2-40B4-BE49-F238E27FC236}">
-                <a16:creationId xmlns:a16="http://schemas.microsoft.com/office/drawing/2014/main" id="{CB0346F2-8F82-43D8-A18D-AC983AB5F552}"/>
+                <a16:creationId xmlns:a16="http://schemas.microsoft.com/office/drawing/2014/main" id="{128CB552-67D6-4061-BFD4-DF6A03E8D71C}"/>
               </a:ext>
             </a:extLst>
           </p:cNvPr>
@@ -4191,7 +4191,7 @@
     </p:spTree>
     <p:extLst>
       <p:ext uri="{BB962C8B-B14F-4D97-AF65-F5344CB8AC3E}">
-        <p14:creationId xmlns:p14="http://schemas.microsoft.com/office/powerpoint/2010/main" val="376866593"/>
+        <p14:creationId xmlns:p14="http://schemas.microsoft.com/office/powerpoint/2010/main" val="197672856"/>
       </p:ext>
     </p:extLst>
   </p:cSld>
@@ -4222,7 +4222,7 @@
           <p:cNvPr id="57" name="">
             <a:extLst xmlns:a="http://schemas.openxmlformats.org/drawingml/2006/main">
               <a:ext uri="{FF2B5EF4-FFF2-40B4-BE49-F238E27FC236}">
-                <a16:creationId xmlns:a16="http://schemas.microsoft.com/office/drawing/2014/main" id="{69CB6C18-25BA-4D33-A11A-BEA642DF8221}"/>
+                <a16:creationId xmlns:a16="http://schemas.microsoft.com/office/drawing/2014/main" id="{64F011BB-FF34-43DA-86B7-5A32C7D5EB46}"/>
               </a:ext>
             </a:extLst>
           </p:cNvPr>
@@ -4252,7 +4252,7 @@
           <p:cNvPr id="2" name="">
             <a:extLst xmlns:a="http://schemas.openxmlformats.org/drawingml/2006/main">
               <a:ext uri="{FF2B5EF4-FFF2-40B4-BE49-F238E27FC236}">
-                <a16:creationId xmlns:a16="http://schemas.microsoft.com/office/drawing/2014/main" id="{9F9FF240-13DC-4646-931A-F84BF617810A}"/>
+                <a16:creationId xmlns:a16="http://schemas.microsoft.com/office/drawing/2014/main" id="{259BD839-25A6-4899-89FD-C047910FB1F6}"/>
               </a:ext>
             </a:extLst>
           </p:cNvPr>
@@ -4309,7 +4309,7 @@
           <p:cNvPr id="3" name="">
             <a:extLst xmlns:a="http://schemas.openxmlformats.org/drawingml/2006/main">
               <a:ext uri="{FF2B5EF4-FFF2-40B4-BE49-F238E27FC236}">
-                <a16:creationId xmlns:a16="http://schemas.microsoft.com/office/drawing/2014/main" id="{EFC94DEB-F33E-4583-9875-2C069C7A0B6A}"/>
+                <a16:creationId xmlns:a16="http://schemas.microsoft.com/office/drawing/2014/main" id="{8139E8DC-544B-4C6D-96B2-28F3B3BF846A}"/>
               </a:ext>
             </a:extLst>
           </p:cNvPr>
@@ -4339,7 +4339,7 @@
           <p:cNvPr id="4" name="">
             <a:extLst xmlns:a="http://schemas.openxmlformats.org/drawingml/2006/main">
               <a:ext uri="{FF2B5EF4-FFF2-40B4-BE49-F238E27FC236}">
-                <a16:creationId xmlns:a16="http://schemas.microsoft.com/office/drawing/2014/main" id="{1AFF4680-A91E-4D3D-A5F0-E8D2322AD76E}"/>
+                <a16:creationId xmlns:a16="http://schemas.microsoft.com/office/drawing/2014/main" id="{22864318-7B0A-4B53-B072-F9F3A185B1F9}"/>
               </a:ext>
             </a:extLst>
           </p:cNvPr>
@@ -4396,7 +4396,7 @@
           <p:cNvPr id="5" name="">
             <a:extLst xmlns:a="http://schemas.openxmlformats.org/drawingml/2006/main">
               <a:ext uri="{FF2B5EF4-FFF2-40B4-BE49-F238E27FC236}">
-                <a16:creationId xmlns:a16="http://schemas.microsoft.com/office/drawing/2014/main" id="{86ADC36E-ADA2-4E84-BC7D-14D591D381E1}"/>
+                <a16:creationId xmlns:a16="http://schemas.microsoft.com/office/drawing/2014/main" id="{7582A647-A186-4264-870F-8D8606D71B98}"/>
               </a:ext>
             </a:extLst>
           </p:cNvPr>
@@ -4453,7 +4453,7 @@
           <p:cNvPr id="6" name="">
             <a:extLst xmlns:a="http://schemas.openxmlformats.org/drawingml/2006/main">
               <a:ext uri="{FF2B5EF4-FFF2-40B4-BE49-F238E27FC236}">
-                <a16:creationId xmlns:a16="http://schemas.microsoft.com/office/drawing/2014/main" id="{A7788689-680A-4B4B-8E50-6103E4845F2E}"/>
+                <a16:creationId xmlns:a16="http://schemas.microsoft.com/office/drawing/2014/main" id="{41FD03DE-CBC2-4515-A229-D57164FA80FA}"/>
               </a:ext>
             </a:extLst>
           </p:cNvPr>
@@ -4487,7 +4487,7 @@
           <p:cNvPr id="7" name="">
             <a:extLst xmlns:a="http://schemas.openxmlformats.org/drawingml/2006/main">
               <a:ext uri="{FF2B5EF4-FFF2-40B4-BE49-F238E27FC236}">
-                <a16:creationId xmlns:a16="http://schemas.microsoft.com/office/drawing/2014/main" id="{1249C2E5-3C4A-4707-9AF0-06B1847E48F2}"/>
+                <a16:creationId xmlns:a16="http://schemas.microsoft.com/office/drawing/2014/main" id="{DD2270A5-7312-48CC-B533-E094705E2C29}"/>
               </a:ext>
             </a:extLst>
           </p:cNvPr>
@@ -4519,7 +4519,7 @@
           <p:cNvPr id="8" name="">
             <a:extLst xmlns:a="http://schemas.openxmlformats.org/drawingml/2006/main">
               <a:ext uri="{FF2B5EF4-FFF2-40B4-BE49-F238E27FC236}">
-                <a16:creationId xmlns:a16="http://schemas.microsoft.com/office/drawing/2014/main" id="{D132B4B8-4860-4F46-9FBC-BA238DA6FEFB}"/>
+                <a16:creationId xmlns:a16="http://schemas.microsoft.com/office/drawing/2014/main" id="{B8740235-F449-42AB-8F37-E1E7ABE52F34}"/>
               </a:ext>
             </a:extLst>
           </p:cNvPr>
@@ -4576,7 +4576,7 @@
           <p:cNvPr id="9" name="">
             <a:extLst xmlns:a="http://schemas.openxmlformats.org/drawingml/2006/main">
               <a:ext uri="{FF2B5EF4-FFF2-40B4-BE49-F238E27FC236}">
-                <a16:creationId xmlns:a16="http://schemas.microsoft.com/office/drawing/2014/main" id="{1115566C-9C69-44B0-8690-D12BA0A8639C}"/>
+                <a16:creationId xmlns:a16="http://schemas.microsoft.com/office/drawing/2014/main" id="{2DD87E20-6C2C-4B9C-992B-7DDF6D2BB8A9}"/>
               </a:ext>
             </a:extLst>
           </p:cNvPr>
@@ -4633,7 +4633,7 @@
           <p:cNvPr id="10" name="">
             <a:extLst xmlns:a="http://schemas.openxmlformats.org/drawingml/2006/main">
               <a:ext uri="{FF2B5EF4-FFF2-40B4-BE49-F238E27FC236}">
-                <a16:creationId xmlns:a16="http://schemas.microsoft.com/office/drawing/2014/main" id="{5A46C7D7-DEFB-4FC8-82F5-A856CC9A0357}"/>
+                <a16:creationId xmlns:a16="http://schemas.microsoft.com/office/drawing/2014/main" id="{6FFF794D-6D8A-4C0C-83E3-76B7CFD1BAF6}"/>
               </a:ext>
             </a:extLst>
           </p:cNvPr>
@@ -4690,7 +4690,7 @@
           <p:cNvPr id="11" name="">
             <a:extLst xmlns:a="http://schemas.openxmlformats.org/drawingml/2006/main">
               <a:ext uri="{FF2B5EF4-FFF2-40B4-BE49-F238E27FC236}">
-                <a16:creationId xmlns:a16="http://schemas.microsoft.com/office/drawing/2014/main" id="{F4DE997E-874B-40A4-8622-963CF0962BA4}"/>
+                <a16:creationId xmlns:a16="http://schemas.microsoft.com/office/drawing/2014/main" id="{D6546307-6BFD-4EA0-8E7E-33951D5512E5}"/>
               </a:ext>
             </a:extLst>
           </p:cNvPr>
@@ -4720,7 +4720,7 @@
           <p:cNvPr id="12" name="">
             <a:extLst xmlns:a="http://schemas.openxmlformats.org/drawingml/2006/main">
               <a:ext uri="{FF2B5EF4-FFF2-40B4-BE49-F238E27FC236}">
-                <a16:creationId xmlns:a16="http://schemas.microsoft.com/office/drawing/2014/main" id="{CBF2D581-0F25-426B-B1E3-F0C0ABE9943E}"/>
+                <a16:creationId xmlns:a16="http://schemas.microsoft.com/office/drawing/2014/main" id="{E532C84D-E9A0-4AEC-A4D2-8A957C627D0A}"/>
               </a:ext>
             </a:extLst>
           </p:cNvPr>
@@ -4754,7 +4754,7 @@
           <p:cNvPr id="13" name="">
             <a:extLst xmlns:a="http://schemas.openxmlformats.org/drawingml/2006/main">
               <a:ext uri="{FF2B5EF4-FFF2-40B4-BE49-F238E27FC236}">
-                <a16:creationId xmlns:a16="http://schemas.microsoft.com/office/drawing/2014/main" id="{024F83B6-1D63-4410-9EA2-6F13775ACBAA}"/>
+                <a16:creationId xmlns:a16="http://schemas.microsoft.com/office/drawing/2014/main" id="{AEF8D5F7-4A3C-410F-A907-0C2102C435EE}"/>
               </a:ext>
             </a:extLst>
           </p:cNvPr>
@@ -4786,7 +4786,7 @@
           <p:cNvPr id="14" name="">
             <a:extLst xmlns:a="http://schemas.openxmlformats.org/drawingml/2006/main">
               <a:ext uri="{FF2B5EF4-FFF2-40B4-BE49-F238E27FC236}">
-                <a16:creationId xmlns:a16="http://schemas.microsoft.com/office/drawing/2014/main" id="{FA8211C3-F4EF-4183-896A-2F840AD75DEA}"/>
+                <a16:creationId xmlns:a16="http://schemas.microsoft.com/office/drawing/2014/main" id="{66747862-4F6C-4424-A06E-111DC29D7679}"/>
               </a:ext>
             </a:extLst>
           </p:cNvPr>
@@ -4843,7 +4843,7 @@
           <p:cNvPr id="15" name="">
             <a:extLst xmlns:a="http://schemas.openxmlformats.org/drawingml/2006/main">
               <a:ext uri="{FF2B5EF4-FFF2-40B4-BE49-F238E27FC236}">
-                <a16:creationId xmlns:a16="http://schemas.microsoft.com/office/drawing/2014/main" id="{A60027F4-D419-46F6-8882-B0F8B743655E}"/>
+                <a16:creationId xmlns:a16="http://schemas.microsoft.com/office/drawing/2014/main" id="{E561D083-4575-4553-824A-D6CADC62B3A9}"/>
               </a:ext>
             </a:extLst>
           </p:cNvPr>
@@ -4900,7 +4900,7 @@
           <p:cNvPr id="16" name="">
             <a:extLst xmlns:a="http://schemas.openxmlformats.org/drawingml/2006/main">
               <a:ext uri="{FF2B5EF4-FFF2-40B4-BE49-F238E27FC236}">
-                <a16:creationId xmlns:a16="http://schemas.microsoft.com/office/drawing/2014/main" id="{0A150B9B-0EEF-4A47-B7C4-5DABF07DD1B9}"/>
+                <a16:creationId xmlns:a16="http://schemas.microsoft.com/office/drawing/2014/main" id="{62B591A1-09C8-45E3-BE2C-31FC007445F7}"/>
               </a:ext>
             </a:extLst>
           </p:cNvPr>
@@ -4957,7 +4957,7 @@
           <p:cNvPr id="17" name="">
             <a:extLst xmlns:a="http://schemas.openxmlformats.org/drawingml/2006/main">
               <a:ext uri="{FF2B5EF4-FFF2-40B4-BE49-F238E27FC236}">
-                <a16:creationId xmlns:a16="http://schemas.microsoft.com/office/drawing/2014/main" id="{E587C59A-2D10-4D79-830A-F022E2A2F2DB}"/>
+                <a16:creationId xmlns:a16="http://schemas.microsoft.com/office/drawing/2014/main" id="{1EA2E514-E61B-4D5E-BCBD-FC0799ADBCA2}"/>
               </a:ext>
             </a:extLst>
           </p:cNvPr>
@@ -4987,7 +4987,7 @@
           <p:cNvPr id="18" name="">
             <a:extLst xmlns:a="http://schemas.openxmlformats.org/drawingml/2006/main">
               <a:ext uri="{FF2B5EF4-FFF2-40B4-BE49-F238E27FC236}">
-                <a16:creationId xmlns:a16="http://schemas.microsoft.com/office/drawing/2014/main" id="{E661D9D6-19C1-4D00-BF76-A2F8AAA79499}"/>
+                <a16:creationId xmlns:a16="http://schemas.microsoft.com/office/drawing/2014/main" id="{10F1A724-8112-4F10-94F2-217CFA88BA6C}"/>
               </a:ext>
             </a:extLst>
           </p:cNvPr>
@@ -5021,7 +5021,7 @@
           <p:cNvPr id="19" name="">
             <a:extLst xmlns:a="http://schemas.openxmlformats.org/drawingml/2006/main">
               <a:ext uri="{FF2B5EF4-FFF2-40B4-BE49-F238E27FC236}">
-                <a16:creationId xmlns:a16="http://schemas.microsoft.com/office/drawing/2014/main" id="{0F7699E9-2CC8-4B34-B39B-F3028E42FF77}"/>
+                <a16:creationId xmlns:a16="http://schemas.microsoft.com/office/drawing/2014/main" id="{3F72B3E7-44BB-4965-80F3-84FF877F9C6E}"/>
               </a:ext>
             </a:extLst>
           </p:cNvPr>
@@ -5053,7 +5053,7 @@
           <p:cNvPr id="20" name="">
             <a:extLst xmlns:a="http://schemas.openxmlformats.org/drawingml/2006/main">
               <a:ext uri="{FF2B5EF4-FFF2-40B4-BE49-F238E27FC236}">
-                <a16:creationId xmlns:a16="http://schemas.microsoft.com/office/drawing/2014/main" id="{A2CADD41-82FA-427D-B0F1-53AFDBF735BC}"/>
+                <a16:creationId xmlns:a16="http://schemas.microsoft.com/office/drawing/2014/main" id="{814E15A7-14A0-4EBD-AA91-1BDFE2EF9F33}"/>
               </a:ext>
             </a:extLst>
           </p:cNvPr>
@@ -5110,7 +5110,7 @@
           <p:cNvPr id="21" name="">
             <a:extLst xmlns:a="http://schemas.openxmlformats.org/drawingml/2006/main">
               <a:ext uri="{FF2B5EF4-FFF2-40B4-BE49-F238E27FC236}">
-                <a16:creationId xmlns:a16="http://schemas.microsoft.com/office/drawing/2014/main" id="{DC8F2EF5-F5CB-46EA-AD45-1B2A7AEF66E7}"/>
+                <a16:creationId xmlns:a16="http://schemas.microsoft.com/office/drawing/2014/main" id="{9D015403-4B79-4BA7-BB9A-3C02BF1513FA}"/>
               </a:ext>
             </a:extLst>
           </p:cNvPr>
@@ -5167,7 +5167,7 @@
           <p:cNvPr id="22" name="">
             <a:extLst xmlns:a="http://schemas.openxmlformats.org/drawingml/2006/main">
               <a:ext uri="{FF2B5EF4-FFF2-40B4-BE49-F238E27FC236}">
-                <a16:creationId xmlns:a16="http://schemas.microsoft.com/office/drawing/2014/main" id="{505D5FAA-B911-48F1-AB6A-622624495141}"/>
+                <a16:creationId xmlns:a16="http://schemas.microsoft.com/office/drawing/2014/main" id="{B73F83C8-966A-4832-B4D0-FDE570EA85A5}"/>
               </a:ext>
             </a:extLst>
           </p:cNvPr>
@@ -5224,7 +5224,7 @@
           <p:cNvPr id="23" name="">
             <a:extLst xmlns:a="http://schemas.openxmlformats.org/drawingml/2006/main">
               <a:ext uri="{FF2B5EF4-FFF2-40B4-BE49-F238E27FC236}">
-                <a16:creationId xmlns:a16="http://schemas.microsoft.com/office/drawing/2014/main" id="{A8DCCD34-1686-4C8A-9250-8334D6C6B6D2}"/>
+                <a16:creationId xmlns:a16="http://schemas.microsoft.com/office/drawing/2014/main" id="{B2515A4B-1A53-49AD-BF61-D68EC5288D09}"/>
               </a:ext>
             </a:extLst>
           </p:cNvPr>
@@ -5254,7 +5254,7 @@
           <p:cNvPr id="24" name="">
             <a:extLst xmlns:a="http://schemas.openxmlformats.org/drawingml/2006/main">
               <a:ext uri="{FF2B5EF4-FFF2-40B4-BE49-F238E27FC236}">
-                <a16:creationId xmlns:a16="http://schemas.microsoft.com/office/drawing/2014/main" id="{294748F1-C119-4A0A-BA83-5CB051AEE8D9}"/>
+                <a16:creationId xmlns:a16="http://schemas.microsoft.com/office/drawing/2014/main" id="{83CF0A87-82B9-4B16-956A-47DA203E78FB}"/>
               </a:ext>
             </a:extLst>
           </p:cNvPr>
@@ -5288,7 +5288,7 @@
           <p:cNvPr id="25" name="">
             <a:extLst xmlns:a="http://schemas.openxmlformats.org/drawingml/2006/main">
               <a:ext uri="{FF2B5EF4-FFF2-40B4-BE49-F238E27FC236}">
-                <a16:creationId xmlns:a16="http://schemas.microsoft.com/office/drawing/2014/main" id="{A4AC8D93-60DB-421D-842D-8B9ABEED1D67}"/>
+                <a16:creationId xmlns:a16="http://schemas.microsoft.com/office/drawing/2014/main" id="{0FE7E642-67BF-44F8-9343-3ED871C79E72}"/>
               </a:ext>
             </a:extLst>
           </p:cNvPr>
@@ -5320,7 +5320,7 @@
           <p:cNvPr id="26" name="">
             <a:extLst xmlns:a="http://schemas.openxmlformats.org/drawingml/2006/main">
               <a:ext uri="{FF2B5EF4-FFF2-40B4-BE49-F238E27FC236}">
-                <a16:creationId xmlns:a16="http://schemas.microsoft.com/office/drawing/2014/main" id="{C7824557-B7E9-41D5-ABB1-A9401CDF540D}"/>
+                <a16:creationId xmlns:a16="http://schemas.microsoft.com/office/drawing/2014/main" id="{FD1A5DEE-2DA2-409B-8FD1-1F4D42DBE038}"/>
               </a:ext>
             </a:extLst>
           </p:cNvPr>
@@ -5377,7 +5377,7 @@
           <p:cNvPr id="27" name="">
             <a:extLst xmlns:a="http://schemas.openxmlformats.org/drawingml/2006/main">
               <a:ext uri="{FF2B5EF4-FFF2-40B4-BE49-F238E27FC236}">
-                <a16:creationId xmlns:a16="http://schemas.microsoft.com/office/drawing/2014/main" id="{7D448AD3-D0B6-4CDC-A9E0-7BA0CD10F675}"/>
+                <a16:creationId xmlns:a16="http://schemas.microsoft.com/office/drawing/2014/main" id="{DA69CFDC-669C-48AA-A440-1D25FDF1A45E}"/>
               </a:ext>
             </a:extLst>
           </p:cNvPr>
@@ -5434,7 +5434,7 @@
           <p:cNvPr id="28" name="">
             <a:extLst xmlns:a="http://schemas.openxmlformats.org/drawingml/2006/main">
               <a:ext uri="{FF2B5EF4-FFF2-40B4-BE49-F238E27FC236}">
-                <a16:creationId xmlns:a16="http://schemas.microsoft.com/office/drawing/2014/main" id="{6A8D3AE7-D45E-4347-B4EC-8A75C05F6222}"/>
+                <a16:creationId xmlns:a16="http://schemas.microsoft.com/office/drawing/2014/main" id="{78B0B0B7-C44F-433A-A8E3-9BFF6306A617}"/>
               </a:ext>
             </a:extLst>
           </p:cNvPr>
@@ -5491,7 +5491,7 @@
           <p:cNvPr id="29" name="">
             <a:extLst xmlns:a="http://schemas.openxmlformats.org/drawingml/2006/main">
               <a:ext uri="{FF2B5EF4-FFF2-40B4-BE49-F238E27FC236}">
-                <a16:creationId xmlns:a16="http://schemas.microsoft.com/office/drawing/2014/main" id="{2AB37C5E-6D76-4854-8490-7DE872C1D95E}"/>
+                <a16:creationId xmlns:a16="http://schemas.microsoft.com/office/drawing/2014/main" id="{2768DBAC-6101-407F-A17B-CC8A5D3C0C18}"/>
               </a:ext>
             </a:extLst>
           </p:cNvPr>
@@ -5521,7 +5521,7 @@
           <p:cNvPr id="30" name="">
             <a:extLst xmlns:a="http://schemas.openxmlformats.org/drawingml/2006/main">
               <a:ext uri="{FF2B5EF4-FFF2-40B4-BE49-F238E27FC236}">
-                <a16:creationId xmlns:a16="http://schemas.microsoft.com/office/drawing/2014/main" id="{D90549E9-3338-4A5C-BC02-11477B05BAE0}"/>
+                <a16:creationId xmlns:a16="http://schemas.microsoft.com/office/drawing/2014/main" id="{244CAA04-A447-4408-87A9-90AA1931AFAB}"/>
               </a:ext>
             </a:extLst>
           </p:cNvPr>
@@ -5555,7 +5555,7 @@
           <p:cNvPr id="31" name="">
             <a:extLst xmlns:a="http://schemas.openxmlformats.org/drawingml/2006/main">
               <a:ext uri="{FF2B5EF4-FFF2-40B4-BE49-F238E27FC236}">
-                <a16:creationId xmlns:a16="http://schemas.microsoft.com/office/drawing/2014/main" id="{38494FAD-B77B-469F-88E0-D1C8DA1121F4}"/>
+                <a16:creationId xmlns:a16="http://schemas.microsoft.com/office/drawing/2014/main" id="{2C646DC0-FC88-459A-B08F-7C67E78FC426}"/>
               </a:ext>
             </a:extLst>
           </p:cNvPr>
@@ -5587,7 +5587,7 @@
           <p:cNvPr id="32" name="">
             <a:extLst xmlns:a="http://schemas.openxmlformats.org/drawingml/2006/main">
               <a:ext uri="{FF2B5EF4-FFF2-40B4-BE49-F238E27FC236}">
-                <a16:creationId xmlns:a16="http://schemas.microsoft.com/office/drawing/2014/main" id="{BF0BC6C1-B066-408A-8161-B1BF9E9E0F48}"/>
+                <a16:creationId xmlns:a16="http://schemas.microsoft.com/office/drawing/2014/main" id="{5A73E1E3-E8F6-4B5C-8199-0F582CF6503A}"/>
               </a:ext>
             </a:extLst>
           </p:cNvPr>
@@ -5644,7 +5644,7 @@
           <p:cNvPr id="33" name="">
             <a:extLst xmlns:a="http://schemas.openxmlformats.org/drawingml/2006/main">
               <a:ext uri="{FF2B5EF4-FFF2-40B4-BE49-F238E27FC236}">
-                <a16:creationId xmlns:a16="http://schemas.microsoft.com/office/drawing/2014/main" id="{4E27B85F-F3D6-4206-AA2A-99B39FA0710D}"/>
+                <a16:creationId xmlns:a16="http://schemas.microsoft.com/office/drawing/2014/main" id="{EA0BB935-6303-465D-B07C-30F9C20ABEFC}"/>
               </a:ext>
             </a:extLst>
           </p:cNvPr>
@@ -5701,7 +5701,7 @@
           <p:cNvPr id="34" name="">
             <a:extLst xmlns:a="http://schemas.openxmlformats.org/drawingml/2006/main">
               <a:ext uri="{FF2B5EF4-FFF2-40B4-BE49-F238E27FC236}">
-                <a16:creationId xmlns:a16="http://schemas.microsoft.com/office/drawing/2014/main" id="{C3328018-682F-4CDC-AD81-3D4605C6B8A4}"/>
+                <a16:creationId xmlns:a16="http://schemas.microsoft.com/office/drawing/2014/main" id="{DF550ABA-8790-4B3A-9016-E292BA13F4E1}"/>
               </a:ext>
             </a:extLst>
           </p:cNvPr>
@@ -5758,7 +5758,7 @@
           <p:cNvPr id="35" name="">
             <a:extLst xmlns:a="http://schemas.openxmlformats.org/drawingml/2006/main">
               <a:ext uri="{FF2B5EF4-FFF2-40B4-BE49-F238E27FC236}">
-                <a16:creationId xmlns:a16="http://schemas.microsoft.com/office/drawing/2014/main" id="{DCCAC21B-4178-4BD3-92DA-EAC92A3DDE71}"/>
+                <a16:creationId xmlns:a16="http://schemas.microsoft.com/office/drawing/2014/main" id="{8DF0171E-5FFA-4B3A-9CB4-887652A51F87}"/>
               </a:ext>
             </a:extLst>
           </p:cNvPr>
@@ -5788,7 +5788,7 @@
           <p:cNvPr id="36" name="">
             <a:extLst xmlns:a="http://schemas.openxmlformats.org/drawingml/2006/main">
               <a:ext uri="{FF2B5EF4-FFF2-40B4-BE49-F238E27FC236}">
-                <a16:creationId xmlns:a16="http://schemas.microsoft.com/office/drawing/2014/main" id="{E169117A-6A11-4571-9516-D5453D7D33FC}"/>
+                <a16:creationId xmlns:a16="http://schemas.microsoft.com/office/drawing/2014/main" id="{5547D4C2-1D7C-48E1-9137-9585E51126EF}"/>
               </a:ext>
             </a:extLst>
           </p:cNvPr>
@@ -5822,7 +5822,7 @@
           <p:cNvPr id="37" name="">
             <a:extLst xmlns:a="http://schemas.openxmlformats.org/drawingml/2006/main">
               <a:ext uri="{FF2B5EF4-FFF2-40B4-BE49-F238E27FC236}">
-                <a16:creationId xmlns:a16="http://schemas.microsoft.com/office/drawing/2014/main" id="{03EB4AD0-1FF5-4C0B-B8D4-49C3668235E2}"/>
+                <a16:creationId xmlns:a16="http://schemas.microsoft.com/office/drawing/2014/main" id="{EF4E2F5F-4C54-4E40-835B-9EC56C2F974E}"/>
               </a:ext>
             </a:extLst>
           </p:cNvPr>
@@ -5854,7 +5854,7 @@
           <p:cNvPr id="38" name="">
             <a:extLst xmlns:a="http://schemas.openxmlformats.org/drawingml/2006/main">
               <a:ext uri="{FF2B5EF4-FFF2-40B4-BE49-F238E27FC236}">
-                <a16:creationId xmlns:a16="http://schemas.microsoft.com/office/drawing/2014/main" id="{0983BD9D-F453-4F98-9A69-1386CBB1621C}"/>
+                <a16:creationId xmlns:a16="http://schemas.microsoft.com/office/drawing/2014/main" id="{B5ADBE04-E087-4723-99DE-15307D415958}"/>
               </a:ext>
             </a:extLst>
           </p:cNvPr>
@@ -5911,7 +5911,7 @@
           <p:cNvPr id="39" name="">
             <a:extLst xmlns:a="http://schemas.openxmlformats.org/drawingml/2006/main">
               <a:ext uri="{FF2B5EF4-FFF2-40B4-BE49-F238E27FC236}">
-                <a16:creationId xmlns:a16="http://schemas.microsoft.com/office/drawing/2014/main" id="{4770B9B6-D556-4AA7-B39B-EE08F605FBFB}"/>
+                <a16:creationId xmlns:a16="http://schemas.microsoft.com/office/drawing/2014/main" id="{4C822F58-0567-4539-8874-3EC8ADABE143}"/>
               </a:ext>
             </a:extLst>
           </p:cNvPr>
@@ -5968,7 +5968,7 @@
           <p:cNvPr id="40" name="">
             <a:extLst xmlns:a="http://schemas.openxmlformats.org/drawingml/2006/main">
               <a:ext uri="{FF2B5EF4-FFF2-40B4-BE49-F238E27FC236}">
-                <a16:creationId xmlns:a16="http://schemas.microsoft.com/office/drawing/2014/main" id="{C9B9EDBD-7BC8-42B4-815F-682C230394B8}"/>
+                <a16:creationId xmlns:a16="http://schemas.microsoft.com/office/drawing/2014/main" id="{4679FCB5-2953-4260-940B-D31B0ADF160F}"/>
               </a:ext>
             </a:extLst>
           </p:cNvPr>
@@ -6025,7 +6025,7 @@
           <p:cNvPr id="41" name="">
             <a:extLst xmlns:a="http://schemas.openxmlformats.org/drawingml/2006/main">
               <a:ext uri="{FF2B5EF4-FFF2-40B4-BE49-F238E27FC236}">
-                <a16:creationId xmlns:a16="http://schemas.microsoft.com/office/drawing/2014/main" id="{564F3662-76E8-4B87-94C8-B0E8F332A62D}"/>
+                <a16:creationId xmlns:a16="http://schemas.microsoft.com/office/drawing/2014/main" id="{E0B5CAD6-8E86-4387-8356-74DC720B520A}"/>
               </a:ext>
             </a:extLst>
           </p:cNvPr>
@@ -6082,7 +6082,7 @@
           <p:cNvPr id="42" name="">
             <a:extLst xmlns:a="http://schemas.openxmlformats.org/drawingml/2006/main">
               <a:ext uri="{FF2B5EF4-FFF2-40B4-BE49-F238E27FC236}">
-                <a16:creationId xmlns:a16="http://schemas.microsoft.com/office/drawing/2014/main" id="{4DF498D6-6D2E-4F75-B4FB-9F4EC99C651D}"/>
+                <a16:creationId xmlns:a16="http://schemas.microsoft.com/office/drawing/2014/main" id="{D2871928-D8FF-4F0D-9BCC-5CA4B4934581}"/>
               </a:ext>
             </a:extLst>
           </p:cNvPr>
@@ -6114,7 +6114,7 @@
           <p:cNvPr id="43" name="">
             <a:extLst xmlns:a="http://schemas.openxmlformats.org/drawingml/2006/main">
               <a:ext uri="{FF2B5EF4-FFF2-40B4-BE49-F238E27FC236}">
-                <a16:creationId xmlns:a16="http://schemas.microsoft.com/office/drawing/2014/main" id="{241F8B91-A5FC-44FC-9649-5F4A4FC3F65C}"/>
+                <a16:creationId xmlns:a16="http://schemas.microsoft.com/office/drawing/2014/main" id="{0D4F73EA-716D-4BDF-A958-958B8AA061B8}"/>
               </a:ext>
             </a:extLst>
           </p:cNvPr>
@@ -6171,7 +6171,7 @@
           <p:cNvPr id="44" name="">
             <a:extLst xmlns:a="http://schemas.openxmlformats.org/drawingml/2006/main">
               <a:ext uri="{FF2B5EF4-FFF2-40B4-BE49-F238E27FC236}">
-                <a16:creationId xmlns:a16="http://schemas.microsoft.com/office/drawing/2014/main" id="{96AFB86E-7281-4234-B8FE-0EF9B5CC7113}"/>
+                <a16:creationId xmlns:a16="http://schemas.microsoft.com/office/drawing/2014/main" id="{FCB78B87-FA4D-4497-959E-F6F71C431988}"/>
               </a:ext>
             </a:extLst>
           </p:cNvPr>
@@ -6228,7 +6228,7 @@
           <p:cNvPr id="45" name="">
             <a:extLst xmlns:a="http://schemas.openxmlformats.org/drawingml/2006/main">
               <a:ext uri="{FF2B5EF4-FFF2-40B4-BE49-F238E27FC236}">
-                <a16:creationId xmlns:a16="http://schemas.microsoft.com/office/drawing/2014/main" id="{C92953D0-B903-4E37-80C4-8B9B66635152}"/>
+                <a16:creationId xmlns:a16="http://schemas.microsoft.com/office/drawing/2014/main" id="{D07928A8-3E9A-4F1D-948E-5C56D73787F1}"/>
               </a:ext>
             </a:extLst>
           </p:cNvPr>
@@ -6285,7 +6285,7 @@
           <p:cNvPr id="46" name="">
             <a:extLst xmlns:a="http://schemas.openxmlformats.org/drawingml/2006/main">
               <a:ext uri="{FF2B5EF4-FFF2-40B4-BE49-F238E27FC236}">
-                <a16:creationId xmlns:a16="http://schemas.microsoft.com/office/drawing/2014/main" id="{340C8274-C458-4630-B0CC-500C97EB9E11}"/>
+                <a16:creationId xmlns:a16="http://schemas.microsoft.com/office/drawing/2014/main" id="{7C3D2FA8-88A0-45BD-B6BD-59912C151B70}"/>
               </a:ext>
             </a:extLst>
           </p:cNvPr>
@@ -6342,7 +6342,7 @@
           <p:cNvPr id="47" name="">
             <a:extLst xmlns:a="http://schemas.openxmlformats.org/drawingml/2006/main">
               <a:ext uri="{FF2B5EF4-FFF2-40B4-BE49-F238E27FC236}">
-                <a16:creationId xmlns:a16="http://schemas.microsoft.com/office/drawing/2014/main" id="{EEB4A7A7-972D-43E2-A242-49B8A9A8C99E}"/>
+                <a16:creationId xmlns:a16="http://schemas.microsoft.com/office/drawing/2014/main" id="{BF01C491-5641-43DC-ABF8-228FEA6F5546}"/>
               </a:ext>
             </a:extLst>
           </p:cNvPr>
@@ -6399,7 +6399,7 @@
           <p:cNvPr id="48" name="">
             <a:extLst xmlns:a="http://schemas.openxmlformats.org/drawingml/2006/main">
               <a:ext uri="{FF2B5EF4-FFF2-40B4-BE49-F238E27FC236}">
-                <a16:creationId xmlns:a16="http://schemas.microsoft.com/office/drawing/2014/main" id="{4DAAC224-51C5-421B-BA42-8329BB83F293}"/>
+                <a16:creationId xmlns:a16="http://schemas.microsoft.com/office/drawing/2014/main" id="{0638137A-E622-446E-BF57-798340F594C6}"/>
               </a:ext>
             </a:extLst>
           </p:cNvPr>
@@ -6456,7 +6456,7 @@
           <p:cNvPr id="49" name="">
             <a:extLst xmlns:a="http://schemas.openxmlformats.org/drawingml/2006/main">
               <a:ext uri="{FF2B5EF4-FFF2-40B4-BE49-F238E27FC236}">
-                <a16:creationId xmlns:a16="http://schemas.microsoft.com/office/drawing/2014/main" id="{A26CDF2A-FD7F-49C8-A69F-2A4935ADD368}"/>
+                <a16:creationId xmlns:a16="http://schemas.microsoft.com/office/drawing/2014/main" id="{6986A958-1B5E-4E52-A77C-D84EDDB8225F}"/>
               </a:ext>
             </a:extLst>
           </p:cNvPr>
@@ -6513,7 +6513,7 @@
           <p:cNvPr id="50" name="">
             <a:extLst xmlns:a="http://schemas.openxmlformats.org/drawingml/2006/main">
               <a:ext uri="{FF2B5EF4-FFF2-40B4-BE49-F238E27FC236}">
-                <a16:creationId xmlns:a16="http://schemas.microsoft.com/office/drawing/2014/main" id="{76ACAC60-5AAA-4118-B518-402F83E23843}"/>
+                <a16:creationId xmlns:a16="http://schemas.microsoft.com/office/drawing/2014/main" id="{030D383E-1A02-4E6D-AA34-6296C62B643B}"/>
               </a:ext>
             </a:extLst>
           </p:cNvPr>
@@ -6593,7 +6593,7 @@
           <p:cNvPr id="51" name="">
             <a:extLst xmlns:a="http://schemas.openxmlformats.org/drawingml/2006/main">
               <a:ext uri="{FF2B5EF4-FFF2-40B4-BE49-F238E27FC236}">
-                <a16:creationId xmlns:a16="http://schemas.microsoft.com/office/drawing/2014/main" id="{29AA84BA-2D15-44F2-825A-181036A3E486}"/>
+                <a16:creationId xmlns:a16="http://schemas.microsoft.com/office/drawing/2014/main" id="{ADEC3B8B-8413-491E-B721-F159EB9BD0B7}"/>
               </a:ext>
             </a:extLst>
           </p:cNvPr>
@@ -6650,7 +6650,7 @@
           <p:cNvPr id="52" name="">
             <a:extLst xmlns:a="http://schemas.openxmlformats.org/drawingml/2006/main">
               <a:ext uri="{FF2B5EF4-FFF2-40B4-BE49-F238E27FC236}">
-                <a16:creationId xmlns:a16="http://schemas.microsoft.com/office/drawing/2014/main" id="{E9121261-A367-41D4-B357-ED6A94AA0A09}"/>
+                <a16:creationId xmlns:a16="http://schemas.microsoft.com/office/drawing/2014/main" id="{3A7C0B19-01F5-441B-B3F8-3570836294E4}"/>
               </a:ext>
             </a:extLst>
           </p:cNvPr>
@@ -6730,7 +6730,7 @@
           <p:cNvPr id="53" name="">
             <a:extLst xmlns:a="http://schemas.openxmlformats.org/drawingml/2006/main">
               <a:ext uri="{FF2B5EF4-FFF2-40B4-BE49-F238E27FC236}">
-                <a16:creationId xmlns:a16="http://schemas.microsoft.com/office/drawing/2014/main" id="{7FCB778B-4C4C-47FB-99BA-D074AF53872E}"/>
+                <a16:creationId xmlns:a16="http://schemas.microsoft.com/office/drawing/2014/main" id="{3A01DC34-1758-4C01-9EC1-3BAFA98775A4}"/>
               </a:ext>
             </a:extLst>
           </p:cNvPr>
@@ -6787,7 +6787,7 @@
           <p:cNvPr id="54" name="">
             <a:extLst xmlns:a="http://schemas.openxmlformats.org/drawingml/2006/main">
               <a:ext uri="{FF2B5EF4-FFF2-40B4-BE49-F238E27FC236}">
-                <a16:creationId xmlns:a16="http://schemas.microsoft.com/office/drawing/2014/main" id="{E4109BC0-B15C-436F-88F5-1F41BF164FE6}"/>
+                <a16:creationId xmlns:a16="http://schemas.microsoft.com/office/drawing/2014/main" id="{B22587A5-E9DE-4DAD-9299-C365E5DA0FAC}"/>
               </a:ext>
             </a:extLst>
           </p:cNvPr>
@@ -6867,7 +6867,7 @@
           <p:cNvPr id="55" name="">
             <a:extLst xmlns:a="http://schemas.openxmlformats.org/drawingml/2006/main">
               <a:ext uri="{FF2B5EF4-FFF2-40B4-BE49-F238E27FC236}">
-                <a16:creationId xmlns:a16="http://schemas.microsoft.com/office/drawing/2014/main" id="{7838BF10-383F-4C63-928A-DC1E3F621D1B}"/>
+                <a16:creationId xmlns:a16="http://schemas.microsoft.com/office/drawing/2014/main" id="{47DBD8D4-EDD9-401C-94B2-5F883772B281}"/>
               </a:ext>
             </a:extLst>
           </p:cNvPr>
@@ -6899,7 +6899,7 @@
           <p:cNvPr id="56" name="">
             <a:extLst xmlns:a="http://schemas.openxmlformats.org/drawingml/2006/main">
               <a:ext uri="{FF2B5EF4-FFF2-40B4-BE49-F238E27FC236}">
-                <a16:creationId xmlns:a16="http://schemas.microsoft.com/office/drawing/2014/main" id="{E76480E4-25AA-4F00-B09A-8796F192FF0E}"/>
+                <a16:creationId xmlns:a16="http://schemas.microsoft.com/office/drawing/2014/main" id="{D2A13A4B-6F4F-4D25-A128-6231BF7918EC}"/>
               </a:ext>
             </a:extLst>
           </p:cNvPr>
@@ -6954,7 +6954,7 @@
     </p:spTree>
     <p:extLst>
       <p:ext uri="{BB962C8B-B14F-4D97-AF65-F5344CB8AC3E}">
-        <p14:creationId xmlns:p14="http://schemas.microsoft.com/office/powerpoint/2010/main" val="671958288"/>
+        <p14:creationId xmlns:p14="http://schemas.microsoft.com/office/powerpoint/2010/main" val="369713276"/>
       </p:ext>
     </p:extLst>
   </p:cSld>
@@ -6985,7 +6985,7 @@
           <p:cNvPr id="44" name="">
             <a:extLst xmlns:a="http://schemas.openxmlformats.org/drawingml/2006/main">
               <a:ext uri="{FF2B5EF4-FFF2-40B4-BE49-F238E27FC236}">
-                <a16:creationId xmlns:a16="http://schemas.microsoft.com/office/drawing/2014/main" id="{D45EA8FE-718C-4A7E-9300-30B7A19D70F5}"/>
+                <a16:creationId xmlns:a16="http://schemas.microsoft.com/office/drawing/2014/main" id="{A301DC41-1C2D-4F2B-AD8C-85A5ECD61ED2}"/>
               </a:ext>
             </a:extLst>
           </p:cNvPr>
@@ -7015,7 +7015,7 @@
           <p:cNvPr id="2" name="">
             <a:extLst xmlns:a="http://schemas.openxmlformats.org/drawingml/2006/main">
               <a:ext uri="{FF2B5EF4-FFF2-40B4-BE49-F238E27FC236}">
-                <a16:creationId xmlns:a16="http://schemas.microsoft.com/office/drawing/2014/main" id="{8BD59600-4BBC-4D26-9795-9604A15C7E2D}"/>
+                <a16:creationId xmlns:a16="http://schemas.microsoft.com/office/drawing/2014/main" id="{1E441AA8-0B20-43C2-BBB8-95CF06C50F6E}"/>
               </a:ext>
             </a:extLst>
           </p:cNvPr>
@@ -7072,7 +7072,7 @@
           <p:cNvPr id="3" name="">
             <a:extLst xmlns:a="http://schemas.openxmlformats.org/drawingml/2006/main">
               <a:ext uri="{FF2B5EF4-FFF2-40B4-BE49-F238E27FC236}">
-                <a16:creationId xmlns:a16="http://schemas.microsoft.com/office/drawing/2014/main" id="{380662E1-0A63-42E6-9E82-0C2254C314E7}"/>
+                <a16:creationId xmlns:a16="http://schemas.microsoft.com/office/drawing/2014/main" id="{42BBCC6D-ADA0-4C2C-8562-9949078E652D}"/>
               </a:ext>
             </a:extLst>
           </p:cNvPr>
@@ -7102,7 +7102,7 @@
           <p:cNvPr id="4" name="">
             <a:extLst xmlns:a="http://schemas.openxmlformats.org/drawingml/2006/main">
               <a:ext uri="{FF2B5EF4-FFF2-40B4-BE49-F238E27FC236}">
-                <a16:creationId xmlns:a16="http://schemas.microsoft.com/office/drawing/2014/main" id="{DA2BCA77-4294-46D9-852A-3FB8EC2CA539}"/>
+                <a16:creationId xmlns:a16="http://schemas.microsoft.com/office/drawing/2014/main" id="{3C39DFE0-6BFD-4C84-BB8D-EA22FF6D0B1A}"/>
               </a:ext>
             </a:extLst>
           </p:cNvPr>
@@ -7159,7 +7159,7 @@
           <p:cNvPr id="5" name="">
             <a:extLst xmlns:a="http://schemas.openxmlformats.org/drawingml/2006/main">
               <a:ext uri="{FF2B5EF4-FFF2-40B4-BE49-F238E27FC236}">
-                <a16:creationId xmlns:a16="http://schemas.microsoft.com/office/drawing/2014/main" id="{E39F366E-506B-490E-BFF1-5804212885C7}"/>
+                <a16:creationId xmlns:a16="http://schemas.microsoft.com/office/drawing/2014/main" id="{21123301-B235-4A6C-A941-86438BE10626}"/>
               </a:ext>
             </a:extLst>
           </p:cNvPr>
@@ -7216,7 +7216,7 @@
           <p:cNvPr id="6" name="">
             <a:extLst xmlns:a="http://schemas.openxmlformats.org/drawingml/2006/main">
               <a:ext uri="{FF2B5EF4-FFF2-40B4-BE49-F238E27FC236}">
-                <a16:creationId xmlns:a16="http://schemas.microsoft.com/office/drawing/2014/main" id="{77685EFF-5BCA-404B-A196-021AECE10538}"/>
+                <a16:creationId xmlns:a16="http://schemas.microsoft.com/office/drawing/2014/main" id="{43AEF528-3075-4C82-934D-F07CBD6C80FD}"/>
               </a:ext>
             </a:extLst>
           </p:cNvPr>
@@ -7273,7 +7273,7 @@
           <p:cNvPr id="7" name="">
             <a:extLst xmlns:a="http://schemas.openxmlformats.org/drawingml/2006/main">
               <a:ext uri="{FF2B5EF4-FFF2-40B4-BE49-F238E27FC236}">
-                <a16:creationId xmlns:a16="http://schemas.microsoft.com/office/drawing/2014/main" id="{DBEDFF91-9E6B-44C8-B842-4B63986E4A30}"/>
+                <a16:creationId xmlns:a16="http://schemas.microsoft.com/office/drawing/2014/main" id="{337FACAB-384A-47F5-B56E-73E3FE8BBF70}"/>
               </a:ext>
             </a:extLst>
           </p:cNvPr>
@@ -7303,7 +7303,7 @@
           <p:cNvPr id="8" name="">
             <a:extLst xmlns:a="http://schemas.openxmlformats.org/drawingml/2006/main">
               <a:ext uri="{FF2B5EF4-FFF2-40B4-BE49-F238E27FC236}">
-                <a16:creationId xmlns:a16="http://schemas.microsoft.com/office/drawing/2014/main" id="{0E9BD3E0-E427-4AB1-80C8-FD0BF3A88558}"/>
+                <a16:creationId xmlns:a16="http://schemas.microsoft.com/office/drawing/2014/main" id="{C580BC1A-D137-4562-9597-D5EAD378EB6F}"/>
               </a:ext>
             </a:extLst>
           </p:cNvPr>
@@ -7360,7 +7360,7 @@
           <p:cNvPr id="9" name="">
             <a:extLst xmlns:a="http://schemas.openxmlformats.org/drawingml/2006/main">
               <a:ext uri="{FF2B5EF4-FFF2-40B4-BE49-F238E27FC236}">
-                <a16:creationId xmlns:a16="http://schemas.microsoft.com/office/drawing/2014/main" id="{1A722D93-1DE7-47F0-918C-95CDCBB4DC49}"/>
+                <a16:creationId xmlns:a16="http://schemas.microsoft.com/office/drawing/2014/main" id="{988620DA-64C5-46B9-A3DE-86BF2EEDFD52}"/>
               </a:ext>
             </a:extLst>
           </p:cNvPr>
@@ -7407,7 +7407,7 @@
                 <a:ea typeface="Malgun Gothic"/>
                 <a:cs typeface="Malgun Gothic"/>
               </a:rPr>
-              <a:t>적용 기법  |  Bounded Deliberation + 제한적 ReAct Self-Correction</a:t>
+              <a:t>적용 기법  |  Bounded Multi-Hypothesis Deliberation + 제한적 ReAct Self-Correction</a:t>
             </a:r>
           </a:p>
         </p:txBody>
@@ -7417,7 +7417,7 @@
           <p:cNvPr id="10" name="">
             <a:extLst xmlns:a="http://schemas.openxmlformats.org/drawingml/2006/main">
               <a:ext uri="{FF2B5EF4-FFF2-40B4-BE49-F238E27FC236}">
-                <a16:creationId xmlns:a16="http://schemas.microsoft.com/office/drawing/2014/main" id="{F16D4674-DE55-4740-8006-96AA05EBB2E9}"/>
+                <a16:creationId xmlns:a16="http://schemas.microsoft.com/office/drawing/2014/main" id="{09E453D0-7C6D-4EDA-9434-4ECB9EC813D5}"/>
               </a:ext>
             </a:extLst>
           </p:cNvPr>
@@ -7474,7 +7474,7 @@
           <p:cNvPr id="11" name="">
             <a:extLst xmlns:a="http://schemas.openxmlformats.org/drawingml/2006/main">
               <a:ext uri="{FF2B5EF4-FFF2-40B4-BE49-F238E27FC236}">
-                <a16:creationId xmlns:a16="http://schemas.microsoft.com/office/drawing/2014/main" id="{6994D7A4-50E1-4FB9-81D4-CF15053C8291}"/>
+                <a16:creationId xmlns:a16="http://schemas.microsoft.com/office/drawing/2014/main" id="{EDB7A92D-DDC1-460E-BD99-6D6A67F81D53}"/>
               </a:ext>
             </a:extLst>
           </p:cNvPr>
@@ -7506,7 +7506,7 @@
           <p:cNvPr id="12" name="">
             <a:extLst xmlns:a="http://schemas.openxmlformats.org/drawingml/2006/main">
               <a:ext uri="{FF2B5EF4-FFF2-40B4-BE49-F238E27FC236}">
-                <a16:creationId xmlns:a16="http://schemas.microsoft.com/office/drawing/2014/main" id="{CBCF50F6-01DF-48D0-B245-DBE393FBDD29}"/>
+                <a16:creationId xmlns:a16="http://schemas.microsoft.com/office/drawing/2014/main" id="{6EFE7D67-3C66-4327-82BF-6EEF58D1C99B}"/>
               </a:ext>
             </a:extLst>
           </p:cNvPr>
@@ -7563,7 +7563,7 @@
           <p:cNvPr id="13" name="">
             <a:extLst xmlns:a="http://schemas.openxmlformats.org/drawingml/2006/main">
               <a:ext uri="{FF2B5EF4-FFF2-40B4-BE49-F238E27FC236}">
-                <a16:creationId xmlns:a16="http://schemas.microsoft.com/office/drawing/2014/main" id="{E758E61B-D2FA-4561-952E-4F103CB71C4E}"/>
+                <a16:creationId xmlns:a16="http://schemas.microsoft.com/office/drawing/2014/main" id="{2A6FC9DA-9C0A-453F-88D0-FF08F42D6105}"/>
               </a:ext>
             </a:extLst>
           </p:cNvPr>
@@ -7620,7 +7620,7 @@
           <p:cNvPr id="14" name="">
             <a:extLst xmlns:a="http://schemas.openxmlformats.org/drawingml/2006/main">
               <a:ext uri="{FF2B5EF4-FFF2-40B4-BE49-F238E27FC236}">
-                <a16:creationId xmlns:a16="http://schemas.microsoft.com/office/drawing/2014/main" id="{6B528EEB-507E-4C9A-831B-D1D04A20FA69}"/>
+                <a16:creationId xmlns:a16="http://schemas.microsoft.com/office/drawing/2014/main" id="{5FCDFFB2-D8C2-48DD-A7C3-66FB909A3E1B}"/>
               </a:ext>
             </a:extLst>
           </p:cNvPr>
@@ -7677,7 +7677,7 @@
           <p:cNvPr id="15" name="">
             <a:extLst xmlns:a="http://schemas.openxmlformats.org/drawingml/2006/main">
               <a:ext uri="{FF2B5EF4-FFF2-40B4-BE49-F238E27FC236}">
-                <a16:creationId xmlns:a16="http://schemas.microsoft.com/office/drawing/2014/main" id="{915DFB29-BB19-42AA-9933-A700A5E9E4A3}"/>
+                <a16:creationId xmlns:a16="http://schemas.microsoft.com/office/drawing/2014/main" id="{B6438852-EB3E-4EF1-96C0-CBBEAA34A865}"/>
               </a:ext>
             </a:extLst>
           </p:cNvPr>
@@ -7709,7 +7709,7 @@
           <p:cNvPr id="16" name="">
             <a:extLst xmlns:a="http://schemas.openxmlformats.org/drawingml/2006/main">
               <a:ext uri="{FF2B5EF4-FFF2-40B4-BE49-F238E27FC236}">
-                <a16:creationId xmlns:a16="http://schemas.microsoft.com/office/drawing/2014/main" id="{937F272D-5DCC-4315-A531-BD6616A0BBBF}"/>
+                <a16:creationId xmlns:a16="http://schemas.microsoft.com/office/drawing/2014/main" id="{F9BFADE9-876F-4F8B-8B7B-54A8B30752EA}"/>
               </a:ext>
             </a:extLst>
           </p:cNvPr>
@@ -7766,7 +7766,7 @@
           <p:cNvPr id="17" name="">
             <a:extLst xmlns:a="http://schemas.openxmlformats.org/drawingml/2006/main">
               <a:ext uri="{FF2B5EF4-FFF2-40B4-BE49-F238E27FC236}">
-                <a16:creationId xmlns:a16="http://schemas.microsoft.com/office/drawing/2014/main" id="{7CD6B9E3-D0D4-4405-8AFE-A33FB8310822}"/>
+                <a16:creationId xmlns:a16="http://schemas.microsoft.com/office/drawing/2014/main" id="{A053DEEA-4831-4437-951C-C6758EB7606C}"/>
               </a:ext>
             </a:extLst>
           </p:cNvPr>
@@ -7823,7 +7823,7 @@
           <p:cNvPr id="18" name="">
             <a:extLst xmlns:a="http://schemas.openxmlformats.org/drawingml/2006/main">
               <a:ext uri="{FF2B5EF4-FFF2-40B4-BE49-F238E27FC236}">
-                <a16:creationId xmlns:a16="http://schemas.microsoft.com/office/drawing/2014/main" id="{11A09723-3B0D-4F93-A163-8AEF8350C6AA}"/>
+                <a16:creationId xmlns:a16="http://schemas.microsoft.com/office/drawing/2014/main" id="{52A023B7-E1A1-4181-A7D8-1F29FD3CDAC1}"/>
               </a:ext>
             </a:extLst>
           </p:cNvPr>
@@ -7880,7 +7880,7 @@
           <p:cNvPr id="19" name="">
             <a:extLst xmlns:a="http://schemas.openxmlformats.org/drawingml/2006/main">
               <a:ext uri="{FF2B5EF4-FFF2-40B4-BE49-F238E27FC236}">
-                <a16:creationId xmlns:a16="http://schemas.microsoft.com/office/drawing/2014/main" id="{5B18B30F-B1BE-490B-A69F-6825A2E4F58F}"/>
+                <a16:creationId xmlns:a16="http://schemas.microsoft.com/office/drawing/2014/main" id="{2FC328A1-0695-4F8C-B87E-10FE3304A98F}"/>
               </a:ext>
             </a:extLst>
           </p:cNvPr>
@@ -7912,7 +7912,7 @@
           <p:cNvPr id="20" name="">
             <a:extLst xmlns:a="http://schemas.openxmlformats.org/drawingml/2006/main">
               <a:ext uri="{FF2B5EF4-FFF2-40B4-BE49-F238E27FC236}">
-                <a16:creationId xmlns:a16="http://schemas.microsoft.com/office/drawing/2014/main" id="{52649182-7600-41B7-8AAF-F5C9829DD3DD}"/>
+                <a16:creationId xmlns:a16="http://schemas.microsoft.com/office/drawing/2014/main" id="{C18024DC-158F-46EE-B3C0-B78FE066456A}"/>
               </a:ext>
             </a:extLst>
           </p:cNvPr>
@@ -7969,7 +7969,7 @@
           <p:cNvPr id="21" name="">
             <a:extLst xmlns:a="http://schemas.openxmlformats.org/drawingml/2006/main">
               <a:ext uri="{FF2B5EF4-FFF2-40B4-BE49-F238E27FC236}">
-                <a16:creationId xmlns:a16="http://schemas.microsoft.com/office/drawing/2014/main" id="{66F6EEEC-C706-4503-81D1-673174BB1789}"/>
+                <a16:creationId xmlns:a16="http://schemas.microsoft.com/office/drawing/2014/main" id="{11F5541D-32D3-47CD-83B2-247F91210B25}"/>
               </a:ext>
             </a:extLst>
           </p:cNvPr>
@@ -8026,7 +8026,7 @@
           <p:cNvPr id="22" name="">
             <a:extLst xmlns:a="http://schemas.openxmlformats.org/drawingml/2006/main">
               <a:ext uri="{FF2B5EF4-FFF2-40B4-BE49-F238E27FC236}">
-                <a16:creationId xmlns:a16="http://schemas.microsoft.com/office/drawing/2014/main" id="{446A9631-1B36-4CE2-BBE9-00EF581BDEAB}"/>
+                <a16:creationId xmlns:a16="http://schemas.microsoft.com/office/drawing/2014/main" id="{6B404302-E623-4D59-B408-384EB4DD5122}"/>
               </a:ext>
             </a:extLst>
           </p:cNvPr>
@@ -8083,7 +8083,7 @@
           <p:cNvPr id="23" name="">
             <a:extLst xmlns:a="http://schemas.openxmlformats.org/drawingml/2006/main">
               <a:ext uri="{FF2B5EF4-FFF2-40B4-BE49-F238E27FC236}">
-                <a16:creationId xmlns:a16="http://schemas.microsoft.com/office/drawing/2014/main" id="{9A34C278-8B83-418D-83E9-5ED1B08899A9}"/>
+                <a16:creationId xmlns:a16="http://schemas.microsoft.com/office/drawing/2014/main" id="{C6B13F5E-6A70-40DD-8B76-C644917C2996}"/>
               </a:ext>
             </a:extLst>
           </p:cNvPr>
@@ -8115,7 +8115,7 @@
           <p:cNvPr id="24" name="">
             <a:extLst xmlns:a="http://schemas.openxmlformats.org/drawingml/2006/main">
               <a:ext uri="{FF2B5EF4-FFF2-40B4-BE49-F238E27FC236}">
-                <a16:creationId xmlns:a16="http://schemas.microsoft.com/office/drawing/2014/main" id="{14203EBB-5D4D-411C-87BE-EA9EFCF75FC6}"/>
+                <a16:creationId xmlns:a16="http://schemas.microsoft.com/office/drawing/2014/main" id="{7878D297-AAE6-45E1-B57E-E5666F0103B0}"/>
               </a:ext>
             </a:extLst>
           </p:cNvPr>
@@ -8172,7 +8172,7 @@
           <p:cNvPr id="25" name="">
             <a:extLst xmlns:a="http://schemas.openxmlformats.org/drawingml/2006/main">
               <a:ext uri="{FF2B5EF4-FFF2-40B4-BE49-F238E27FC236}">
-                <a16:creationId xmlns:a16="http://schemas.microsoft.com/office/drawing/2014/main" id="{26686297-ADAC-4236-BD5F-1D19F8302BCB}"/>
+                <a16:creationId xmlns:a16="http://schemas.microsoft.com/office/drawing/2014/main" id="{A22CAF27-7B06-4654-81CA-A9E357FF9BAF}"/>
               </a:ext>
             </a:extLst>
           </p:cNvPr>
@@ -8229,7 +8229,7 @@
           <p:cNvPr id="26" name="">
             <a:extLst xmlns:a="http://schemas.openxmlformats.org/drawingml/2006/main">
               <a:ext uri="{FF2B5EF4-FFF2-40B4-BE49-F238E27FC236}">
-                <a16:creationId xmlns:a16="http://schemas.microsoft.com/office/drawing/2014/main" id="{986F2152-762D-4FFF-BE18-E7650F0A26A9}"/>
+                <a16:creationId xmlns:a16="http://schemas.microsoft.com/office/drawing/2014/main" id="{26A8002F-E131-4D00-8D13-05452E6801CA}"/>
               </a:ext>
             </a:extLst>
           </p:cNvPr>
@@ -8286,7 +8286,7 @@
           <p:cNvPr id="27" name="">
             <a:extLst xmlns:a="http://schemas.openxmlformats.org/drawingml/2006/main">
               <a:ext uri="{FF2B5EF4-FFF2-40B4-BE49-F238E27FC236}">
-                <a16:creationId xmlns:a16="http://schemas.microsoft.com/office/drawing/2014/main" id="{F9189868-CBFD-4D8B-A7CB-EDF5ACC1A2EA}"/>
+                <a16:creationId xmlns:a16="http://schemas.microsoft.com/office/drawing/2014/main" id="{57B10865-03BE-4644-8AA0-E81139C0850A}"/>
               </a:ext>
             </a:extLst>
           </p:cNvPr>
@@ -8318,7 +8318,7 @@
           <p:cNvPr id="28" name="">
             <a:extLst xmlns:a="http://schemas.openxmlformats.org/drawingml/2006/main">
               <a:ext uri="{FF2B5EF4-FFF2-40B4-BE49-F238E27FC236}">
-                <a16:creationId xmlns:a16="http://schemas.microsoft.com/office/drawing/2014/main" id="{8C73E783-A828-4375-A658-A3D1FE533BC4}"/>
+                <a16:creationId xmlns:a16="http://schemas.microsoft.com/office/drawing/2014/main" id="{BA433EC9-20EA-4BC3-BDC4-FD148E35BC28}"/>
               </a:ext>
             </a:extLst>
           </p:cNvPr>
@@ -8375,7 +8375,7 @@
           <p:cNvPr id="29" name="">
             <a:extLst xmlns:a="http://schemas.openxmlformats.org/drawingml/2006/main">
               <a:ext uri="{FF2B5EF4-FFF2-40B4-BE49-F238E27FC236}">
-                <a16:creationId xmlns:a16="http://schemas.microsoft.com/office/drawing/2014/main" id="{96D70B26-2BD2-4E67-8349-BF8580236D11}"/>
+                <a16:creationId xmlns:a16="http://schemas.microsoft.com/office/drawing/2014/main" id="{6CD9CC25-92FA-40B7-A005-2456FC872FEA}"/>
               </a:ext>
             </a:extLst>
           </p:cNvPr>
@@ -8432,7 +8432,7 @@
           <p:cNvPr id="30" name="">
             <a:extLst xmlns:a="http://schemas.openxmlformats.org/drawingml/2006/main">
               <a:ext uri="{FF2B5EF4-FFF2-40B4-BE49-F238E27FC236}">
-                <a16:creationId xmlns:a16="http://schemas.microsoft.com/office/drawing/2014/main" id="{3A9888DF-72CD-4A2E-83C2-ADC82D95F408}"/>
+                <a16:creationId xmlns:a16="http://schemas.microsoft.com/office/drawing/2014/main" id="{48FD3243-B80A-4C27-8293-24CE7E823F6C}"/>
               </a:ext>
             </a:extLst>
           </p:cNvPr>
@@ -8489,7 +8489,7 @@
           <p:cNvPr id="31" name="">
             <a:extLst xmlns:a="http://schemas.openxmlformats.org/drawingml/2006/main">
               <a:ext uri="{FF2B5EF4-FFF2-40B4-BE49-F238E27FC236}">
-                <a16:creationId xmlns:a16="http://schemas.microsoft.com/office/drawing/2014/main" id="{7370C074-8E85-4CC6-9A02-6788A6960E77}"/>
+                <a16:creationId xmlns:a16="http://schemas.microsoft.com/office/drawing/2014/main" id="{8D00C8E6-8E26-4AE7-871B-09E96461C55F}"/>
               </a:ext>
             </a:extLst>
           </p:cNvPr>
@@ -8546,7 +8546,7 @@
           <p:cNvPr id="32" name="">
             <a:extLst xmlns:a="http://schemas.openxmlformats.org/drawingml/2006/main">
               <a:ext uri="{FF2B5EF4-FFF2-40B4-BE49-F238E27FC236}">
-                <a16:creationId xmlns:a16="http://schemas.microsoft.com/office/drawing/2014/main" id="{F8DCA58E-5BC9-4DAB-AABA-03D51E068222}"/>
+                <a16:creationId xmlns:a16="http://schemas.microsoft.com/office/drawing/2014/main" id="{2D02D7AA-39D9-4072-B762-21C8EB75B4DF}"/>
               </a:ext>
             </a:extLst>
           </p:cNvPr>
@@ -8603,7 +8603,7 @@
           <p:cNvPr id="33" name="">
             <a:extLst xmlns:a="http://schemas.openxmlformats.org/drawingml/2006/main">
               <a:ext uri="{FF2B5EF4-FFF2-40B4-BE49-F238E27FC236}">
-                <a16:creationId xmlns:a16="http://schemas.microsoft.com/office/drawing/2014/main" id="{EBD8A046-4D9B-4FAF-85D1-0FAC6231B7AE}"/>
+                <a16:creationId xmlns:a16="http://schemas.microsoft.com/office/drawing/2014/main" id="{489DBB6A-A9FB-4C7E-8F38-6C13F474FAC2}"/>
               </a:ext>
             </a:extLst>
           </p:cNvPr>
@@ -8660,7 +8660,7 @@
           <p:cNvPr id="34" name="">
             <a:extLst xmlns:a="http://schemas.openxmlformats.org/drawingml/2006/main">
               <a:ext uri="{FF2B5EF4-FFF2-40B4-BE49-F238E27FC236}">
-                <a16:creationId xmlns:a16="http://schemas.microsoft.com/office/drawing/2014/main" id="{24217D38-1617-4087-A0FB-3978C494A4D2}"/>
+                <a16:creationId xmlns:a16="http://schemas.microsoft.com/office/drawing/2014/main" id="{83769B00-86F1-4E60-9D67-7DC6BD10C06E}"/>
               </a:ext>
             </a:extLst>
           </p:cNvPr>
@@ -8717,7 +8717,7 @@
           <p:cNvPr id="35" name="">
             <a:extLst xmlns:a="http://schemas.openxmlformats.org/drawingml/2006/main">
               <a:ext uri="{FF2B5EF4-FFF2-40B4-BE49-F238E27FC236}">
-                <a16:creationId xmlns:a16="http://schemas.microsoft.com/office/drawing/2014/main" id="{BC5C7679-D79D-4DCD-8B5D-96B45EDEAE11}"/>
+                <a16:creationId xmlns:a16="http://schemas.microsoft.com/office/drawing/2014/main" id="{626AA2AC-3AA6-459E-9D2E-AF502C18C349}"/>
               </a:ext>
             </a:extLst>
           </p:cNvPr>
@@ -8774,7 +8774,7 @@
           <p:cNvPr id="36" name="">
             <a:extLst xmlns:a="http://schemas.openxmlformats.org/drawingml/2006/main">
               <a:ext uri="{FF2B5EF4-FFF2-40B4-BE49-F238E27FC236}">
-                <a16:creationId xmlns:a16="http://schemas.microsoft.com/office/drawing/2014/main" id="{DF9A65E3-C6D3-4193-A191-6361962272A2}"/>
+                <a16:creationId xmlns:a16="http://schemas.microsoft.com/office/drawing/2014/main" id="{CAD3DE1D-920A-44AC-B01A-5093E4398E9C}"/>
               </a:ext>
             </a:extLst>
           </p:cNvPr>
@@ -8831,7 +8831,7 @@
           <p:cNvPr id="37" name="">
             <a:extLst xmlns:a="http://schemas.openxmlformats.org/drawingml/2006/main">
               <a:ext uri="{FF2B5EF4-FFF2-40B4-BE49-F238E27FC236}">
-                <a16:creationId xmlns:a16="http://schemas.microsoft.com/office/drawing/2014/main" id="{ED410242-80F8-4BFF-B5F8-C4C6F98DC000}"/>
+                <a16:creationId xmlns:a16="http://schemas.microsoft.com/office/drawing/2014/main" id="{5F58B33E-2EAC-4682-9266-DDCD8A249B89}"/>
               </a:ext>
             </a:extLst>
           </p:cNvPr>
@@ -8888,7 +8888,7 @@
           <p:cNvPr id="38" name="">
             <a:extLst xmlns:a="http://schemas.openxmlformats.org/drawingml/2006/main">
               <a:ext uri="{FF2B5EF4-FFF2-40B4-BE49-F238E27FC236}">
-                <a16:creationId xmlns:a16="http://schemas.microsoft.com/office/drawing/2014/main" id="{98EC9282-3FEA-4440-B555-5FA432753F2E}"/>
+                <a16:creationId xmlns:a16="http://schemas.microsoft.com/office/drawing/2014/main" id="{D0ABD081-9378-49D8-B5F5-244B83C2BEC6}"/>
               </a:ext>
             </a:extLst>
           </p:cNvPr>
@@ -8945,7 +8945,7 @@
           <p:cNvPr id="39" name="">
             <a:extLst xmlns:a="http://schemas.openxmlformats.org/drawingml/2006/main">
               <a:ext uri="{FF2B5EF4-FFF2-40B4-BE49-F238E27FC236}">
-                <a16:creationId xmlns:a16="http://schemas.microsoft.com/office/drawing/2014/main" id="{61D305EA-345A-4B56-991D-CCCAB82C017F}"/>
+                <a16:creationId xmlns:a16="http://schemas.microsoft.com/office/drawing/2014/main" id="{40BF25EB-67E7-4629-8F6C-AA0D91F856DE}"/>
               </a:ext>
             </a:extLst>
           </p:cNvPr>
@@ -9002,7 +9002,7 @@
           <p:cNvPr id="40" name="">
             <a:extLst xmlns:a="http://schemas.openxmlformats.org/drawingml/2006/main">
               <a:ext uri="{FF2B5EF4-FFF2-40B4-BE49-F238E27FC236}">
-                <a16:creationId xmlns:a16="http://schemas.microsoft.com/office/drawing/2014/main" id="{31D37235-A187-46A5-9CC7-79ED952F56E7}"/>
+                <a16:creationId xmlns:a16="http://schemas.microsoft.com/office/drawing/2014/main" id="{AB4B4A68-1F3D-488B-9E24-57A2A0548C47}"/>
               </a:ext>
             </a:extLst>
           </p:cNvPr>
@@ -9059,7 +9059,7 @@
           <p:cNvPr id="41" name="">
             <a:extLst xmlns:a="http://schemas.openxmlformats.org/drawingml/2006/main">
               <a:ext uri="{FF2B5EF4-FFF2-40B4-BE49-F238E27FC236}">
-                <a16:creationId xmlns:a16="http://schemas.microsoft.com/office/drawing/2014/main" id="{52654303-F064-4346-99C1-010603521015}"/>
+                <a16:creationId xmlns:a16="http://schemas.microsoft.com/office/drawing/2014/main" id="{8DE5B363-A1EF-47F9-A506-95DD69B76D41}"/>
               </a:ext>
             </a:extLst>
           </p:cNvPr>
@@ -9116,7 +9116,7 @@
           <p:cNvPr id="42" name="">
             <a:extLst xmlns:a="http://schemas.openxmlformats.org/drawingml/2006/main">
               <a:ext uri="{FF2B5EF4-FFF2-40B4-BE49-F238E27FC236}">
-                <a16:creationId xmlns:a16="http://schemas.microsoft.com/office/drawing/2014/main" id="{16EE07E3-7A8C-47A4-BCCB-00E256095194}"/>
+                <a16:creationId xmlns:a16="http://schemas.microsoft.com/office/drawing/2014/main" id="{B955F98A-00D9-4218-A984-156F36A10911}"/>
               </a:ext>
             </a:extLst>
           </p:cNvPr>
@@ -9173,7 +9173,7 @@
           <p:cNvPr id="43" name="">
             <a:extLst xmlns:a="http://schemas.openxmlformats.org/drawingml/2006/main">
               <a:ext uri="{FF2B5EF4-FFF2-40B4-BE49-F238E27FC236}">
-                <a16:creationId xmlns:a16="http://schemas.microsoft.com/office/drawing/2014/main" id="{B858B5FB-E076-4A8A-A18A-A15B3E8C9EE6}"/>
+                <a16:creationId xmlns:a16="http://schemas.microsoft.com/office/drawing/2014/main" id="{176CA9D8-471D-4D1B-8F67-C8916A5C600F}"/>
               </a:ext>
             </a:extLst>
           </p:cNvPr>
@@ -9228,7 +9228,7 @@
     </p:spTree>
     <p:extLst>
       <p:ext uri="{BB962C8B-B14F-4D97-AF65-F5344CB8AC3E}">
-        <p14:creationId xmlns:p14="http://schemas.microsoft.com/office/powerpoint/2010/main" val="1396109529"/>
+        <p14:creationId xmlns:p14="http://schemas.microsoft.com/office/powerpoint/2010/main" val="1125401533"/>
       </p:ext>
     </p:extLst>
   </p:cSld>

</xml_diff>

<commit_message>
feat: draw the two feedback loops on the architecture slide
The guide asks for the flow between components to be shown with arrows, and
the node row only ever pointed forward. The two paths that make this more than
a one-pass Workflow — the Self-Correction retry back to retrieval, and the
re-read of what was actually saved — were a line of small text under the row,
easy to miss. They are arrows now, and the text line shrinks to the loop's name
and moves above the row where it labels the flow before you read it.

Placed inline the labels collided: the second loop's arrowhead lands where the
first loop's label started, and the band under the row is 40pt with two lines
already in it. Both labels sit in the right margin instead, stacked at the
depths of the arrows they name.

Co-Authored-By: Claude Opus 5 <noreply@anthropic.com>
</commit_message>
<xml_diff>
--- a/Docs/PRESENTATION/2. 최종/09285_백준현_AI_Master_최종발표자료_v12.pptx
+++ b/Docs/PRESENTATION/2. 최종/09285_백준현_AI_Master_최종발표자료_v12.pptx
@@ -2,16 +2,16 @@
 <file path=ppt/presentation.xml><?xml version="1.0" encoding="utf-8"?>
 <p:presentation xmlns:p="http://schemas.openxmlformats.org/presentationml/2006/main">
   <p:sldMasterIdLst>
-    <p:sldMasterId xmlns:r="http://schemas.openxmlformats.org/officeDocument/2006/relationships" id="2147483648" r:id="Rcd1754c3c12a434a"/>
+    <p:sldMasterId xmlns:r="http://schemas.openxmlformats.org/officeDocument/2006/relationships" id="2147483648" r:id="Re8a61bb2df5a4c68"/>
   </p:sldMasterIdLst>
   <p:notesMasterIdLst>
-    <p:notesMasterId xmlns:r="http://schemas.openxmlformats.org/officeDocument/2006/relationships" r:id="R287c579f3b644bad"/>
+    <p:notesMasterId xmlns:r="http://schemas.openxmlformats.org/officeDocument/2006/relationships" r:id="Ra63ab19727a8477f"/>
   </p:notesMasterIdLst>
   <p:sldIdLst>
-    <p:sldId xmlns:r="http://schemas.openxmlformats.org/officeDocument/2006/relationships" id="256" r:id="R60020e4769d543d0"/>
-    <p:sldId xmlns:r="http://schemas.openxmlformats.org/officeDocument/2006/relationships" id="257" r:id="Ra79bb92d6adc4ce6"/>
-    <p:sldId xmlns:r="http://schemas.openxmlformats.org/officeDocument/2006/relationships" id="258" r:id="R67cc131e61e84f19"/>
-    <p:sldId xmlns:r="http://schemas.openxmlformats.org/officeDocument/2006/relationships" id="259" r:id="R7f7cee2c0ade4502"/>
+    <p:sldId xmlns:r="http://schemas.openxmlformats.org/officeDocument/2006/relationships" id="256" r:id="Rf57bdcf478a94bb5"/>
+    <p:sldId xmlns:r="http://schemas.openxmlformats.org/officeDocument/2006/relationships" id="257" r:id="Rd58b9110529547de"/>
+    <p:sldId xmlns:r="http://schemas.openxmlformats.org/officeDocument/2006/relationships" id="258" r:id="R7e05621a50574628"/>
+    <p:sldId xmlns:r="http://schemas.openxmlformats.org/officeDocument/2006/relationships" id="259" r:id="Rd3822b1f51fe4ddb"/>
   </p:sldIdLst>
   <p:sldSz cx="12192000" cy="6858000"/>
   <p:notesSz cx="6858000" cy="9144000"/>
@@ -958,7 +958,7 @@
   </p:cSld>
   <p:clrMap bg1="lt1" tx1="dk1" bg2="lt2" tx2="dk2" accent1="accent1" accent2="accent2" accent3="accent3" accent4="accent4" accent5="accent5" accent6="accent6" hlink="hlink" folHlink="folHlink"/>
   <p:sldLayoutIdLst>
-    <p:sldLayoutId xmlns:r="http://schemas.openxmlformats.org/officeDocument/2006/relationships" id="2147483649" r:id="R62346af0844241e6"/>
+    <p:sldLayoutId xmlns:r="http://schemas.openxmlformats.org/officeDocument/2006/relationships" id="2147483649" r:id="Rebdb766ec8bd4a91"/>
   </p:sldLayoutIdLst>
   <p:txStyles>
     <p:titleStyle>
@@ -1509,7 +1509,7 @@
           <p:cNvPr id="10" name="">
             <a:extLst xmlns:a="http://schemas.openxmlformats.org/drawingml/2006/main">
               <a:ext uri="{FF2B5EF4-FFF2-40B4-BE49-F238E27FC236}">
-                <a16:creationId xmlns:a16="http://schemas.microsoft.com/office/drawing/2014/main" id="{F053FC08-2DF2-44FC-8FA7-66DDC46AD5E0}"/>
+                <a16:creationId xmlns:a16="http://schemas.microsoft.com/office/drawing/2014/main" id="{6F2EA1D0-443F-4422-B094-115104BE6361}"/>
               </a:ext>
             </a:extLst>
           </p:cNvPr>
@@ -1539,7 +1539,7 @@
           <p:cNvPr id="2" name="">
             <a:extLst xmlns:a="http://schemas.openxmlformats.org/drawingml/2006/main">
               <a:ext uri="{FF2B5EF4-FFF2-40B4-BE49-F238E27FC236}">
-                <a16:creationId xmlns:a16="http://schemas.microsoft.com/office/drawing/2014/main" id="{48499040-E3F0-47E1-8B5C-4F0D9A764491}"/>
+                <a16:creationId xmlns:a16="http://schemas.microsoft.com/office/drawing/2014/main" id="{14C020FE-D984-49D9-BF9A-98EFFA0F9315}"/>
               </a:ext>
             </a:extLst>
           </p:cNvPr>
@@ -1596,7 +1596,7 @@
           <p:cNvPr id="3" name="">
             <a:extLst xmlns:a="http://schemas.openxmlformats.org/drawingml/2006/main">
               <a:ext uri="{FF2B5EF4-FFF2-40B4-BE49-F238E27FC236}">
-                <a16:creationId xmlns:a16="http://schemas.microsoft.com/office/drawing/2014/main" id="{6A511555-E696-4BA9-A3D7-FB125B9B3E76}"/>
+                <a16:creationId xmlns:a16="http://schemas.microsoft.com/office/drawing/2014/main" id="{E1F2948A-7737-4087-BF92-5C29CA275276}"/>
               </a:ext>
             </a:extLst>
           </p:cNvPr>
@@ -1653,7 +1653,7 @@
           <p:cNvPr id="4" name="">
             <a:extLst xmlns:a="http://schemas.openxmlformats.org/drawingml/2006/main">
               <a:ext uri="{FF2B5EF4-FFF2-40B4-BE49-F238E27FC236}">
-                <a16:creationId xmlns:a16="http://schemas.microsoft.com/office/drawing/2014/main" id="{1D894824-4894-4360-B0AA-DE233CC4F4E3}"/>
+                <a16:creationId xmlns:a16="http://schemas.microsoft.com/office/drawing/2014/main" id="{497E2131-EEB2-434C-8F91-6D3E1C0FA4EC}"/>
               </a:ext>
             </a:extLst>
           </p:cNvPr>
@@ -1710,7 +1710,7 @@
           <p:cNvPr id="5" name="">
             <a:extLst xmlns:a="http://schemas.openxmlformats.org/drawingml/2006/main">
               <a:ext uri="{FF2B5EF4-FFF2-40B4-BE49-F238E27FC236}">
-                <a16:creationId xmlns:a16="http://schemas.microsoft.com/office/drawing/2014/main" id="{471CCBAC-1224-443B-A6BC-1373B88319F5}"/>
+                <a16:creationId xmlns:a16="http://schemas.microsoft.com/office/drawing/2014/main" id="{80396238-805C-405A-A829-186A87C77764}"/>
               </a:ext>
             </a:extLst>
           </p:cNvPr>
@@ -1740,7 +1740,7 @@
           <p:cNvPr id="6" name="">
             <a:extLst xmlns:a="http://schemas.openxmlformats.org/drawingml/2006/main">
               <a:ext uri="{FF2B5EF4-FFF2-40B4-BE49-F238E27FC236}">
-                <a16:creationId xmlns:a16="http://schemas.microsoft.com/office/drawing/2014/main" id="{46367213-4049-45B0-ADD2-A1F9E801142E}"/>
+                <a16:creationId xmlns:a16="http://schemas.microsoft.com/office/drawing/2014/main" id="{CACD7293-F414-4874-9BB9-00E52F4D6340}"/>
               </a:ext>
             </a:extLst>
           </p:cNvPr>
@@ -1797,7 +1797,7 @@
           <p:cNvPr id="7" name="">
             <a:extLst xmlns:a="http://schemas.openxmlformats.org/drawingml/2006/main">
               <a:ext uri="{FF2B5EF4-FFF2-40B4-BE49-F238E27FC236}">
-                <a16:creationId xmlns:a16="http://schemas.microsoft.com/office/drawing/2014/main" id="{F02C081C-077D-4E3C-BF5C-72C759A3BCCC}"/>
+                <a16:creationId xmlns:a16="http://schemas.microsoft.com/office/drawing/2014/main" id="{D1BF7E1B-ED0B-4C66-8BA9-BA90494E602C}"/>
               </a:ext>
             </a:extLst>
           </p:cNvPr>
@@ -1854,7 +1854,7 @@
           <p:cNvPr id="8" name="">
             <a:extLst xmlns:a="http://schemas.openxmlformats.org/drawingml/2006/main">
               <a:ext uri="{FF2B5EF4-FFF2-40B4-BE49-F238E27FC236}">
-                <a16:creationId xmlns:a16="http://schemas.microsoft.com/office/drawing/2014/main" id="{C920F767-3B17-4154-88E1-1429AFD1CC7C}"/>
+                <a16:creationId xmlns:a16="http://schemas.microsoft.com/office/drawing/2014/main" id="{7167D13C-3FCC-4F88-9A58-BF52C2A18044}"/>
               </a:ext>
             </a:extLst>
           </p:cNvPr>
@@ -1911,7 +1911,7 @@
           <p:cNvPr id="9" name="">
             <a:extLst xmlns:a="http://schemas.openxmlformats.org/drawingml/2006/main">
               <a:ext uri="{FF2B5EF4-FFF2-40B4-BE49-F238E27FC236}">
-                <a16:creationId xmlns:a16="http://schemas.microsoft.com/office/drawing/2014/main" id="{4EF5B3FB-7E4E-403F-A8D4-003EF2D30E33}"/>
+                <a16:creationId xmlns:a16="http://schemas.microsoft.com/office/drawing/2014/main" id="{2FE339DB-EE13-479C-9977-3BF1F22584F7}"/>
               </a:ext>
             </a:extLst>
           </p:cNvPr>
@@ -1966,7 +1966,7 @@
     </p:spTree>
     <p:extLst>
       <p:ext uri="{BB962C8B-B14F-4D97-AF65-F5344CB8AC3E}">
-        <p14:creationId xmlns:p14="http://schemas.microsoft.com/office/powerpoint/2010/main" val="380924366"/>
+        <p14:creationId xmlns:p14="http://schemas.microsoft.com/office/powerpoint/2010/main" val="1040960521"/>
       </p:ext>
     </p:extLst>
   </p:cSld>
@@ -1997,7 +1997,7 @@
           <p:cNvPr id="46" name="">
             <a:extLst xmlns:a="http://schemas.openxmlformats.org/drawingml/2006/main">
               <a:ext uri="{FF2B5EF4-FFF2-40B4-BE49-F238E27FC236}">
-                <a16:creationId xmlns:a16="http://schemas.microsoft.com/office/drawing/2014/main" id="{DAEB7639-6C78-46F9-AB64-C8C57119BE45}"/>
+                <a16:creationId xmlns:a16="http://schemas.microsoft.com/office/drawing/2014/main" id="{C2369876-0DE2-4EA7-987F-CDAA7E524EAD}"/>
               </a:ext>
             </a:extLst>
           </p:cNvPr>
@@ -2027,7 +2027,7 @@
           <p:cNvPr id="2" name="">
             <a:extLst xmlns:a="http://schemas.openxmlformats.org/drawingml/2006/main">
               <a:ext uri="{FF2B5EF4-FFF2-40B4-BE49-F238E27FC236}">
-                <a16:creationId xmlns:a16="http://schemas.microsoft.com/office/drawing/2014/main" id="{67D757DE-B558-4A2D-B7D9-6ABBA401E1C3}"/>
+                <a16:creationId xmlns:a16="http://schemas.microsoft.com/office/drawing/2014/main" id="{92DF4CB9-675C-4E94-ABEE-A32CF961A893}"/>
               </a:ext>
             </a:extLst>
           </p:cNvPr>
@@ -2084,7 +2084,7 @@
           <p:cNvPr id="3" name="">
             <a:extLst xmlns:a="http://schemas.openxmlformats.org/drawingml/2006/main">
               <a:ext uri="{FF2B5EF4-FFF2-40B4-BE49-F238E27FC236}">
-                <a16:creationId xmlns:a16="http://schemas.microsoft.com/office/drawing/2014/main" id="{D7F81F98-1339-4AA8-93EF-275E28E649C7}"/>
+                <a16:creationId xmlns:a16="http://schemas.microsoft.com/office/drawing/2014/main" id="{8CF3603F-1C04-46AE-BE08-5582E909FEF1}"/>
               </a:ext>
             </a:extLst>
           </p:cNvPr>
@@ -2114,7 +2114,7 @@
           <p:cNvPr id="4" name="">
             <a:extLst xmlns:a="http://schemas.openxmlformats.org/drawingml/2006/main">
               <a:ext uri="{FF2B5EF4-FFF2-40B4-BE49-F238E27FC236}">
-                <a16:creationId xmlns:a16="http://schemas.microsoft.com/office/drawing/2014/main" id="{77AFE142-551E-497C-8A31-D0D016225EEF}"/>
+                <a16:creationId xmlns:a16="http://schemas.microsoft.com/office/drawing/2014/main" id="{64646371-6837-47E8-8A2B-90D2214872AF}"/>
               </a:ext>
             </a:extLst>
           </p:cNvPr>
@@ -2171,7 +2171,7 @@
           <p:cNvPr id="5" name="">
             <a:extLst xmlns:a="http://schemas.openxmlformats.org/drawingml/2006/main">
               <a:ext uri="{FF2B5EF4-FFF2-40B4-BE49-F238E27FC236}">
-                <a16:creationId xmlns:a16="http://schemas.microsoft.com/office/drawing/2014/main" id="{5A98DC29-F106-476D-BAE8-4B4DD6FCD237}"/>
+                <a16:creationId xmlns:a16="http://schemas.microsoft.com/office/drawing/2014/main" id="{B9EC04C6-F251-4D4E-AD99-64115BC6D0EB}"/>
               </a:ext>
             </a:extLst>
           </p:cNvPr>
@@ -2228,7 +2228,7 @@
           <p:cNvPr id="6" name="">
             <a:extLst xmlns:a="http://schemas.openxmlformats.org/drawingml/2006/main">
               <a:ext uri="{FF2B5EF4-FFF2-40B4-BE49-F238E27FC236}">
-                <a16:creationId xmlns:a16="http://schemas.microsoft.com/office/drawing/2014/main" id="{F5127486-EB01-4F90-8B20-CD3D7B1AF1E6}"/>
+                <a16:creationId xmlns:a16="http://schemas.microsoft.com/office/drawing/2014/main" id="{DB606FDC-BB75-40D2-9B0E-4AED8BFA5E84}"/>
               </a:ext>
             </a:extLst>
           </p:cNvPr>
@@ -2285,7 +2285,7 @@
           <p:cNvPr id="7" name="">
             <a:extLst xmlns:a="http://schemas.openxmlformats.org/drawingml/2006/main">
               <a:ext uri="{FF2B5EF4-FFF2-40B4-BE49-F238E27FC236}">
-                <a16:creationId xmlns:a16="http://schemas.microsoft.com/office/drawing/2014/main" id="{8AD21712-3D00-4CCD-82ED-2CF7668AEFD1}"/>
+                <a16:creationId xmlns:a16="http://schemas.microsoft.com/office/drawing/2014/main" id="{9B8F57E3-2A26-4CFC-9FB9-153A68312685}"/>
               </a:ext>
             </a:extLst>
           </p:cNvPr>
@@ -2319,7 +2319,7 @@
           <p:cNvPr id="8" name="">
             <a:extLst xmlns:a="http://schemas.openxmlformats.org/drawingml/2006/main">
               <a:ext uri="{FF2B5EF4-FFF2-40B4-BE49-F238E27FC236}">
-                <a16:creationId xmlns:a16="http://schemas.microsoft.com/office/drawing/2014/main" id="{17AD07F5-9CFC-4E7B-B52B-7666E3360560}"/>
+                <a16:creationId xmlns:a16="http://schemas.microsoft.com/office/drawing/2014/main" id="{5553A1E0-76CA-4384-8D1F-54974577AA30}"/>
               </a:ext>
             </a:extLst>
           </p:cNvPr>
@@ -2351,7 +2351,7 @@
           <p:cNvPr id="9" name="">
             <a:extLst xmlns:a="http://schemas.openxmlformats.org/drawingml/2006/main">
               <a:ext uri="{FF2B5EF4-FFF2-40B4-BE49-F238E27FC236}">
-                <a16:creationId xmlns:a16="http://schemas.microsoft.com/office/drawing/2014/main" id="{46F4DE53-83FF-4B42-83CD-F86348687AD1}"/>
+                <a16:creationId xmlns:a16="http://schemas.microsoft.com/office/drawing/2014/main" id="{7DA0DC31-88EA-4E86-9C36-1D88D872D595}"/>
               </a:ext>
             </a:extLst>
           </p:cNvPr>
@@ -2408,7 +2408,7 @@
           <p:cNvPr id="10" name="">
             <a:extLst xmlns:a="http://schemas.openxmlformats.org/drawingml/2006/main">
               <a:ext uri="{FF2B5EF4-FFF2-40B4-BE49-F238E27FC236}">
-                <a16:creationId xmlns:a16="http://schemas.microsoft.com/office/drawing/2014/main" id="{31F6AE3D-6DE0-4F0D-991D-7A2C20A64311}"/>
+                <a16:creationId xmlns:a16="http://schemas.microsoft.com/office/drawing/2014/main" id="{C73AB01E-EFC7-4930-90CD-869744DC9C7C}"/>
               </a:ext>
             </a:extLst>
           </p:cNvPr>
@@ -2488,7 +2488,7 @@
           <p:cNvPr id="11" name="">
             <a:extLst xmlns:a="http://schemas.openxmlformats.org/drawingml/2006/main">
               <a:ext uri="{FF2B5EF4-FFF2-40B4-BE49-F238E27FC236}">
-                <a16:creationId xmlns:a16="http://schemas.microsoft.com/office/drawing/2014/main" id="{F941602A-3B67-4431-B055-C678D260DC09}"/>
+                <a16:creationId xmlns:a16="http://schemas.microsoft.com/office/drawing/2014/main" id="{24146371-81CF-4C68-890C-6EA289B4EB8B}"/>
               </a:ext>
             </a:extLst>
           </p:cNvPr>
@@ -2518,7 +2518,7 @@
           <p:cNvPr id="12" name="">
             <a:extLst xmlns:a="http://schemas.openxmlformats.org/drawingml/2006/main">
               <a:ext uri="{FF2B5EF4-FFF2-40B4-BE49-F238E27FC236}">
-                <a16:creationId xmlns:a16="http://schemas.microsoft.com/office/drawing/2014/main" id="{54830D6A-867A-49CA-8B45-E47F1ED4A090}"/>
+                <a16:creationId xmlns:a16="http://schemas.microsoft.com/office/drawing/2014/main" id="{029BF41B-80C9-492B-B66B-594F4967189A}"/>
               </a:ext>
             </a:extLst>
           </p:cNvPr>
@@ -2552,7 +2552,7 @@
           <p:cNvPr id="13" name="">
             <a:extLst xmlns:a="http://schemas.openxmlformats.org/drawingml/2006/main">
               <a:ext uri="{FF2B5EF4-FFF2-40B4-BE49-F238E27FC236}">
-                <a16:creationId xmlns:a16="http://schemas.microsoft.com/office/drawing/2014/main" id="{D11F5099-AEDB-4E7E-A479-09E2D7627563}"/>
+                <a16:creationId xmlns:a16="http://schemas.microsoft.com/office/drawing/2014/main" id="{6992A099-DC02-4446-B81A-D21FE28CCE9F}"/>
               </a:ext>
             </a:extLst>
           </p:cNvPr>
@@ -2584,7 +2584,7 @@
           <p:cNvPr id="14" name="">
             <a:extLst xmlns:a="http://schemas.openxmlformats.org/drawingml/2006/main">
               <a:ext uri="{FF2B5EF4-FFF2-40B4-BE49-F238E27FC236}">
-                <a16:creationId xmlns:a16="http://schemas.microsoft.com/office/drawing/2014/main" id="{07EA1319-A132-45C3-839D-29FC714A1ADD}"/>
+                <a16:creationId xmlns:a16="http://schemas.microsoft.com/office/drawing/2014/main" id="{1ABEE977-2E7E-4AB5-986C-BE4C42DED647}"/>
               </a:ext>
             </a:extLst>
           </p:cNvPr>
@@ -2641,7 +2641,7 @@
           <p:cNvPr id="15" name="">
             <a:extLst xmlns:a="http://schemas.openxmlformats.org/drawingml/2006/main">
               <a:ext uri="{FF2B5EF4-FFF2-40B4-BE49-F238E27FC236}">
-                <a16:creationId xmlns:a16="http://schemas.microsoft.com/office/drawing/2014/main" id="{A41710D7-0DCD-4266-BFA0-1944ABF4028E}"/>
+                <a16:creationId xmlns:a16="http://schemas.microsoft.com/office/drawing/2014/main" id="{5D9CBA13-FFFB-4BEC-88D6-E8492F704865}"/>
               </a:ext>
             </a:extLst>
           </p:cNvPr>
@@ -2721,7 +2721,7 @@
           <p:cNvPr id="16" name="">
             <a:extLst xmlns:a="http://schemas.openxmlformats.org/drawingml/2006/main">
               <a:ext uri="{FF2B5EF4-FFF2-40B4-BE49-F238E27FC236}">
-                <a16:creationId xmlns:a16="http://schemas.microsoft.com/office/drawing/2014/main" id="{EA9A8FF5-A08E-404A-A969-FE81BA37B555}"/>
+                <a16:creationId xmlns:a16="http://schemas.microsoft.com/office/drawing/2014/main" id="{1571CB7C-F59A-40E2-8047-E639D24DF633}"/>
               </a:ext>
             </a:extLst>
           </p:cNvPr>
@@ -2751,7 +2751,7 @@
           <p:cNvPr id="17" name="">
             <a:extLst xmlns:a="http://schemas.openxmlformats.org/drawingml/2006/main">
               <a:ext uri="{FF2B5EF4-FFF2-40B4-BE49-F238E27FC236}">
-                <a16:creationId xmlns:a16="http://schemas.microsoft.com/office/drawing/2014/main" id="{ED1B186D-EB56-4D3A-B5B8-A21E2C30EE64}"/>
+                <a16:creationId xmlns:a16="http://schemas.microsoft.com/office/drawing/2014/main" id="{372D01F9-DB32-4477-9C16-5D3D86E78DC3}"/>
               </a:ext>
             </a:extLst>
           </p:cNvPr>
@@ -2785,7 +2785,7 @@
           <p:cNvPr id="18" name="">
             <a:extLst xmlns:a="http://schemas.openxmlformats.org/drawingml/2006/main">
               <a:ext uri="{FF2B5EF4-FFF2-40B4-BE49-F238E27FC236}">
-                <a16:creationId xmlns:a16="http://schemas.microsoft.com/office/drawing/2014/main" id="{3BCEEF1A-E210-4F68-B50B-B93C82F67D4B}"/>
+                <a16:creationId xmlns:a16="http://schemas.microsoft.com/office/drawing/2014/main" id="{BF69A26A-D084-403A-B38E-B86986588818}"/>
               </a:ext>
             </a:extLst>
           </p:cNvPr>
@@ -2817,7 +2817,7 @@
           <p:cNvPr id="19" name="">
             <a:extLst xmlns:a="http://schemas.openxmlformats.org/drawingml/2006/main">
               <a:ext uri="{FF2B5EF4-FFF2-40B4-BE49-F238E27FC236}">
-                <a16:creationId xmlns:a16="http://schemas.microsoft.com/office/drawing/2014/main" id="{D6B1F6DF-4FAD-438D-A907-7439B00C51E7}"/>
+                <a16:creationId xmlns:a16="http://schemas.microsoft.com/office/drawing/2014/main" id="{52158617-52C7-4F38-90E6-6339B3630F04}"/>
               </a:ext>
             </a:extLst>
           </p:cNvPr>
@@ -2874,7 +2874,7 @@
           <p:cNvPr id="20" name="">
             <a:extLst xmlns:a="http://schemas.openxmlformats.org/drawingml/2006/main">
               <a:ext uri="{FF2B5EF4-FFF2-40B4-BE49-F238E27FC236}">
-                <a16:creationId xmlns:a16="http://schemas.microsoft.com/office/drawing/2014/main" id="{DC5E87A5-1C3D-42A4-9C71-3EF9A3842D56}"/>
+                <a16:creationId xmlns:a16="http://schemas.microsoft.com/office/drawing/2014/main" id="{B04B589C-3E83-413F-8668-73A274372E35}"/>
               </a:ext>
             </a:extLst>
           </p:cNvPr>
@@ -2954,7 +2954,7 @@
           <p:cNvPr id="21" name="">
             <a:extLst xmlns:a="http://schemas.openxmlformats.org/drawingml/2006/main">
               <a:ext uri="{FF2B5EF4-FFF2-40B4-BE49-F238E27FC236}">
-                <a16:creationId xmlns:a16="http://schemas.microsoft.com/office/drawing/2014/main" id="{FC8B4A20-3BC6-493F-8363-63BB55D4C1EB}"/>
+                <a16:creationId xmlns:a16="http://schemas.microsoft.com/office/drawing/2014/main" id="{97F4C3E5-BB39-4DDB-8841-1EEF399D191A}"/>
               </a:ext>
             </a:extLst>
           </p:cNvPr>
@@ -2984,7 +2984,7 @@
           <p:cNvPr id="22" name="">
             <a:extLst xmlns:a="http://schemas.openxmlformats.org/drawingml/2006/main">
               <a:ext uri="{FF2B5EF4-FFF2-40B4-BE49-F238E27FC236}">
-                <a16:creationId xmlns:a16="http://schemas.microsoft.com/office/drawing/2014/main" id="{68F05A7B-22E0-4E5A-820A-012B7BC65305}"/>
+                <a16:creationId xmlns:a16="http://schemas.microsoft.com/office/drawing/2014/main" id="{F6358CD4-91ED-4119-8F1B-90FF6E251D3B}"/>
               </a:ext>
             </a:extLst>
           </p:cNvPr>
@@ -3018,7 +3018,7 @@
           <p:cNvPr id="23" name="">
             <a:extLst xmlns:a="http://schemas.openxmlformats.org/drawingml/2006/main">
               <a:ext uri="{FF2B5EF4-FFF2-40B4-BE49-F238E27FC236}">
-                <a16:creationId xmlns:a16="http://schemas.microsoft.com/office/drawing/2014/main" id="{C9AB9642-A5B0-4C4F-A887-2D4AF19A5275}"/>
+                <a16:creationId xmlns:a16="http://schemas.microsoft.com/office/drawing/2014/main" id="{3EE36B4D-B524-43FB-987C-6D6944F76A55}"/>
               </a:ext>
             </a:extLst>
           </p:cNvPr>
@@ -3050,7 +3050,7 @@
           <p:cNvPr id="24" name="">
             <a:extLst xmlns:a="http://schemas.openxmlformats.org/drawingml/2006/main">
               <a:ext uri="{FF2B5EF4-FFF2-40B4-BE49-F238E27FC236}">
-                <a16:creationId xmlns:a16="http://schemas.microsoft.com/office/drawing/2014/main" id="{631A0F4C-D3B3-4044-845B-0110B0357AE5}"/>
+                <a16:creationId xmlns:a16="http://schemas.microsoft.com/office/drawing/2014/main" id="{0F2BFDF7-E2AE-4A77-BB4C-8D904004A699}"/>
               </a:ext>
             </a:extLst>
           </p:cNvPr>
@@ -3107,7 +3107,7 @@
           <p:cNvPr id="25" name="">
             <a:extLst xmlns:a="http://schemas.openxmlformats.org/drawingml/2006/main">
               <a:ext uri="{FF2B5EF4-FFF2-40B4-BE49-F238E27FC236}">
-                <a16:creationId xmlns:a16="http://schemas.microsoft.com/office/drawing/2014/main" id="{C28FA831-F844-4E9A-8DF4-2986F78305E1}"/>
+                <a16:creationId xmlns:a16="http://schemas.microsoft.com/office/drawing/2014/main" id="{9E8FB08C-509F-4CE6-A999-B1DBCF69DC1E}"/>
               </a:ext>
             </a:extLst>
           </p:cNvPr>
@@ -3187,7 +3187,7 @@
           <p:cNvPr id="26" name="">
             <a:extLst xmlns:a="http://schemas.openxmlformats.org/drawingml/2006/main">
               <a:ext uri="{FF2B5EF4-FFF2-40B4-BE49-F238E27FC236}">
-                <a16:creationId xmlns:a16="http://schemas.microsoft.com/office/drawing/2014/main" id="{6C70D3A2-B49A-4E64-84A4-6C8805A4F00D}"/>
+                <a16:creationId xmlns:a16="http://schemas.microsoft.com/office/drawing/2014/main" id="{674F3D7C-3775-4812-BE9F-9B4B041ACFAB}"/>
               </a:ext>
             </a:extLst>
           </p:cNvPr>
@@ -3217,7 +3217,7 @@
           <p:cNvPr id="27" name="">
             <a:extLst xmlns:a="http://schemas.openxmlformats.org/drawingml/2006/main">
               <a:ext uri="{FF2B5EF4-FFF2-40B4-BE49-F238E27FC236}">
-                <a16:creationId xmlns:a16="http://schemas.microsoft.com/office/drawing/2014/main" id="{4BCA47C8-67AB-4547-ACB7-880CF70388CD}"/>
+                <a16:creationId xmlns:a16="http://schemas.microsoft.com/office/drawing/2014/main" id="{B55E27BF-D445-4E24-B353-38C182A122CD}"/>
               </a:ext>
             </a:extLst>
           </p:cNvPr>
@@ -3251,7 +3251,7 @@
           <p:cNvPr id="28" name="">
             <a:extLst xmlns:a="http://schemas.openxmlformats.org/drawingml/2006/main">
               <a:ext uri="{FF2B5EF4-FFF2-40B4-BE49-F238E27FC236}">
-                <a16:creationId xmlns:a16="http://schemas.microsoft.com/office/drawing/2014/main" id="{81D2521B-2361-4C77-9F87-525714570CA5}"/>
+                <a16:creationId xmlns:a16="http://schemas.microsoft.com/office/drawing/2014/main" id="{ADC74C92-ACFB-4E58-8D62-06880FCE2019}"/>
               </a:ext>
             </a:extLst>
           </p:cNvPr>
@@ -3283,7 +3283,7 @@
           <p:cNvPr id="29" name="">
             <a:extLst xmlns:a="http://schemas.openxmlformats.org/drawingml/2006/main">
               <a:ext uri="{FF2B5EF4-FFF2-40B4-BE49-F238E27FC236}">
-                <a16:creationId xmlns:a16="http://schemas.microsoft.com/office/drawing/2014/main" id="{AB9E074E-AC43-44A5-9130-EED966FA2A89}"/>
+                <a16:creationId xmlns:a16="http://schemas.microsoft.com/office/drawing/2014/main" id="{7E7F256F-3DF4-426F-A7AC-8FEB2EA64BF7}"/>
               </a:ext>
             </a:extLst>
           </p:cNvPr>
@@ -3340,7 +3340,7 @@
           <p:cNvPr id="30" name="">
             <a:extLst xmlns:a="http://schemas.openxmlformats.org/drawingml/2006/main">
               <a:ext uri="{FF2B5EF4-FFF2-40B4-BE49-F238E27FC236}">
-                <a16:creationId xmlns:a16="http://schemas.microsoft.com/office/drawing/2014/main" id="{2D262F68-0FD6-4A4F-A79D-FD221AE9C74D}"/>
+                <a16:creationId xmlns:a16="http://schemas.microsoft.com/office/drawing/2014/main" id="{2C48F397-2E49-42C2-BD77-28CDE3059C3F}"/>
               </a:ext>
             </a:extLst>
           </p:cNvPr>
@@ -3420,7 +3420,7 @@
           <p:cNvPr id="31" name="">
             <a:extLst xmlns:a="http://schemas.openxmlformats.org/drawingml/2006/main">
               <a:ext uri="{FF2B5EF4-FFF2-40B4-BE49-F238E27FC236}">
-                <a16:creationId xmlns:a16="http://schemas.microsoft.com/office/drawing/2014/main" id="{93C17D65-1542-4429-9B68-BA0E452AD9B6}"/>
+                <a16:creationId xmlns:a16="http://schemas.microsoft.com/office/drawing/2014/main" id="{F06EFF18-B978-4A4A-B5D0-8112D441FF6B}"/>
               </a:ext>
             </a:extLst>
           </p:cNvPr>
@@ -3477,7 +3477,7 @@
           <p:cNvPr id="32" name="">
             <a:extLst xmlns:a="http://schemas.openxmlformats.org/drawingml/2006/main">
               <a:ext uri="{FF2B5EF4-FFF2-40B4-BE49-F238E27FC236}">
-                <a16:creationId xmlns:a16="http://schemas.microsoft.com/office/drawing/2014/main" id="{DE48F164-53D8-4751-968D-800AAEB288EC}"/>
+                <a16:creationId xmlns:a16="http://schemas.microsoft.com/office/drawing/2014/main" id="{E45B1A5E-A830-44E9-8362-DFCB82046F0D}"/>
               </a:ext>
             </a:extLst>
           </p:cNvPr>
@@ -3534,7 +3534,7 @@
           <p:cNvPr id="33" name="">
             <a:extLst xmlns:a="http://schemas.openxmlformats.org/drawingml/2006/main">
               <a:ext uri="{FF2B5EF4-FFF2-40B4-BE49-F238E27FC236}">
-                <a16:creationId xmlns:a16="http://schemas.microsoft.com/office/drawing/2014/main" id="{0E7460FF-55B9-40AF-9EDA-6ABC18EB6131}"/>
+                <a16:creationId xmlns:a16="http://schemas.microsoft.com/office/drawing/2014/main" id="{5867838A-20E8-4A0F-A39B-221E5BEA6D0D}"/>
               </a:ext>
             </a:extLst>
           </p:cNvPr>
@@ -3591,7 +3591,7 @@
           <p:cNvPr id="34" name="">
             <a:extLst xmlns:a="http://schemas.openxmlformats.org/drawingml/2006/main">
               <a:ext uri="{FF2B5EF4-FFF2-40B4-BE49-F238E27FC236}">
-                <a16:creationId xmlns:a16="http://schemas.microsoft.com/office/drawing/2014/main" id="{2449621F-4A58-47E2-BD6B-FEE8B47FE6C8}"/>
+                <a16:creationId xmlns:a16="http://schemas.microsoft.com/office/drawing/2014/main" id="{D94A0607-23D1-49F6-96F4-4013B20FC724}"/>
               </a:ext>
             </a:extLst>
           </p:cNvPr>
@@ -3648,7 +3648,7 @@
           <p:cNvPr id="35" name="">
             <a:extLst xmlns:a="http://schemas.openxmlformats.org/drawingml/2006/main">
               <a:ext uri="{FF2B5EF4-FFF2-40B4-BE49-F238E27FC236}">
-                <a16:creationId xmlns:a16="http://schemas.microsoft.com/office/drawing/2014/main" id="{8E648D2A-430E-47A5-8155-77A530400D4B}"/>
+                <a16:creationId xmlns:a16="http://schemas.microsoft.com/office/drawing/2014/main" id="{A0AE3536-6103-48D9-B17F-43C3D01B1324}"/>
               </a:ext>
             </a:extLst>
           </p:cNvPr>
@@ -3705,7 +3705,7 @@
           <p:cNvPr id="36" name="">
             <a:extLst xmlns:a="http://schemas.openxmlformats.org/drawingml/2006/main">
               <a:ext uri="{FF2B5EF4-FFF2-40B4-BE49-F238E27FC236}">
-                <a16:creationId xmlns:a16="http://schemas.microsoft.com/office/drawing/2014/main" id="{6F815282-EAC4-44B5-BC75-5947F4B3F880}"/>
+                <a16:creationId xmlns:a16="http://schemas.microsoft.com/office/drawing/2014/main" id="{517A70AE-67E3-43A2-BF21-788810D684DF}"/>
               </a:ext>
             </a:extLst>
           </p:cNvPr>
@@ -3762,7 +3762,7 @@
           <p:cNvPr id="37" name="">
             <a:extLst xmlns:a="http://schemas.openxmlformats.org/drawingml/2006/main">
               <a:ext uri="{FF2B5EF4-FFF2-40B4-BE49-F238E27FC236}">
-                <a16:creationId xmlns:a16="http://schemas.microsoft.com/office/drawing/2014/main" id="{3C5339E0-4922-485A-8097-04E70A8A3A8E}"/>
+                <a16:creationId xmlns:a16="http://schemas.microsoft.com/office/drawing/2014/main" id="{97F7033D-4119-47BF-82BD-B472ABD7A965}"/>
               </a:ext>
             </a:extLst>
           </p:cNvPr>
@@ -3819,7 +3819,7 @@
           <p:cNvPr id="38" name="">
             <a:extLst xmlns:a="http://schemas.openxmlformats.org/drawingml/2006/main">
               <a:ext uri="{FF2B5EF4-FFF2-40B4-BE49-F238E27FC236}">
-                <a16:creationId xmlns:a16="http://schemas.microsoft.com/office/drawing/2014/main" id="{F43FDD74-FFCA-4D01-8289-CE4DE7CCC897}"/>
+                <a16:creationId xmlns:a16="http://schemas.microsoft.com/office/drawing/2014/main" id="{8FB8FFDD-F39E-4456-BAF2-97C46A1724B0}"/>
               </a:ext>
             </a:extLst>
           </p:cNvPr>
@@ -3876,7 +3876,7 @@
           <p:cNvPr id="39" name="">
             <a:extLst xmlns:a="http://schemas.openxmlformats.org/drawingml/2006/main">
               <a:ext uri="{FF2B5EF4-FFF2-40B4-BE49-F238E27FC236}">
-                <a16:creationId xmlns:a16="http://schemas.microsoft.com/office/drawing/2014/main" id="{1A48615F-98F4-4402-8C62-9E0DDBE1D68E}"/>
+                <a16:creationId xmlns:a16="http://schemas.microsoft.com/office/drawing/2014/main" id="{DFAF6FA9-A1B9-4DFA-A015-23F70B097D56}"/>
               </a:ext>
             </a:extLst>
           </p:cNvPr>
@@ -3933,7 +3933,7 @@
           <p:cNvPr id="40" name="">
             <a:extLst xmlns:a="http://schemas.openxmlformats.org/drawingml/2006/main">
               <a:ext uri="{FF2B5EF4-FFF2-40B4-BE49-F238E27FC236}">
-                <a16:creationId xmlns:a16="http://schemas.microsoft.com/office/drawing/2014/main" id="{58ADFE38-ED9B-4008-96A1-A7BC9F4E1D9F}"/>
+                <a16:creationId xmlns:a16="http://schemas.microsoft.com/office/drawing/2014/main" id="{E5891A5B-5CB1-424A-BB23-7F8BCFCF5CB2}"/>
               </a:ext>
             </a:extLst>
           </p:cNvPr>
@@ -3990,7 +3990,7 @@
           <p:cNvPr id="41" name="">
             <a:extLst xmlns:a="http://schemas.openxmlformats.org/drawingml/2006/main">
               <a:ext uri="{FF2B5EF4-FFF2-40B4-BE49-F238E27FC236}">
-                <a16:creationId xmlns:a16="http://schemas.microsoft.com/office/drawing/2014/main" id="{C68E7284-3E15-47F0-9461-83C02AF9E5AB}"/>
+                <a16:creationId xmlns:a16="http://schemas.microsoft.com/office/drawing/2014/main" id="{192965F0-2362-47A0-B770-82BD09D44A95}"/>
               </a:ext>
             </a:extLst>
           </p:cNvPr>
@@ -4047,7 +4047,7 @@
           <p:cNvPr id="42" name="">
             <a:extLst xmlns:a="http://schemas.openxmlformats.org/drawingml/2006/main">
               <a:ext uri="{FF2B5EF4-FFF2-40B4-BE49-F238E27FC236}">
-                <a16:creationId xmlns:a16="http://schemas.microsoft.com/office/drawing/2014/main" id="{C7894AF2-3A14-4A17-93C7-981CC6715F65}"/>
+                <a16:creationId xmlns:a16="http://schemas.microsoft.com/office/drawing/2014/main" id="{53CAA4BB-B547-433D-AEA6-85801E5D9973}"/>
               </a:ext>
             </a:extLst>
           </p:cNvPr>
@@ -4104,7 +4104,7 @@
           <p:cNvPr id="43" name="">
             <a:extLst xmlns:a="http://schemas.openxmlformats.org/drawingml/2006/main">
               <a:ext uri="{FF2B5EF4-FFF2-40B4-BE49-F238E27FC236}">
-                <a16:creationId xmlns:a16="http://schemas.microsoft.com/office/drawing/2014/main" id="{EED9CE8F-D3DE-4B58-96C1-58B950D35AA3}"/>
+                <a16:creationId xmlns:a16="http://schemas.microsoft.com/office/drawing/2014/main" id="{17463977-FBC3-480A-938A-B60CD85E2B0D}"/>
               </a:ext>
             </a:extLst>
           </p:cNvPr>
@@ -4161,7 +4161,7 @@
           <p:cNvPr id="44" name="">
             <a:extLst xmlns:a="http://schemas.openxmlformats.org/drawingml/2006/main">
               <a:ext uri="{FF2B5EF4-FFF2-40B4-BE49-F238E27FC236}">
-                <a16:creationId xmlns:a16="http://schemas.microsoft.com/office/drawing/2014/main" id="{B2E9E3BD-2CFB-4835-9054-350C17E1E656}"/>
+                <a16:creationId xmlns:a16="http://schemas.microsoft.com/office/drawing/2014/main" id="{E1B5649B-F569-4E24-A7CB-5E8196B2C8B5}"/>
               </a:ext>
             </a:extLst>
           </p:cNvPr>
@@ -4193,7 +4193,7 @@
           <p:cNvPr id="45" name="">
             <a:extLst xmlns:a="http://schemas.openxmlformats.org/drawingml/2006/main">
               <a:ext uri="{FF2B5EF4-FFF2-40B4-BE49-F238E27FC236}">
-                <a16:creationId xmlns:a16="http://schemas.microsoft.com/office/drawing/2014/main" id="{AE06A2A7-690C-401D-916C-55DCB35A2693}"/>
+                <a16:creationId xmlns:a16="http://schemas.microsoft.com/office/drawing/2014/main" id="{C61B7D3A-49D5-4703-B26F-35E3C8046931}"/>
               </a:ext>
             </a:extLst>
           </p:cNvPr>
@@ -4248,7 +4248,7 @@
     </p:spTree>
     <p:extLst>
       <p:ext uri="{BB962C8B-B14F-4D97-AF65-F5344CB8AC3E}">
-        <p14:creationId xmlns:p14="http://schemas.microsoft.com/office/powerpoint/2010/main" val="1391267623"/>
+        <p14:creationId xmlns:p14="http://schemas.microsoft.com/office/powerpoint/2010/main" val="1735654231"/>
       </p:ext>
     </p:extLst>
   </p:cSld>
@@ -4276,10 +4276,10 @@
       </p:grpSpPr>
       <p:sp>
         <p:nvSpPr>
-          <p:cNvPr id="60" name="">
-            <a:extLst xmlns:a="http://schemas.openxmlformats.org/drawingml/2006/main">
-              <a:ext uri="{FF2B5EF4-FFF2-40B4-BE49-F238E27FC236}">
-                <a16:creationId xmlns:a16="http://schemas.microsoft.com/office/drawing/2014/main" id="{09C2349F-33E0-4886-82AA-19059B78000E}"/>
+          <p:cNvPr id="70" name="">
+            <a:extLst xmlns:a="http://schemas.openxmlformats.org/drawingml/2006/main">
+              <a:ext uri="{FF2B5EF4-FFF2-40B4-BE49-F238E27FC236}">
+                <a16:creationId xmlns:a16="http://schemas.microsoft.com/office/drawing/2014/main" id="{12D26B0F-88C0-46EC-8A12-985F70C1A388}"/>
               </a:ext>
             </a:extLst>
           </p:cNvPr>
@@ -4309,7 +4309,7 @@
           <p:cNvPr id="2" name="">
             <a:extLst xmlns:a="http://schemas.openxmlformats.org/drawingml/2006/main">
               <a:ext uri="{FF2B5EF4-FFF2-40B4-BE49-F238E27FC236}">
-                <a16:creationId xmlns:a16="http://schemas.microsoft.com/office/drawing/2014/main" id="{EBE5AA3D-4C1E-4AAE-8A58-0952E217425A}"/>
+                <a16:creationId xmlns:a16="http://schemas.microsoft.com/office/drawing/2014/main" id="{8653106F-4A8F-44EA-9605-206773F79F37}"/>
               </a:ext>
             </a:extLst>
           </p:cNvPr>
@@ -4366,7 +4366,7 @@
           <p:cNvPr id="3" name="">
             <a:extLst xmlns:a="http://schemas.openxmlformats.org/drawingml/2006/main">
               <a:ext uri="{FF2B5EF4-FFF2-40B4-BE49-F238E27FC236}">
-                <a16:creationId xmlns:a16="http://schemas.microsoft.com/office/drawing/2014/main" id="{7269C19B-99CE-4F3A-AE95-75E3CDF1AD08}"/>
+                <a16:creationId xmlns:a16="http://schemas.microsoft.com/office/drawing/2014/main" id="{6C1C88C5-9F91-4269-A8AB-B253C74080BC}"/>
               </a:ext>
             </a:extLst>
           </p:cNvPr>
@@ -4396,7 +4396,7 @@
           <p:cNvPr id="4" name="">
             <a:extLst xmlns:a="http://schemas.openxmlformats.org/drawingml/2006/main">
               <a:ext uri="{FF2B5EF4-FFF2-40B4-BE49-F238E27FC236}">
-                <a16:creationId xmlns:a16="http://schemas.microsoft.com/office/drawing/2014/main" id="{C229DD4C-9454-4416-9CE8-45BF015541F7}"/>
+                <a16:creationId xmlns:a16="http://schemas.microsoft.com/office/drawing/2014/main" id="{3894A5FC-3DB1-42DE-A13F-2E0A6F2F81F0}"/>
               </a:ext>
             </a:extLst>
           </p:cNvPr>
@@ -4453,18 +4453,18 @@
           <p:cNvPr id="5" name="">
             <a:extLst xmlns:a="http://schemas.openxmlformats.org/drawingml/2006/main">
               <a:ext uri="{FF2B5EF4-FFF2-40B4-BE49-F238E27FC236}">
-                <a16:creationId xmlns:a16="http://schemas.microsoft.com/office/drawing/2014/main" id="{0B35B348-A86B-45F2-8F59-4C903BBB9BF2}"/>
-              </a:ext>
-            </a:extLst>
-          </p:cNvPr>
-          <p:cNvSpPr>
-            <a:spLocks xmlns:a="http://schemas.openxmlformats.org/drawingml/2006/main" noGrp="1"/>
-          </p:cNvSpPr>
-          <p:nvPr/>
-        </p:nvSpPr>
-        <p:spPr>
-          <a:xfrm xmlns:a="http://schemas.openxmlformats.org/drawingml/2006/main">
-            <a:off x="571500" y="1200150"/>
+                <a16:creationId xmlns:a16="http://schemas.microsoft.com/office/drawing/2014/main" id="{0733929B-9164-420D-9352-44AA0AC04AA6}"/>
+              </a:ext>
+            </a:extLst>
+          </p:cNvPr>
+          <p:cNvSpPr>
+            <a:spLocks xmlns:a="http://schemas.openxmlformats.org/drawingml/2006/main" noGrp="1"/>
+          </p:cNvSpPr>
+          <p:nvPr/>
+        </p:nvSpPr>
+        <p:spPr>
+          <a:xfrm xmlns:a="http://schemas.openxmlformats.org/drawingml/2006/main">
+            <a:off x="571500" y="1181100"/>
             <a:ext cx="10953750" cy="285750"/>
           </a:xfrm>
           <a:prstGeom xmlns:a="http://schemas.openxmlformats.org/drawingml/2006/main" prst="rect">
@@ -4510,7 +4510,64 @@
           <p:cNvPr id="6" name="">
             <a:extLst xmlns:a="http://schemas.openxmlformats.org/drawingml/2006/main">
               <a:ext uri="{FF2B5EF4-FFF2-40B4-BE49-F238E27FC236}">
-                <a16:creationId xmlns:a16="http://schemas.microsoft.com/office/drawing/2014/main" id="{014C47C7-781B-4B1A-BAAD-502257B2F24F}"/>
+                <a16:creationId xmlns:a16="http://schemas.microsoft.com/office/drawing/2014/main" id="{1B76979D-4FFE-4218-8862-2BD92EC7429F}"/>
+              </a:ext>
+            </a:extLst>
+          </p:cNvPr>
+          <p:cNvSpPr>
+            <a:spLocks xmlns:a="http://schemas.openxmlformats.org/drawingml/2006/main" noGrp="1"/>
+          </p:cNvSpPr>
+          <p:nvPr/>
+        </p:nvSpPr>
+        <p:spPr>
+          <a:xfrm xmlns:a="http://schemas.openxmlformats.org/drawingml/2006/main">
+            <a:off x="571500" y="1504950"/>
+            <a:ext cx="11049000" cy="209550"/>
+          </a:xfrm>
+          <a:prstGeom xmlns:a="http://schemas.openxmlformats.org/drawingml/2006/main" prst="rect">
+            <a:avLst/>
+          </a:prstGeom>
+          <a:noFill xmlns:a="http://schemas.openxmlformats.org/drawingml/2006/main"/>
+          <a:ln xmlns:a="http://schemas.openxmlformats.org/drawingml/2006/main" w="0">
+            <a:noFill/>
+          </a:ln>
+        </p:spPr>
+        <p:txBody>
+          <a:bodyPr xmlns:a="http://schemas.openxmlformats.org/drawingml/2006/main" anchor="ctr">
+            <a:normAutofit fontScale="73809"/>
+          </a:bodyPr>
+          <a:lstStyle xmlns:a="http://schemas.openxmlformats.org/drawingml/2006/main"/>
+          <a:p xmlns:a="http://schemas.openxmlformats.org/drawingml/2006/main">
+            <a:pPr algn="l">
+              <a:defRPr sz="1050" b="1">
+                <a:solidFill>
+                  <a:srgbClr val="7657D6"/>
+                </a:solidFill>
+                <a:latin typeface="Malgun Gothic"/>
+                <a:ea typeface="Malgun Gothic"/>
+                <a:cs typeface="Malgun Gothic"/>
+              </a:defRPr>
+            </a:pPr>
+            <a:r>
+              <a:rPr sz="1050" b="1">
+                <a:solidFill>
+                  <a:srgbClr val="7657D6"/>
+                </a:solidFill>
+                <a:latin typeface="Malgun Gothic"/>
+                <a:ea typeface="Malgun Gothic"/>
+                <a:cs typeface="Malgun Gothic"/>
+              </a:rPr>
+              <a:t>제한적 ReAct  |  Observe → Retrieve → Reason → Act → Observe</a:t>
+            </a:r>
+          </a:p>
+        </p:txBody>
+      </p:sp>
+      <p:sp>
+        <p:nvSpPr>
+          <p:cNvPr id="7" name="">
+            <a:extLst xmlns:a="http://schemas.openxmlformats.org/drawingml/2006/main">
+              <a:ext uri="{FF2B5EF4-FFF2-40B4-BE49-F238E27FC236}">
+                <a16:creationId xmlns:a16="http://schemas.microsoft.com/office/drawing/2014/main" id="{2B926F75-E132-48EC-AD4C-652E91E0A844}"/>
               </a:ext>
             </a:extLst>
           </p:cNvPr>
@@ -4541,10 +4598,10 @@
       </p:sp>
       <p:sp>
         <p:nvSpPr>
-          <p:cNvPr id="7" name="">
-            <a:extLst xmlns:a="http://schemas.openxmlformats.org/drawingml/2006/main">
-              <a:ext uri="{FF2B5EF4-FFF2-40B4-BE49-F238E27FC236}">
-                <a16:creationId xmlns:a16="http://schemas.microsoft.com/office/drawing/2014/main" id="{C09875B4-2CFA-4089-A085-C47CBFCA0CE1}"/>
+          <p:cNvPr id="8" name="">
+            <a:extLst xmlns:a="http://schemas.openxmlformats.org/drawingml/2006/main">
+              <a:ext uri="{FF2B5EF4-FFF2-40B4-BE49-F238E27FC236}">
+                <a16:creationId xmlns:a16="http://schemas.microsoft.com/office/drawing/2014/main" id="{C6208B3B-C85D-4A21-9594-B76DC9D81CC6}"/>
               </a:ext>
             </a:extLst>
           </p:cNvPr>
@@ -4573,10 +4630,10 @@
       </p:sp>
       <p:sp>
         <p:nvSpPr>
-          <p:cNvPr id="8" name="">
-            <a:extLst xmlns:a="http://schemas.openxmlformats.org/drawingml/2006/main">
-              <a:ext uri="{FF2B5EF4-FFF2-40B4-BE49-F238E27FC236}">
-                <a16:creationId xmlns:a16="http://schemas.microsoft.com/office/drawing/2014/main" id="{61DB83FE-FD47-430F-8C46-296C9C0832F4}"/>
+          <p:cNvPr id="9" name="">
+            <a:extLst xmlns:a="http://schemas.openxmlformats.org/drawingml/2006/main">
+              <a:ext uri="{FF2B5EF4-FFF2-40B4-BE49-F238E27FC236}">
+                <a16:creationId xmlns:a16="http://schemas.microsoft.com/office/drawing/2014/main" id="{E0060723-7692-4238-BDF5-5F6D79112BBE}"/>
               </a:ext>
             </a:extLst>
           </p:cNvPr>
@@ -4630,10 +4687,10 @@
       </p:sp>
       <p:sp>
         <p:nvSpPr>
-          <p:cNvPr id="9" name="">
-            <a:extLst xmlns:a="http://schemas.openxmlformats.org/drawingml/2006/main">
-              <a:ext uri="{FF2B5EF4-FFF2-40B4-BE49-F238E27FC236}">
-                <a16:creationId xmlns:a16="http://schemas.microsoft.com/office/drawing/2014/main" id="{C05CE73B-1E4B-4B00-A09D-1AA9236219FB}"/>
+          <p:cNvPr id="10" name="">
+            <a:extLst xmlns:a="http://schemas.openxmlformats.org/drawingml/2006/main">
+              <a:ext uri="{FF2B5EF4-FFF2-40B4-BE49-F238E27FC236}">
+                <a16:creationId xmlns:a16="http://schemas.microsoft.com/office/drawing/2014/main" id="{33685F15-DE01-470D-AAE6-39E7FB27BCC9}"/>
               </a:ext>
             </a:extLst>
           </p:cNvPr>
@@ -4687,10 +4744,10 @@
       </p:sp>
       <p:sp>
         <p:nvSpPr>
-          <p:cNvPr id="10" name="">
-            <a:extLst xmlns:a="http://schemas.openxmlformats.org/drawingml/2006/main">
-              <a:ext uri="{FF2B5EF4-FFF2-40B4-BE49-F238E27FC236}">
-                <a16:creationId xmlns:a16="http://schemas.microsoft.com/office/drawing/2014/main" id="{48379D53-C48F-45E1-97FC-EF9B58D0AC21}"/>
+          <p:cNvPr id="11" name="">
+            <a:extLst xmlns:a="http://schemas.openxmlformats.org/drawingml/2006/main">
+              <a:ext uri="{FF2B5EF4-FFF2-40B4-BE49-F238E27FC236}">
+                <a16:creationId xmlns:a16="http://schemas.microsoft.com/office/drawing/2014/main" id="{5577FBD7-74D2-4E31-8F09-DFD62C53C9E0}"/>
               </a:ext>
             </a:extLst>
           </p:cNvPr>
@@ -4744,10 +4801,10 @@
       </p:sp>
       <p:sp>
         <p:nvSpPr>
-          <p:cNvPr id="11" name="">
-            <a:extLst xmlns:a="http://schemas.openxmlformats.org/drawingml/2006/main">
-              <a:ext uri="{FF2B5EF4-FFF2-40B4-BE49-F238E27FC236}">
-                <a16:creationId xmlns:a16="http://schemas.microsoft.com/office/drawing/2014/main" id="{121E24A7-354A-41E4-80F3-851D8743483B}"/>
+          <p:cNvPr id="12" name="">
+            <a:extLst xmlns:a="http://schemas.openxmlformats.org/drawingml/2006/main">
+              <a:ext uri="{FF2B5EF4-FFF2-40B4-BE49-F238E27FC236}">
+                <a16:creationId xmlns:a16="http://schemas.microsoft.com/office/drawing/2014/main" id="{1BE68F2F-6B7F-4610-BB7A-DB6AAEBC1393}"/>
               </a:ext>
             </a:extLst>
           </p:cNvPr>
@@ -4774,10 +4831,10 @@
       </p:sp>
       <p:sp>
         <p:nvSpPr>
-          <p:cNvPr id="12" name="">
-            <a:extLst xmlns:a="http://schemas.openxmlformats.org/drawingml/2006/main">
-              <a:ext uri="{FF2B5EF4-FFF2-40B4-BE49-F238E27FC236}">
-                <a16:creationId xmlns:a16="http://schemas.microsoft.com/office/drawing/2014/main" id="{7694409F-9F56-448C-9C1E-8042654C3E4E}"/>
+          <p:cNvPr id="13" name="">
+            <a:extLst xmlns:a="http://schemas.openxmlformats.org/drawingml/2006/main">
+              <a:ext uri="{FF2B5EF4-FFF2-40B4-BE49-F238E27FC236}">
+                <a16:creationId xmlns:a16="http://schemas.microsoft.com/office/drawing/2014/main" id="{A855E74A-909F-42AD-A36E-8D74C81B5B6D}"/>
               </a:ext>
             </a:extLst>
           </p:cNvPr>
@@ -4808,10 +4865,10 @@
       </p:sp>
       <p:sp>
         <p:nvSpPr>
-          <p:cNvPr id="13" name="">
-            <a:extLst xmlns:a="http://schemas.openxmlformats.org/drawingml/2006/main">
-              <a:ext uri="{FF2B5EF4-FFF2-40B4-BE49-F238E27FC236}">
-                <a16:creationId xmlns:a16="http://schemas.microsoft.com/office/drawing/2014/main" id="{6F0CC1A1-D332-4F0F-9A0B-28429C4CE1C4}"/>
+          <p:cNvPr id="14" name="">
+            <a:extLst xmlns:a="http://schemas.openxmlformats.org/drawingml/2006/main">
+              <a:ext uri="{FF2B5EF4-FFF2-40B4-BE49-F238E27FC236}">
+                <a16:creationId xmlns:a16="http://schemas.microsoft.com/office/drawing/2014/main" id="{F2658BDB-35F0-4DB2-B7CD-15FF3DF288B5}"/>
               </a:ext>
             </a:extLst>
           </p:cNvPr>
@@ -4840,10 +4897,10 @@
       </p:sp>
       <p:sp>
         <p:nvSpPr>
-          <p:cNvPr id="14" name="">
-            <a:extLst xmlns:a="http://schemas.openxmlformats.org/drawingml/2006/main">
-              <a:ext uri="{FF2B5EF4-FFF2-40B4-BE49-F238E27FC236}">
-                <a16:creationId xmlns:a16="http://schemas.microsoft.com/office/drawing/2014/main" id="{2A6372B1-DA18-4741-805C-22891DC57633}"/>
+          <p:cNvPr id="15" name="">
+            <a:extLst xmlns:a="http://schemas.openxmlformats.org/drawingml/2006/main">
+              <a:ext uri="{FF2B5EF4-FFF2-40B4-BE49-F238E27FC236}">
+                <a16:creationId xmlns:a16="http://schemas.microsoft.com/office/drawing/2014/main" id="{9FEFD270-B9B2-4990-B7F9-90C107105833}"/>
               </a:ext>
             </a:extLst>
           </p:cNvPr>
@@ -4897,10 +4954,10 @@
       </p:sp>
       <p:sp>
         <p:nvSpPr>
-          <p:cNvPr id="15" name="">
-            <a:extLst xmlns:a="http://schemas.openxmlformats.org/drawingml/2006/main">
-              <a:ext uri="{FF2B5EF4-FFF2-40B4-BE49-F238E27FC236}">
-                <a16:creationId xmlns:a16="http://schemas.microsoft.com/office/drawing/2014/main" id="{45101FA9-AE5D-4879-A492-0E9EFCEBD257}"/>
+          <p:cNvPr id="16" name="">
+            <a:extLst xmlns:a="http://schemas.openxmlformats.org/drawingml/2006/main">
+              <a:ext uri="{FF2B5EF4-FFF2-40B4-BE49-F238E27FC236}">
+                <a16:creationId xmlns:a16="http://schemas.microsoft.com/office/drawing/2014/main" id="{56CB37EF-247F-45FD-A231-379791425BE9}"/>
               </a:ext>
             </a:extLst>
           </p:cNvPr>
@@ -4954,10 +5011,10 @@
       </p:sp>
       <p:sp>
         <p:nvSpPr>
-          <p:cNvPr id="16" name="">
-            <a:extLst xmlns:a="http://schemas.openxmlformats.org/drawingml/2006/main">
-              <a:ext uri="{FF2B5EF4-FFF2-40B4-BE49-F238E27FC236}">
-                <a16:creationId xmlns:a16="http://schemas.microsoft.com/office/drawing/2014/main" id="{DC120C8C-65BB-4428-8563-64CA74D34442}"/>
+          <p:cNvPr id="17" name="">
+            <a:extLst xmlns:a="http://schemas.openxmlformats.org/drawingml/2006/main">
+              <a:ext uri="{FF2B5EF4-FFF2-40B4-BE49-F238E27FC236}">
+                <a16:creationId xmlns:a16="http://schemas.microsoft.com/office/drawing/2014/main" id="{096427D8-8146-4FE6-A8D9-F795F9969292}"/>
               </a:ext>
             </a:extLst>
           </p:cNvPr>
@@ -5011,10 +5068,10 @@
       </p:sp>
       <p:sp>
         <p:nvSpPr>
-          <p:cNvPr id="17" name="">
-            <a:extLst xmlns:a="http://schemas.openxmlformats.org/drawingml/2006/main">
-              <a:ext uri="{FF2B5EF4-FFF2-40B4-BE49-F238E27FC236}">
-                <a16:creationId xmlns:a16="http://schemas.microsoft.com/office/drawing/2014/main" id="{C86922AB-C7C3-4BA9-BB0A-71A71F608F5B}"/>
+          <p:cNvPr id="18" name="">
+            <a:extLst xmlns:a="http://schemas.openxmlformats.org/drawingml/2006/main">
+              <a:ext uri="{FF2B5EF4-FFF2-40B4-BE49-F238E27FC236}">
+                <a16:creationId xmlns:a16="http://schemas.microsoft.com/office/drawing/2014/main" id="{602F8AB7-8B09-49F2-84A5-9A53CBD60A97}"/>
               </a:ext>
             </a:extLst>
           </p:cNvPr>
@@ -5041,10 +5098,10 @@
       </p:sp>
       <p:sp>
         <p:nvSpPr>
-          <p:cNvPr id="18" name="">
-            <a:extLst xmlns:a="http://schemas.openxmlformats.org/drawingml/2006/main">
-              <a:ext uri="{FF2B5EF4-FFF2-40B4-BE49-F238E27FC236}">
-                <a16:creationId xmlns:a16="http://schemas.microsoft.com/office/drawing/2014/main" id="{AF9D12ED-BD11-4C9C-B75A-DD485FA2556B}"/>
+          <p:cNvPr id="19" name="">
+            <a:extLst xmlns:a="http://schemas.openxmlformats.org/drawingml/2006/main">
+              <a:ext uri="{FF2B5EF4-FFF2-40B4-BE49-F238E27FC236}">
+                <a16:creationId xmlns:a16="http://schemas.microsoft.com/office/drawing/2014/main" id="{06D4A616-F88C-4106-AB83-B11DCA6917A7}"/>
               </a:ext>
             </a:extLst>
           </p:cNvPr>
@@ -5075,10 +5132,10 @@
       </p:sp>
       <p:sp>
         <p:nvSpPr>
-          <p:cNvPr id="19" name="">
-            <a:extLst xmlns:a="http://schemas.openxmlformats.org/drawingml/2006/main">
-              <a:ext uri="{FF2B5EF4-FFF2-40B4-BE49-F238E27FC236}">
-                <a16:creationId xmlns:a16="http://schemas.microsoft.com/office/drawing/2014/main" id="{A594F333-A38E-47F0-94C1-8494103FAE09}"/>
+          <p:cNvPr id="20" name="">
+            <a:extLst xmlns:a="http://schemas.openxmlformats.org/drawingml/2006/main">
+              <a:ext uri="{FF2B5EF4-FFF2-40B4-BE49-F238E27FC236}">
+                <a16:creationId xmlns:a16="http://schemas.microsoft.com/office/drawing/2014/main" id="{7A88A53A-6258-4510-9276-D1E5F6C39AE0}"/>
               </a:ext>
             </a:extLst>
           </p:cNvPr>
@@ -5107,10 +5164,10 @@
       </p:sp>
       <p:sp>
         <p:nvSpPr>
-          <p:cNvPr id="20" name="">
-            <a:extLst xmlns:a="http://schemas.openxmlformats.org/drawingml/2006/main">
-              <a:ext uri="{FF2B5EF4-FFF2-40B4-BE49-F238E27FC236}">
-                <a16:creationId xmlns:a16="http://schemas.microsoft.com/office/drawing/2014/main" id="{B95C2EEB-241C-4BBC-B73D-976C0BFC9BC3}"/>
+          <p:cNvPr id="21" name="">
+            <a:extLst xmlns:a="http://schemas.openxmlformats.org/drawingml/2006/main">
+              <a:ext uri="{FF2B5EF4-FFF2-40B4-BE49-F238E27FC236}">
+                <a16:creationId xmlns:a16="http://schemas.microsoft.com/office/drawing/2014/main" id="{FD5514E3-51A8-4ECF-897D-3FD7E3894450}"/>
               </a:ext>
             </a:extLst>
           </p:cNvPr>
@@ -5164,10 +5221,10 @@
       </p:sp>
       <p:sp>
         <p:nvSpPr>
-          <p:cNvPr id="21" name="">
-            <a:extLst xmlns:a="http://schemas.openxmlformats.org/drawingml/2006/main">
-              <a:ext uri="{FF2B5EF4-FFF2-40B4-BE49-F238E27FC236}">
-                <a16:creationId xmlns:a16="http://schemas.microsoft.com/office/drawing/2014/main" id="{F9BC6141-0C3A-4B83-B803-07B8FB7D007A}"/>
+          <p:cNvPr id="22" name="">
+            <a:extLst xmlns:a="http://schemas.openxmlformats.org/drawingml/2006/main">
+              <a:ext uri="{FF2B5EF4-FFF2-40B4-BE49-F238E27FC236}">
+                <a16:creationId xmlns:a16="http://schemas.microsoft.com/office/drawing/2014/main" id="{D45F3E1A-EA94-4CC1-8ABF-48F42856B786}"/>
               </a:ext>
             </a:extLst>
           </p:cNvPr>
@@ -5221,10 +5278,10 @@
       </p:sp>
       <p:sp>
         <p:nvSpPr>
-          <p:cNvPr id="22" name="">
-            <a:extLst xmlns:a="http://schemas.openxmlformats.org/drawingml/2006/main">
-              <a:ext uri="{FF2B5EF4-FFF2-40B4-BE49-F238E27FC236}">
-                <a16:creationId xmlns:a16="http://schemas.microsoft.com/office/drawing/2014/main" id="{3A9A31B0-6B1F-4FF6-8B24-F0BDE1D593C3}"/>
+          <p:cNvPr id="23" name="">
+            <a:extLst xmlns:a="http://schemas.openxmlformats.org/drawingml/2006/main">
+              <a:ext uri="{FF2B5EF4-FFF2-40B4-BE49-F238E27FC236}">
+                <a16:creationId xmlns:a16="http://schemas.microsoft.com/office/drawing/2014/main" id="{E7728601-285D-4125-94FD-A7AF34C47AC1}"/>
               </a:ext>
             </a:extLst>
           </p:cNvPr>
@@ -5278,10 +5335,10 @@
       </p:sp>
       <p:sp>
         <p:nvSpPr>
-          <p:cNvPr id="23" name="">
-            <a:extLst xmlns:a="http://schemas.openxmlformats.org/drawingml/2006/main">
-              <a:ext uri="{FF2B5EF4-FFF2-40B4-BE49-F238E27FC236}">
-                <a16:creationId xmlns:a16="http://schemas.microsoft.com/office/drawing/2014/main" id="{19914CA6-E4BB-4853-9DFE-A66CAAA47D8D}"/>
+          <p:cNvPr id="24" name="">
+            <a:extLst xmlns:a="http://schemas.openxmlformats.org/drawingml/2006/main">
+              <a:ext uri="{FF2B5EF4-FFF2-40B4-BE49-F238E27FC236}">
+                <a16:creationId xmlns:a16="http://schemas.microsoft.com/office/drawing/2014/main" id="{985D3364-8D49-47F3-BCBF-4F0DAC690944}"/>
               </a:ext>
             </a:extLst>
           </p:cNvPr>
@@ -5308,10 +5365,10 @@
       </p:sp>
       <p:sp>
         <p:nvSpPr>
-          <p:cNvPr id="24" name="">
-            <a:extLst xmlns:a="http://schemas.openxmlformats.org/drawingml/2006/main">
-              <a:ext uri="{FF2B5EF4-FFF2-40B4-BE49-F238E27FC236}">
-                <a16:creationId xmlns:a16="http://schemas.microsoft.com/office/drawing/2014/main" id="{52DC1D12-84C7-40B1-A427-2DF56BF5DC0C}"/>
+          <p:cNvPr id="25" name="">
+            <a:extLst xmlns:a="http://schemas.openxmlformats.org/drawingml/2006/main">
+              <a:ext uri="{FF2B5EF4-FFF2-40B4-BE49-F238E27FC236}">
+                <a16:creationId xmlns:a16="http://schemas.microsoft.com/office/drawing/2014/main" id="{058DD7DC-0836-4230-80C4-8CCE3392CB88}"/>
               </a:ext>
             </a:extLst>
           </p:cNvPr>
@@ -5342,10 +5399,10 @@
       </p:sp>
       <p:sp>
         <p:nvSpPr>
-          <p:cNvPr id="25" name="">
-            <a:extLst xmlns:a="http://schemas.openxmlformats.org/drawingml/2006/main">
-              <a:ext uri="{FF2B5EF4-FFF2-40B4-BE49-F238E27FC236}">
-                <a16:creationId xmlns:a16="http://schemas.microsoft.com/office/drawing/2014/main" id="{29C442D6-1B10-4EF5-B8D3-447C144631BA}"/>
+          <p:cNvPr id="26" name="">
+            <a:extLst xmlns:a="http://schemas.openxmlformats.org/drawingml/2006/main">
+              <a:ext uri="{FF2B5EF4-FFF2-40B4-BE49-F238E27FC236}">
+                <a16:creationId xmlns:a16="http://schemas.microsoft.com/office/drawing/2014/main" id="{2099373D-3751-4D53-BA55-6230572EC718}"/>
               </a:ext>
             </a:extLst>
           </p:cNvPr>
@@ -5374,10 +5431,10 @@
       </p:sp>
       <p:sp>
         <p:nvSpPr>
-          <p:cNvPr id="26" name="">
-            <a:extLst xmlns:a="http://schemas.openxmlformats.org/drawingml/2006/main">
-              <a:ext uri="{FF2B5EF4-FFF2-40B4-BE49-F238E27FC236}">
-                <a16:creationId xmlns:a16="http://schemas.microsoft.com/office/drawing/2014/main" id="{287CE94F-AA92-4523-9803-B8586850EAD4}"/>
+          <p:cNvPr id="27" name="">
+            <a:extLst xmlns:a="http://schemas.openxmlformats.org/drawingml/2006/main">
+              <a:ext uri="{FF2B5EF4-FFF2-40B4-BE49-F238E27FC236}">
+                <a16:creationId xmlns:a16="http://schemas.microsoft.com/office/drawing/2014/main" id="{E0E8F807-7B5E-4534-A05B-936912451B03}"/>
               </a:ext>
             </a:extLst>
           </p:cNvPr>
@@ -5431,10 +5488,10 @@
       </p:sp>
       <p:sp>
         <p:nvSpPr>
-          <p:cNvPr id="27" name="">
-            <a:extLst xmlns:a="http://schemas.openxmlformats.org/drawingml/2006/main">
-              <a:ext uri="{FF2B5EF4-FFF2-40B4-BE49-F238E27FC236}">
-                <a16:creationId xmlns:a16="http://schemas.microsoft.com/office/drawing/2014/main" id="{3B7141E0-E911-4B8C-A612-4CA0BA1716C4}"/>
+          <p:cNvPr id="28" name="">
+            <a:extLst xmlns:a="http://schemas.openxmlformats.org/drawingml/2006/main">
+              <a:ext uri="{FF2B5EF4-FFF2-40B4-BE49-F238E27FC236}">
+                <a16:creationId xmlns:a16="http://schemas.microsoft.com/office/drawing/2014/main" id="{B2B78716-F168-4B45-9E73-0EB52C0D4532}"/>
               </a:ext>
             </a:extLst>
           </p:cNvPr>
@@ -5488,10 +5545,10 @@
       </p:sp>
       <p:sp>
         <p:nvSpPr>
-          <p:cNvPr id="28" name="">
-            <a:extLst xmlns:a="http://schemas.openxmlformats.org/drawingml/2006/main">
-              <a:ext uri="{FF2B5EF4-FFF2-40B4-BE49-F238E27FC236}">
-                <a16:creationId xmlns:a16="http://schemas.microsoft.com/office/drawing/2014/main" id="{F87D2DCA-A88C-4785-8BCA-89DBB4E47586}"/>
+          <p:cNvPr id="29" name="">
+            <a:extLst xmlns:a="http://schemas.openxmlformats.org/drawingml/2006/main">
+              <a:ext uri="{FF2B5EF4-FFF2-40B4-BE49-F238E27FC236}">
+                <a16:creationId xmlns:a16="http://schemas.microsoft.com/office/drawing/2014/main" id="{1F5EFE4B-F508-445A-A975-936DEA3AA820}"/>
               </a:ext>
             </a:extLst>
           </p:cNvPr>
@@ -5545,10 +5602,10 @@
       </p:sp>
       <p:sp>
         <p:nvSpPr>
-          <p:cNvPr id="29" name="">
-            <a:extLst xmlns:a="http://schemas.openxmlformats.org/drawingml/2006/main">
-              <a:ext uri="{FF2B5EF4-FFF2-40B4-BE49-F238E27FC236}">
-                <a16:creationId xmlns:a16="http://schemas.microsoft.com/office/drawing/2014/main" id="{022BCE76-C021-4785-A666-3E7E55B47685}"/>
+          <p:cNvPr id="30" name="">
+            <a:extLst xmlns:a="http://schemas.openxmlformats.org/drawingml/2006/main">
+              <a:ext uri="{FF2B5EF4-FFF2-40B4-BE49-F238E27FC236}">
+                <a16:creationId xmlns:a16="http://schemas.microsoft.com/office/drawing/2014/main" id="{4F216C12-0E11-4A2F-B16F-9E5A57F5D295}"/>
               </a:ext>
             </a:extLst>
           </p:cNvPr>
@@ -5575,10 +5632,10 @@
       </p:sp>
       <p:sp>
         <p:nvSpPr>
-          <p:cNvPr id="30" name="">
-            <a:extLst xmlns:a="http://schemas.openxmlformats.org/drawingml/2006/main">
-              <a:ext uri="{FF2B5EF4-FFF2-40B4-BE49-F238E27FC236}">
-                <a16:creationId xmlns:a16="http://schemas.microsoft.com/office/drawing/2014/main" id="{A6E051AF-4993-42F4-AFCD-1B01A4F80CCF}"/>
+          <p:cNvPr id="31" name="">
+            <a:extLst xmlns:a="http://schemas.openxmlformats.org/drawingml/2006/main">
+              <a:ext uri="{FF2B5EF4-FFF2-40B4-BE49-F238E27FC236}">
+                <a16:creationId xmlns:a16="http://schemas.microsoft.com/office/drawing/2014/main" id="{B131F215-FBD0-4F4C-9FA0-37A547243645}"/>
               </a:ext>
             </a:extLst>
           </p:cNvPr>
@@ -5609,10 +5666,10 @@
       </p:sp>
       <p:sp>
         <p:nvSpPr>
-          <p:cNvPr id="31" name="">
-            <a:extLst xmlns:a="http://schemas.openxmlformats.org/drawingml/2006/main">
-              <a:ext uri="{FF2B5EF4-FFF2-40B4-BE49-F238E27FC236}">
-                <a16:creationId xmlns:a16="http://schemas.microsoft.com/office/drawing/2014/main" id="{254E2689-1B9C-4CA9-8D21-97181A0209AA}"/>
+          <p:cNvPr id="32" name="">
+            <a:extLst xmlns:a="http://schemas.openxmlformats.org/drawingml/2006/main">
+              <a:ext uri="{FF2B5EF4-FFF2-40B4-BE49-F238E27FC236}">
+                <a16:creationId xmlns:a16="http://schemas.microsoft.com/office/drawing/2014/main" id="{8E9B4575-A78F-45F2-889D-1942A1A93638}"/>
               </a:ext>
             </a:extLst>
           </p:cNvPr>
@@ -5641,10 +5698,10 @@
       </p:sp>
       <p:sp>
         <p:nvSpPr>
-          <p:cNvPr id="32" name="">
-            <a:extLst xmlns:a="http://schemas.openxmlformats.org/drawingml/2006/main">
-              <a:ext uri="{FF2B5EF4-FFF2-40B4-BE49-F238E27FC236}">
-                <a16:creationId xmlns:a16="http://schemas.microsoft.com/office/drawing/2014/main" id="{0E790197-BE01-434E-A62F-1F1D198387C8}"/>
+          <p:cNvPr id="33" name="">
+            <a:extLst xmlns:a="http://schemas.openxmlformats.org/drawingml/2006/main">
+              <a:ext uri="{FF2B5EF4-FFF2-40B4-BE49-F238E27FC236}">
+                <a16:creationId xmlns:a16="http://schemas.microsoft.com/office/drawing/2014/main" id="{BEE990E2-658A-4C96-897D-D0C191AF276A}"/>
               </a:ext>
             </a:extLst>
           </p:cNvPr>
@@ -5698,10 +5755,10 @@
       </p:sp>
       <p:sp>
         <p:nvSpPr>
-          <p:cNvPr id="33" name="">
-            <a:extLst xmlns:a="http://schemas.openxmlformats.org/drawingml/2006/main">
-              <a:ext uri="{FF2B5EF4-FFF2-40B4-BE49-F238E27FC236}">
-                <a16:creationId xmlns:a16="http://schemas.microsoft.com/office/drawing/2014/main" id="{DC455294-4F23-42A4-9D2B-1DFE30250A87}"/>
+          <p:cNvPr id="34" name="">
+            <a:extLst xmlns:a="http://schemas.openxmlformats.org/drawingml/2006/main">
+              <a:ext uri="{FF2B5EF4-FFF2-40B4-BE49-F238E27FC236}">
+                <a16:creationId xmlns:a16="http://schemas.microsoft.com/office/drawing/2014/main" id="{B1A39EB8-1B40-4B28-95AE-8D7A47FF892E}"/>
               </a:ext>
             </a:extLst>
           </p:cNvPr>
@@ -5755,10 +5812,10 @@
       </p:sp>
       <p:sp>
         <p:nvSpPr>
-          <p:cNvPr id="34" name="">
-            <a:extLst xmlns:a="http://schemas.openxmlformats.org/drawingml/2006/main">
-              <a:ext uri="{FF2B5EF4-FFF2-40B4-BE49-F238E27FC236}">
-                <a16:creationId xmlns:a16="http://schemas.microsoft.com/office/drawing/2014/main" id="{F17B3871-5302-4755-A7F7-24A5E850BD42}"/>
+          <p:cNvPr id="35" name="">
+            <a:extLst xmlns:a="http://schemas.openxmlformats.org/drawingml/2006/main">
+              <a:ext uri="{FF2B5EF4-FFF2-40B4-BE49-F238E27FC236}">
+                <a16:creationId xmlns:a16="http://schemas.microsoft.com/office/drawing/2014/main" id="{222128E6-384A-4044-8ED8-CD9B6D645683}"/>
               </a:ext>
             </a:extLst>
           </p:cNvPr>
@@ -5812,10 +5869,10 @@
       </p:sp>
       <p:sp>
         <p:nvSpPr>
-          <p:cNvPr id="35" name="">
-            <a:extLst xmlns:a="http://schemas.openxmlformats.org/drawingml/2006/main">
-              <a:ext uri="{FF2B5EF4-FFF2-40B4-BE49-F238E27FC236}">
-                <a16:creationId xmlns:a16="http://schemas.microsoft.com/office/drawing/2014/main" id="{0DA46C72-A06C-442A-B802-E057AC1FCADA}"/>
+          <p:cNvPr id="36" name="">
+            <a:extLst xmlns:a="http://schemas.openxmlformats.org/drawingml/2006/main">
+              <a:ext uri="{FF2B5EF4-FFF2-40B4-BE49-F238E27FC236}">
+                <a16:creationId xmlns:a16="http://schemas.microsoft.com/office/drawing/2014/main" id="{FBAA2C1C-2AB3-4B54-8C26-D19038E01E52}"/>
               </a:ext>
             </a:extLst>
           </p:cNvPr>
@@ -5842,10 +5899,10 @@
       </p:sp>
       <p:sp>
         <p:nvSpPr>
-          <p:cNvPr id="36" name="">
-            <a:extLst xmlns:a="http://schemas.openxmlformats.org/drawingml/2006/main">
-              <a:ext uri="{FF2B5EF4-FFF2-40B4-BE49-F238E27FC236}">
-                <a16:creationId xmlns:a16="http://schemas.microsoft.com/office/drawing/2014/main" id="{63694F7F-566E-469F-8199-817EB59BB950}"/>
+          <p:cNvPr id="37" name="">
+            <a:extLst xmlns:a="http://schemas.openxmlformats.org/drawingml/2006/main">
+              <a:ext uri="{FF2B5EF4-FFF2-40B4-BE49-F238E27FC236}">
+                <a16:creationId xmlns:a16="http://schemas.microsoft.com/office/drawing/2014/main" id="{CA7A2FF1-B538-4D2A-B81A-9B95EC2B3174}"/>
               </a:ext>
             </a:extLst>
           </p:cNvPr>
@@ -5876,10 +5933,10 @@
       </p:sp>
       <p:sp>
         <p:nvSpPr>
-          <p:cNvPr id="37" name="">
-            <a:extLst xmlns:a="http://schemas.openxmlformats.org/drawingml/2006/main">
-              <a:ext uri="{FF2B5EF4-FFF2-40B4-BE49-F238E27FC236}">
-                <a16:creationId xmlns:a16="http://schemas.microsoft.com/office/drawing/2014/main" id="{F781F7EE-2BB6-45D8-A7BB-04836211B7B7}"/>
+          <p:cNvPr id="38" name="">
+            <a:extLst xmlns:a="http://schemas.openxmlformats.org/drawingml/2006/main">
+              <a:ext uri="{FF2B5EF4-FFF2-40B4-BE49-F238E27FC236}">
+                <a16:creationId xmlns:a16="http://schemas.microsoft.com/office/drawing/2014/main" id="{0CFBB81E-AB67-43FA-BED0-8DD99F095CF6}"/>
               </a:ext>
             </a:extLst>
           </p:cNvPr>
@@ -5908,10 +5965,10 @@
       </p:sp>
       <p:sp>
         <p:nvSpPr>
-          <p:cNvPr id="38" name="">
-            <a:extLst xmlns:a="http://schemas.openxmlformats.org/drawingml/2006/main">
-              <a:ext uri="{FF2B5EF4-FFF2-40B4-BE49-F238E27FC236}">
-                <a16:creationId xmlns:a16="http://schemas.microsoft.com/office/drawing/2014/main" id="{F6BCAA64-CCC3-4B89-AA1F-50D6F1C2F528}"/>
+          <p:cNvPr id="39" name="">
+            <a:extLst xmlns:a="http://schemas.openxmlformats.org/drawingml/2006/main">
+              <a:ext uri="{FF2B5EF4-FFF2-40B4-BE49-F238E27FC236}">
+                <a16:creationId xmlns:a16="http://schemas.microsoft.com/office/drawing/2014/main" id="{D9D5922F-82D8-4CBD-910C-473150F8E30E}"/>
               </a:ext>
             </a:extLst>
           </p:cNvPr>
@@ -5965,10 +6022,10 @@
       </p:sp>
       <p:sp>
         <p:nvSpPr>
-          <p:cNvPr id="39" name="">
-            <a:extLst xmlns:a="http://schemas.openxmlformats.org/drawingml/2006/main">
-              <a:ext uri="{FF2B5EF4-FFF2-40B4-BE49-F238E27FC236}">
-                <a16:creationId xmlns:a16="http://schemas.microsoft.com/office/drawing/2014/main" id="{9D059C68-D3E8-4B24-9AB0-B9E057A441E0}"/>
+          <p:cNvPr id="40" name="">
+            <a:extLst xmlns:a="http://schemas.openxmlformats.org/drawingml/2006/main">
+              <a:ext uri="{FF2B5EF4-FFF2-40B4-BE49-F238E27FC236}">
+                <a16:creationId xmlns:a16="http://schemas.microsoft.com/office/drawing/2014/main" id="{00AE967A-204D-4150-97A1-65E6541E84B4}"/>
               </a:ext>
             </a:extLst>
           </p:cNvPr>
@@ -6022,10 +6079,10 @@
       </p:sp>
       <p:sp>
         <p:nvSpPr>
-          <p:cNvPr id="40" name="">
-            <a:extLst xmlns:a="http://schemas.openxmlformats.org/drawingml/2006/main">
-              <a:ext uri="{FF2B5EF4-FFF2-40B4-BE49-F238E27FC236}">
-                <a16:creationId xmlns:a16="http://schemas.microsoft.com/office/drawing/2014/main" id="{7B72EE36-2970-4750-A482-3B18932ECFF6}"/>
+          <p:cNvPr id="41" name="">
+            <a:extLst xmlns:a="http://schemas.openxmlformats.org/drawingml/2006/main">
+              <a:ext uri="{FF2B5EF4-FFF2-40B4-BE49-F238E27FC236}">
+                <a16:creationId xmlns:a16="http://schemas.microsoft.com/office/drawing/2014/main" id="{31690165-8345-4965-970D-734796C3E8CA}"/>
               </a:ext>
             </a:extLst>
           </p:cNvPr>
@@ -6079,39 +6136,159 @@
       </p:sp>
       <p:sp>
         <p:nvSpPr>
-          <p:cNvPr id="41" name="">
-            <a:extLst xmlns:a="http://schemas.openxmlformats.org/drawingml/2006/main">
-              <a:ext uri="{FF2B5EF4-FFF2-40B4-BE49-F238E27FC236}">
-                <a16:creationId xmlns:a16="http://schemas.microsoft.com/office/drawing/2014/main" id="{73B26FB8-8427-40B6-AD2F-00D1D59BA787}"/>
-              </a:ext>
-            </a:extLst>
-          </p:cNvPr>
-          <p:cNvSpPr>
-            <a:spLocks xmlns:a="http://schemas.openxmlformats.org/drawingml/2006/main" noGrp="1"/>
-          </p:cNvSpPr>
-          <p:nvPr/>
-        </p:nvSpPr>
-        <p:spPr>
-          <a:xfrm xmlns:a="http://schemas.openxmlformats.org/drawingml/2006/main">
-            <a:off x="571500" y="3143250"/>
-            <a:ext cx="11049000" cy="190500"/>
-          </a:xfrm>
-          <a:prstGeom xmlns:a="http://schemas.openxmlformats.org/drawingml/2006/main" prst="rect">
-            <a:avLst/>
-          </a:prstGeom>
-          <a:noFill xmlns:a="http://schemas.openxmlformats.org/drawingml/2006/main"/>
-          <a:ln xmlns:a="http://schemas.openxmlformats.org/drawingml/2006/main" w="0">
-            <a:noFill/>
-          </a:ln>
-        </p:spPr>
-        <p:txBody>
-          <a:bodyPr xmlns:a="http://schemas.openxmlformats.org/drawingml/2006/main" anchor="ctr">
-            <a:normAutofit fontScale="66667"/>
+          <p:cNvPr id="42" name="">
+            <a:extLst xmlns:a="http://schemas.openxmlformats.org/drawingml/2006/main">
+              <a:ext uri="{FF2B5EF4-FFF2-40B4-BE49-F238E27FC236}">
+                <a16:creationId xmlns:a16="http://schemas.microsoft.com/office/drawing/2014/main" id="{4BAA0587-A0E1-4248-93FE-97AAA4F45E13}"/>
+              </a:ext>
+            </a:extLst>
+          </p:cNvPr>
+          <p:cNvSpPr>
+            <a:spLocks xmlns:a="http://schemas.openxmlformats.org/drawingml/2006/main" noGrp="1"/>
+          </p:cNvSpPr>
+          <p:nvPr/>
+        </p:nvSpPr>
+        <p:spPr>
+          <a:xfrm xmlns:a="http://schemas.openxmlformats.org/drawingml/2006/main">
+            <a:off x="4752975" y="3067050"/>
+            <a:ext cx="19050" cy="133350"/>
+          </a:xfrm>
+          <a:prstGeom xmlns:a="http://schemas.openxmlformats.org/drawingml/2006/main" prst="rect">
+            <a:avLst/>
+          </a:prstGeom>
+          <a:solidFill xmlns:a="http://schemas.openxmlformats.org/drawingml/2006/main">
+            <a:srgbClr val="7657D6"/>
+          </a:solidFill>
+          <a:ln xmlns:a="http://schemas.openxmlformats.org/drawingml/2006/main" w="0">
+            <a:noFill/>
+          </a:ln>
+        </p:spPr>
+      </p:sp>
+      <p:sp>
+        <p:nvSpPr>
+          <p:cNvPr id="43" name="">
+            <a:extLst xmlns:a="http://schemas.openxmlformats.org/drawingml/2006/main">
+              <a:ext uri="{FF2B5EF4-FFF2-40B4-BE49-F238E27FC236}">
+                <a16:creationId xmlns:a16="http://schemas.microsoft.com/office/drawing/2014/main" id="{F31838FF-2ECC-4042-89AE-6C5D88B733A9}"/>
+              </a:ext>
+            </a:extLst>
+          </p:cNvPr>
+          <p:cNvSpPr>
+            <a:spLocks xmlns:a="http://schemas.openxmlformats.org/drawingml/2006/main" noGrp="1"/>
+          </p:cNvSpPr>
+          <p:nvPr/>
+        </p:nvSpPr>
+        <p:spPr>
+          <a:xfrm xmlns:a="http://schemas.openxmlformats.org/drawingml/2006/main">
+            <a:off x="3143250" y="3190875"/>
+            <a:ext cx="1619250" cy="19050"/>
+          </a:xfrm>
+          <a:prstGeom xmlns:a="http://schemas.openxmlformats.org/drawingml/2006/main" prst="rect">
+            <a:avLst/>
+          </a:prstGeom>
+          <a:solidFill xmlns:a="http://schemas.openxmlformats.org/drawingml/2006/main">
+            <a:srgbClr val="7657D6"/>
+          </a:solidFill>
+          <a:ln xmlns:a="http://schemas.openxmlformats.org/drawingml/2006/main" w="0">
+            <a:noFill/>
+          </a:ln>
+        </p:spPr>
+      </p:sp>
+      <p:sp>
+        <p:nvSpPr>
+          <p:cNvPr id="44" name="">
+            <a:extLst xmlns:a="http://schemas.openxmlformats.org/drawingml/2006/main">
+              <a:ext uri="{FF2B5EF4-FFF2-40B4-BE49-F238E27FC236}">
+                <a16:creationId xmlns:a16="http://schemas.microsoft.com/office/drawing/2014/main" id="{B4631D53-ABAE-4802-B56F-26698D36C454}"/>
+              </a:ext>
+            </a:extLst>
+          </p:cNvPr>
+          <p:cNvSpPr>
+            <a:spLocks xmlns:a="http://schemas.openxmlformats.org/drawingml/2006/main" noGrp="1"/>
+          </p:cNvSpPr>
+          <p:nvPr/>
+        </p:nvSpPr>
+        <p:spPr>
+          <a:xfrm xmlns:a="http://schemas.openxmlformats.org/drawingml/2006/main">
+            <a:off x="3133725" y="3152775"/>
+            <a:ext cx="19050" cy="47625"/>
+          </a:xfrm>
+          <a:prstGeom xmlns:a="http://schemas.openxmlformats.org/drawingml/2006/main" prst="rect">
+            <a:avLst/>
+          </a:prstGeom>
+          <a:solidFill xmlns:a="http://schemas.openxmlformats.org/drawingml/2006/main">
+            <a:srgbClr val="7657D6"/>
+          </a:solidFill>
+          <a:ln xmlns:a="http://schemas.openxmlformats.org/drawingml/2006/main" w="0">
+            <a:noFill/>
+          </a:ln>
+        </p:spPr>
+      </p:sp>
+      <p:sp>
+        <p:nvSpPr>
+          <p:cNvPr id="45" name="">
+            <a:extLst xmlns:a="http://schemas.openxmlformats.org/drawingml/2006/main">
+              <a:ext uri="{FF2B5EF4-FFF2-40B4-BE49-F238E27FC236}">
+                <a16:creationId xmlns:a16="http://schemas.microsoft.com/office/drawing/2014/main" id="{5223B845-364F-42D9-9A11-432DF7C5B476}"/>
+              </a:ext>
+            </a:extLst>
+          </p:cNvPr>
+          <p:cNvSpPr>
+            <a:spLocks xmlns:a="http://schemas.openxmlformats.org/drawingml/2006/main" noGrp="1"/>
+          </p:cNvSpPr>
+          <p:nvPr/>
+        </p:nvSpPr>
+        <p:spPr>
+          <a:xfrm xmlns:a="http://schemas.openxmlformats.org/drawingml/2006/main">
+            <a:off x="3076575" y="3067050"/>
+            <a:ext cx="133350" cy="95250"/>
+          </a:xfrm>
+          <a:prstGeom xmlns:a="http://schemas.openxmlformats.org/drawingml/2006/main" prst="triangle">
+            <a:avLst/>
+          </a:prstGeom>
+          <a:solidFill xmlns:a="http://schemas.openxmlformats.org/drawingml/2006/main">
+            <a:srgbClr val="7657D6"/>
+          </a:solidFill>
+          <a:ln xmlns:a="http://schemas.openxmlformats.org/drawingml/2006/main" w="0">
+            <a:noFill/>
+          </a:ln>
+        </p:spPr>
+      </p:sp>
+      <p:sp>
+        <p:nvSpPr>
+          <p:cNvPr id="46" name="">
+            <a:extLst xmlns:a="http://schemas.openxmlformats.org/drawingml/2006/main">
+              <a:ext uri="{FF2B5EF4-FFF2-40B4-BE49-F238E27FC236}">
+                <a16:creationId xmlns:a16="http://schemas.microsoft.com/office/drawing/2014/main" id="{7019679D-1B6F-4CBB-963B-ABFC1D736E5E}"/>
+              </a:ext>
+            </a:extLst>
+          </p:cNvPr>
+          <p:cNvSpPr>
+            <a:spLocks xmlns:a="http://schemas.openxmlformats.org/drawingml/2006/main" noGrp="1"/>
+          </p:cNvSpPr>
+          <p:nvPr/>
+        </p:nvSpPr>
+        <p:spPr>
+          <a:xfrm xmlns:a="http://schemas.openxmlformats.org/drawingml/2006/main">
+            <a:off x="8686800" y="3067050"/>
+            <a:ext cx="2933700" cy="161925"/>
+          </a:xfrm>
+          <a:prstGeom xmlns:a="http://schemas.openxmlformats.org/drawingml/2006/main" prst="rect">
+            <a:avLst/>
+          </a:prstGeom>
+          <a:noFill xmlns:a="http://schemas.openxmlformats.org/drawingml/2006/main"/>
+          <a:ln xmlns:a="http://schemas.openxmlformats.org/drawingml/2006/main" w="0">
+            <a:noFill/>
+          </a:ln>
+        </p:spPr>
+        <p:txBody>
+          <a:bodyPr xmlns:a="http://schemas.openxmlformats.org/drawingml/2006/main" anchor="ctr">
+            <a:normAutofit fontScale="56061"/>
           </a:bodyPr>
           <a:lstStyle xmlns:a="http://schemas.openxmlformats.org/drawingml/2006/main"/>
           <a:p xmlns:a="http://schemas.openxmlformats.org/drawingml/2006/main">
             <a:pPr algn="l">
-              <a:defRPr sz="975" b="1">
+              <a:defRPr sz="825" b="1">
                 <a:solidFill>
                   <a:srgbClr val="7657D6"/>
                 </a:solidFill>
@@ -6121,7 +6298,7 @@
               </a:defRPr>
             </a:pPr>
             <a:r>
-              <a:rPr sz="975" b="1">
+              <a:rPr sz="825" b="1">
                 <a:solidFill>
                   <a:srgbClr val="7657D6"/>
                 </a:solidFill>
@@ -6129,28 +6306,205 @@
                 <a:ea typeface="Malgun Gothic"/>
                 <a:cs typeface="Malgun Gothic"/>
               </a:rPr>
-              <a:t>제한적 ReAct  |  Observe → Retrieve → Reason → Act → Observe   (저신뢰·모호하면 Query Rewrite 후 재검색·재판단 최대 1회)</a:t>
-            </a:r>
-          </a:p>
-        </p:txBody>
-      </p:sp>
-      <p:sp>
-        <p:nvSpPr>
-          <p:cNvPr id="42" name="">
-            <a:extLst xmlns:a="http://schemas.openxmlformats.org/drawingml/2006/main">
-              <a:ext uri="{FF2B5EF4-FFF2-40B4-BE49-F238E27FC236}">
-                <a16:creationId xmlns:a16="http://schemas.microsoft.com/office/drawing/2014/main" id="{B188ECA0-369F-4FC7-AE49-AC37DC4B7AE6}"/>
-              </a:ext>
-            </a:extLst>
-          </p:cNvPr>
-          <p:cNvSpPr>
-            <a:spLocks xmlns:a="http://schemas.openxmlformats.org/drawingml/2006/main" noGrp="1"/>
-          </p:cNvSpPr>
-          <p:nvPr/>
-        </p:nvSpPr>
-        <p:spPr>
-          <a:xfrm xmlns:a="http://schemas.openxmlformats.org/drawingml/2006/main">
-            <a:off x="571500" y="3371850"/>
+              <a:t>Self-Correction  |  Query Rewrite 후 재검색, 최대 1회</a:t>
+            </a:r>
+          </a:p>
+        </p:txBody>
+      </p:sp>
+      <p:sp>
+        <p:nvSpPr>
+          <p:cNvPr id="47" name="">
+            <a:extLst xmlns:a="http://schemas.openxmlformats.org/drawingml/2006/main">
+              <a:ext uri="{FF2B5EF4-FFF2-40B4-BE49-F238E27FC236}">
+                <a16:creationId xmlns:a16="http://schemas.microsoft.com/office/drawing/2014/main" id="{E58E6196-84DB-48CB-9479-666B511DA85B}"/>
+              </a:ext>
+            </a:extLst>
+          </p:cNvPr>
+          <p:cNvSpPr>
+            <a:spLocks xmlns:a="http://schemas.openxmlformats.org/drawingml/2006/main" noGrp="1"/>
+          </p:cNvSpPr>
+          <p:nvPr/>
+        </p:nvSpPr>
+        <p:spPr>
+          <a:xfrm xmlns:a="http://schemas.openxmlformats.org/drawingml/2006/main">
+            <a:off x="8562975" y="3067050"/>
+            <a:ext cx="19050" cy="285750"/>
+          </a:xfrm>
+          <a:prstGeom xmlns:a="http://schemas.openxmlformats.org/drawingml/2006/main" prst="rect">
+            <a:avLst/>
+          </a:prstGeom>
+          <a:solidFill xmlns:a="http://schemas.openxmlformats.org/drawingml/2006/main">
+            <a:srgbClr val="0F8A99"/>
+          </a:solidFill>
+          <a:ln xmlns:a="http://schemas.openxmlformats.org/drawingml/2006/main" w="0">
+            <a:noFill/>
+          </a:ln>
+        </p:spPr>
+      </p:sp>
+      <p:sp>
+        <p:nvSpPr>
+          <p:cNvPr id="48" name="">
+            <a:extLst xmlns:a="http://schemas.openxmlformats.org/drawingml/2006/main">
+              <a:ext uri="{FF2B5EF4-FFF2-40B4-BE49-F238E27FC236}">
+                <a16:creationId xmlns:a16="http://schemas.microsoft.com/office/drawing/2014/main" id="{B51F96E4-A1EF-4742-BFBE-2F783BFDE77F}"/>
+              </a:ext>
+            </a:extLst>
+          </p:cNvPr>
+          <p:cNvSpPr>
+            <a:spLocks xmlns:a="http://schemas.openxmlformats.org/drawingml/2006/main" noGrp="1"/>
+          </p:cNvSpPr>
+          <p:nvPr/>
+        </p:nvSpPr>
+        <p:spPr>
+          <a:xfrm xmlns:a="http://schemas.openxmlformats.org/drawingml/2006/main">
+            <a:off x="5238750" y="3343275"/>
+            <a:ext cx="3333750" cy="19050"/>
+          </a:xfrm>
+          <a:prstGeom xmlns:a="http://schemas.openxmlformats.org/drawingml/2006/main" prst="rect">
+            <a:avLst/>
+          </a:prstGeom>
+          <a:solidFill xmlns:a="http://schemas.openxmlformats.org/drawingml/2006/main">
+            <a:srgbClr val="0F8A99"/>
+          </a:solidFill>
+          <a:ln xmlns:a="http://schemas.openxmlformats.org/drawingml/2006/main" w="0">
+            <a:noFill/>
+          </a:ln>
+        </p:spPr>
+      </p:sp>
+      <p:sp>
+        <p:nvSpPr>
+          <p:cNvPr id="49" name="">
+            <a:extLst xmlns:a="http://schemas.openxmlformats.org/drawingml/2006/main">
+              <a:ext uri="{FF2B5EF4-FFF2-40B4-BE49-F238E27FC236}">
+                <a16:creationId xmlns:a16="http://schemas.microsoft.com/office/drawing/2014/main" id="{B02AA93F-EAD2-441E-B0AB-26777DB39AF1}"/>
+              </a:ext>
+            </a:extLst>
+          </p:cNvPr>
+          <p:cNvSpPr>
+            <a:spLocks xmlns:a="http://schemas.openxmlformats.org/drawingml/2006/main" noGrp="1"/>
+          </p:cNvSpPr>
+          <p:nvPr/>
+        </p:nvSpPr>
+        <p:spPr>
+          <a:xfrm xmlns:a="http://schemas.openxmlformats.org/drawingml/2006/main">
+            <a:off x="5229225" y="3152775"/>
+            <a:ext cx="19050" cy="200025"/>
+          </a:xfrm>
+          <a:prstGeom xmlns:a="http://schemas.openxmlformats.org/drawingml/2006/main" prst="rect">
+            <a:avLst/>
+          </a:prstGeom>
+          <a:solidFill xmlns:a="http://schemas.openxmlformats.org/drawingml/2006/main">
+            <a:srgbClr val="0F8A99"/>
+          </a:solidFill>
+          <a:ln xmlns:a="http://schemas.openxmlformats.org/drawingml/2006/main" w="0">
+            <a:noFill/>
+          </a:ln>
+        </p:spPr>
+      </p:sp>
+      <p:sp>
+        <p:nvSpPr>
+          <p:cNvPr id="50" name="">
+            <a:extLst xmlns:a="http://schemas.openxmlformats.org/drawingml/2006/main">
+              <a:ext uri="{FF2B5EF4-FFF2-40B4-BE49-F238E27FC236}">
+                <a16:creationId xmlns:a16="http://schemas.microsoft.com/office/drawing/2014/main" id="{2830D1EC-6E2C-4AED-AE42-3F622611A5E9}"/>
+              </a:ext>
+            </a:extLst>
+          </p:cNvPr>
+          <p:cNvSpPr>
+            <a:spLocks xmlns:a="http://schemas.openxmlformats.org/drawingml/2006/main" noGrp="1"/>
+          </p:cNvSpPr>
+          <p:nvPr/>
+        </p:nvSpPr>
+        <p:spPr>
+          <a:xfrm xmlns:a="http://schemas.openxmlformats.org/drawingml/2006/main">
+            <a:off x="5172075" y="3067050"/>
+            <a:ext cx="133350" cy="95250"/>
+          </a:xfrm>
+          <a:prstGeom xmlns:a="http://schemas.openxmlformats.org/drawingml/2006/main" prst="triangle">
+            <a:avLst/>
+          </a:prstGeom>
+          <a:solidFill xmlns:a="http://schemas.openxmlformats.org/drawingml/2006/main">
+            <a:srgbClr val="0F8A99"/>
+          </a:solidFill>
+          <a:ln xmlns:a="http://schemas.openxmlformats.org/drawingml/2006/main" w="0">
+            <a:noFill/>
+          </a:ln>
+        </p:spPr>
+      </p:sp>
+      <p:sp>
+        <p:nvSpPr>
+          <p:cNvPr id="51" name="">
+            <a:extLst xmlns:a="http://schemas.openxmlformats.org/drawingml/2006/main">
+              <a:ext uri="{FF2B5EF4-FFF2-40B4-BE49-F238E27FC236}">
+                <a16:creationId xmlns:a16="http://schemas.microsoft.com/office/drawing/2014/main" id="{7C9C4CBB-B4D6-4020-A168-C08F45323E95}"/>
+              </a:ext>
+            </a:extLst>
+          </p:cNvPr>
+          <p:cNvSpPr>
+            <a:spLocks xmlns:a="http://schemas.openxmlformats.org/drawingml/2006/main" noGrp="1"/>
+          </p:cNvSpPr>
+          <p:nvPr/>
+        </p:nvSpPr>
+        <p:spPr>
+          <a:xfrm xmlns:a="http://schemas.openxmlformats.org/drawingml/2006/main">
+            <a:off x="8686800" y="3248025"/>
+            <a:ext cx="2933700" cy="161925"/>
+          </a:xfrm>
+          <a:prstGeom xmlns:a="http://schemas.openxmlformats.org/drawingml/2006/main" prst="rect">
+            <a:avLst/>
+          </a:prstGeom>
+          <a:noFill xmlns:a="http://schemas.openxmlformats.org/drawingml/2006/main"/>
+          <a:ln xmlns:a="http://schemas.openxmlformats.org/drawingml/2006/main" w="0">
+            <a:noFill/>
+          </a:ln>
+        </p:spPr>
+        <p:txBody>
+          <a:bodyPr xmlns:a="http://schemas.openxmlformats.org/drawingml/2006/main" anchor="ctr">
+            <a:normAutofit fontScale="56061"/>
+          </a:bodyPr>
+          <a:lstStyle xmlns:a="http://schemas.openxmlformats.org/drawingml/2006/main"/>
+          <a:p xmlns:a="http://schemas.openxmlformats.org/drawingml/2006/main">
+            <a:pPr algn="l">
+              <a:defRPr sz="825" b="1">
+                <a:solidFill>
+                  <a:srgbClr val="0F8A99"/>
+                </a:solidFill>
+                <a:latin typeface="Malgun Gothic"/>
+                <a:ea typeface="Malgun Gothic"/>
+                <a:cs typeface="Malgun Gothic"/>
+              </a:defRPr>
+            </a:pPr>
+            <a:r>
+              <a:rPr sz="825" b="1">
+                <a:solidFill>
+                  <a:srgbClr val="0F8A99"/>
+                </a:solidFill>
+                <a:latin typeface="Malgun Gothic"/>
+                <a:ea typeface="Malgun Gothic"/>
+                <a:cs typeface="Malgun Gothic"/>
+              </a:rPr>
+              <a:t>Act → Observe  |  저장 결과를 다시 조회</a:t>
+            </a:r>
+          </a:p>
+        </p:txBody>
+      </p:sp>
+      <p:sp>
+        <p:nvSpPr>
+          <p:cNvPr id="52" name="">
+            <a:extLst xmlns:a="http://schemas.openxmlformats.org/drawingml/2006/main">
+              <a:ext uri="{FF2B5EF4-FFF2-40B4-BE49-F238E27FC236}">
+                <a16:creationId xmlns:a16="http://schemas.microsoft.com/office/drawing/2014/main" id="{0FC6A962-CD6D-4860-BD6F-37D7E7215A8B}"/>
+              </a:ext>
+            </a:extLst>
+          </p:cNvPr>
+          <p:cNvSpPr>
+            <a:spLocks xmlns:a="http://schemas.openxmlformats.org/drawingml/2006/main" noGrp="1"/>
+          </p:cNvSpPr>
+          <p:nvPr/>
+        </p:nvSpPr>
+        <p:spPr>
+          <a:xfrm xmlns:a="http://schemas.openxmlformats.org/drawingml/2006/main">
+            <a:off x="571500" y="3448050"/>
             <a:ext cx="11049000" cy="762000"/>
           </a:xfrm>
           <a:prstGeom xmlns:a="http://schemas.openxmlformats.org/drawingml/2006/main" prst="roundRect">
@@ -6168,21 +6522,21 @@
       </p:sp>
       <p:sp>
         <p:nvSpPr>
-          <p:cNvPr id="43" name="">
-            <a:extLst xmlns:a="http://schemas.openxmlformats.org/drawingml/2006/main">
-              <a:ext uri="{FF2B5EF4-FFF2-40B4-BE49-F238E27FC236}">
-                <a16:creationId xmlns:a16="http://schemas.microsoft.com/office/drawing/2014/main" id="{7DBCF324-1506-4DE1-A3BC-E9A6E949C0BE}"/>
-              </a:ext>
-            </a:extLst>
-          </p:cNvPr>
-          <p:cNvSpPr>
-            <a:spLocks xmlns:a="http://schemas.openxmlformats.org/drawingml/2006/main" noGrp="1"/>
-          </p:cNvSpPr>
-          <p:nvPr/>
-        </p:nvSpPr>
-        <p:spPr>
-          <a:xfrm xmlns:a="http://schemas.openxmlformats.org/drawingml/2006/main">
-            <a:off x="781050" y="3429000"/>
+          <p:cNvPr id="53" name="">
+            <a:extLst xmlns:a="http://schemas.openxmlformats.org/drawingml/2006/main">
+              <a:ext uri="{FF2B5EF4-FFF2-40B4-BE49-F238E27FC236}">
+                <a16:creationId xmlns:a16="http://schemas.microsoft.com/office/drawing/2014/main" id="{9A5B2548-4243-4C2C-ABA4-A6E16865DA92}"/>
+              </a:ext>
+            </a:extLst>
+          </p:cNvPr>
+          <p:cNvSpPr>
+            <a:spLocks xmlns:a="http://schemas.openxmlformats.org/drawingml/2006/main" noGrp="1"/>
+          </p:cNvSpPr>
+          <p:nvPr/>
+        </p:nvSpPr>
+        <p:spPr>
+          <a:xfrm xmlns:a="http://schemas.openxmlformats.org/drawingml/2006/main">
+            <a:off x="781050" y="3505200"/>
             <a:ext cx="1143000" cy="266700"/>
           </a:xfrm>
           <a:prstGeom xmlns:a="http://schemas.openxmlformats.org/drawingml/2006/main" prst="rect">
@@ -6225,21 +6579,21 @@
       </p:sp>
       <p:sp>
         <p:nvSpPr>
-          <p:cNvPr id="44" name="">
-            <a:extLst xmlns:a="http://schemas.openxmlformats.org/drawingml/2006/main">
-              <a:ext uri="{FF2B5EF4-FFF2-40B4-BE49-F238E27FC236}">
-                <a16:creationId xmlns:a16="http://schemas.microsoft.com/office/drawing/2014/main" id="{6A751B9F-B745-4571-B902-5EA8E2345D1A}"/>
-              </a:ext>
-            </a:extLst>
-          </p:cNvPr>
-          <p:cNvSpPr>
-            <a:spLocks xmlns:a="http://schemas.openxmlformats.org/drawingml/2006/main" noGrp="1"/>
-          </p:cNvSpPr>
-          <p:nvPr/>
-        </p:nvSpPr>
-        <p:spPr>
-          <a:xfrm xmlns:a="http://schemas.openxmlformats.org/drawingml/2006/main">
-            <a:off x="1952625" y="3429000"/>
+          <p:cNvPr id="54" name="">
+            <a:extLst xmlns:a="http://schemas.openxmlformats.org/drawingml/2006/main">
+              <a:ext uri="{FF2B5EF4-FFF2-40B4-BE49-F238E27FC236}">
+                <a16:creationId xmlns:a16="http://schemas.microsoft.com/office/drawing/2014/main" id="{27F5F82D-ECB3-47E6-A88D-EB264D2444B0}"/>
+              </a:ext>
+            </a:extLst>
+          </p:cNvPr>
+          <p:cNvSpPr>
+            <a:spLocks xmlns:a="http://schemas.openxmlformats.org/drawingml/2006/main" noGrp="1"/>
+          </p:cNvSpPr>
+          <p:nvPr/>
+        </p:nvSpPr>
+        <p:spPr>
+          <a:xfrm xmlns:a="http://schemas.openxmlformats.org/drawingml/2006/main">
+            <a:off x="1952625" y="3505200"/>
             <a:ext cx="2476500" cy="266700"/>
           </a:xfrm>
           <a:prstGeom xmlns:a="http://schemas.openxmlformats.org/drawingml/2006/main" prst="rect">
@@ -6282,21 +6636,21 @@
       </p:sp>
       <p:sp>
         <p:nvSpPr>
-          <p:cNvPr id="45" name="">
-            <a:extLst xmlns:a="http://schemas.openxmlformats.org/drawingml/2006/main">
-              <a:ext uri="{FF2B5EF4-FFF2-40B4-BE49-F238E27FC236}">
-                <a16:creationId xmlns:a16="http://schemas.microsoft.com/office/drawing/2014/main" id="{63CCCABA-58FE-4754-A549-5B79FBAF9712}"/>
-              </a:ext>
-            </a:extLst>
-          </p:cNvPr>
-          <p:cNvSpPr>
-            <a:spLocks xmlns:a="http://schemas.openxmlformats.org/drawingml/2006/main" noGrp="1"/>
-          </p:cNvSpPr>
-          <p:nvPr/>
-        </p:nvSpPr>
-        <p:spPr>
-          <a:xfrm xmlns:a="http://schemas.openxmlformats.org/drawingml/2006/main">
-            <a:off x="4524375" y="3429000"/>
+          <p:cNvPr id="55" name="">
+            <a:extLst xmlns:a="http://schemas.openxmlformats.org/drawingml/2006/main">
+              <a:ext uri="{FF2B5EF4-FFF2-40B4-BE49-F238E27FC236}">
+                <a16:creationId xmlns:a16="http://schemas.microsoft.com/office/drawing/2014/main" id="{5D5EEE56-906B-47A8-9C30-6A049E655335}"/>
+              </a:ext>
+            </a:extLst>
+          </p:cNvPr>
+          <p:cNvSpPr>
+            <a:spLocks xmlns:a="http://schemas.openxmlformats.org/drawingml/2006/main" noGrp="1"/>
+          </p:cNvSpPr>
+          <p:nvPr/>
+        </p:nvSpPr>
+        <p:spPr>
+          <a:xfrm xmlns:a="http://schemas.openxmlformats.org/drawingml/2006/main">
+            <a:off x="4524375" y="3505200"/>
             <a:ext cx="6762750" cy="266700"/>
           </a:xfrm>
           <a:prstGeom xmlns:a="http://schemas.openxmlformats.org/drawingml/2006/main" prst="rect">
@@ -6339,21 +6693,21 @@
       </p:sp>
       <p:sp>
         <p:nvSpPr>
-          <p:cNvPr id="46" name="">
-            <a:extLst xmlns:a="http://schemas.openxmlformats.org/drawingml/2006/main">
-              <a:ext uri="{FF2B5EF4-FFF2-40B4-BE49-F238E27FC236}">
-                <a16:creationId xmlns:a16="http://schemas.microsoft.com/office/drawing/2014/main" id="{3A16E88A-25BB-40D9-B656-EF9F6796B660}"/>
-              </a:ext>
-            </a:extLst>
-          </p:cNvPr>
-          <p:cNvSpPr>
-            <a:spLocks xmlns:a="http://schemas.openxmlformats.org/drawingml/2006/main" noGrp="1"/>
-          </p:cNvSpPr>
-          <p:nvPr/>
-        </p:nvSpPr>
-        <p:spPr>
-          <a:xfrm xmlns:a="http://schemas.openxmlformats.org/drawingml/2006/main">
-            <a:off x="781050" y="3790950"/>
+          <p:cNvPr id="56" name="">
+            <a:extLst xmlns:a="http://schemas.openxmlformats.org/drawingml/2006/main">
+              <a:ext uri="{FF2B5EF4-FFF2-40B4-BE49-F238E27FC236}">
+                <a16:creationId xmlns:a16="http://schemas.microsoft.com/office/drawing/2014/main" id="{8C880631-7274-47D6-A625-CAAF12D8DE2E}"/>
+              </a:ext>
+            </a:extLst>
+          </p:cNvPr>
+          <p:cNvSpPr>
+            <a:spLocks xmlns:a="http://schemas.openxmlformats.org/drawingml/2006/main" noGrp="1"/>
+          </p:cNvSpPr>
+          <p:nvPr/>
+        </p:nvSpPr>
+        <p:spPr>
+          <a:xfrm xmlns:a="http://schemas.openxmlformats.org/drawingml/2006/main">
+            <a:off x="781050" y="3867150"/>
             <a:ext cx="1143000" cy="266700"/>
           </a:xfrm>
           <a:prstGeom xmlns:a="http://schemas.openxmlformats.org/drawingml/2006/main" prst="rect">
@@ -6396,21 +6750,21 @@
       </p:sp>
       <p:sp>
         <p:nvSpPr>
-          <p:cNvPr id="47" name="">
-            <a:extLst xmlns:a="http://schemas.openxmlformats.org/drawingml/2006/main">
-              <a:ext uri="{FF2B5EF4-FFF2-40B4-BE49-F238E27FC236}">
-                <a16:creationId xmlns:a16="http://schemas.microsoft.com/office/drawing/2014/main" id="{4EC95D5D-23D8-4DB8-8F0B-D450E2635626}"/>
-              </a:ext>
-            </a:extLst>
-          </p:cNvPr>
-          <p:cNvSpPr>
-            <a:spLocks xmlns:a="http://schemas.openxmlformats.org/drawingml/2006/main" noGrp="1"/>
-          </p:cNvSpPr>
-          <p:nvPr/>
-        </p:nvSpPr>
-        <p:spPr>
-          <a:xfrm xmlns:a="http://schemas.openxmlformats.org/drawingml/2006/main">
-            <a:off x="1952625" y="3790950"/>
+          <p:cNvPr id="57" name="">
+            <a:extLst xmlns:a="http://schemas.openxmlformats.org/drawingml/2006/main">
+              <a:ext uri="{FF2B5EF4-FFF2-40B4-BE49-F238E27FC236}">
+                <a16:creationId xmlns:a16="http://schemas.microsoft.com/office/drawing/2014/main" id="{2A7B7A16-8E09-4B9A-924E-711FFDF93E48}"/>
+              </a:ext>
+            </a:extLst>
+          </p:cNvPr>
+          <p:cNvSpPr>
+            <a:spLocks xmlns:a="http://schemas.openxmlformats.org/drawingml/2006/main" noGrp="1"/>
+          </p:cNvSpPr>
+          <p:nvPr/>
+        </p:nvSpPr>
+        <p:spPr>
+          <a:xfrm xmlns:a="http://schemas.openxmlformats.org/drawingml/2006/main">
+            <a:off x="1952625" y="3867150"/>
             <a:ext cx="9334500" cy="266700"/>
           </a:xfrm>
           <a:prstGeom xmlns:a="http://schemas.openxmlformats.org/drawingml/2006/main" prst="rect">
@@ -6453,21 +6807,21 @@
       </p:sp>
       <p:sp>
         <p:nvSpPr>
-          <p:cNvPr id="48" name="">
-            <a:extLst xmlns:a="http://schemas.openxmlformats.org/drawingml/2006/main">
-              <a:ext uri="{FF2B5EF4-FFF2-40B4-BE49-F238E27FC236}">
-                <a16:creationId xmlns:a16="http://schemas.microsoft.com/office/drawing/2014/main" id="{26AEA056-2D42-4134-BD6C-996817CFE0FB}"/>
-              </a:ext>
-            </a:extLst>
-          </p:cNvPr>
-          <p:cNvSpPr>
-            <a:spLocks xmlns:a="http://schemas.openxmlformats.org/drawingml/2006/main" noGrp="1"/>
-          </p:cNvSpPr>
-          <p:nvPr/>
-        </p:nvSpPr>
-        <p:spPr>
-          <a:xfrm xmlns:a="http://schemas.openxmlformats.org/drawingml/2006/main">
-            <a:off x="571500" y="4286250"/>
+          <p:cNvPr id="58" name="">
+            <a:extLst xmlns:a="http://schemas.openxmlformats.org/drawingml/2006/main">
+              <a:ext uri="{FF2B5EF4-FFF2-40B4-BE49-F238E27FC236}">
+                <a16:creationId xmlns:a16="http://schemas.microsoft.com/office/drawing/2014/main" id="{FB248B7C-5900-4270-B384-18239C09E68A}"/>
+              </a:ext>
+            </a:extLst>
+          </p:cNvPr>
+          <p:cNvSpPr>
+            <a:spLocks xmlns:a="http://schemas.openxmlformats.org/drawingml/2006/main" noGrp="1"/>
+          </p:cNvSpPr>
+          <p:nvPr/>
+        </p:nvSpPr>
+        <p:spPr>
+          <a:xfrm xmlns:a="http://schemas.openxmlformats.org/drawingml/2006/main">
+            <a:off x="571500" y="4362450"/>
             <a:ext cx="1714500" cy="266700"/>
           </a:xfrm>
           <a:prstGeom xmlns:a="http://schemas.openxmlformats.org/drawingml/2006/main" prst="rect">
@@ -6510,21 +6864,21 @@
       </p:sp>
       <p:sp>
         <p:nvSpPr>
-          <p:cNvPr id="49" name="">
-            <a:extLst xmlns:a="http://schemas.openxmlformats.org/drawingml/2006/main">
-              <a:ext uri="{FF2B5EF4-FFF2-40B4-BE49-F238E27FC236}">
-                <a16:creationId xmlns:a16="http://schemas.microsoft.com/office/drawing/2014/main" id="{54A43162-FAE2-4CDE-BCCC-691FD53646DE}"/>
-              </a:ext>
-            </a:extLst>
-          </p:cNvPr>
-          <p:cNvSpPr>
-            <a:spLocks xmlns:a="http://schemas.openxmlformats.org/drawingml/2006/main" noGrp="1"/>
-          </p:cNvSpPr>
-          <p:nvPr/>
-        </p:nvSpPr>
-        <p:spPr>
-          <a:xfrm xmlns:a="http://schemas.openxmlformats.org/drawingml/2006/main">
-            <a:off x="571500" y="4610100"/>
+          <p:cNvPr id="59" name="">
+            <a:extLst xmlns:a="http://schemas.openxmlformats.org/drawingml/2006/main">
+              <a:ext uri="{FF2B5EF4-FFF2-40B4-BE49-F238E27FC236}">
+                <a16:creationId xmlns:a16="http://schemas.microsoft.com/office/drawing/2014/main" id="{0771F9BA-9259-426F-8705-1053C0D3296E}"/>
+              </a:ext>
+            </a:extLst>
+          </p:cNvPr>
+          <p:cNvSpPr>
+            <a:spLocks xmlns:a="http://schemas.openxmlformats.org/drawingml/2006/main" noGrp="1"/>
+          </p:cNvSpPr>
+          <p:nvPr/>
+        </p:nvSpPr>
+        <p:spPr>
+          <a:xfrm xmlns:a="http://schemas.openxmlformats.org/drawingml/2006/main">
+            <a:off x="571500" y="4686300"/>
             <a:ext cx="3314700" cy="228600"/>
           </a:xfrm>
           <a:prstGeom xmlns:a="http://schemas.openxmlformats.org/drawingml/2006/main" prst="rect">
@@ -6567,21 +6921,21 @@
       </p:sp>
       <p:sp>
         <p:nvSpPr>
-          <p:cNvPr id="50" name="">
-            <a:extLst xmlns:a="http://schemas.openxmlformats.org/drawingml/2006/main">
-              <a:ext uri="{FF2B5EF4-FFF2-40B4-BE49-F238E27FC236}">
-                <a16:creationId xmlns:a16="http://schemas.microsoft.com/office/drawing/2014/main" id="{080F2501-1463-455B-ACC2-E3733F2EDAA8}"/>
-              </a:ext>
-            </a:extLst>
-          </p:cNvPr>
-          <p:cNvSpPr>
-            <a:spLocks xmlns:a="http://schemas.openxmlformats.org/drawingml/2006/main" noGrp="1"/>
-          </p:cNvSpPr>
-          <p:nvPr/>
-        </p:nvSpPr>
-        <p:spPr>
-          <a:xfrm xmlns:a="http://schemas.openxmlformats.org/drawingml/2006/main">
-            <a:off x="571500" y="4876800"/>
+          <p:cNvPr id="60" name="">
+            <a:extLst xmlns:a="http://schemas.openxmlformats.org/drawingml/2006/main">
+              <a:ext uri="{FF2B5EF4-FFF2-40B4-BE49-F238E27FC236}">
+                <a16:creationId xmlns:a16="http://schemas.microsoft.com/office/drawing/2014/main" id="{1069C041-7CB8-4C6F-9D83-2BA099BC87D4}"/>
+              </a:ext>
+            </a:extLst>
+          </p:cNvPr>
+          <p:cNvSpPr>
+            <a:spLocks xmlns:a="http://schemas.openxmlformats.org/drawingml/2006/main" noGrp="1"/>
+          </p:cNvSpPr>
+          <p:nvPr/>
+        </p:nvSpPr>
+        <p:spPr>
+          <a:xfrm xmlns:a="http://schemas.openxmlformats.org/drawingml/2006/main">
+            <a:off x="571500" y="4953000"/>
             <a:ext cx="3314700" cy="361950"/>
           </a:xfrm>
           <a:prstGeom xmlns:a="http://schemas.openxmlformats.org/drawingml/2006/main" prst="rect">
@@ -6624,21 +6978,21 @@
       </p:sp>
       <p:sp>
         <p:nvSpPr>
-          <p:cNvPr id="51" name="">
-            <a:extLst xmlns:a="http://schemas.openxmlformats.org/drawingml/2006/main">
-              <a:ext uri="{FF2B5EF4-FFF2-40B4-BE49-F238E27FC236}">
-                <a16:creationId xmlns:a16="http://schemas.microsoft.com/office/drawing/2014/main" id="{6BC421D2-431C-45B3-B211-3DB9AE75126C}"/>
-              </a:ext>
-            </a:extLst>
-          </p:cNvPr>
-          <p:cNvSpPr>
-            <a:spLocks xmlns:a="http://schemas.openxmlformats.org/drawingml/2006/main" noGrp="1"/>
-          </p:cNvSpPr>
-          <p:nvPr/>
-        </p:nvSpPr>
-        <p:spPr>
-          <a:xfrm xmlns:a="http://schemas.openxmlformats.org/drawingml/2006/main">
-            <a:off x="571500" y="5257800"/>
+          <p:cNvPr id="61" name="">
+            <a:extLst xmlns:a="http://schemas.openxmlformats.org/drawingml/2006/main">
+              <a:ext uri="{FF2B5EF4-FFF2-40B4-BE49-F238E27FC236}">
+                <a16:creationId xmlns:a16="http://schemas.microsoft.com/office/drawing/2014/main" id="{0805C618-31A9-4FB8-815D-EF674BF3B306}"/>
+              </a:ext>
+            </a:extLst>
+          </p:cNvPr>
+          <p:cNvSpPr>
+            <a:spLocks xmlns:a="http://schemas.openxmlformats.org/drawingml/2006/main" noGrp="1"/>
+          </p:cNvSpPr>
+          <p:nvPr/>
+        </p:nvSpPr>
+        <p:spPr>
+          <a:xfrm xmlns:a="http://schemas.openxmlformats.org/drawingml/2006/main">
+            <a:off x="571500" y="5334000"/>
             <a:ext cx="3314700" cy="361950"/>
           </a:xfrm>
           <a:prstGeom xmlns:a="http://schemas.openxmlformats.org/drawingml/2006/main" prst="rect">
@@ -6681,21 +7035,21 @@
       </p:sp>
       <p:sp>
         <p:nvSpPr>
-          <p:cNvPr id="52" name="">
-            <a:extLst xmlns:a="http://schemas.openxmlformats.org/drawingml/2006/main">
-              <a:ext uri="{FF2B5EF4-FFF2-40B4-BE49-F238E27FC236}">
-                <a16:creationId xmlns:a16="http://schemas.microsoft.com/office/drawing/2014/main" id="{F382CF9B-36DD-43E5-AB49-7A588E9881F1}"/>
-              </a:ext>
-            </a:extLst>
-          </p:cNvPr>
-          <p:cNvSpPr>
-            <a:spLocks xmlns:a="http://schemas.openxmlformats.org/drawingml/2006/main" noGrp="1"/>
-          </p:cNvSpPr>
-          <p:nvPr/>
-        </p:nvSpPr>
-        <p:spPr>
-          <a:xfrm xmlns:a="http://schemas.openxmlformats.org/drawingml/2006/main">
-            <a:off x="4248150" y="4610100"/>
+          <p:cNvPr id="62" name="">
+            <a:extLst xmlns:a="http://schemas.openxmlformats.org/drawingml/2006/main">
+              <a:ext uri="{FF2B5EF4-FFF2-40B4-BE49-F238E27FC236}">
+                <a16:creationId xmlns:a16="http://schemas.microsoft.com/office/drawing/2014/main" id="{C65CF203-6FFE-4929-8DFB-EA146D8EE641}"/>
+              </a:ext>
+            </a:extLst>
+          </p:cNvPr>
+          <p:cNvSpPr>
+            <a:spLocks xmlns:a="http://schemas.openxmlformats.org/drawingml/2006/main" noGrp="1"/>
+          </p:cNvSpPr>
+          <p:nvPr/>
+        </p:nvSpPr>
+        <p:spPr>
+          <a:xfrm xmlns:a="http://schemas.openxmlformats.org/drawingml/2006/main">
+            <a:off x="4248150" y="4686300"/>
             <a:ext cx="3314700" cy="228600"/>
           </a:xfrm>
           <a:prstGeom xmlns:a="http://schemas.openxmlformats.org/drawingml/2006/main" prst="rect">
@@ -6738,21 +7092,21 @@
       </p:sp>
       <p:sp>
         <p:nvSpPr>
-          <p:cNvPr id="53" name="">
-            <a:extLst xmlns:a="http://schemas.openxmlformats.org/drawingml/2006/main">
-              <a:ext uri="{FF2B5EF4-FFF2-40B4-BE49-F238E27FC236}">
-                <a16:creationId xmlns:a16="http://schemas.microsoft.com/office/drawing/2014/main" id="{0F7F0C0D-94FA-4ED9-AEF8-4D396355E3F9}"/>
-              </a:ext>
-            </a:extLst>
-          </p:cNvPr>
-          <p:cNvSpPr>
-            <a:spLocks xmlns:a="http://schemas.openxmlformats.org/drawingml/2006/main" noGrp="1"/>
-          </p:cNvSpPr>
-          <p:nvPr/>
-        </p:nvSpPr>
-        <p:spPr>
-          <a:xfrm xmlns:a="http://schemas.openxmlformats.org/drawingml/2006/main">
-            <a:off x="4248150" y="4876800"/>
+          <p:cNvPr id="63" name="">
+            <a:extLst xmlns:a="http://schemas.openxmlformats.org/drawingml/2006/main">
+              <a:ext uri="{FF2B5EF4-FFF2-40B4-BE49-F238E27FC236}">
+                <a16:creationId xmlns:a16="http://schemas.microsoft.com/office/drawing/2014/main" id="{94FACC14-F5C1-43E2-A97F-2D62C34CAD85}"/>
+              </a:ext>
+            </a:extLst>
+          </p:cNvPr>
+          <p:cNvSpPr>
+            <a:spLocks xmlns:a="http://schemas.openxmlformats.org/drawingml/2006/main" noGrp="1"/>
+          </p:cNvSpPr>
+          <p:nvPr/>
+        </p:nvSpPr>
+        <p:spPr>
+          <a:xfrm xmlns:a="http://schemas.openxmlformats.org/drawingml/2006/main">
+            <a:off x="4248150" y="4953000"/>
             <a:ext cx="3314700" cy="361950"/>
           </a:xfrm>
           <a:prstGeom xmlns:a="http://schemas.openxmlformats.org/drawingml/2006/main" prst="rect">
@@ -6795,21 +7149,21 @@
       </p:sp>
       <p:sp>
         <p:nvSpPr>
-          <p:cNvPr id="54" name="">
-            <a:extLst xmlns:a="http://schemas.openxmlformats.org/drawingml/2006/main">
-              <a:ext uri="{FF2B5EF4-FFF2-40B4-BE49-F238E27FC236}">
-                <a16:creationId xmlns:a16="http://schemas.microsoft.com/office/drawing/2014/main" id="{8FE5FC27-AE06-47D1-BC86-18CF949B080E}"/>
-              </a:ext>
-            </a:extLst>
-          </p:cNvPr>
-          <p:cNvSpPr>
-            <a:spLocks xmlns:a="http://schemas.openxmlformats.org/drawingml/2006/main" noGrp="1"/>
-          </p:cNvSpPr>
-          <p:nvPr/>
-        </p:nvSpPr>
-        <p:spPr>
-          <a:xfrm xmlns:a="http://schemas.openxmlformats.org/drawingml/2006/main">
-            <a:off x="4248150" y="5257800"/>
+          <p:cNvPr id="64" name="">
+            <a:extLst xmlns:a="http://schemas.openxmlformats.org/drawingml/2006/main">
+              <a:ext uri="{FF2B5EF4-FFF2-40B4-BE49-F238E27FC236}">
+                <a16:creationId xmlns:a16="http://schemas.microsoft.com/office/drawing/2014/main" id="{3ACE8C73-F464-438C-8957-B7145AD47DD2}"/>
+              </a:ext>
+            </a:extLst>
+          </p:cNvPr>
+          <p:cNvSpPr>
+            <a:spLocks xmlns:a="http://schemas.openxmlformats.org/drawingml/2006/main" noGrp="1"/>
+          </p:cNvSpPr>
+          <p:nvPr/>
+        </p:nvSpPr>
+        <p:spPr>
+          <a:xfrm xmlns:a="http://schemas.openxmlformats.org/drawingml/2006/main">
+            <a:off x="4248150" y="5334000"/>
             <a:ext cx="3314700" cy="361950"/>
           </a:xfrm>
           <a:prstGeom xmlns:a="http://schemas.openxmlformats.org/drawingml/2006/main" prst="rect">
@@ -6852,21 +7206,21 @@
       </p:sp>
       <p:sp>
         <p:nvSpPr>
-          <p:cNvPr id="55" name="">
-            <a:extLst xmlns:a="http://schemas.openxmlformats.org/drawingml/2006/main">
-              <a:ext uri="{FF2B5EF4-FFF2-40B4-BE49-F238E27FC236}">
-                <a16:creationId xmlns:a16="http://schemas.microsoft.com/office/drawing/2014/main" id="{2488489A-13A5-4932-BC78-A5C1F8383E06}"/>
-              </a:ext>
-            </a:extLst>
-          </p:cNvPr>
-          <p:cNvSpPr>
-            <a:spLocks xmlns:a="http://schemas.openxmlformats.org/drawingml/2006/main" noGrp="1"/>
-          </p:cNvSpPr>
-          <p:nvPr/>
-        </p:nvSpPr>
-        <p:spPr>
-          <a:xfrm xmlns:a="http://schemas.openxmlformats.org/drawingml/2006/main">
-            <a:off x="7924800" y="4610100"/>
+          <p:cNvPr id="65" name="">
+            <a:extLst xmlns:a="http://schemas.openxmlformats.org/drawingml/2006/main">
+              <a:ext uri="{FF2B5EF4-FFF2-40B4-BE49-F238E27FC236}">
+                <a16:creationId xmlns:a16="http://schemas.microsoft.com/office/drawing/2014/main" id="{5D8B78D7-970B-484E-8DCE-1826EFFB734A}"/>
+              </a:ext>
+            </a:extLst>
+          </p:cNvPr>
+          <p:cNvSpPr>
+            <a:spLocks xmlns:a="http://schemas.openxmlformats.org/drawingml/2006/main" noGrp="1"/>
+          </p:cNvSpPr>
+          <p:nvPr/>
+        </p:nvSpPr>
+        <p:spPr>
+          <a:xfrm xmlns:a="http://schemas.openxmlformats.org/drawingml/2006/main">
+            <a:off x="7924800" y="4686300"/>
             <a:ext cx="3314700" cy="228600"/>
           </a:xfrm>
           <a:prstGeom xmlns:a="http://schemas.openxmlformats.org/drawingml/2006/main" prst="rect">
@@ -6909,21 +7263,21 @@
       </p:sp>
       <p:sp>
         <p:nvSpPr>
-          <p:cNvPr id="56" name="">
-            <a:extLst xmlns:a="http://schemas.openxmlformats.org/drawingml/2006/main">
-              <a:ext uri="{FF2B5EF4-FFF2-40B4-BE49-F238E27FC236}">
-                <a16:creationId xmlns:a16="http://schemas.microsoft.com/office/drawing/2014/main" id="{ABD79311-73F1-47C5-9A42-2E9567CC7E01}"/>
-              </a:ext>
-            </a:extLst>
-          </p:cNvPr>
-          <p:cNvSpPr>
-            <a:spLocks xmlns:a="http://schemas.openxmlformats.org/drawingml/2006/main" noGrp="1"/>
-          </p:cNvSpPr>
-          <p:nvPr/>
-        </p:nvSpPr>
-        <p:spPr>
-          <a:xfrm xmlns:a="http://schemas.openxmlformats.org/drawingml/2006/main">
-            <a:off x="7924800" y="4876800"/>
+          <p:cNvPr id="66" name="">
+            <a:extLst xmlns:a="http://schemas.openxmlformats.org/drawingml/2006/main">
+              <a:ext uri="{FF2B5EF4-FFF2-40B4-BE49-F238E27FC236}">
+                <a16:creationId xmlns:a16="http://schemas.microsoft.com/office/drawing/2014/main" id="{668938D2-8AD0-44B9-963B-7D531C30FF28}"/>
+              </a:ext>
+            </a:extLst>
+          </p:cNvPr>
+          <p:cNvSpPr>
+            <a:spLocks xmlns:a="http://schemas.openxmlformats.org/drawingml/2006/main" noGrp="1"/>
+          </p:cNvSpPr>
+          <p:nvPr/>
+        </p:nvSpPr>
+        <p:spPr>
+          <a:xfrm xmlns:a="http://schemas.openxmlformats.org/drawingml/2006/main">
+            <a:off x="7924800" y="4953000"/>
             <a:ext cx="3314700" cy="361950"/>
           </a:xfrm>
           <a:prstGeom xmlns:a="http://schemas.openxmlformats.org/drawingml/2006/main" prst="rect">
@@ -6966,21 +7320,21 @@
       </p:sp>
       <p:sp>
         <p:nvSpPr>
-          <p:cNvPr id="57" name="">
-            <a:extLst xmlns:a="http://schemas.openxmlformats.org/drawingml/2006/main">
-              <a:ext uri="{FF2B5EF4-FFF2-40B4-BE49-F238E27FC236}">
-                <a16:creationId xmlns:a16="http://schemas.microsoft.com/office/drawing/2014/main" id="{02CAF709-E7B9-47E6-BBA6-82796B541E66}"/>
-              </a:ext>
-            </a:extLst>
-          </p:cNvPr>
-          <p:cNvSpPr>
-            <a:spLocks xmlns:a="http://schemas.openxmlformats.org/drawingml/2006/main" noGrp="1"/>
-          </p:cNvSpPr>
-          <p:nvPr/>
-        </p:nvSpPr>
-        <p:spPr>
-          <a:xfrm xmlns:a="http://schemas.openxmlformats.org/drawingml/2006/main">
-            <a:off x="7924800" y="5257800"/>
+          <p:cNvPr id="67" name="">
+            <a:extLst xmlns:a="http://schemas.openxmlformats.org/drawingml/2006/main">
+              <a:ext uri="{FF2B5EF4-FFF2-40B4-BE49-F238E27FC236}">
+                <a16:creationId xmlns:a16="http://schemas.microsoft.com/office/drawing/2014/main" id="{F94345E3-5FB5-468B-A3D0-1657FFB44001}"/>
+              </a:ext>
+            </a:extLst>
+          </p:cNvPr>
+          <p:cNvSpPr>
+            <a:spLocks xmlns:a="http://schemas.openxmlformats.org/drawingml/2006/main" noGrp="1"/>
+          </p:cNvSpPr>
+          <p:nvPr/>
+        </p:nvSpPr>
+        <p:spPr>
+          <a:xfrm xmlns:a="http://schemas.openxmlformats.org/drawingml/2006/main">
+            <a:off x="7924800" y="5334000"/>
             <a:ext cx="3314700" cy="361950"/>
           </a:xfrm>
           <a:prstGeom xmlns:a="http://schemas.openxmlformats.org/drawingml/2006/main" prst="rect">
@@ -7023,21 +7377,21 @@
       </p:sp>
       <p:sp>
         <p:nvSpPr>
-          <p:cNvPr id="58" name="">
-            <a:extLst xmlns:a="http://schemas.openxmlformats.org/drawingml/2006/main">
-              <a:ext uri="{FF2B5EF4-FFF2-40B4-BE49-F238E27FC236}">
-                <a16:creationId xmlns:a16="http://schemas.microsoft.com/office/drawing/2014/main" id="{8B88EA27-8A29-4788-B150-DDED1C3CC3C0}"/>
-              </a:ext>
-            </a:extLst>
-          </p:cNvPr>
-          <p:cNvSpPr>
-            <a:spLocks xmlns:a="http://schemas.openxmlformats.org/drawingml/2006/main" noGrp="1"/>
-          </p:cNvSpPr>
-          <p:nvPr/>
-        </p:nvSpPr>
-        <p:spPr>
-          <a:xfrm xmlns:a="http://schemas.openxmlformats.org/drawingml/2006/main">
-            <a:off x="571500" y="5619750"/>
+          <p:cNvPr id="68" name="">
+            <a:extLst xmlns:a="http://schemas.openxmlformats.org/drawingml/2006/main">
+              <a:ext uri="{FF2B5EF4-FFF2-40B4-BE49-F238E27FC236}">
+                <a16:creationId xmlns:a16="http://schemas.microsoft.com/office/drawing/2014/main" id="{0C64D2AD-C7D4-4E22-8117-8F824E652E8F}"/>
+              </a:ext>
+            </a:extLst>
+          </p:cNvPr>
+          <p:cNvSpPr>
+            <a:spLocks xmlns:a="http://schemas.openxmlformats.org/drawingml/2006/main" noGrp="1"/>
+          </p:cNvSpPr>
+          <p:nvPr/>
+        </p:nvSpPr>
+        <p:spPr>
+          <a:xfrm xmlns:a="http://schemas.openxmlformats.org/drawingml/2006/main">
+            <a:off x="571500" y="5753100"/>
             <a:ext cx="11049000" cy="419100"/>
           </a:xfrm>
           <a:prstGeom xmlns:a="http://schemas.openxmlformats.org/drawingml/2006/main" prst="roundRect">
@@ -7055,21 +7409,21 @@
       </p:sp>
       <p:sp>
         <p:nvSpPr>
-          <p:cNvPr id="59" name="">
-            <a:extLst xmlns:a="http://schemas.openxmlformats.org/drawingml/2006/main">
-              <a:ext uri="{FF2B5EF4-FFF2-40B4-BE49-F238E27FC236}">
-                <a16:creationId xmlns:a16="http://schemas.microsoft.com/office/drawing/2014/main" id="{6F830FF3-5ABC-44CC-B3FB-BD15F490983A}"/>
-              </a:ext>
-            </a:extLst>
-          </p:cNvPr>
-          <p:cNvSpPr>
-            <a:spLocks xmlns:a="http://schemas.openxmlformats.org/drawingml/2006/main" noGrp="1"/>
-          </p:cNvSpPr>
-          <p:nvPr/>
-        </p:nvSpPr>
-        <p:spPr>
-          <a:xfrm xmlns:a="http://schemas.openxmlformats.org/drawingml/2006/main">
-            <a:off x="781050" y="5695950"/>
+          <p:cNvPr id="69" name="">
+            <a:extLst xmlns:a="http://schemas.openxmlformats.org/drawingml/2006/main">
+              <a:ext uri="{FF2B5EF4-FFF2-40B4-BE49-F238E27FC236}">
+                <a16:creationId xmlns:a16="http://schemas.microsoft.com/office/drawing/2014/main" id="{B86E7191-CF00-4151-8361-63BB87AD3BC8}"/>
+              </a:ext>
+            </a:extLst>
+          </p:cNvPr>
+          <p:cNvSpPr>
+            <a:spLocks xmlns:a="http://schemas.openxmlformats.org/drawingml/2006/main" noGrp="1"/>
+          </p:cNvSpPr>
+          <p:nvPr/>
+        </p:nvSpPr>
+        <p:spPr>
+          <a:xfrm xmlns:a="http://schemas.openxmlformats.org/drawingml/2006/main">
+            <a:off x="781050" y="5829300"/>
             <a:ext cx="10572750" cy="257175"/>
           </a:xfrm>
           <a:prstGeom xmlns:a="http://schemas.openxmlformats.org/drawingml/2006/main" prst="rect">
@@ -7113,7 +7467,7 @@
     </p:spTree>
     <p:extLst>
       <p:ext uri="{BB962C8B-B14F-4D97-AF65-F5344CB8AC3E}">
-        <p14:creationId xmlns:p14="http://schemas.microsoft.com/office/powerpoint/2010/main" val="1210513944"/>
+        <p14:creationId xmlns:p14="http://schemas.microsoft.com/office/powerpoint/2010/main" val="786344174"/>
       </p:ext>
     </p:extLst>
   </p:cSld>
@@ -7144,7 +7498,7 @@
           <p:cNvPr id="44" name="">
             <a:extLst xmlns:a="http://schemas.openxmlformats.org/drawingml/2006/main">
               <a:ext uri="{FF2B5EF4-FFF2-40B4-BE49-F238E27FC236}">
-                <a16:creationId xmlns:a16="http://schemas.microsoft.com/office/drawing/2014/main" id="{96681DC1-751C-46EF-8927-6FDE3C29CC3A}"/>
+                <a16:creationId xmlns:a16="http://schemas.microsoft.com/office/drawing/2014/main" id="{D8CAC97D-7010-480B-B768-BCEE6312B0D2}"/>
               </a:ext>
             </a:extLst>
           </p:cNvPr>
@@ -7174,7 +7528,7 @@
           <p:cNvPr id="2" name="">
             <a:extLst xmlns:a="http://schemas.openxmlformats.org/drawingml/2006/main">
               <a:ext uri="{FF2B5EF4-FFF2-40B4-BE49-F238E27FC236}">
-                <a16:creationId xmlns:a16="http://schemas.microsoft.com/office/drawing/2014/main" id="{D820F628-973B-4BFD-B2E1-69E76C8D412F}"/>
+                <a16:creationId xmlns:a16="http://schemas.microsoft.com/office/drawing/2014/main" id="{44541AF6-3297-4AA3-A178-9D72CF3E50BD}"/>
               </a:ext>
             </a:extLst>
           </p:cNvPr>
@@ -7231,7 +7585,7 @@
           <p:cNvPr id="3" name="">
             <a:extLst xmlns:a="http://schemas.openxmlformats.org/drawingml/2006/main">
               <a:ext uri="{FF2B5EF4-FFF2-40B4-BE49-F238E27FC236}">
-                <a16:creationId xmlns:a16="http://schemas.microsoft.com/office/drawing/2014/main" id="{777767B2-BAAA-46A4-BC03-1B8F0A1A3163}"/>
+                <a16:creationId xmlns:a16="http://schemas.microsoft.com/office/drawing/2014/main" id="{F37204A0-8755-45A0-975A-B55FC43990E5}"/>
               </a:ext>
             </a:extLst>
           </p:cNvPr>
@@ -7261,7 +7615,7 @@
           <p:cNvPr id="4" name="">
             <a:extLst xmlns:a="http://schemas.openxmlformats.org/drawingml/2006/main">
               <a:ext uri="{FF2B5EF4-FFF2-40B4-BE49-F238E27FC236}">
-                <a16:creationId xmlns:a16="http://schemas.microsoft.com/office/drawing/2014/main" id="{2CBFB80F-588D-48C8-8726-67B84CB1A415}"/>
+                <a16:creationId xmlns:a16="http://schemas.microsoft.com/office/drawing/2014/main" id="{40CF29B3-624C-4F1D-B59B-4643A1367720}"/>
               </a:ext>
             </a:extLst>
           </p:cNvPr>
@@ -7318,7 +7672,7 @@
           <p:cNvPr id="5" name="">
             <a:extLst xmlns:a="http://schemas.openxmlformats.org/drawingml/2006/main">
               <a:ext uri="{FF2B5EF4-FFF2-40B4-BE49-F238E27FC236}">
-                <a16:creationId xmlns:a16="http://schemas.microsoft.com/office/drawing/2014/main" id="{300C475D-FF82-4C49-8668-8417535D2ABE}"/>
+                <a16:creationId xmlns:a16="http://schemas.microsoft.com/office/drawing/2014/main" id="{AD02F9E4-E00D-4AEF-8D07-333E5EF45884}"/>
               </a:ext>
             </a:extLst>
           </p:cNvPr>
@@ -7375,7 +7729,7 @@
           <p:cNvPr id="6" name="">
             <a:extLst xmlns:a="http://schemas.openxmlformats.org/drawingml/2006/main">
               <a:ext uri="{FF2B5EF4-FFF2-40B4-BE49-F238E27FC236}">
-                <a16:creationId xmlns:a16="http://schemas.microsoft.com/office/drawing/2014/main" id="{19DC154E-2C9E-4421-B43F-A91E82F3D48B}"/>
+                <a16:creationId xmlns:a16="http://schemas.microsoft.com/office/drawing/2014/main" id="{5A4666D5-8891-4021-9D26-284D9C459297}"/>
               </a:ext>
             </a:extLst>
           </p:cNvPr>
@@ -7432,7 +7786,7 @@
           <p:cNvPr id="7" name="">
             <a:extLst xmlns:a="http://schemas.openxmlformats.org/drawingml/2006/main">
               <a:ext uri="{FF2B5EF4-FFF2-40B4-BE49-F238E27FC236}">
-                <a16:creationId xmlns:a16="http://schemas.microsoft.com/office/drawing/2014/main" id="{00204DF6-A7FC-4CFF-83C4-24888AFCA226}"/>
+                <a16:creationId xmlns:a16="http://schemas.microsoft.com/office/drawing/2014/main" id="{0114865F-EA1F-43B3-A9B0-A017BF649578}"/>
               </a:ext>
             </a:extLst>
           </p:cNvPr>
@@ -7462,7 +7816,7 @@
           <p:cNvPr id="8" name="">
             <a:extLst xmlns:a="http://schemas.openxmlformats.org/drawingml/2006/main">
               <a:ext uri="{FF2B5EF4-FFF2-40B4-BE49-F238E27FC236}">
-                <a16:creationId xmlns:a16="http://schemas.microsoft.com/office/drawing/2014/main" id="{A97A2B17-602A-4824-A603-89AF74E25781}"/>
+                <a16:creationId xmlns:a16="http://schemas.microsoft.com/office/drawing/2014/main" id="{C24EE9BF-4620-4674-B4AA-6F4E41A62E43}"/>
               </a:ext>
             </a:extLst>
           </p:cNvPr>
@@ -7519,7 +7873,7 @@
           <p:cNvPr id="9" name="">
             <a:extLst xmlns:a="http://schemas.openxmlformats.org/drawingml/2006/main">
               <a:ext uri="{FF2B5EF4-FFF2-40B4-BE49-F238E27FC236}">
-                <a16:creationId xmlns:a16="http://schemas.microsoft.com/office/drawing/2014/main" id="{3DDEB44D-9032-494D-BA6C-BB2B72FFE52A}"/>
+                <a16:creationId xmlns:a16="http://schemas.microsoft.com/office/drawing/2014/main" id="{093D76F6-EC77-4BF3-8F8C-60FA6F48894A}"/>
               </a:ext>
             </a:extLst>
           </p:cNvPr>
@@ -7576,7 +7930,7 @@
           <p:cNvPr id="10" name="">
             <a:extLst xmlns:a="http://schemas.openxmlformats.org/drawingml/2006/main">
               <a:ext uri="{FF2B5EF4-FFF2-40B4-BE49-F238E27FC236}">
-                <a16:creationId xmlns:a16="http://schemas.microsoft.com/office/drawing/2014/main" id="{7EC7B1C0-AC84-4BFD-8362-FA63F445488F}"/>
+                <a16:creationId xmlns:a16="http://schemas.microsoft.com/office/drawing/2014/main" id="{DEC23DD6-0D0B-40C3-ADC3-33CEE016BF9F}"/>
               </a:ext>
             </a:extLst>
           </p:cNvPr>
@@ -7633,7 +7987,7 @@
           <p:cNvPr id="11" name="">
             <a:extLst xmlns:a="http://schemas.openxmlformats.org/drawingml/2006/main">
               <a:ext uri="{FF2B5EF4-FFF2-40B4-BE49-F238E27FC236}">
-                <a16:creationId xmlns:a16="http://schemas.microsoft.com/office/drawing/2014/main" id="{BD5C8BAD-9CAA-4D04-A48C-021F38B1E091}"/>
+                <a16:creationId xmlns:a16="http://schemas.microsoft.com/office/drawing/2014/main" id="{C5029260-7B4D-484E-9686-0E1CE65A7319}"/>
               </a:ext>
             </a:extLst>
           </p:cNvPr>
@@ -7665,7 +8019,7 @@
           <p:cNvPr id="12" name="">
             <a:extLst xmlns:a="http://schemas.openxmlformats.org/drawingml/2006/main">
               <a:ext uri="{FF2B5EF4-FFF2-40B4-BE49-F238E27FC236}">
-                <a16:creationId xmlns:a16="http://schemas.microsoft.com/office/drawing/2014/main" id="{AC762984-8780-4608-B469-99393DAE2048}"/>
+                <a16:creationId xmlns:a16="http://schemas.microsoft.com/office/drawing/2014/main" id="{9381F433-DEBD-4298-AA46-729A8DC0ECB2}"/>
               </a:ext>
             </a:extLst>
           </p:cNvPr>
@@ -7722,7 +8076,7 @@
           <p:cNvPr id="13" name="">
             <a:extLst xmlns:a="http://schemas.openxmlformats.org/drawingml/2006/main">
               <a:ext uri="{FF2B5EF4-FFF2-40B4-BE49-F238E27FC236}">
-                <a16:creationId xmlns:a16="http://schemas.microsoft.com/office/drawing/2014/main" id="{B7E5FDB5-C06D-429B-955B-CB8BA4506935}"/>
+                <a16:creationId xmlns:a16="http://schemas.microsoft.com/office/drawing/2014/main" id="{B370B6AE-18A4-4349-A09B-E269E7BF2122}"/>
               </a:ext>
             </a:extLst>
           </p:cNvPr>
@@ -7779,7 +8133,7 @@
           <p:cNvPr id="14" name="">
             <a:extLst xmlns:a="http://schemas.openxmlformats.org/drawingml/2006/main">
               <a:ext uri="{FF2B5EF4-FFF2-40B4-BE49-F238E27FC236}">
-                <a16:creationId xmlns:a16="http://schemas.microsoft.com/office/drawing/2014/main" id="{FE980190-6586-42CC-A0F2-D7AC5DE13E61}"/>
+                <a16:creationId xmlns:a16="http://schemas.microsoft.com/office/drawing/2014/main" id="{A9669949-A31C-4061-97AC-ABBDB63AAAC6}"/>
               </a:ext>
             </a:extLst>
           </p:cNvPr>
@@ -7836,7 +8190,7 @@
           <p:cNvPr id="15" name="">
             <a:extLst xmlns:a="http://schemas.openxmlformats.org/drawingml/2006/main">
               <a:ext uri="{FF2B5EF4-FFF2-40B4-BE49-F238E27FC236}">
-                <a16:creationId xmlns:a16="http://schemas.microsoft.com/office/drawing/2014/main" id="{7E25E382-461B-4BDF-8206-DD66341F9AA6}"/>
+                <a16:creationId xmlns:a16="http://schemas.microsoft.com/office/drawing/2014/main" id="{B22B0F6E-231A-4A05-9779-1F2C08366D96}"/>
               </a:ext>
             </a:extLst>
           </p:cNvPr>
@@ -7868,7 +8222,7 @@
           <p:cNvPr id="16" name="">
             <a:extLst xmlns:a="http://schemas.openxmlformats.org/drawingml/2006/main">
               <a:ext uri="{FF2B5EF4-FFF2-40B4-BE49-F238E27FC236}">
-                <a16:creationId xmlns:a16="http://schemas.microsoft.com/office/drawing/2014/main" id="{D15E143C-8481-456D-B5DF-5176B34C6D60}"/>
+                <a16:creationId xmlns:a16="http://schemas.microsoft.com/office/drawing/2014/main" id="{DC007AB3-7649-4115-AE1E-F88484342BFC}"/>
               </a:ext>
             </a:extLst>
           </p:cNvPr>
@@ -7925,7 +8279,7 @@
           <p:cNvPr id="17" name="">
             <a:extLst xmlns:a="http://schemas.openxmlformats.org/drawingml/2006/main">
               <a:ext uri="{FF2B5EF4-FFF2-40B4-BE49-F238E27FC236}">
-                <a16:creationId xmlns:a16="http://schemas.microsoft.com/office/drawing/2014/main" id="{8AFBEF12-BB1D-4180-A8A2-F1DAE7D68BC1}"/>
+                <a16:creationId xmlns:a16="http://schemas.microsoft.com/office/drawing/2014/main" id="{A4AB67A3-16B2-4683-9852-75DC06D0CB1C}"/>
               </a:ext>
             </a:extLst>
           </p:cNvPr>
@@ -7982,7 +8336,7 @@
           <p:cNvPr id="18" name="">
             <a:extLst xmlns:a="http://schemas.openxmlformats.org/drawingml/2006/main">
               <a:ext uri="{FF2B5EF4-FFF2-40B4-BE49-F238E27FC236}">
-                <a16:creationId xmlns:a16="http://schemas.microsoft.com/office/drawing/2014/main" id="{C65912EF-CFF7-47BA-9BBB-3211A852D3B3}"/>
+                <a16:creationId xmlns:a16="http://schemas.microsoft.com/office/drawing/2014/main" id="{ABD2183A-F94A-406F-9F8B-31B17EB12A72}"/>
               </a:ext>
             </a:extLst>
           </p:cNvPr>
@@ -8039,7 +8393,7 @@
           <p:cNvPr id="19" name="">
             <a:extLst xmlns:a="http://schemas.openxmlformats.org/drawingml/2006/main">
               <a:ext uri="{FF2B5EF4-FFF2-40B4-BE49-F238E27FC236}">
-                <a16:creationId xmlns:a16="http://schemas.microsoft.com/office/drawing/2014/main" id="{20D07586-5E6F-44B6-8C8F-A1C85AD83207}"/>
+                <a16:creationId xmlns:a16="http://schemas.microsoft.com/office/drawing/2014/main" id="{E0ADB943-B0B1-4AFE-A9B6-8306FB9AA7A9}"/>
               </a:ext>
             </a:extLst>
           </p:cNvPr>
@@ -8071,7 +8425,7 @@
           <p:cNvPr id="20" name="">
             <a:extLst xmlns:a="http://schemas.openxmlformats.org/drawingml/2006/main">
               <a:ext uri="{FF2B5EF4-FFF2-40B4-BE49-F238E27FC236}">
-                <a16:creationId xmlns:a16="http://schemas.microsoft.com/office/drawing/2014/main" id="{C4260116-476B-43F3-A72D-C775383D1170}"/>
+                <a16:creationId xmlns:a16="http://schemas.microsoft.com/office/drawing/2014/main" id="{F7AAE329-24CE-4259-A9E0-690BCFDF7219}"/>
               </a:ext>
             </a:extLst>
           </p:cNvPr>
@@ -8128,7 +8482,7 @@
           <p:cNvPr id="21" name="">
             <a:extLst xmlns:a="http://schemas.openxmlformats.org/drawingml/2006/main">
               <a:ext uri="{FF2B5EF4-FFF2-40B4-BE49-F238E27FC236}">
-                <a16:creationId xmlns:a16="http://schemas.microsoft.com/office/drawing/2014/main" id="{FD822BC9-86B0-40C8-9CE8-3F70A74A1412}"/>
+                <a16:creationId xmlns:a16="http://schemas.microsoft.com/office/drawing/2014/main" id="{C4D95542-D643-4677-996C-DB98154E8A95}"/>
               </a:ext>
             </a:extLst>
           </p:cNvPr>
@@ -8185,7 +8539,7 @@
           <p:cNvPr id="22" name="">
             <a:extLst xmlns:a="http://schemas.openxmlformats.org/drawingml/2006/main">
               <a:ext uri="{FF2B5EF4-FFF2-40B4-BE49-F238E27FC236}">
-                <a16:creationId xmlns:a16="http://schemas.microsoft.com/office/drawing/2014/main" id="{7079F811-7058-41CD-A7E5-1A639D857A6F}"/>
+                <a16:creationId xmlns:a16="http://schemas.microsoft.com/office/drawing/2014/main" id="{2AEA3F11-2CFF-402F-8FFC-2695E496D1B1}"/>
               </a:ext>
             </a:extLst>
           </p:cNvPr>
@@ -8242,7 +8596,7 @@
           <p:cNvPr id="23" name="">
             <a:extLst xmlns:a="http://schemas.openxmlformats.org/drawingml/2006/main">
               <a:ext uri="{FF2B5EF4-FFF2-40B4-BE49-F238E27FC236}">
-                <a16:creationId xmlns:a16="http://schemas.microsoft.com/office/drawing/2014/main" id="{34C5641A-9DB1-409C-AEEE-8EA69D6A8704}"/>
+                <a16:creationId xmlns:a16="http://schemas.microsoft.com/office/drawing/2014/main" id="{C857A87E-EAF8-4665-978A-2CAC511870A5}"/>
               </a:ext>
             </a:extLst>
           </p:cNvPr>
@@ -8274,7 +8628,7 @@
           <p:cNvPr id="24" name="">
             <a:extLst xmlns:a="http://schemas.openxmlformats.org/drawingml/2006/main">
               <a:ext uri="{FF2B5EF4-FFF2-40B4-BE49-F238E27FC236}">
-                <a16:creationId xmlns:a16="http://schemas.microsoft.com/office/drawing/2014/main" id="{D32ED7F0-7DB0-4CB5-9361-AD53DB2D0D82}"/>
+                <a16:creationId xmlns:a16="http://schemas.microsoft.com/office/drawing/2014/main" id="{AABD5CAB-E7C5-4551-A4E9-0A4DABCEC83C}"/>
               </a:ext>
             </a:extLst>
           </p:cNvPr>
@@ -8331,7 +8685,7 @@
           <p:cNvPr id="25" name="">
             <a:extLst xmlns:a="http://schemas.openxmlformats.org/drawingml/2006/main">
               <a:ext uri="{FF2B5EF4-FFF2-40B4-BE49-F238E27FC236}">
-                <a16:creationId xmlns:a16="http://schemas.microsoft.com/office/drawing/2014/main" id="{5F09F65F-A7AC-4988-9D59-F76C194E25E4}"/>
+                <a16:creationId xmlns:a16="http://schemas.microsoft.com/office/drawing/2014/main" id="{8E4F3B9E-29D3-4927-BACB-D2DFD8DC84D0}"/>
               </a:ext>
             </a:extLst>
           </p:cNvPr>
@@ -8388,7 +8742,7 @@
           <p:cNvPr id="26" name="">
             <a:extLst xmlns:a="http://schemas.openxmlformats.org/drawingml/2006/main">
               <a:ext uri="{FF2B5EF4-FFF2-40B4-BE49-F238E27FC236}">
-                <a16:creationId xmlns:a16="http://schemas.microsoft.com/office/drawing/2014/main" id="{80EBDF7D-EBA4-434C-84B7-58D5FBE22157}"/>
+                <a16:creationId xmlns:a16="http://schemas.microsoft.com/office/drawing/2014/main" id="{254211CA-4DCB-4A03-A41E-D34AA194F857}"/>
               </a:ext>
             </a:extLst>
           </p:cNvPr>
@@ -8445,7 +8799,7 @@
           <p:cNvPr id="27" name="">
             <a:extLst xmlns:a="http://schemas.openxmlformats.org/drawingml/2006/main">
               <a:ext uri="{FF2B5EF4-FFF2-40B4-BE49-F238E27FC236}">
-                <a16:creationId xmlns:a16="http://schemas.microsoft.com/office/drawing/2014/main" id="{A03607ED-D291-4202-8267-5A9CC541366A}"/>
+                <a16:creationId xmlns:a16="http://schemas.microsoft.com/office/drawing/2014/main" id="{A31596DE-E3EA-4098-A8AE-84B680921512}"/>
               </a:ext>
             </a:extLst>
           </p:cNvPr>
@@ -8477,7 +8831,7 @@
           <p:cNvPr id="28" name="">
             <a:extLst xmlns:a="http://schemas.openxmlformats.org/drawingml/2006/main">
               <a:ext uri="{FF2B5EF4-FFF2-40B4-BE49-F238E27FC236}">
-                <a16:creationId xmlns:a16="http://schemas.microsoft.com/office/drawing/2014/main" id="{6E2A889B-3B4A-4CDC-8F6F-EA38097841B3}"/>
+                <a16:creationId xmlns:a16="http://schemas.microsoft.com/office/drawing/2014/main" id="{19818306-9FAA-4C0E-BDEE-FEDC2A8E9D74}"/>
               </a:ext>
             </a:extLst>
           </p:cNvPr>
@@ -8534,7 +8888,7 @@
           <p:cNvPr id="29" name="">
             <a:extLst xmlns:a="http://schemas.openxmlformats.org/drawingml/2006/main">
               <a:ext uri="{FF2B5EF4-FFF2-40B4-BE49-F238E27FC236}">
-                <a16:creationId xmlns:a16="http://schemas.microsoft.com/office/drawing/2014/main" id="{E3BC036C-5E2E-4D79-9726-76551D290248}"/>
+                <a16:creationId xmlns:a16="http://schemas.microsoft.com/office/drawing/2014/main" id="{75E3115E-C57E-45F9-818D-96A10F4CC7F0}"/>
               </a:ext>
             </a:extLst>
           </p:cNvPr>
@@ -8591,7 +8945,7 @@
           <p:cNvPr id="30" name="">
             <a:extLst xmlns:a="http://schemas.openxmlformats.org/drawingml/2006/main">
               <a:ext uri="{FF2B5EF4-FFF2-40B4-BE49-F238E27FC236}">
-                <a16:creationId xmlns:a16="http://schemas.microsoft.com/office/drawing/2014/main" id="{B04573B2-7980-4783-ACCE-B2236FBBBC39}"/>
+                <a16:creationId xmlns:a16="http://schemas.microsoft.com/office/drawing/2014/main" id="{6B1C753C-A313-484E-AFCD-5588C2460EDC}"/>
               </a:ext>
             </a:extLst>
           </p:cNvPr>
@@ -8648,7 +9002,7 @@
           <p:cNvPr id="31" name="">
             <a:extLst xmlns:a="http://schemas.openxmlformats.org/drawingml/2006/main">
               <a:ext uri="{FF2B5EF4-FFF2-40B4-BE49-F238E27FC236}">
-                <a16:creationId xmlns:a16="http://schemas.microsoft.com/office/drawing/2014/main" id="{374DDE8F-6AC5-4A71-ABD4-2168FEBF3CD7}"/>
+                <a16:creationId xmlns:a16="http://schemas.microsoft.com/office/drawing/2014/main" id="{E83F06C4-114B-40B5-BA38-740AB95C6CD0}"/>
               </a:ext>
             </a:extLst>
           </p:cNvPr>
@@ -8705,7 +9059,7 @@
           <p:cNvPr id="32" name="">
             <a:extLst xmlns:a="http://schemas.openxmlformats.org/drawingml/2006/main">
               <a:ext uri="{FF2B5EF4-FFF2-40B4-BE49-F238E27FC236}">
-                <a16:creationId xmlns:a16="http://schemas.microsoft.com/office/drawing/2014/main" id="{7C04E634-C9DD-4FAB-835D-12B0427B14BF}"/>
+                <a16:creationId xmlns:a16="http://schemas.microsoft.com/office/drawing/2014/main" id="{DB8D0951-73CA-45D4-B6FB-42BD366D4819}"/>
               </a:ext>
             </a:extLst>
           </p:cNvPr>
@@ -8762,7 +9116,7 @@
           <p:cNvPr id="33" name="">
             <a:extLst xmlns:a="http://schemas.openxmlformats.org/drawingml/2006/main">
               <a:ext uri="{FF2B5EF4-FFF2-40B4-BE49-F238E27FC236}">
-                <a16:creationId xmlns:a16="http://schemas.microsoft.com/office/drawing/2014/main" id="{83B4FC4E-DE4D-49A2-BE16-3FC642E409B7}"/>
+                <a16:creationId xmlns:a16="http://schemas.microsoft.com/office/drawing/2014/main" id="{B1C590E9-B1E4-44B7-84EE-127355049B0B}"/>
               </a:ext>
             </a:extLst>
           </p:cNvPr>
@@ -8819,7 +9173,7 @@
           <p:cNvPr id="34" name="">
             <a:extLst xmlns:a="http://schemas.openxmlformats.org/drawingml/2006/main">
               <a:ext uri="{FF2B5EF4-FFF2-40B4-BE49-F238E27FC236}">
-                <a16:creationId xmlns:a16="http://schemas.microsoft.com/office/drawing/2014/main" id="{D38ABFFD-4C10-46D9-A26E-010249E77A1C}"/>
+                <a16:creationId xmlns:a16="http://schemas.microsoft.com/office/drawing/2014/main" id="{91429BB3-6139-45A2-A5EF-7F012D94EC80}"/>
               </a:ext>
             </a:extLst>
           </p:cNvPr>
@@ -8876,7 +9230,7 @@
           <p:cNvPr id="35" name="">
             <a:extLst xmlns:a="http://schemas.openxmlformats.org/drawingml/2006/main">
               <a:ext uri="{FF2B5EF4-FFF2-40B4-BE49-F238E27FC236}">
-                <a16:creationId xmlns:a16="http://schemas.microsoft.com/office/drawing/2014/main" id="{E55F0718-E672-4C9F-B704-74B018378049}"/>
+                <a16:creationId xmlns:a16="http://schemas.microsoft.com/office/drawing/2014/main" id="{44B2E15E-2898-483F-97B4-9D825882FAB9}"/>
               </a:ext>
             </a:extLst>
           </p:cNvPr>
@@ -8933,7 +9287,7 @@
           <p:cNvPr id="36" name="">
             <a:extLst xmlns:a="http://schemas.openxmlformats.org/drawingml/2006/main">
               <a:ext uri="{FF2B5EF4-FFF2-40B4-BE49-F238E27FC236}">
-                <a16:creationId xmlns:a16="http://schemas.microsoft.com/office/drawing/2014/main" id="{EB9C349E-57C4-40B0-91B4-37787ED34A07}"/>
+                <a16:creationId xmlns:a16="http://schemas.microsoft.com/office/drawing/2014/main" id="{1F754461-ACA3-4847-8FB5-6C0804939E5A}"/>
               </a:ext>
             </a:extLst>
           </p:cNvPr>
@@ -8990,7 +9344,7 @@
           <p:cNvPr id="37" name="">
             <a:extLst xmlns:a="http://schemas.openxmlformats.org/drawingml/2006/main">
               <a:ext uri="{FF2B5EF4-FFF2-40B4-BE49-F238E27FC236}">
-                <a16:creationId xmlns:a16="http://schemas.microsoft.com/office/drawing/2014/main" id="{6A2BFBE5-1141-4C75-9A8B-B2A845836BDA}"/>
+                <a16:creationId xmlns:a16="http://schemas.microsoft.com/office/drawing/2014/main" id="{15733A27-E924-4C13-BA4F-F959C4EA5D35}"/>
               </a:ext>
             </a:extLst>
           </p:cNvPr>
@@ -9047,7 +9401,7 @@
           <p:cNvPr id="38" name="">
             <a:extLst xmlns:a="http://schemas.openxmlformats.org/drawingml/2006/main">
               <a:ext uri="{FF2B5EF4-FFF2-40B4-BE49-F238E27FC236}">
-                <a16:creationId xmlns:a16="http://schemas.microsoft.com/office/drawing/2014/main" id="{5F23BB67-174B-49BB-A04C-41C8180FE842}"/>
+                <a16:creationId xmlns:a16="http://schemas.microsoft.com/office/drawing/2014/main" id="{17B14302-C54D-41A6-BAA0-425323101BAD}"/>
               </a:ext>
             </a:extLst>
           </p:cNvPr>
@@ -9104,7 +9458,7 @@
           <p:cNvPr id="39" name="">
             <a:extLst xmlns:a="http://schemas.openxmlformats.org/drawingml/2006/main">
               <a:ext uri="{FF2B5EF4-FFF2-40B4-BE49-F238E27FC236}">
-                <a16:creationId xmlns:a16="http://schemas.microsoft.com/office/drawing/2014/main" id="{4C0245C5-E680-48F0-ACE2-664F528B1B38}"/>
+                <a16:creationId xmlns:a16="http://schemas.microsoft.com/office/drawing/2014/main" id="{056ED0D6-6BDC-4AE8-9C11-EB8B92F4AB6C}"/>
               </a:ext>
             </a:extLst>
           </p:cNvPr>
@@ -9161,7 +9515,7 @@
           <p:cNvPr id="40" name="">
             <a:extLst xmlns:a="http://schemas.openxmlformats.org/drawingml/2006/main">
               <a:ext uri="{FF2B5EF4-FFF2-40B4-BE49-F238E27FC236}">
-                <a16:creationId xmlns:a16="http://schemas.microsoft.com/office/drawing/2014/main" id="{56870775-A514-4115-A89B-F01E8D7F47D8}"/>
+                <a16:creationId xmlns:a16="http://schemas.microsoft.com/office/drawing/2014/main" id="{7B20F3D0-6710-4836-931C-2BF0148BA229}"/>
               </a:ext>
             </a:extLst>
           </p:cNvPr>
@@ -9218,7 +9572,7 @@
           <p:cNvPr id="41" name="">
             <a:extLst xmlns:a="http://schemas.openxmlformats.org/drawingml/2006/main">
               <a:ext uri="{FF2B5EF4-FFF2-40B4-BE49-F238E27FC236}">
-                <a16:creationId xmlns:a16="http://schemas.microsoft.com/office/drawing/2014/main" id="{43EDDF1E-DF12-4BCD-B715-A2CF93974EEF}"/>
+                <a16:creationId xmlns:a16="http://schemas.microsoft.com/office/drawing/2014/main" id="{7AFDEFD8-A7E7-4071-BBB8-CBC4CCB9D0E4}"/>
               </a:ext>
             </a:extLst>
           </p:cNvPr>
@@ -9275,7 +9629,7 @@
           <p:cNvPr id="42" name="">
             <a:extLst xmlns:a="http://schemas.openxmlformats.org/drawingml/2006/main">
               <a:ext uri="{FF2B5EF4-FFF2-40B4-BE49-F238E27FC236}">
-                <a16:creationId xmlns:a16="http://schemas.microsoft.com/office/drawing/2014/main" id="{E6D22D49-E425-4F16-BA25-CC03563ED944}"/>
+                <a16:creationId xmlns:a16="http://schemas.microsoft.com/office/drawing/2014/main" id="{D0763B03-329E-45B3-A47D-F2690A71DDD7}"/>
               </a:ext>
             </a:extLst>
           </p:cNvPr>
@@ -9332,7 +9686,7 @@
           <p:cNvPr id="43" name="">
             <a:extLst xmlns:a="http://schemas.openxmlformats.org/drawingml/2006/main">
               <a:ext uri="{FF2B5EF4-FFF2-40B4-BE49-F238E27FC236}">
-                <a16:creationId xmlns:a16="http://schemas.microsoft.com/office/drawing/2014/main" id="{0F234668-A784-4A45-BBD9-5A2EC9D9F42A}"/>
+                <a16:creationId xmlns:a16="http://schemas.microsoft.com/office/drawing/2014/main" id="{1B83B400-021B-4117-B53E-B181CF1132AF}"/>
               </a:ext>
             </a:extLst>
           </p:cNvPr>
@@ -9387,7 +9741,7 @@
     </p:spTree>
     <p:extLst>
       <p:ext uri="{BB962C8B-B14F-4D97-AF65-F5344CB8AC3E}">
-        <p14:creationId xmlns:p14="http://schemas.microsoft.com/office/powerpoint/2010/main" val="885722203"/>
+        <p14:creationId xmlns:p14="http://schemas.microsoft.com/office/powerpoint/2010/main" val="396966587"/>
       </p:ext>
     </p:extLst>
   </p:cSld>

</xml_diff>